<commit_message>
Add Reddit/X/GitHub usage reviews to community slide
Restructure the community usage slide into a 5-channel table
(Reddit, X, GitHub, Slack, Discord) with representative quotes per platform.

Co-authored-by: Cursor <cursoragent@cursor.com>
</commit_message>
<xml_diff>
--- a/외부AI_3종_비교조사.pptx
+++ b/외부AI_3종_비교조사.pptx
@@ -3513,29 +3513,205 @@
                 </a:solidFill>
                 <a:latin typeface="Apple SD Gothic Neo"/>
               </a:rPr>
-              <a:t>Slack · Discord 커뮤니티 사용기</a:t>
-            </a:r>
-          </a:p>
-        </p:txBody>
-      </p:sp>
-      <p:sp>
-        <p:nvSpPr>
-          <p:cNvPr id="6" name="Rounded Rectangle 5"/>
+              <a:t>커뮤니티 사용기 (Reddit·X·GitHub·Slack·Discord)</a:t>
+            </a:r>
+          </a:p>
+        </p:txBody>
+      </p:sp>
+      <p:sp>
+        <p:nvSpPr>
+          <p:cNvPr id="6" name="Rectangle 5"/>
           <p:cNvSpPr/>
           <p:nvPr/>
         </p:nvSpPr>
         <p:spPr>
           <a:xfrm>
-            <a:off x="502920" y="1234440"/>
-            <a:ext cx="5486400" cy="2743200"/>
-          </a:xfrm>
-          <a:prstGeom prst="roundRect">
+            <a:off x="457200" y="1234440"/>
+            <a:ext cx="1463040" cy="621792"/>
+          </a:xfrm>
+          <a:prstGeom prst="rect">
             <a:avLst/>
           </a:prstGeom>
           <a:solidFill>
-            <a:srgbClr val="E8F1FA"/>
+            <a:srgbClr val="1F6FB2"/>
           </a:solidFill>
           <a:ln w="12700">
+            <a:solidFill>
+              <a:srgbClr val="FFFFFF"/>
+            </a:solidFill>
+          </a:ln>
+          <a:effectLst/>
+        </p:spPr>
+        <p:style>
+          <a:lnRef idx="1">
+            <a:schemeClr val="accent1"/>
+          </a:lnRef>
+          <a:fillRef idx="3">
+            <a:schemeClr val="accent1"/>
+          </a:fillRef>
+          <a:effectRef idx="2">
+            <a:schemeClr val="accent1"/>
+          </a:effectRef>
+          <a:fontRef idx="minor">
+            <a:schemeClr val="lt1"/>
+          </a:fontRef>
+        </p:style>
+        <p:txBody>
+          <a:bodyPr rtlCol="0" anchor="ctr"/>
+          <a:lstStyle/>
+          <a:p>
+            <a:pPr algn="ctr"/>
+          </a:p>
+        </p:txBody>
+      </p:sp>
+      <p:sp>
+        <p:nvSpPr>
+          <p:cNvPr id="7" name="TextBox 6"/>
+          <p:cNvSpPr txBox="1"/>
+          <p:nvPr/>
+        </p:nvSpPr>
+        <p:spPr>
+          <a:xfrm>
+            <a:off x="457200" y="1234440"/>
+            <a:ext cx="1463040" cy="621792"/>
+          </a:xfrm>
+          <a:prstGeom prst="rect">
+            <a:avLst/>
+          </a:prstGeom>
+          <a:noFill/>
+        </p:spPr>
+        <p:txBody>
+          <a:bodyPr wrap="square" anchor="ctr">
+            <a:spAutoFit/>
+          </a:bodyPr>
+          <a:lstStyle/>
+          <a:p>
+            <a:pPr algn="ctr">
+              <a:lnSpc>
+                <a:spcPct val="100000"/>
+              </a:lnSpc>
+              <a:spcAft>
+                <a:spcPts val="400"/>
+              </a:spcAft>
+            </a:pPr>
+            <a:r>
+              <a:rPr sz="1150" b="1">
+                <a:solidFill>
+                  <a:srgbClr val="FFFFFF"/>
+                </a:solidFill>
+                <a:latin typeface="Apple SD Gothic Neo"/>
+              </a:rPr>
+              <a:t>커뮤니티</a:t>
+            </a:r>
+          </a:p>
+        </p:txBody>
+      </p:sp>
+      <p:sp>
+        <p:nvSpPr>
+          <p:cNvPr id="8" name="Rectangle 7"/>
+          <p:cNvSpPr/>
+          <p:nvPr/>
+        </p:nvSpPr>
+        <p:spPr>
+          <a:xfrm>
+            <a:off x="1920240" y="1234440"/>
+            <a:ext cx="9738360" cy="621792"/>
+          </a:xfrm>
+          <a:prstGeom prst="rect">
+            <a:avLst/>
+          </a:prstGeom>
+          <a:solidFill>
+            <a:srgbClr val="1F6FB2"/>
+          </a:solidFill>
+          <a:ln w="12700">
+            <a:solidFill>
+              <a:srgbClr val="FFFFFF"/>
+            </a:solidFill>
+          </a:ln>
+          <a:effectLst/>
+        </p:spPr>
+        <p:style>
+          <a:lnRef idx="1">
+            <a:schemeClr val="accent1"/>
+          </a:lnRef>
+          <a:fillRef idx="3">
+            <a:schemeClr val="accent1"/>
+          </a:fillRef>
+          <a:effectRef idx="2">
+            <a:schemeClr val="accent1"/>
+          </a:effectRef>
+          <a:fontRef idx="minor">
+            <a:schemeClr val="lt1"/>
+          </a:fontRef>
+        </p:style>
+        <p:txBody>
+          <a:bodyPr rtlCol="0" anchor="ctr"/>
+          <a:lstStyle/>
+          <a:p>
+            <a:pPr algn="ctr"/>
+          </a:p>
+        </p:txBody>
+      </p:sp>
+      <p:sp>
+        <p:nvSpPr>
+          <p:cNvPr id="9" name="TextBox 8"/>
+          <p:cNvSpPr txBox="1"/>
+          <p:nvPr/>
+        </p:nvSpPr>
+        <p:spPr>
+          <a:xfrm>
+            <a:off x="1920240" y="1234440"/>
+            <a:ext cx="9738360" cy="621792"/>
+          </a:xfrm>
+          <a:prstGeom prst="rect">
+            <a:avLst/>
+          </a:prstGeom>
+          <a:noFill/>
+        </p:spPr>
+        <p:txBody>
+          <a:bodyPr wrap="square" anchor="ctr">
+            <a:spAutoFit/>
+          </a:bodyPr>
+          <a:lstStyle/>
+          <a:p>
+            <a:pPr algn="ctr">
+              <a:lnSpc>
+                <a:spcPct val="100000"/>
+              </a:lnSpc>
+              <a:spcAft>
+                <a:spcPts val="400"/>
+              </a:spcAft>
+            </a:pPr>
+            <a:r>
+              <a:rPr sz="1150" b="1">
+                <a:solidFill>
+                  <a:srgbClr val="FFFFFF"/>
+                </a:solidFill>
+                <a:latin typeface="Apple SD Gothic Neo"/>
+              </a:rPr>
+              <a:t>대표 사용기 · 인용 패턴 (참고)</a:t>
+            </a:r>
+          </a:p>
+        </p:txBody>
+      </p:sp>
+      <p:sp>
+        <p:nvSpPr>
+          <p:cNvPr id="10" name="Rectangle 9"/>
+          <p:cNvSpPr/>
+          <p:nvPr/>
+        </p:nvSpPr>
+        <p:spPr>
+          <a:xfrm>
+            <a:off x="457200" y="1856232"/>
+            <a:ext cx="1463040" cy="621792"/>
+          </a:xfrm>
+          <a:prstGeom prst="rect">
+            <a:avLst/>
+          </a:prstGeom>
+          <a:solidFill>
+            <a:srgbClr val="FFFFFF"/>
+          </a:solidFill>
+          <a:ln w="9525">
             <a:solidFill>
               <a:srgbClr val="D5DDE6"/>
             </a:solidFill>
@@ -3566,23 +3742,67 @@
       </p:sp>
       <p:sp>
         <p:nvSpPr>
-          <p:cNvPr id="7" name="Rectangle 6"/>
+          <p:cNvPr id="11" name="TextBox 10"/>
+          <p:cNvSpPr txBox="1"/>
+          <p:nvPr/>
+        </p:nvSpPr>
+        <p:spPr>
+          <a:xfrm>
+            <a:off x="495300" y="1856232"/>
+            <a:ext cx="1386840" cy="621792"/>
+          </a:xfrm>
+          <a:prstGeom prst="rect">
+            <a:avLst/>
+          </a:prstGeom>
+          <a:noFill/>
+        </p:spPr>
+        <p:txBody>
+          <a:bodyPr wrap="square" anchor="ctr">
+            <a:spAutoFit/>
+          </a:bodyPr>
+          <a:lstStyle/>
+          <a:p>
+            <a:pPr algn="ctr">
+              <a:lnSpc>
+                <a:spcPct val="92000"/>
+              </a:lnSpc>
+              <a:spcAft>
+                <a:spcPts val="400"/>
+              </a:spcAft>
+            </a:pPr>
+            <a:r>
+              <a:rPr sz="1050" b="0">
+                <a:solidFill>
+                  <a:srgbClr val="444A55"/>
+                </a:solidFill>
+                <a:latin typeface="Apple SD Gothic Neo"/>
+              </a:rPr>
+              <a:t>Reddit</a:t>
+            </a:r>
+          </a:p>
+        </p:txBody>
+      </p:sp>
+      <p:sp>
+        <p:nvSpPr>
+          <p:cNvPr id="12" name="Rectangle 11"/>
           <p:cNvSpPr/>
           <p:nvPr/>
         </p:nvSpPr>
         <p:spPr>
           <a:xfrm>
-            <a:off x="502920" y="1234440"/>
-            <a:ext cx="76200" cy="2743200"/>
+            <a:off x="1920240" y="1856232"/>
+            <a:ext cx="9738360" cy="621792"/>
           </a:xfrm>
           <a:prstGeom prst="rect">
             <a:avLst/>
           </a:prstGeom>
           <a:solidFill>
-            <a:srgbClr val="1F6FB2"/>
+            <a:srgbClr val="FFFFFF"/>
           </a:solidFill>
-          <a:ln>
-            <a:noFill/>
+          <a:ln w="9525">
+            <a:solidFill>
+              <a:srgbClr val="D5DDE6"/>
+            </a:solidFill>
           </a:ln>
           <a:effectLst/>
         </p:spPr>
@@ -3610,232 +3830,64 @@
       </p:sp>
       <p:sp>
         <p:nvSpPr>
-          <p:cNvPr id="8" name="TextBox 7"/>
-          <p:cNvSpPr txBox="1"/>
-          <p:nvPr/>
-        </p:nvSpPr>
-        <p:spPr>
-          <a:xfrm>
-            <a:off x="685800" y="1325880"/>
-            <a:ext cx="5120640" cy="320040"/>
-          </a:xfrm>
-          <a:prstGeom prst="rect">
-            <a:avLst/>
-          </a:prstGeom>
-          <a:noFill/>
-        </p:spPr>
-        <p:txBody>
-          <a:bodyPr wrap="square" anchor="t">
+          <p:cNvPr id="13" name="TextBox 12"/>
+          <p:cNvSpPr txBox="1"/>
+          <p:nvPr/>
+        </p:nvSpPr>
+        <p:spPr>
+          <a:xfrm>
+            <a:off x="1958340" y="1856232"/>
+            <a:ext cx="9662160" cy="621792"/>
+          </a:xfrm>
+          <a:prstGeom prst="rect">
+            <a:avLst/>
+          </a:prstGeom>
+          <a:noFill/>
+        </p:spPr>
+        <p:txBody>
+          <a:bodyPr wrap="square" anchor="ctr">
             <a:spAutoFit/>
           </a:bodyPr>
           <a:lstStyle/>
           <a:p>
             <a:pPr algn="l">
               <a:lnSpc>
-                <a:spcPct val="100000"/>
-              </a:lnSpc>
-              <a:spcAft>
-                <a:spcPts val="400"/>
-              </a:spcAft>
-            </a:pPr>
-            <a:r>
-              <a:rPr sz="1300" b="1">
-                <a:solidFill>
-                  <a:srgbClr val="1F6FB2"/>
-                </a:solidFill>
-                <a:latin typeface="Apple SD Gothic Neo"/>
-              </a:rPr>
-              <a:t>Slack (팀 협업 관점)</a:t>
-            </a:r>
-          </a:p>
-        </p:txBody>
-      </p:sp>
-      <p:sp>
-        <p:nvSpPr>
-          <p:cNvPr id="9" name="TextBox 8"/>
-          <p:cNvSpPr txBox="1"/>
-          <p:nvPr/>
-        </p:nvSpPr>
-        <p:spPr>
-          <a:xfrm>
-            <a:off x="731520" y="1673352"/>
-            <a:ext cx="5074920" cy="347472"/>
-          </a:xfrm>
-          <a:prstGeom prst="rect">
-            <a:avLst/>
-          </a:prstGeom>
-          <a:noFill/>
-        </p:spPr>
-        <p:txBody>
-          <a:bodyPr wrap="square" anchor="t">
-            <a:spAutoFit/>
-          </a:bodyPr>
-          <a:lstStyle/>
-          <a:p>
-            <a:pPr algn="l">
-              <a:lnSpc>
-                <a:spcPct val="100000"/>
-              </a:lnSpc>
-              <a:spcAft>
-                <a:spcPts val="400"/>
-              </a:spcAft>
-            </a:pPr>
-            <a:r>
-              <a:rPr sz="1100" b="0">
+                <a:spcPct val="92000"/>
+              </a:lnSpc>
+              <a:spcAft>
+                <a:spcPts val="400"/>
+              </a:spcAft>
+            </a:pPr>
+            <a:r>
+              <a:rPr sz="1050" b="0">
                 <a:solidFill>
                   <a:srgbClr val="444A55"/>
                 </a:solidFill>
                 <a:latin typeface="Apple SD Gothic Neo"/>
               </a:rPr>
-              <a:t>• Slack AI: 스레드 요약·액션아이템 추출 효율 호평</a:t>
-            </a:r>
-          </a:p>
-        </p:txBody>
-      </p:sp>
-      <p:sp>
-        <p:nvSpPr>
-          <p:cNvPr id="10" name="TextBox 9"/>
-          <p:cNvSpPr txBox="1"/>
-          <p:nvPr/>
-        </p:nvSpPr>
-        <p:spPr>
-          <a:xfrm>
-            <a:off x="731520" y="2039112"/>
-            <a:ext cx="5074920" cy="347472"/>
-          </a:xfrm>
-          <a:prstGeom prst="rect">
-            <a:avLst/>
-          </a:prstGeom>
-          <a:noFill/>
-        </p:spPr>
-        <p:txBody>
-          <a:bodyPr wrap="square" anchor="t">
-            <a:spAutoFit/>
-          </a:bodyPr>
-          <a:lstStyle/>
-          <a:p>
-            <a:pPr algn="l">
-              <a:lnSpc>
-                <a:spcPct val="100000"/>
-              </a:lnSpc>
-              <a:spcAft>
-                <a:spcPts val="400"/>
-              </a:spcAft>
-            </a:pPr>
-            <a:r>
-              <a:rPr sz="1100" b="0">
-                <a:solidFill>
-                  <a:srgbClr val="444A55"/>
-                </a:solidFill>
-                <a:latin typeface="Apple SD Gothic Neo"/>
-              </a:rPr>
-              <a:t>• ChatGPT: Slack·Git·Confluence에 RAG로 연결한 '프론트도어 비서' 사례</a:t>
-            </a:r>
-          </a:p>
-        </p:txBody>
-      </p:sp>
-      <p:sp>
-        <p:nvSpPr>
-          <p:cNvPr id="11" name="TextBox 10"/>
-          <p:cNvSpPr txBox="1"/>
-          <p:nvPr/>
-        </p:nvSpPr>
-        <p:spPr>
-          <a:xfrm>
-            <a:off x="731520" y="2404872"/>
-            <a:ext cx="5074920" cy="347472"/>
-          </a:xfrm>
-          <a:prstGeom prst="rect">
-            <a:avLst/>
-          </a:prstGeom>
-          <a:noFill/>
-        </p:spPr>
-        <p:txBody>
-          <a:bodyPr wrap="square" anchor="t">
-            <a:spAutoFit/>
-          </a:bodyPr>
-          <a:lstStyle/>
-          <a:p>
-            <a:pPr algn="l">
-              <a:lnSpc>
-                <a:spcPct val="100000"/>
-              </a:lnSpc>
-              <a:spcAft>
-                <a:spcPts val="400"/>
-              </a:spcAft>
-            </a:pPr>
-            <a:r>
-              <a:rPr sz="1100" b="0">
-                <a:solidFill>
-                  <a:srgbClr val="444A55"/>
-                </a:solidFill>
-                <a:latin typeface="Apple SD Gothic Neo"/>
-              </a:rPr>
-              <a:t>• 엔터프라이즈: 'Slack → 작업(task) 자동화' 가능 여부를 비교 기준으로 둠</a:t>
-            </a:r>
-          </a:p>
-        </p:txBody>
-      </p:sp>
-      <p:sp>
-        <p:nvSpPr>
-          <p:cNvPr id="12" name="TextBox 11"/>
-          <p:cNvSpPr txBox="1"/>
-          <p:nvPr/>
-        </p:nvSpPr>
-        <p:spPr>
-          <a:xfrm>
-            <a:off x="731520" y="2770632"/>
-            <a:ext cx="5074920" cy="347472"/>
-          </a:xfrm>
-          <a:prstGeom prst="rect">
-            <a:avLst/>
-          </a:prstGeom>
-          <a:noFill/>
-        </p:spPr>
-        <p:txBody>
-          <a:bodyPr wrap="square" anchor="t">
-            <a:spAutoFit/>
-          </a:bodyPr>
-          <a:lstStyle/>
-          <a:p>
-            <a:pPr algn="l">
-              <a:lnSpc>
-                <a:spcPct val="100000"/>
-              </a:lnSpc>
-              <a:spcAft>
-                <a:spcPts val="400"/>
-              </a:spcAft>
-            </a:pPr>
-            <a:r>
-              <a:rPr sz="1100" b="0">
-                <a:solidFill>
-                  <a:srgbClr val="444A55"/>
-                </a:solidFill>
-                <a:latin typeface="Apple SD Gothic Neo"/>
-              </a:rPr>
-              <a:t>• Gemini: Workspace·Meet 요약과 함께 묶어서 평가</a:t>
-            </a:r>
-          </a:p>
-        </p:txBody>
-      </p:sp>
-      <p:sp>
-        <p:nvSpPr>
-          <p:cNvPr id="13" name="Rounded Rectangle 12"/>
+              <a:t>"만능 칼(ChatGPT) vs 정밀 메스(Claude)"; GPT-5 '답 짧다' 불만 4,600+ upvotes; Claude 한도 불만 최다</a:t>
+            </a:r>
+          </a:p>
+        </p:txBody>
+      </p:sp>
+      <p:sp>
+        <p:nvSpPr>
+          <p:cNvPr id="14" name="Rectangle 13"/>
           <p:cNvSpPr/>
           <p:nvPr/>
         </p:nvSpPr>
         <p:spPr>
           <a:xfrm>
-            <a:off x="6172200" y="1234440"/>
-            <a:ext cx="5532120" cy="2743200"/>
-          </a:xfrm>
-          <a:prstGeom prst="roundRect">
+            <a:off x="457200" y="2478024"/>
+            <a:ext cx="1463040" cy="621792"/>
+          </a:xfrm>
+          <a:prstGeom prst="rect">
             <a:avLst/>
           </a:prstGeom>
           <a:solidFill>
             <a:srgbClr val="E8F1FA"/>
           </a:solidFill>
-          <a:ln w="12700">
+          <a:ln w="9525">
             <a:solidFill>
               <a:srgbClr val="D5DDE6"/>
             </a:solidFill>
@@ -3866,23 +3918,67 @@
       </p:sp>
       <p:sp>
         <p:nvSpPr>
-          <p:cNvPr id="14" name="Rectangle 13"/>
+          <p:cNvPr id="15" name="TextBox 14"/>
+          <p:cNvSpPr txBox="1"/>
+          <p:nvPr/>
+        </p:nvSpPr>
+        <p:spPr>
+          <a:xfrm>
+            <a:off x="495300" y="2478024"/>
+            <a:ext cx="1386840" cy="621792"/>
+          </a:xfrm>
+          <a:prstGeom prst="rect">
+            <a:avLst/>
+          </a:prstGeom>
+          <a:noFill/>
+        </p:spPr>
+        <p:txBody>
+          <a:bodyPr wrap="square" anchor="ctr">
+            <a:spAutoFit/>
+          </a:bodyPr>
+          <a:lstStyle/>
+          <a:p>
+            <a:pPr algn="ctr">
+              <a:lnSpc>
+                <a:spcPct val="92000"/>
+              </a:lnSpc>
+              <a:spcAft>
+                <a:spcPts val="400"/>
+              </a:spcAft>
+            </a:pPr>
+            <a:r>
+              <a:rPr sz="1050" b="0">
+                <a:solidFill>
+                  <a:srgbClr val="444A55"/>
+                </a:solidFill>
+                <a:latin typeface="Apple SD Gothic Neo"/>
+              </a:rPr>
+              <a:t>X·개발자</a:t>
+            </a:r>
+          </a:p>
+        </p:txBody>
+      </p:sp>
+      <p:sp>
+        <p:nvSpPr>
+          <p:cNvPr id="16" name="Rectangle 15"/>
           <p:cNvSpPr/>
           <p:nvPr/>
         </p:nvSpPr>
         <p:spPr>
           <a:xfrm>
-            <a:off x="6172200" y="1234440"/>
-            <a:ext cx="76200" cy="2743200"/>
+            <a:off x="1920240" y="2478024"/>
+            <a:ext cx="9738360" cy="621792"/>
           </a:xfrm>
           <a:prstGeom prst="rect">
             <a:avLst/>
           </a:prstGeom>
           <a:solidFill>
-            <a:srgbClr val="F27E2E"/>
+            <a:srgbClr val="E8F1FA"/>
           </a:solidFill>
-          <a:ln>
-            <a:noFill/>
+          <a:ln w="9525">
+            <a:solidFill>
+              <a:srgbClr val="D5DDE6"/>
+            </a:solidFill>
           </a:ln>
           <a:effectLst/>
         </p:spPr>
@@ -3910,224 +4006,584 @@
       </p:sp>
       <p:sp>
         <p:nvSpPr>
-          <p:cNvPr id="15" name="TextBox 14"/>
-          <p:cNvSpPr txBox="1"/>
-          <p:nvPr/>
-        </p:nvSpPr>
-        <p:spPr>
-          <a:xfrm>
-            <a:off x="6355080" y="1325880"/>
-            <a:ext cx="5166360" cy="320040"/>
-          </a:xfrm>
-          <a:prstGeom prst="rect">
-            <a:avLst/>
-          </a:prstGeom>
-          <a:noFill/>
-        </p:spPr>
-        <p:txBody>
-          <a:bodyPr wrap="square" anchor="t">
+          <p:cNvPr id="17" name="TextBox 16"/>
+          <p:cNvSpPr txBox="1"/>
+          <p:nvPr/>
+        </p:nvSpPr>
+        <p:spPr>
+          <a:xfrm>
+            <a:off x="1958340" y="2478024"/>
+            <a:ext cx="9662160" cy="621792"/>
+          </a:xfrm>
+          <a:prstGeom prst="rect">
+            <a:avLst/>
+          </a:prstGeom>
+          <a:noFill/>
+        </p:spPr>
+        <p:txBody>
+          <a:bodyPr wrap="square" anchor="ctr">
             <a:spAutoFit/>
           </a:bodyPr>
           <a:lstStyle/>
           <a:p>
             <a:pPr algn="l">
               <a:lnSpc>
-                <a:spcPct val="100000"/>
-              </a:lnSpc>
-              <a:spcAft>
-                <a:spcPts val="400"/>
-              </a:spcAft>
-            </a:pPr>
-            <a:r>
-              <a:rPr sz="1300" b="1">
-                <a:solidFill>
-                  <a:srgbClr val="F27E2E"/>
-                </a:solidFill>
-                <a:latin typeface="Apple SD Gothic Neo"/>
-              </a:rPr>
-              <a:t>Discord (개발자 커뮤니티)</a:t>
-            </a:r>
-          </a:p>
-        </p:txBody>
-      </p:sp>
-      <p:sp>
-        <p:nvSpPr>
-          <p:cNvPr id="16" name="TextBox 15"/>
-          <p:cNvSpPr txBox="1"/>
-          <p:nvPr/>
-        </p:nvSpPr>
-        <p:spPr>
-          <a:xfrm>
-            <a:off x="6400800" y="1673352"/>
-            <a:ext cx="5120640" cy="347472"/>
-          </a:xfrm>
-          <a:prstGeom prst="rect">
-            <a:avLst/>
-          </a:prstGeom>
-          <a:noFill/>
-        </p:spPr>
-        <p:txBody>
-          <a:bodyPr wrap="square" anchor="t">
+                <a:spcPct val="92000"/>
+              </a:lnSpc>
+              <a:spcAft>
+                <a:spcPts val="400"/>
+              </a:spcAft>
+            </a:pPr>
+            <a:r>
+              <a:rPr sz="1050" b="0">
+                <a:solidFill>
+                  <a:srgbClr val="444A55"/>
+                </a:solidFill>
+                <a:latin typeface="Apple SD Gothic Neo"/>
+              </a:rPr>
+              <a:t>2025~26 빌더·개발자층 Claude 이동; Codex(속도·비용·위임) vs Claude Code(코드 품질) 논쟁</a:t>
+            </a:r>
+          </a:p>
+        </p:txBody>
+      </p:sp>
+      <p:sp>
+        <p:nvSpPr>
+          <p:cNvPr id="18" name="Rectangle 17"/>
+          <p:cNvSpPr/>
+          <p:nvPr/>
+        </p:nvSpPr>
+        <p:spPr>
+          <a:xfrm>
+            <a:off x="457200" y="3099816"/>
+            <a:ext cx="1463040" cy="621792"/>
+          </a:xfrm>
+          <a:prstGeom prst="rect">
+            <a:avLst/>
+          </a:prstGeom>
+          <a:solidFill>
+            <a:srgbClr val="FFFFFF"/>
+          </a:solidFill>
+          <a:ln w="9525">
+            <a:solidFill>
+              <a:srgbClr val="D5DDE6"/>
+            </a:solidFill>
+          </a:ln>
+          <a:effectLst/>
+        </p:spPr>
+        <p:style>
+          <a:lnRef idx="1">
+            <a:schemeClr val="accent1"/>
+          </a:lnRef>
+          <a:fillRef idx="3">
+            <a:schemeClr val="accent1"/>
+          </a:fillRef>
+          <a:effectRef idx="2">
+            <a:schemeClr val="accent1"/>
+          </a:effectRef>
+          <a:fontRef idx="minor">
+            <a:schemeClr val="lt1"/>
+          </a:fontRef>
+        </p:style>
+        <p:txBody>
+          <a:bodyPr rtlCol="0" anchor="ctr"/>
+          <a:lstStyle/>
+          <a:p>
+            <a:pPr algn="ctr"/>
+          </a:p>
+        </p:txBody>
+      </p:sp>
+      <p:sp>
+        <p:nvSpPr>
+          <p:cNvPr id="19" name="TextBox 18"/>
+          <p:cNvSpPr txBox="1"/>
+          <p:nvPr/>
+        </p:nvSpPr>
+        <p:spPr>
+          <a:xfrm>
+            <a:off x="495300" y="3099816"/>
+            <a:ext cx="1386840" cy="621792"/>
+          </a:xfrm>
+          <a:prstGeom prst="rect">
+            <a:avLst/>
+          </a:prstGeom>
+          <a:noFill/>
+        </p:spPr>
+        <p:txBody>
+          <a:bodyPr wrap="square" anchor="ctr">
+            <a:spAutoFit/>
+          </a:bodyPr>
+          <a:lstStyle/>
+          <a:p>
+            <a:pPr algn="ctr">
+              <a:lnSpc>
+                <a:spcPct val="92000"/>
+              </a:lnSpc>
+              <a:spcAft>
+                <a:spcPts val="400"/>
+              </a:spcAft>
+            </a:pPr>
+            <a:r>
+              <a:rPr sz="1050" b="0">
+                <a:solidFill>
+                  <a:srgbClr val="444A55"/>
+                </a:solidFill>
+                <a:latin typeface="Apple SD Gothic Neo"/>
+              </a:rPr>
+              <a:t>GitHub</a:t>
+            </a:r>
+          </a:p>
+        </p:txBody>
+      </p:sp>
+      <p:sp>
+        <p:nvSpPr>
+          <p:cNvPr id="20" name="Rectangle 19"/>
+          <p:cNvSpPr/>
+          <p:nvPr/>
+        </p:nvSpPr>
+        <p:spPr>
+          <a:xfrm>
+            <a:off x="1920240" y="3099816"/>
+            <a:ext cx="9738360" cy="621792"/>
+          </a:xfrm>
+          <a:prstGeom prst="rect">
+            <a:avLst/>
+          </a:prstGeom>
+          <a:solidFill>
+            <a:srgbClr val="FFFFFF"/>
+          </a:solidFill>
+          <a:ln w="9525">
+            <a:solidFill>
+              <a:srgbClr val="D5DDE6"/>
+            </a:solidFill>
+          </a:ln>
+          <a:effectLst/>
+        </p:spPr>
+        <p:style>
+          <a:lnRef idx="1">
+            <a:schemeClr val="accent1"/>
+          </a:lnRef>
+          <a:fillRef idx="3">
+            <a:schemeClr val="accent1"/>
+          </a:fillRef>
+          <a:effectRef idx="2">
+            <a:schemeClr val="accent1"/>
+          </a:effectRef>
+          <a:fontRef idx="minor">
+            <a:schemeClr val="lt1"/>
+          </a:fontRef>
+        </p:style>
+        <p:txBody>
+          <a:bodyPr rtlCol="0" anchor="ctr"/>
+          <a:lstStyle/>
+          <a:p>
+            <a:pPr algn="ctr"/>
+          </a:p>
+        </p:txBody>
+      </p:sp>
+      <p:sp>
+        <p:nvSpPr>
+          <p:cNvPr id="21" name="TextBox 20"/>
+          <p:cNvSpPr txBox="1"/>
+          <p:nvPr/>
+        </p:nvSpPr>
+        <p:spPr>
+          <a:xfrm>
+            <a:off x="1958340" y="3099816"/>
+            <a:ext cx="9662160" cy="621792"/>
+          </a:xfrm>
+          <a:prstGeom prst="rect">
+            <a:avLst/>
+          </a:prstGeom>
+          <a:noFill/>
+        </p:spPr>
+        <p:txBody>
+          <a:bodyPr wrap="square" anchor="ctr">
             <a:spAutoFit/>
           </a:bodyPr>
           <a:lstStyle/>
           <a:p>
             <a:pPr algn="l">
               <a:lnSpc>
-                <a:spcPct val="100000"/>
-              </a:lnSpc>
-              <a:spcAft>
-                <a:spcPts val="400"/>
-              </a:spcAft>
-            </a:pPr>
-            <a:r>
-              <a:rPr sz="1100" b="0">
+                <a:spcPct val="92000"/>
+              </a:lnSpc>
+              <a:spcAft>
+                <a:spcPts val="400"/>
+              </a:spcAft>
+            </a:pPr>
+            <a:r>
+              <a:rPr sz="1050" b="0">
                 <a:solidFill>
                   <a:srgbClr val="444A55"/>
                 </a:solidFill>
                 <a:latin typeface="Apple SD Gothic Neo"/>
               </a:rPr>
-              <a:t>• Claude Code를 Discord에서 원격 제어(MCP) — 폰으로 코딩 지시·결과 수신</a:t>
-            </a:r>
-          </a:p>
-        </p:txBody>
-      </p:sp>
-      <p:sp>
-        <p:nvSpPr>
-          <p:cNvPr id="17" name="TextBox 16"/>
-          <p:cNvSpPr txBox="1"/>
-          <p:nvPr/>
-        </p:nvSpPr>
-        <p:spPr>
-          <a:xfrm>
-            <a:off x="6400800" y="2039112"/>
-            <a:ext cx="5120640" cy="347472"/>
-          </a:xfrm>
-          <a:prstGeom prst="rect">
-            <a:avLst/>
-          </a:prstGeom>
-          <a:noFill/>
-        </p:spPr>
-        <p:txBody>
-          <a:bodyPr wrap="square" anchor="t">
+              <a:t>Gist 비교: Claude 확장성·맥락 / Codex 샌드박스 보안; claude-code·gemini-cli Issues에 한도·자율과잉 불만</a:t>
+            </a:r>
+          </a:p>
+        </p:txBody>
+      </p:sp>
+      <p:sp>
+        <p:nvSpPr>
+          <p:cNvPr id="22" name="Rectangle 21"/>
+          <p:cNvSpPr/>
+          <p:nvPr/>
+        </p:nvSpPr>
+        <p:spPr>
+          <a:xfrm>
+            <a:off x="457200" y="3721608"/>
+            <a:ext cx="1463040" cy="621792"/>
+          </a:xfrm>
+          <a:prstGeom prst="rect">
+            <a:avLst/>
+          </a:prstGeom>
+          <a:solidFill>
+            <a:srgbClr val="E8F1FA"/>
+          </a:solidFill>
+          <a:ln w="9525">
+            <a:solidFill>
+              <a:srgbClr val="D5DDE6"/>
+            </a:solidFill>
+          </a:ln>
+          <a:effectLst/>
+        </p:spPr>
+        <p:style>
+          <a:lnRef idx="1">
+            <a:schemeClr val="accent1"/>
+          </a:lnRef>
+          <a:fillRef idx="3">
+            <a:schemeClr val="accent1"/>
+          </a:fillRef>
+          <a:effectRef idx="2">
+            <a:schemeClr val="accent1"/>
+          </a:effectRef>
+          <a:fontRef idx="minor">
+            <a:schemeClr val="lt1"/>
+          </a:fontRef>
+        </p:style>
+        <p:txBody>
+          <a:bodyPr rtlCol="0" anchor="ctr"/>
+          <a:lstStyle/>
+          <a:p>
+            <a:pPr algn="ctr"/>
+          </a:p>
+        </p:txBody>
+      </p:sp>
+      <p:sp>
+        <p:nvSpPr>
+          <p:cNvPr id="23" name="TextBox 22"/>
+          <p:cNvSpPr txBox="1"/>
+          <p:nvPr/>
+        </p:nvSpPr>
+        <p:spPr>
+          <a:xfrm>
+            <a:off x="495300" y="3721608"/>
+            <a:ext cx="1386840" cy="621792"/>
+          </a:xfrm>
+          <a:prstGeom prst="rect">
+            <a:avLst/>
+          </a:prstGeom>
+          <a:noFill/>
+        </p:spPr>
+        <p:txBody>
+          <a:bodyPr wrap="square" anchor="ctr">
+            <a:spAutoFit/>
+          </a:bodyPr>
+          <a:lstStyle/>
+          <a:p>
+            <a:pPr algn="ctr">
+              <a:lnSpc>
+                <a:spcPct val="92000"/>
+              </a:lnSpc>
+              <a:spcAft>
+                <a:spcPts val="400"/>
+              </a:spcAft>
+            </a:pPr>
+            <a:r>
+              <a:rPr sz="1050" b="0">
+                <a:solidFill>
+                  <a:srgbClr val="444A55"/>
+                </a:solidFill>
+                <a:latin typeface="Apple SD Gothic Neo"/>
+              </a:rPr>
+              <a:t>Slack</a:t>
+            </a:r>
+          </a:p>
+        </p:txBody>
+      </p:sp>
+      <p:sp>
+        <p:nvSpPr>
+          <p:cNvPr id="24" name="Rectangle 23"/>
+          <p:cNvSpPr/>
+          <p:nvPr/>
+        </p:nvSpPr>
+        <p:spPr>
+          <a:xfrm>
+            <a:off x="1920240" y="3721608"/>
+            <a:ext cx="9738360" cy="621792"/>
+          </a:xfrm>
+          <a:prstGeom prst="rect">
+            <a:avLst/>
+          </a:prstGeom>
+          <a:solidFill>
+            <a:srgbClr val="E8F1FA"/>
+          </a:solidFill>
+          <a:ln w="9525">
+            <a:solidFill>
+              <a:srgbClr val="D5DDE6"/>
+            </a:solidFill>
+          </a:ln>
+          <a:effectLst/>
+        </p:spPr>
+        <p:style>
+          <a:lnRef idx="1">
+            <a:schemeClr val="accent1"/>
+          </a:lnRef>
+          <a:fillRef idx="3">
+            <a:schemeClr val="accent1"/>
+          </a:fillRef>
+          <a:effectRef idx="2">
+            <a:schemeClr val="accent1"/>
+          </a:effectRef>
+          <a:fontRef idx="minor">
+            <a:schemeClr val="lt1"/>
+          </a:fontRef>
+        </p:style>
+        <p:txBody>
+          <a:bodyPr rtlCol="0" anchor="ctr"/>
+          <a:lstStyle/>
+          <a:p>
+            <a:pPr algn="ctr"/>
+          </a:p>
+        </p:txBody>
+      </p:sp>
+      <p:sp>
+        <p:nvSpPr>
+          <p:cNvPr id="25" name="TextBox 24"/>
+          <p:cNvSpPr txBox="1"/>
+          <p:nvPr/>
+        </p:nvSpPr>
+        <p:spPr>
+          <a:xfrm>
+            <a:off x="1958340" y="3721608"/>
+            <a:ext cx="9662160" cy="621792"/>
+          </a:xfrm>
+          <a:prstGeom prst="rect">
+            <a:avLst/>
+          </a:prstGeom>
+          <a:noFill/>
+        </p:spPr>
+        <p:txBody>
+          <a:bodyPr wrap="square" anchor="ctr">
             <a:spAutoFit/>
           </a:bodyPr>
           <a:lstStyle/>
           <a:p>
             <a:pPr algn="l">
               <a:lnSpc>
-                <a:spcPct val="100000"/>
-              </a:lnSpc>
-              <a:spcAft>
-                <a:spcPts val="400"/>
-              </a:spcAft>
-            </a:pPr>
-            <a:r>
-              <a:rPr sz="1100" b="0">
+                <a:spcPct val="92000"/>
+              </a:lnSpc>
+              <a:spcAft>
+                <a:spcPts val="400"/>
+              </a:spcAft>
+            </a:pPr>
+            <a:r>
+              <a:rPr sz="1050" b="0">
                 <a:solidFill>
                   <a:srgbClr val="444A55"/>
                 </a:solidFill>
                 <a:latin typeface="Apple SD Gothic Neo"/>
               </a:rPr>
-              <a:t>• AI 코딩 설문이 Discord 채널로 배포될 만큼 토론 활발 (Ivern 312명 등)</a:t>
-            </a:r>
-          </a:p>
-        </p:txBody>
-      </p:sp>
-      <p:sp>
-        <p:nvSpPr>
-          <p:cNvPr id="18" name="TextBox 17"/>
-          <p:cNvSpPr txBox="1"/>
-          <p:nvPr/>
-        </p:nvSpPr>
-        <p:spPr>
-          <a:xfrm>
-            <a:off x="6400800" y="2404872"/>
-            <a:ext cx="5120640" cy="347472"/>
-          </a:xfrm>
-          <a:prstGeom prst="rect">
-            <a:avLst/>
-          </a:prstGeom>
-          <a:noFill/>
-        </p:spPr>
-        <p:txBody>
-          <a:bodyPr wrap="square" anchor="t">
+              <a:t>Slack AI: 스레드 요약·액션아이템; ChatGPT를 RAG '프론트도어 비서'로; 'Slack → 작업 자동화' 비교 기준</a:t>
+            </a:r>
+          </a:p>
+        </p:txBody>
+      </p:sp>
+      <p:sp>
+        <p:nvSpPr>
+          <p:cNvPr id="26" name="Rectangle 25"/>
+          <p:cNvSpPr/>
+          <p:nvPr/>
+        </p:nvSpPr>
+        <p:spPr>
+          <a:xfrm>
+            <a:off x="457200" y="4343400"/>
+            <a:ext cx="1463040" cy="621792"/>
+          </a:xfrm>
+          <a:prstGeom prst="rect">
+            <a:avLst/>
+          </a:prstGeom>
+          <a:solidFill>
+            <a:srgbClr val="FFFFFF"/>
+          </a:solidFill>
+          <a:ln w="9525">
+            <a:solidFill>
+              <a:srgbClr val="D5DDE6"/>
+            </a:solidFill>
+          </a:ln>
+          <a:effectLst/>
+        </p:spPr>
+        <p:style>
+          <a:lnRef idx="1">
+            <a:schemeClr val="accent1"/>
+          </a:lnRef>
+          <a:fillRef idx="3">
+            <a:schemeClr val="accent1"/>
+          </a:fillRef>
+          <a:effectRef idx="2">
+            <a:schemeClr val="accent1"/>
+          </a:effectRef>
+          <a:fontRef idx="minor">
+            <a:schemeClr val="lt1"/>
+          </a:fontRef>
+        </p:style>
+        <p:txBody>
+          <a:bodyPr rtlCol="0" anchor="ctr"/>
+          <a:lstStyle/>
+          <a:p>
+            <a:pPr algn="ctr"/>
+          </a:p>
+        </p:txBody>
+      </p:sp>
+      <p:sp>
+        <p:nvSpPr>
+          <p:cNvPr id="27" name="TextBox 26"/>
+          <p:cNvSpPr txBox="1"/>
+          <p:nvPr/>
+        </p:nvSpPr>
+        <p:spPr>
+          <a:xfrm>
+            <a:off x="495300" y="4343400"/>
+            <a:ext cx="1386840" cy="621792"/>
+          </a:xfrm>
+          <a:prstGeom prst="rect">
+            <a:avLst/>
+          </a:prstGeom>
+          <a:noFill/>
+        </p:spPr>
+        <p:txBody>
+          <a:bodyPr wrap="square" anchor="ctr">
+            <a:spAutoFit/>
+          </a:bodyPr>
+          <a:lstStyle/>
+          <a:p>
+            <a:pPr algn="ctr">
+              <a:lnSpc>
+                <a:spcPct val="92000"/>
+              </a:lnSpc>
+              <a:spcAft>
+                <a:spcPts val="400"/>
+              </a:spcAft>
+            </a:pPr>
+            <a:r>
+              <a:rPr sz="1050" b="0">
+                <a:solidFill>
+                  <a:srgbClr val="444A55"/>
+                </a:solidFill>
+                <a:latin typeface="Apple SD Gothic Neo"/>
+              </a:rPr>
+              <a:t>Discord</a:t>
+            </a:r>
+          </a:p>
+        </p:txBody>
+      </p:sp>
+      <p:sp>
+        <p:nvSpPr>
+          <p:cNvPr id="28" name="Rectangle 27"/>
+          <p:cNvSpPr/>
+          <p:nvPr/>
+        </p:nvSpPr>
+        <p:spPr>
+          <a:xfrm>
+            <a:off x="1920240" y="4343400"/>
+            <a:ext cx="9738360" cy="621792"/>
+          </a:xfrm>
+          <a:prstGeom prst="rect">
+            <a:avLst/>
+          </a:prstGeom>
+          <a:solidFill>
+            <a:srgbClr val="FFFFFF"/>
+          </a:solidFill>
+          <a:ln w="9525">
+            <a:solidFill>
+              <a:srgbClr val="D5DDE6"/>
+            </a:solidFill>
+          </a:ln>
+          <a:effectLst/>
+        </p:spPr>
+        <p:style>
+          <a:lnRef idx="1">
+            <a:schemeClr val="accent1"/>
+          </a:lnRef>
+          <a:fillRef idx="3">
+            <a:schemeClr val="accent1"/>
+          </a:fillRef>
+          <a:effectRef idx="2">
+            <a:schemeClr val="accent1"/>
+          </a:effectRef>
+          <a:fontRef idx="minor">
+            <a:schemeClr val="lt1"/>
+          </a:fontRef>
+        </p:style>
+        <p:txBody>
+          <a:bodyPr rtlCol="0" anchor="ctr"/>
+          <a:lstStyle/>
+          <a:p>
+            <a:pPr algn="ctr"/>
+          </a:p>
+        </p:txBody>
+      </p:sp>
+      <p:sp>
+        <p:nvSpPr>
+          <p:cNvPr id="29" name="TextBox 28"/>
+          <p:cNvSpPr txBox="1"/>
+          <p:nvPr/>
+        </p:nvSpPr>
+        <p:spPr>
+          <a:xfrm>
+            <a:off x="1958340" y="4343400"/>
+            <a:ext cx="9662160" cy="621792"/>
+          </a:xfrm>
+          <a:prstGeom prst="rect">
+            <a:avLst/>
+          </a:prstGeom>
+          <a:noFill/>
+        </p:spPr>
+        <p:txBody>
+          <a:bodyPr wrap="square" anchor="ctr">
             <a:spAutoFit/>
           </a:bodyPr>
           <a:lstStyle/>
           <a:p>
             <a:pPr algn="l">
               <a:lnSpc>
-                <a:spcPct val="100000"/>
-              </a:lnSpc>
-              <a:spcAft>
-                <a:spcPts val="400"/>
-              </a:spcAft>
-            </a:pPr>
-            <a:r>
-              <a:rPr sz="1100" b="0">
+                <a:spcPct val="92000"/>
+              </a:lnSpc>
+              <a:spcAft>
+                <a:spcPts val="400"/>
+              </a:spcAft>
+            </a:pPr>
+            <a:r>
+              <a:rPr sz="1050" b="0">
                 <a:solidFill>
                   <a:srgbClr val="444A55"/>
                 </a:solidFill>
                 <a:latin typeface="Apple SD Gothic Neo"/>
               </a:rPr>
-              <a:t>• 단골 주제: 도구 갈아타기 · 한도 · 비용 · 신뢰(틀린 코드)</a:t>
-            </a:r>
-          </a:p>
-        </p:txBody>
-      </p:sp>
-      <p:sp>
-        <p:nvSpPr>
-          <p:cNvPr id="19" name="TextBox 18"/>
-          <p:cNvSpPr txBox="1"/>
-          <p:nvPr/>
-        </p:nvSpPr>
-        <p:spPr>
-          <a:xfrm>
-            <a:off x="6400800" y="2770632"/>
-            <a:ext cx="5120640" cy="347472"/>
-          </a:xfrm>
-          <a:prstGeom prst="rect">
-            <a:avLst/>
-          </a:prstGeom>
-          <a:noFill/>
-        </p:spPr>
-        <p:txBody>
-          <a:bodyPr wrap="square" anchor="t">
-            <a:spAutoFit/>
-          </a:bodyPr>
-          <a:lstStyle/>
-          <a:p>
-            <a:pPr algn="l">
-              <a:lnSpc>
-                <a:spcPct val="100000"/>
-              </a:lnSpc>
-              <a:spcAft>
-                <a:spcPts val="400"/>
-              </a:spcAft>
-            </a:pPr>
-            <a:r>
-              <a:rPr sz="1100" b="0">
-                <a:solidFill>
-                  <a:srgbClr val="444A55"/>
-                </a:solidFill>
-                <a:latin typeface="Apple SD Gothic Neo"/>
-              </a:rPr>
-              <a:t>• 커뮤니티 톤: '하나만 쓰지 않고 스택으로 쓴다'</a:t>
-            </a:r>
-          </a:p>
-        </p:txBody>
-      </p:sp>
-      <p:sp>
-        <p:nvSpPr>
-          <p:cNvPr id="20" name="Rounded Rectangle 19"/>
+              <a:t>Claude Code를 MCP로 원격 제어(폰으로 코딩 지시·수신); 도구 비교·개발자 설문 토론 활발</a:t>
+            </a:r>
+          </a:p>
+        </p:txBody>
+      </p:sp>
+      <p:sp>
+        <p:nvSpPr>
+          <p:cNvPr id="30" name="Rounded Rectangle 29"/>
           <p:cNvSpPr/>
           <p:nvPr/>
         </p:nvSpPr>
         <p:spPr>
           <a:xfrm>
-            <a:off x="502920" y="4251960"/>
-            <a:ext cx="11201400" cy="1828800"/>
+            <a:off x="457200" y="4983480"/>
+            <a:ext cx="11247120" cy="1143000"/>
           </a:xfrm>
           <a:prstGeom prst="roundRect">
             <a:avLst/>
@@ -4164,14 +4620,14 @@
       </p:sp>
       <p:sp>
         <p:nvSpPr>
-          <p:cNvPr id="21" name="TextBox 20"/>
-          <p:cNvSpPr txBox="1"/>
-          <p:nvPr/>
-        </p:nvSpPr>
-        <p:spPr>
-          <a:xfrm>
-            <a:off x="731520" y="4389120"/>
-            <a:ext cx="10789920" cy="1554480"/>
+          <p:cNvPr id="31" name="TextBox 30"/>
+          <p:cNvSpPr txBox="1"/>
+          <p:nvPr/>
+        </p:nvSpPr>
+        <p:spPr>
+          <a:xfrm>
+            <a:off x="685800" y="5102352"/>
+            <a:ext cx="10835640" cy="914400"/>
           </a:xfrm>
           <a:prstGeom prst="rect">
             <a:avLst/>
@@ -4186,14 +4642,14 @@
           <a:p>
             <a:pPr algn="l">
               <a:lnSpc>
-                <a:spcPct val="112000"/>
+                <a:spcPct val="108000"/>
               </a:lnSpc>
               <a:spcAft>
                 <a:spcPts val="200"/>
               </a:spcAft>
             </a:pPr>
             <a:r>
-              <a:rPr sz="1400" b="1">
+              <a:rPr sz="1350" b="1">
                 <a:solidFill>
                   <a:srgbClr val="9FC4E8"/>
                 </a:solidFill>
@@ -4205,46 +4661,46 @@
           <a:p>
             <a:pPr algn="l">
               <a:lnSpc>
-                <a:spcPct val="112000"/>
+                <a:spcPct val="108000"/>
               </a:lnSpc>
               <a:spcAft>
                 <a:spcPts val="200"/>
               </a:spcAft>
             </a:pPr>
             <a:r>
-              <a:rPr sz="1200" b="0">
+              <a:rPr sz="1150" b="0">
                 <a:solidFill>
                   <a:srgbClr val="FFFFFF"/>
                 </a:solidFill>
                 <a:latin typeface="Apple SD Gothic Neo"/>
               </a:rPr>
-              <a:t>• 팀 단위 활용은 Slack 요약/액션아이템부터 — 회의록·시험결과 공유에 즉시 효과</a:t>
+              <a:t>• 공통 결론: '하나만'이 아니라 업무별 스택 사용 — Reddit·X·GitHub 모두 도구 갈아타기를 권장</a:t>
             </a:r>
           </a:p>
           <a:p>
             <a:pPr algn="l">
               <a:lnSpc>
-                <a:spcPct val="112000"/>
+                <a:spcPct val="108000"/>
               </a:lnSpc>
               <a:spcAft>
                 <a:spcPts val="200"/>
               </a:spcAft>
             </a:pPr>
             <a:r>
-              <a:rPr sz="1200" b="0">
+              <a:rPr sz="1150" b="0">
                 <a:solidFill>
                   <a:srgbClr val="FFFFFF"/>
                 </a:solidFill>
                 <a:latin typeface="Apple SD Gothic Neo"/>
               </a:rPr>
-              <a:t>• Discord·MCP 원격 제어는 보안상 사내 정책 검토 후에만 (외부 연동 주의)</a:t>
-            </a:r>
-          </a:p>
-        </p:txBody>
-      </p:sp>
-      <p:sp>
-        <p:nvSpPr>
-          <p:cNvPr id="22" name="TextBox 21"/>
+              <a:t>• 팀 활용은 Slack 요약부터, Discord·MCP 원격 제어는 사내 보안 검토 후 (외부 연동 주의)</a:t>
+            </a:r>
+          </a:p>
+        </p:txBody>
+      </p:sp>
+      <p:sp>
+        <p:nvSpPr>
+          <p:cNvPr id="32" name="TextBox 31"/>
           <p:cNvSpPr txBox="1"/>
           <p:nvPr/>
         </p:nvSpPr>

</xml_diff>

<commit_message>
Add Chinese LLM appendix page (DeepSeek V4 Pro, Qwen3.7-Max)
- Add final report slide covering top-2 Chinese models with strengths,
  benchmark/eval results, and HW-team security cautions (data residency)
- Repaginate deck to 18 slides (/17 headers)
- Add matching Chinese LLM appendix section to source markdown

Co-authored-by: Cursor <cursoragent@cursor.com>
</commit_message>
<xml_diff>
--- a/외부AI_3종_비교조사.pptx
+++ b/외부AI_3종_비교조사.pptx
@@ -22,6 +22,7 @@
     <p:sldId id="270" r:id="rId21"/>
     <p:sldId id="271" r:id="rId22"/>
     <p:sldId id="272" r:id="rId23"/>
+    <p:sldId id="273" r:id="rId24"/>
   </p:sldIdLst>
   <p:sldSz cx="12191695" cy="6858000" type="screen4x3"/>
   <p:notesSz cx="6858000" cy="9144000"/>
@@ -3471,7 +3472,7 @@
                 </a:solidFill>
                 <a:latin typeface="Apple SD Gothic Neo"/>
               </a:rPr>
-              <a:t>유저 평가 기반 비교  (9/16)</a:t>
+              <a:t>유저 평가 기반 비교  (9/17)</a:t>
             </a:r>
           </a:p>
         </p:txBody>
@@ -4891,7 +4892,7 @@
                 </a:solidFill>
                 <a:latin typeface="Apple SD Gothic Neo"/>
               </a:rPr>
-              <a:t>유저 평가 기반 비교  (10/16)</a:t>
+              <a:t>유저 평가 기반 비교  (10/17)</a:t>
             </a:r>
           </a:p>
         </p:txBody>
@@ -7105,7 +7106,7 @@
                 </a:solidFill>
                 <a:latin typeface="Apple SD Gothic Neo"/>
               </a:rPr>
-              <a:t>유저 평가 기반 비교  (11/16)</a:t>
+              <a:t>유저 평가 기반 비교  (11/17)</a:t>
             </a:r>
           </a:p>
         </p:txBody>
@@ -8369,7 +8370,7 @@
                 </a:solidFill>
                 <a:latin typeface="Apple SD Gothic Neo"/>
               </a:rPr>
-              <a:t>유저 평가 기반 비교  (12/16)</a:t>
+              <a:t>유저 평가 기반 비교  (12/17)</a:t>
             </a:r>
           </a:p>
         </p:txBody>
@@ -10887,7 +10888,7 @@
                 </a:solidFill>
                 <a:latin typeface="Apple SD Gothic Neo"/>
               </a:rPr>
-              <a:t>유저 평가 기반 비교  (13/16)</a:t>
+              <a:t>유저 평가 기반 비교  (13/17)</a:t>
             </a:r>
           </a:p>
         </p:txBody>
@@ -12328,7 +12329,7 @@
                 </a:solidFill>
                 <a:latin typeface="Apple SD Gothic Neo"/>
               </a:rPr>
-              <a:t>외부 AI 3종 비교  (14/16)</a:t>
+              <a:t>외부 AI 3종 비교  (14/17)</a:t>
             </a:r>
           </a:p>
         </p:txBody>
@@ -14542,7 +14543,7 @@
                 </a:solidFill>
                 <a:latin typeface="Apple SD Gothic Neo"/>
               </a:rPr>
-              <a:t>외부 AI 3종 비교  (15/16)</a:t>
+              <a:t>외부 AI 3종 비교  (15/17)</a:t>
             </a:r>
           </a:p>
         </p:txBody>
@@ -15764,7 +15765,7 @@
                 </a:solidFill>
                 <a:latin typeface="Apple SD Gothic Neo"/>
               </a:rPr>
-              <a:t>외부 AI 3종 비교  (16/16)</a:t>
+              <a:t>외부 AI 참고  (16/17)</a:t>
             </a:r>
           </a:p>
         </p:txBody>
@@ -15806,7 +15807,7 @@
                 </a:solidFill>
                 <a:latin typeface="Apple SD Gothic Neo"/>
               </a:rPr>
-              <a:t>출처</a:t>
+              <a:t>중국 LLM 상위 2종 — 강점 및 평가</a:t>
             </a:r>
           </a:p>
         </p:txBody>
@@ -15819,10 +15820,56 @@
         </p:nvSpPr>
         <p:spPr>
           <a:xfrm>
-            <a:off x="640080" y="1417320"/>
-            <a:ext cx="1005840" cy="384048"/>
+            <a:off x="502920" y="1234440"/>
+            <a:ext cx="5486400" cy="2788920"/>
           </a:xfrm>
           <a:prstGeom prst="roundRect">
+            <a:avLst/>
+          </a:prstGeom>
+          <a:solidFill>
+            <a:srgbClr val="E8F1FA"/>
+          </a:solidFill>
+          <a:ln w="12700">
+            <a:solidFill>
+              <a:srgbClr val="D5DDE6"/>
+            </a:solidFill>
+          </a:ln>
+          <a:effectLst/>
+        </p:spPr>
+        <p:style>
+          <a:lnRef idx="1">
+            <a:schemeClr val="accent1"/>
+          </a:lnRef>
+          <a:fillRef idx="3">
+            <a:schemeClr val="accent1"/>
+          </a:fillRef>
+          <a:effectRef idx="2">
+            <a:schemeClr val="accent1"/>
+          </a:effectRef>
+          <a:fontRef idx="minor">
+            <a:schemeClr val="lt1"/>
+          </a:fontRef>
+        </p:style>
+        <p:txBody>
+          <a:bodyPr rtlCol="0" anchor="ctr"/>
+          <a:lstStyle/>
+          <a:p>
+            <a:pPr algn="ctr"/>
+          </a:p>
+        </p:txBody>
+      </p:sp>
+      <p:sp>
+        <p:nvSpPr>
+          <p:cNvPr id="7" name="Rectangle 6"/>
+          <p:cNvSpPr/>
+          <p:nvPr/>
+        </p:nvSpPr>
+        <p:spPr>
+          <a:xfrm>
+            <a:off x="502920" y="1234440"/>
+            <a:ext cx="76200" cy="2788920"/>
+          </a:xfrm>
+          <a:prstGeom prst="rect">
             <a:avLst/>
           </a:prstGeom>
           <a:solidFill>
@@ -15857,27 +15904,27 @@
       </p:sp>
       <p:sp>
         <p:nvSpPr>
-          <p:cNvPr id="7" name="TextBox 6"/>
-          <p:cNvSpPr txBox="1"/>
-          <p:nvPr/>
-        </p:nvSpPr>
-        <p:spPr>
-          <a:xfrm>
-            <a:off x="640080" y="1417320"/>
-            <a:ext cx="1005840" cy="384048"/>
-          </a:xfrm>
-          <a:prstGeom prst="rect">
-            <a:avLst/>
-          </a:prstGeom>
-          <a:noFill/>
-        </p:spPr>
-        <p:txBody>
-          <a:bodyPr wrap="square" anchor="ctr">
-            <a:spAutoFit/>
-          </a:bodyPr>
-          <a:lstStyle/>
-          <a:p>
-            <a:pPr algn="ctr">
+          <p:cNvPr id="8" name="TextBox 7"/>
+          <p:cNvSpPr txBox="1"/>
+          <p:nvPr/>
+        </p:nvSpPr>
+        <p:spPr>
+          <a:xfrm>
+            <a:off x="685800" y="1325880"/>
+            <a:ext cx="5120640" cy="320040"/>
+          </a:xfrm>
+          <a:prstGeom prst="rect">
+            <a:avLst/>
+          </a:prstGeom>
+          <a:noFill/>
+        </p:spPr>
+        <p:txBody>
+          <a:bodyPr wrap="square" anchor="t">
+            <a:spAutoFit/>
+          </a:bodyPr>
+          <a:lstStyle/>
+          <a:p>
+            <a:pPr algn="l">
               <a:lnSpc>
                 <a:spcPct val="100000"/>
               </a:lnSpc>
@@ -15886,35 +15933,35 @@
               </a:spcAft>
             </a:pPr>
             <a:r>
-              <a:rPr sz="1100" b="1">
-                <a:solidFill>
-                  <a:srgbClr val="FFFFFF"/>
-                </a:solidFill>
-                <a:latin typeface="Apple SD Gothic Neo"/>
-              </a:rPr>
-              <a:t>공식</a:t>
-            </a:r>
-          </a:p>
-        </p:txBody>
-      </p:sp>
-      <p:sp>
-        <p:nvSpPr>
-          <p:cNvPr id="8" name="TextBox 7"/>
-          <p:cNvSpPr txBox="1"/>
-          <p:nvPr/>
-        </p:nvSpPr>
-        <p:spPr>
-          <a:xfrm>
-            <a:off x="1828800" y="1417320"/>
-            <a:ext cx="9601200" cy="384048"/>
-          </a:xfrm>
-          <a:prstGeom prst="rect">
-            <a:avLst/>
-          </a:prstGeom>
-          <a:noFill/>
-        </p:spPr>
-        <p:txBody>
-          <a:bodyPr wrap="square" anchor="ctr">
+              <a:rPr sz="1300" b="1">
+                <a:solidFill>
+                  <a:srgbClr val="1F6FB2"/>
+                </a:solidFill>
+                <a:latin typeface="Apple SD Gothic Neo"/>
+              </a:rPr>
+              <a:t>DeepSeek V4 Pro (오픈웨이트·MIT)</a:t>
+            </a:r>
+          </a:p>
+        </p:txBody>
+      </p:sp>
+      <p:sp>
+        <p:nvSpPr>
+          <p:cNvPr id="9" name="TextBox 8"/>
+          <p:cNvSpPr txBox="1"/>
+          <p:nvPr/>
+        </p:nvSpPr>
+        <p:spPr>
+          <a:xfrm>
+            <a:off x="731520" y="1673352"/>
+            <a:ext cx="5074920" cy="347472"/>
+          </a:xfrm>
+          <a:prstGeom prst="rect">
+            <a:avLst/>
+          </a:prstGeom>
+          <a:noFill/>
+        </p:spPr>
+        <p:txBody>
+          <a:bodyPr wrap="square" anchor="t">
             <a:spAutoFit/>
           </a:bodyPr>
           <a:lstStyle/>
@@ -15928,29 +15975,201 @@
               </a:spcAft>
             </a:pPr>
             <a:r>
-              <a:rPr sz="1200" b="0">
+              <a:rPr sz="1100" b="0">
                 <a:solidFill>
                   <a:srgbClr val="444A55"/>
                 </a:solidFill>
                 <a:latin typeface="Apple SD Gothic Neo"/>
               </a:rPr>
-              <a:t>OpenAI / Google Gemini / Anthropic Claude 문서</a:t>
-            </a:r>
-          </a:p>
-        </p:txBody>
-      </p:sp>
-      <p:sp>
-        <p:nvSpPr>
-          <p:cNvPr id="9" name="Rounded Rectangle 8"/>
+              <a:t>• 오픈웨이트(MIT)·1M 맥락 → 자체 호스팅 가능</a:t>
+            </a:r>
+          </a:p>
+        </p:txBody>
+      </p:sp>
+      <p:sp>
+        <p:nvSpPr>
+          <p:cNvPr id="10" name="TextBox 9"/>
+          <p:cNvSpPr txBox="1"/>
+          <p:nvPr/>
+        </p:nvSpPr>
+        <p:spPr>
+          <a:xfrm>
+            <a:off x="731520" y="2039112"/>
+            <a:ext cx="5074920" cy="347472"/>
+          </a:xfrm>
+          <a:prstGeom prst="rect">
+            <a:avLst/>
+          </a:prstGeom>
+          <a:noFill/>
+        </p:spPr>
+        <p:txBody>
+          <a:bodyPr wrap="square" anchor="t">
+            <a:spAutoFit/>
+          </a:bodyPr>
+          <a:lstStyle/>
+          <a:p>
+            <a:pPr algn="l">
+              <a:lnSpc>
+                <a:spcPct val="100000"/>
+              </a:lnSpc>
+              <a:spcAft>
+                <a:spcPts val="400"/>
+              </a:spcAft>
+            </a:pPr>
+            <a:r>
+              <a:rPr sz="1100" b="0">
+                <a:solidFill>
+                  <a:srgbClr val="444A55"/>
+                </a:solidFill>
+                <a:latin typeface="Apple SD Gothic Neo"/>
+              </a:rPr>
+              <a:t>• 코딩·수학 최강 오픈모델: LiveCodeBench 93.5%, SWE-Bench Verified 80.6%</a:t>
+            </a:r>
+          </a:p>
+        </p:txBody>
+      </p:sp>
+      <p:sp>
+        <p:nvSpPr>
+          <p:cNvPr id="11" name="TextBox 10"/>
+          <p:cNvSpPr txBox="1"/>
+          <p:nvPr/>
+        </p:nvSpPr>
+        <p:spPr>
+          <a:xfrm>
+            <a:off x="731520" y="2404872"/>
+            <a:ext cx="5074920" cy="347472"/>
+          </a:xfrm>
+          <a:prstGeom prst="rect">
+            <a:avLst/>
+          </a:prstGeom>
+          <a:noFill/>
+        </p:spPr>
+        <p:txBody>
+          <a:bodyPr wrap="square" anchor="t">
+            <a:spAutoFit/>
+          </a:bodyPr>
+          <a:lstStyle/>
+          <a:p>
+            <a:pPr algn="l">
+              <a:lnSpc>
+                <a:spcPct val="100000"/>
+              </a:lnSpc>
+              <a:spcAft>
+                <a:spcPts val="400"/>
+              </a:spcAft>
+            </a:pPr>
+            <a:r>
+              <a:rPr sz="1100" b="0">
+                <a:solidFill>
+                  <a:srgbClr val="444A55"/>
+                </a:solidFill>
+                <a:latin typeface="Apple SD Gothic Neo"/>
+              </a:rPr>
+              <a:t>• 출력 비용 GPT-5.5 대비 약 1/34 ($0.44/$0.87 per M)</a:t>
+            </a:r>
+          </a:p>
+        </p:txBody>
+      </p:sp>
+      <p:sp>
+        <p:nvSpPr>
+          <p:cNvPr id="12" name="TextBox 11"/>
+          <p:cNvSpPr txBox="1"/>
+          <p:nvPr/>
+        </p:nvSpPr>
+        <p:spPr>
+          <a:xfrm>
+            <a:off x="731520" y="2770632"/>
+            <a:ext cx="5074920" cy="347472"/>
+          </a:xfrm>
+          <a:prstGeom prst="rect">
+            <a:avLst/>
+          </a:prstGeom>
+          <a:noFill/>
+        </p:spPr>
+        <p:txBody>
+          <a:bodyPr wrap="square" anchor="t">
+            <a:spAutoFit/>
+          </a:bodyPr>
+          <a:lstStyle/>
+          <a:p>
+            <a:pPr algn="l">
+              <a:lnSpc>
+                <a:spcPct val="100000"/>
+              </a:lnSpc>
+              <a:spcAft>
+                <a:spcPts val="400"/>
+              </a:spcAft>
+            </a:pPr>
+            <a:r>
+              <a:rPr sz="1100" b="0">
+                <a:solidFill>
+                  <a:srgbClr val="444A55"/>
+                </a:solidFill>
+                <a:latin typeface="Apple SD Gothic Neo"/>
+              </a:rPr>
+              <a:t>• 평가: '가성비 1위', 수학·코드 특화 / BenchLM 중국모델 1위(88점)</a:t>
+            </a:r>
+          </a:p>
+        </p:txBody>
+      </p:sp>
+      <p:sp>
+        <p:nvSpPr>
+          <p:cNvPr id="13" name="Rounded Rectangle 12"/>
           <p:cNvSpPr/>
           <p:nvPr/>
         </p:nvSpPr>
         <p:spPr>
           <a:xfrm>
-            <a:off x="640080" y="1920240"/>
-            <a:ext cx="1005840" cy="384048"/>
+            <a:off x="6172200" y="1234440"/>
+            <a:ext cx="5532120" cy="2788920"/>
           </a:xfrm>
           <a:prstGeom prst="roundRect">
+            <a:avLst/>
+          </a:prstGeom>
+          <a:solidFill>
+            <a:srgbClr val="E8F1FA"/>
+          </a:solidFill>
+          <a:ln w="12700">
+            <a:solidFill>
+              <a:srgbClr val="D5DDE6"/>
+            </a:solidFill>
+          </a:ln>
+          <a:effectLst/>
+        </p:spPr>
+        <p:style>
+          <a:lnRef idx="1">
+            <a:schemeClr val="accent1"/>
+          </a:lnRef>
+          <a:fillRef idx="3">
+            <a:schemeClr val="accent1"/>
+          </a:fillRef>
+          <a:effectRef idx="2">
+            <a:schemeClr val="accent1"/>
+          </a:effectRef>
+          <a:fontRef idx="minor">
+            <a:schemeClr val="lt1"/>
+          </a:fontRef>
+        </p:style>
+        <p:txBody>
+          <a:bodyPr rtlCol="0" anchor="ctr"/>
+          <a:lstStyle/>
+          <a:p>
+            <a:pPr algn="ctr"/>
+          </a:p>
+        </p:txBody>
+      </p:sp>
+      <p:sp>
+        <p:nvSpPr>
+          <p:cNvPr id="14" name="Rectangle 13"/>
+          <p:cNvSpPr/>
+          <p:nvPr/>
+        </p:nvSpPr>
+        <p:spPr>
+          <a:xfrm>
+            <a:off x="6172200" y="1234440"/>
+            <a:ext cx="76200" cy="2788920"/>
+          </a:xfrm>
+          <a:prstGeom prst="rect">
             <a:avLst/>
           </a:prstGeom>
           <a:solidFill>
@@ -15985,27 +16204,27 @@
       </p:sp>
       <p:sp>
         <p:nvSpPr>
-          <p:cNvPr id="10" name="TextBox 9"/>
-          <p:cNvSpPr txBox="1"/>
-          <p:nvPr/>
-        </p:nvSpPr>
-        <p:spPr>
-          <a:xfrm>
-            <a:off x="640080" y="1920240"/>
-            <a:ext cx="1005840" cy="384048"/>
-          </a:xfrm>
-          <a:prstGeom prst="rect">
-            <a:avLst/>
-          </a:prstGeom>
-          <a:noFill/>
-        </p:spPr>
-        <p:txBody>
-          <a:bodyPr wrap="square" anchor="ctr">
-            <a:spAutoFit/>
-          </a:bodyPr>
-          <a:lstStyle/>
-          <a:p>
-            <a:pPr algn="ctr">
+          <p:cNvPr id="15" name="TextBox 14"/>
+          <p:cNvSpPr txBox="1"/>
+          <p:nvPr/>
+        </p:nvSpPr>
+        <p:spPr>
+          <a:xfrm>
+            <a:off x="6355080" y="1325880"/>
+            <a:ext cx="5166360" cy="320040"/>
+          </a:xfrm>
+          <a:prstGeom prst="rect">
+            <a:avLst/>
+          </a:prstGeom>
+          <a:noFill/>
+        </p:spPr>
+        <p:txBody>
+          <a:bodyPr wrap="square" anchor="t">
+            <a:spAutoFit/>
+          </a:bodyPr>
+          <a:lstStyle/>
+          <a:p>
+            <a:pPr algn="l">
               <a:lnSpc>
                 <a:spcPct val="100000"/>
               </a:lnSpc>
@@ -16014,35 +16233,35 @@
               </a:spcAft>
             </a:pPr>
             <a:r>
-              <a:rPr sz="1100" b="1">
-                <a:solidFill>
-                  <a:srgbClr val="FFFFFF"/>
-                </a:solidFill>
-                <a:latin typeface="Apple SD Gothic Neo"/>
-              </a:rPr>
-              <a:t>Reddit</a:t>
-            </a:r>
-          </a:p>
-        </p:txBody>
-      </p:sp>
-      <p:sp>
-        <p:nvSpPr>
-          <p:cNvPr id="11" name="TextBox 10"/>
-          <p:cNvSpPr txBox="1"/>
-          <p:nvPr/>
-        </p:nvSpPr>
-        <p:spPr>
-          <a:xfrm>
-            <a:off x="1828800" y="1920240"/>
-            <a:ext cx="9601200" cy="384048"/>
-          </a:xfrm>
-          <a:prstGeom prst="rect">
-            <a:avLst/>
-          </a:prstGeom>
-          <a:noFill/>
-        </p:spPr>
-        <p:txBody>
-          <a:bodyPr wrap="square" anchor="ctr">
+              <a:rPr sz="1300" b="1">
+                <a:solidFill>
+                  <a:srgbClr val="F27E2E"/>
+                </a:solidFill>
+                <a:latin typeface="Apple SD Gothic Neo"/>
+              </a:rPr>
+              <a:t>Qwen3.7-Max (Alibaba·프로프라이어터리)</a:t>
+            </a:r>
+          </a:p>
+        </p:txBody>
+      </p:sp>
+      <p:sp>
+        <p:nvSpPr>
+          <p:cNvPr id="16" name="TextBox 15"/>
+          <p:cNvSpPr txBox="1"/>
+          <p:nvPr/>
+        </p:nvSpPr>
+        <p:spPr>
+          <a:xfrm>
+            <a:off x="6400800" y="1673352"/>
+            <a:ext cx="5120640" cy="347472"/>
+          </a:xfrm>
+          <a:prstGeom prst="rect">
+            <a:avLst/>
+          </a:prstGeom>
+          <a:noFill/>
+        </p:spPr>
+        <p:txBody>
+          <a:bodyPr wrap="square" anchor="t">
             <a:spAutoFit/>
           </a:bodyPr>
           <a:lstStyle/>
@@ -16056,29 +16275,412 @@
               </a:spcAft>
             </a:pPr>
             <a:r>
+              <a:rPr sz="1100" b="0">
+                <a:solidFill>
+                  <a:srgbClr val="444A55"/>
+                </a:solidFill>
+                <a:latin typeface="Apple SD Gothic Neo"/>
+              </a:rPr>
+              <a:t>• 에이전트 특화 플래그십·1M 맥락·네이티브 확장 사고</a:t>
+            </a:r>
+          </a:p>
+        </p:txBody>
+      </p:sp>
+      <p:sp>
+        <p:nvSpPr>
+          <p:cNvPr id="17" name="TextBox 16"/>
+          <p:cNvSpPr txBox="1"/>
+          <p:nvPr/>
+        </p:nvSpPr>
+        <p:spPr>
+          <a:xfrm>
+            <a:off x="6400800" y="2039112"/>
+            <a:ext cx="5120640" cy="347472"/>
+          </a:xfrm>
+          <a:prstGeom prst="rect">
+            <a:avLst/>
+          </a:prstGeom>
+          <a:noFill/>
+        </p:spPr>
+        <p:txBody>
+          <a:bodyPr wrap="square" anchor="t">
+            <a:spAutoFit/>
+          </a:bodyPr>
+          <a:lstStyle/>
+          <a:p>
+            <a:pPr algn="l">
+              <a:lnSpc>
+                <a:spcPct val="100000"/>
+              </a:lnSpc>
+              <a:spcAft>
+                <a:spcPts val="400"/>
+              </a:spcAft>
+            </a:pPr>
+            <a:r>
+              <a:rPr sz="1100" b="0">
+                <a:solidFill>
+                  <a:srgbClr val="444A55"/>
+                </a:solidFill>
+                <a:latin typeface="Apple SD Gothic Neo"/>
+              </a:rPr>
+              <a:t>• SWE-Bench Pro 60.6%, Terminal-Bench 2.0 69.7%, GPQA 92.4%</a:t>
+            </a:r>
+          </a:p>
+        </p:txBody>
+      </p:sp>
+      <p:sp>
+        <p:nvSpPr>
+          <p:cNvPr id="18" name="TextBox 17"/>
+          <p:cNvSpPr txBox="1"/>
+          <p:nvPr/>
+        </p:nvSpPr>
+        <p:spPr>
+          <a:xfrm>
+            <a:off x="6400800" y="2404872"/>
+            <a:ext cx="5120640" cy="347472"/>
+          </a:xfrm>
+          <a:prstGeom prst="rect">
+            <a:avLst/>
+          </a:prstGeom>
+          <a:noFill/>
+        </p:spPr>
+        <p:txBody>
+          <a:bodyPr wrap="square" anchor="t">
+            <a:spAutoFit/>
+          </a:bodyPr>
+          <a:lstStyle/>
+          <a:p>
+            <a:pPr algn="l">
+              <a:lnSpc>
+                <a:spcPct val="100000"/>
+              </a:lnSpc>
+              <a:spcAft>
+                <a:spcPts val="400"/>
+              </a:spcAft>
+            </a:pPr>
+            <a:r>
+              <a:rPr sz="1100" b="0">
+                <a:solidFill>
+                  <a:srgbClr val="444A55"/>
+                </a:solidFill>
+                <a:latin typeface="Apple SD Gothic Neo"/>
+              </a:rPr>
+              <a:t>• 프런티어 중 최저 환각률 22.9% 보고</a:t>
+            </a:r>
+          </a:p>
+        </p:txBody>
+      </p:sp>
+      <p:sp>
+        <p:nvSpPr>
+          <p:cNvPr id="19" name="TextBox 18"/>
+          <p:cNvSpPr txBox="1"/>
+          <p:nvPr/>
+        </p:nvSpPr>
+        <p:spPr>
+          <a:xfrm>
+            <a:off x="6400800" y="2770632"/>
+            <a:ext cx="5120640" cy="347472"/>
+          </a:xfrm>
+          <a:prstGeom prst="rect">
+            <a:avLst/>
+          </a:prstGeom>
+          <a:noFill/>
+        </p:spPr>
+        <p:txBody>
+          <a:bodyPr wrap="square" anchor="t">
+            <a:spAutoFit/>
+          </a:bodyPr>
+          <a:lstStyle/>
+          <a:p>
+            <a:pPr algn="l">
+              <a:lnSpc>
+                <a:spcPct val="100000"/>
+              </a:lnSpc>
+              <a:spcAft>
+                <a:spcPts val="400"/>
+              </a:spcAft>
+            </a:pPr>
+            <a:r>
+              <a:rPr sz="1100" b="0">
+                <a:solidFill>
+                  <a:srgbClr val="444A55"/>
+                </a:solidFill>
+                <a:latin typeface="Apple SD Gothic Neo"/>
+              </a:rPr>
+              <a:t>• 평가: 'Agent·멀티스텝 벤치 SOTA' / 장기 코딩 에이전트 우위</a:t>
+            </a:r>
+          </a:p>
+        </p:txBody>
+      </p:sp>
+      <p:sp>
+        <p:nvSpPr>
+          <p:cNvPr id="20" name="Rounded Rectangle 19"/>
+          <p:cNvSpPr/>
+          <p:nvPr/>
+        </p:nvSpPr>
+        <p:spPr>
+          <a:xfrm>
+            <a:off x="502920" y="4251960"/>
+            <a:ext cx="11201400" cy="1874519"/>
+          </a:xfrm>
+          <a:prstGeom prst="roundRect">
+            <a:avLst/>
+          </a:prstGeom>
+          <a:solidFill>
+            <a:srgbClr val="FEF1E6"/>
+          </a:solidFill>
+          <a:ln w="17780">
+            <a:solidFill>
+              <a:srgbClr val="F27E2E"/>
+            </a:solidFill>
+          </a:ln>
+          <a:effectLst/>
+        </p:spPr>
+        <p:style>
+          <a:lnRef idx="1">
+            <a:schemeClr val="accent1"/>
+          </a:lnRef>
+          <a:fillRef idx="3">
+            <a:schemeClr val="accent1"/>
+          </a:fillRef>
+          <a:effectRef idx="2">
+            <a:schemeClr val="accent1"/>
+          </a:effectRef>
+          <a:fontRef idx="minor">
+            <a:schemeClr val="lt1"/>
+          </a:fontRef>
+        </p:style>
+        <p:txBody>
+          <a:bodyPr rtlCol="0" anchor="ctr"/>
+          <a:lstStyle/>
+          <a:p>
+            <a:pPr algn="ctr"/>
+          </a:p>
+        </p:txBody>
+      </p:sp>
+      <p:sp>
+        <p:nvSpPr>
+          <p:cNvPr id="21" name="TextBox 20"/>
+          <p:cNvSpPr txBox="1"/>
+          <p:nvPr/>
+        </p:nvSpPr>
+        <p:spPr>
+          <a:xfrm>
+            <a:off x="731520" y="4370832"/>
+            <a:ext cx="10835640" cy="1645920"/>
+          </a:xfrm>
+          <a:prstGeom prst="rect">
+            <a:avLst/>
+          </a:prstGeom>
+          <a:noFill/>
+        </p:spPr>
+        <p:txBody>
+          <a:bodyPr wrap="square" anchor="t">
+            <a:spAutoFit/>
+          </a:bodyPr>
+          <a:lstStyle/>
+          <a:p>
+            <a:pPr algn="l">
+              <a:lnSpc>
+                <a:spcPct val="110000"/>
+              </a:lnSpc>
+              <a:spcAft>
+                <a:spcPts val="200"/>
+              </a:spcAft>
+            </a:pPr>
+            <a:r>
+              <a:rPr sz="1400" b="1">
+                <a:solidFill>
+                  <a:srgbClr val="F27E2E"/>
+                </a:solidFill>
+                <a:latin typeface="Apple SD Gothic Neo"/>
+              </a:rPr>
+              <a:t>도입 주의 (HW팀 보안 관점)</a:t>
+            </a:r>
+          </a:p>
+          <a:p>
+            <a:pPr algn="l">
+              <a:lnSpc>
+                <a:spcPct val="110000"/>
+              </a:lnSpc>
+              <a:spcAft>
+                <a:spcPts val="200"/>
+              </a:spcAft>
+            </a:pPr>
+            <a:r>
+              <a:rPr sz="1200" b="1">
+                <a:solidFill>
+                  <a:srgbClr val="C0392B"/>
+                </a:solidFill>
+                <a:latin typeface="Apple SD Gothic Neo"/>
+              </a:rPr>
+              <a:t>• 데이터 거버넌스: 미국·국내 관할 데이터 레지던시 보장 미흡 → 사내 보안·법무 검토 필수</a:t>
+            </a:r>
+          </a:p>
+          <a:p>
+            <a:pPr algn="l">
+              <a:lnSpc>
+                <a:spcPct val="110000"/>
+              </a:lnSpc>
+              <a:spcAft>
+                <a:spcPts val="200"/>
+              </a:spcAft>
+            </a:pPr>
+            <a:r>
               <a:rPr sz="1200" b="0">
                 <a:solidFill>
                   <a:srgbClr val="444A55"/>
                 </a:solidFill>
                 <a:latin typeface="Apple SD Gothic Neo"/>
               </a:rPr>
-              <a:t>Foxafox 요약, RoboRhythms, TechRadar, ClaudeMeter, OpenTools</a:t>
-            </a:r>
-          </a:p>
-        </p:txBody>
-      </p:sp>
-      <p:sp>
-        <p:nvSpPr>
-          <p:cNvPr id="12" name="Rounded Rectangle 11"/>
+              <a:t>• HW 설계·소스코드 등 민감 정보 입력 금지 권고 (외부 전송 위험)</a:t>
+            </a:r>
+          </a:p>
+          <a:p>
+            <a:pPr algn="l">
+              <a:lnSpc>
+                <a:spcPct val="110000"/>
+              </a:lnSpc>
+              <a:spcAft>
+                <a:spcPts val="200"/>
+              </a:spcAft>
+            </a:pPr>
+            <a:r>
+              <a:rPr sz="1200" b="0">
+                <a:solidFill>
+                  <a:srgbClr val="444A55"/>
+                </a:solidFill>
+                <a:latin typeface="Apple SD Gothic Neo"/>
+              </a:rPr>
+              <a:t>• 수치는 자가보고·제3자 벤치 혼재 → 도입 전 사내 PoC로 재검증 (Gauss 보조 용도)</a:t>
+            </a:r>
+          </a:p>
+        </p:txBody>
+      </p:sp>
+      <p:sp>
+        <p:nvSpPr>
+          <p:cNvPr id="22" name="TextBox 21"/>
+          <p:cNvSpPr txBox="1"/>
+          <p:nvPr/>
+        </p:nvSpPr>
+        <p:spPr>
+          <a:xfrm>
+            <a:off x="11338560" y="6492240"/>
+            <a:ext cx="731520" cy="274320"/>
+          </a:xfrm>
+          <a:prstGeom prst="rect">
+            <a:avLst/>
+          </a:prstGeom>
+          <a:noFill/>
+        </p:spPr>
+        <p:txBody>
+          <a:bodyPr wrap="square" anchor="t">
+            <a:spAutoFit/>
+          </a:bodyPr>
+          <a:lstStyle/>
+          <a:p>
+            <a:pPr algn="r">
+              <a:lnSpc>
+                <a:spcPct val="100000"/>
+              </a:lnSpc>
+              <a:spcAft>
+                <a:spcPts val="400"/>
+              </a:spcAft>
+            </a:pPr>
+            <a:r>
+              <a:rPr sz="1000" b="0">
+                <a:solidFill>
+                  <a:srgbClr val="8A929E"/>
+                </a:solidFill>
+                <a:latin typeface="Apple SD Gothic Neo"/>
+              </a:rPr>
+              <a:t>17</a:t>
+            </a:r>
+          </a:p>
+        </p:txBody>
+      </p:sp>
+    </p:spTree>
+  </p:cSld>
+  <p:clrMapOvr>
+    <a:masterClrMapping/>
+  </p:clrMapOvr>
+</p:sld>
+</file>
+
+<file path=ppt/slides/slide18.xml><?xml version="1.0" encoding="utf-8"?>
+<p:sld xmlns:a="http://schemas.openxmlformats.org/drawingml/2006/main" xmlns:p="http://schemas.openxmlformats.org/presentationml/2006/main" xmlns:r="http://schemas.openxmlformats.org/officeDocument/2006/relationships">
+  <p:cSld>
+    <p:bg>
+      <p:bgPr>
+        <a:solidFill>
+          <a:srgbClr val="FFFFFF"/>
+        </a:solidFill>
+        <a:effectLst/>
+      </p:bgPr>
+    </p:bg>
+    <p:spTree>
+      <p:nvGrpSpPr>
+        <p:cNvPr id="1" name=""/>
+        <p:cNvGrpSpPr/>
+        <p:nvPr/>
+      </p:nvGrpSpPr>
+      <p:grpSpPr/>
+      <p:sp>
+        <p:nvSpPr>
+          <p:cNvPr id="2" name="Rectangle 1"/>
           <p:cNvSpPr/>
           <p:nvPr/>
         </p:nvSpPr>
         <p:spPr>
           <a:xfrm>
-            <a:off x="640080" y="2423160"/>
-            <a:ext cx="1005840" cy="384048"/>
-          </a:xfrm>
-          <a:prstGeom prst="roundRect">
+            <a:off x="0" y="0"/>
+            <a:ext cx="12191695" cy="914400"/>
+          </a:xfrm>
+          <a:prstGeom prst="rect">
+            <a:avLst/>
+          </a:prstGeom>
+          <a:solidFill>
+            <a:srgbClr val="142A4A"/>
+          </a:solidFill>
+          <a:ln>
+            <a:noFill/>
+          </a:ln>
+          <a:effectLst/>
+        </p:spPr>
+        <p:style>
+          <a:lnRef idx="1">
+            <a:schemeClr val="accent1"/>
+          </a:lnRef>
+          <a:fillRef idx="3">
+            <a:schemeClr val="accent1"/>
+          </a:fillRef>
+          <a:effectRef idx="2">
+            <a:schemeClr val="accent1"/>
+          </a:effectRef>
+          <a:fontRef idx="minor">
+            <a:schemeClr val="lt1"/>
+          </a:fontRef>
+        </p:style>
+        <p:txBody>
+          <a:bodyPr rtlCol="0" anchor="ctr"/>
+          <a:lstStyle/>
+          <a:p>
+            <a:pPr algn="ctr"/>
+          </a:p>
+        </p:txBody>
+      </p:sp>
+      <p:sp>
+        <p:nvSpPr>
+          <p:cNvPr id="3" name="Rectangle 2"/>
+          <p:cNvSpPr/>
+          <p:nvPr/>
+        </p:nvSpPr>
+        <p:spPr>
+          <a:xfrm>
+            <a:off x="0" y="914400"/>
+            <a:ext cx="12191695" cy="38100"/>
+          </a:xfrm>
+          <a:prstGeom prst="rect">
             <a:avLst/>
           </a:prstGeom>
           <a:solidFill>
@@ -16113,15 +16715,143 @@
       </p:sp>
       <p:sp>
         <p:nvSpPr>
-          <p:cNvPr id="13" name="TextBox 12"/>
-          <p:cNvSpPr txBox="1"/>
-          <p:nvPr/>
-        </p:nvSpPr>
-        <p:spPr>
-          <a:xfrm>
-            <a:off x="640080" y="2423160"/>
+          <p:cNvPr id="4" name="TextBox 3"/>
+          <p:cNvSpPr txBox="1"/>
+          <p:nvPr/>
+        </p:nvSpPr>
+        <p:spPr>
+          <a:xfrm>
+            <a:off x="502920" y="118872"/>
+            <a:ext cx="10972800" cy="274320"/>
+          </a:xfrm>
+          <a:prstGeom prst="rect">
+            <a:avLst/>
+          </a:prstGeom>
+          <a:noFill/>
+        </p:spPr>
+        <p:txBody>
+          <a:bodyPr wrap="square" anchor="t">
+            <a:spAutoFit/>
+          </a:bodyPr>
+          <a:lstStyle/>
+          <a:p>
+            <a:pPr algn="l">
+              <a:lnSpc>
+                <a:spcPct val="100000"/>
+              </a:lnSpc>
+              <a:spcAft>
+                <a:spcPts val="400"/>
+              </a:spcAft>
+            </a:pPr>
+            <a:r>
+              <a:rPr sz="1100" b="1">
+                <a:solidFill>
+                  <a:srgbClr val="9FC4E8"/>
+                </a:solidFill>
+                <a:latin typeface="Apple SD Gothic Neo"/>
+              </a:rPr>
+              <a:t>외부 AI 3종 비교  (17/17)</a:t>
+            </a:r>
+          </a:p>
+        </p:txBody>
+      </p:sp>
+      <p:sp>
+        <p:nvSpPr>
+          <p:cNvPr id="5" name="TextBox 4"/>
+          <p:cNvSpPr txBox="1"/>
+          <p:nvPr/>
+        </p:nvSpPr>
+        <p:spPr>
+          <a:xfrm>
+            <a:off x="502920" y="365760"/>
+            <a:ext cx="11155680" cy="502920"/>
+          </a:xfrm>
+          <a:prstGeom prst="rect">
+            <a:avLst/>
+          </a:prstGeom>
+          <a:noFill/>
+        </p:spPr>
+        <p:txBody>
+          <a:bodyPr wrap="square" anchor="t">
+            <a:spAutoFit/>
+          </a:bodyPr>
+          <a:lstStyle/>
+          <a:p>
+            <a:pPr algn="l">
+              <a:lnSpc>
+                <a:spcPct val="100000"/>
+              </a:lnSpc>
+              <a:spcAft>
+                <a:spcPts val="400"/>
+              </a:spcAft>
+            </a:pPr>
+            <a:r>
+              <a:rPr sz="2300" b="1">
+                <a:solidFill>
+                  <a:srgbClr val="FFFFFF"/>
+                </a:solidFill>
+                <a:latin typeface="Apple SD Gothic Neo"/>
+              </a:rPr>
+              <a:t>출처</a:t>
+            </a:r>
+          </a:p>
+        </p:txBody>
+      </p:sp>
+      <p:sp>
+        <p:nvSpPr>
+          <p:cNvPr id="6" name="Rounded Rectangle 5"/>
+          <p:cNvSpPr/>
+          <p:nvPr/>
+        </p:nvSpPr>
+        <p:spPr>
+          <a:xfrm>
+            <a:off x="640080" y="1417320"/>
             <a:ext cx="1005840" cy="384048"/>
           </a:xfrm>
+          <a:prstGeom prst="roundRect">
+            <a:avLst/>
+          </a:prstGeom>
+          <a:solidFill>
+            <a:srgbClr val="1F6FB2"/>
+          </a:solidFill>
+          <a:ln>
+            <a:noFill/>
+          </a:ln>
+          <a:effectLst/>
+        </p:spPr>
+        <p:style>
+          <a:lnRef idx="1">
+            <a:schemeClr val="accent1"/>
+          </a:lnRef>
+          <a:fillRef idx="3">
+            <a:schemeClr val="accent1"/>
+          </a:fillRef>
+          <a:effectRef idx="2">
+            <a:schemeClr val="accent1"/>
+          </a:effectRef>
+          <a:fontRef idx="minor">
+            <a:schemeClr val="lt1"/>
+          </a:fontRef>
+        </p:style>
+        <p:txBody>
+          <a:bodyPr rtlCol="0" anchor="ctr"/>
+          <a:lstStyle/>
+          <a:p>
+            <a:pPr algn="ctr"/>
+          </a:p>
+        </p:txBody>
+      </p:sp>
+      <p:sp>
+        <p:nvSpPr>
+          <p:cNvPr id="7" name="TextBox 6"/>
+          <p:cNvSpPr txBox="1"/>
+          <p:nvPr/>
+        </p:nvSpPr>
+        <p:spPr>
+          <a:xfrm>
+            <a:off x="640080" y="1417320"/>
+            <a:ext cx="1005840" cy="384048"/>
+          </a:xfrm>
           <a:prstGeom prst="rect">
             <a:avLst/>
           </a:prstGeom>
@@ -16148,20 +16878,20 @@
                 </a:solidFill>
                 <a:latin typeface="Apple SD Gothic Neo"/>
               </a:rPr>
-              <a:t>GitHub</a:t>
-            </a:r>
-          </a:p>
-        </p:txBody>
-      </p:sp>
-      <p:sp>
-        <p:nvSpPr>
-          <p:cNvPr id="14" name="TextBox 13"/>
-          <p:cNvSpPr txBox="1"/>
-          <p:nvPr/>
-        </p:nvSpPr>
-        <p:spPr>
-          <a:xfrm>
-            <a:off x="1828800" y="2423160"/>
+              <a:t>공식</a:t>
+            </a:r>
+          </a:p>
+        </p:txBody>
+      </p:sp>
+      <p:sp>
+        <p:nvSpPr>
+          <p:cNvPr id="8" name="TextBox 7"/>
+          <p:cNvSpPr txBox="1"/>
+          <p:nvPr/>
+        </p:nvSpPr>
+        <p:spPr>
+          <a:xfrm>
+            <a:off x="1828800" y="1417320"/>
             <a:ext cx="9601200" cy="384048"/>
           </a:xfrm>
           <a:prstGeom prst="rect">
@@ -16190,20 +16920,20 @@
                 </a:solidFill>
                 <a:latin typeface="Apple SD Gothic Neo"/>
               </a:rPr>
-              <a:t>Haseeb Qureshi Gist, rohittcodes/claude-vs-codex, claude-code·gemini-cli Issues, arXiv 20,574 세션</a:t>
-            </a:r>
-          </a:p>
-        </p:txBody>
-      </p:sp>
-      <p:sp>
-        <p:nvSpPr>
-          <p:cNvPr id="15" name="Rounded Rectangle 14"/>
+              <a:t>OpenAI / Google Gemini / Anthropic Claude 문서</a:t>
+            </a:r>
+          </a:p>
+        </p:txBody>
+      </p:sp>
+      <p:sp>
+        <p:nvSpPr>
+          <p:cNvPr id="9" name="Rounded Rectangle 8"/>
           <p:cNvSpPr/>
           <p:nvPr/>
         </p:nvSpPr>
         <p:spPr>
           <a:xfrm>
-            <a:off x="640080" y="2926080"/>
+            <a:off x="640080" y="1920240"/>
             <a:ext cx="1005840" cy="384048"/>
           </a:xfrm>
           <a:prstGeom prst="roundRect">
@@ -16241,13 +16971,13 @@
       </p:sp>
       <p:sp>
         <p:nvSpPr>
-          <p:cNvPr id="16" name="TextBox 15"/>
-          <p:cNvSpPr txBox="1"/>
-          <p:nvPr/>
-        </p:nvSpPr>
-        <p:spPr>
-          <a:xfrm>
-            <a:off x="640080" y="2926080"/>
+          <p:cNvPr id="10" name="TextBox 9"/>
+          <p:cNvSpPr txBox="1"/>
+          <p:nvPr/>
+        </p:nvSpPr>
+        <p:spPr>
+          <a:xfrm>
+            <a:off x="640080" y="1920240"/>
             <a:ext cx="1005840" cy="384048"/>
           </a:xfrm>
           <a:prstGeom prst="rect">
@@ -16276,20 +17006,20 @@
                 </a:solidFill>
                 <a:latin typeface="Apple SD Gothic Neo"/>
               </a:rPr>
-              <a:t>설문</a:t>
-            </a:r>
-          </a:p>
-        </p:txBody>
-      </p:sp>
-      <p:sp>
-        <p:nvSpPr>
-          <p:cNvPr id="17" name="TextBox 16"/>
-          <p:cNvSpPr txBox="1"/>
-          <p:nvPr/>
-        </p:nvSpPr>
-        <p:spPr>
-          <a:xfrm>
-            <a:off x="1828800" y="2926080"/>
+              <a:t>Reddit</a:t>
+            </a:r>
+          </a:p>
+        </p:txBody>
+      </p:sp>
+      <p:sp>
+        <p:nvSpPr>
+          <p:cNvPr id="11" name="TextBox 10"/>
+          <p:cNvSpPr txBox="1"/>
+          <p:nvPr/>
+        </p:nvSpPr>
+        <p:spPr>
+          <a:xfrm>
+            <a:off x="1828800" y="1920240"/>
             <a:ext cx="9601200" cy="384048"/>
           </a:xfrm>
           <a:prstGeom prst="rect">
@@ -16318,20 +17048,20 @@
                 </a:solidFill>
                 <a:latin typeface="Apple SD Gothic Neo"/>
               </a:rPr>
-              <a:t>JetBrains'26, digitalapplied, Ivern(312명), Stack Overflow'25</a:t>
-            </a:r>
-          </a:p>
-        </p:txBody>
-      </p:sp>
-      <p:sp>
-        <p:nvSpPr>
-          <p:cNvPr id="18" name="Rounded Rectangle 17"/>
+              <a:t>Foxafox 요약, RoboRhythms, TechRadar, ClaudeMeter, OpenTools</a:t>
+            </a:r>
+          </a:p>
+        </p:txBody>
+      </p:sp>
+      <p:sp>
+        <p:nvSpPr>
+          <p:cNvPr id="12" name="Rounded Rectangle 11"/>
           <p:cNvSpPr/>
           <p:nvPr/>
         </p:nvSpPr>
         <p:spPr>
           <a:xfrm>
-            <a:off x="640080" y="3429000"/>
+            <a:off x="640080" y="2423160"/>
             <a:ext cx="1005840" cy="384048"/>
           </a:xfrm>
           <a:prstGeom prst="roundRect">
@@ -16369,13 +17099,13 @@
       </p:sp>
       <p:sp>
         <p:nvSpPr>
-          <p:cNvPr id="19" name="TextBox 18"/>
-          <p:cNvSpPr txBox="1"/>
-          <p:nvPr/>
-        </p:nvSpPr>
-        <p:spPr>
-          <a:xfrm>
-            <a:off x="640080" y="3429000"/>
+          <p:cNvPr id="13" name="TextBox 12"/>
+          <p:cNvSpPr txBox="1"/>
+          <p:nvPr/>
+        </p:nvSpPr>
+        <p:spPr>
+          <a:xfrm>
+            <a:off x="640080" y="2423160"/>
             <a:ext cx="1005840" cy="384048"/>
           </a:xfrm>
           <a:prstGeom prst="rect">
@@ -16404,20 +17134,20 @@
                 </a:solidFill>
                 <a:latin typeface="Apple SD Gothic Neo"/>
               </a:rPr>
-              <a:t>Slack·Discord</a:t>
-            </a:r>
-          </a:p>
-        </p:txBody>
-      </p:sp>
-      <p:sp>
-        <p:nvSpPr>
-          <p:cNvPr id="20" name="TextBox 19"/>
-          <p:cNvSpPr txBox="1"/>
-          <p:nvPr/>
-        </p:nvSpPr>
-        <p:spPr>
-          <a:xfrm>
-            <a:off x="1828800" y="3429000"/>
+              <a:t>GitHub</a:t>
+            </a:r>
+          </a:p>
+        </p:txBody>
+      </p:sp>
+      <p:sp>
+        <p:nvSpPr>
+          <p:cNvPr id="14" name="TextBox 13"/>
+          <p:cNvSpPr txBox="1"/>
+          <p:nvPr/>
+        </p:nvSpPr>
+        <p:spPr>
+          <a:xfrm>
+            <a:off x="1828800" y="2423160"/>
             <a:ext cx="9601200" cy="384048"/>
           </a:xfrm>
           <a:prstGeom prst="rect">
@@ -16446,20 +17176,20 @@
                 </a:solidFill>
                 <a:latin typeface="Apple SD Gothic Neo"/>
               </a:rPr>
-              <a:t>editorialge, blockchain-council, State of AI Coding 2026</a:t>
-            </a:r>
-          </a:p>
-        </p:txBody>
-      </p:sp>
-      <p:sp>
-        <p:nvSpPr>
-          <p:cNvPr id="21" name="Rounded Rectangle 20"/>
+              <a:t>Haseeb Qureshi Gist, rohittcodes/claude-vs-codex, claude-code·gemini-cli Issues</a:t>
+            </a:r>
+          </a:p>
+        </p:txBody>
+      </p:sp>
+      <p:sp>
+        <p:nvSpPr>
+          <p:cNvPr id="15" name="Rounded Rectangle 14"/>
           <p:cNvSpPr/>
           <p:nvPr/>
         </p:nvSpPr>
         <p:spPr>
           <a:xfrm>
-            <a:off x="640080" y="3931920"/>
+            <a:off x="640080" y="2926080"/>
             <a:ext cx="1005840" cy="384048"/>
           </a:xfrm>
           <a:prstGeom prst="roundRect">
@@ -16497,13 +17227,13 @@
       </p:sp>
       <p:sp>
         <p:nvSpPr>
-          <p:cNvPr id="22" name="TextBox 21"/>
-          <p:cNvSpPr txBox="1"/>
-          <p:nvPr/>
-        </p:nvSpPr>
-        <p:spPr>
-          <a:xfrm>
-            <a:off x="640080" y="3931920"/>
+          <p:cNvPr id="16" name="TextBox 15"/>
+          <p:cNvSpPr txBox="1"/>
+          <p:nvPr/>
+        </p:nvSpPr>
+        <p:spPr>
+          <a:xfrm>
+            <a:off x="640080" y="2926080"/>
             <a:ext cx="1005840" cy="384048"/>
           </a:xfrm>
           <a:prstGeom prst="rect">
@@ -16532,20 +17262,20 @@
                 </a:solidFill>
                 <a:latin typeface="Apple SD Gothic Neo"/>
               </a:rPr>
-              <a:t>X·참고</a:t>
-            </a:r>
-          </a:p>
-        </p:txBody>
-      </p:sp>
-      <p:sp>
-        <p:nvSpPr>
-          <p:cNvPr id="23" name="TextBox 22"/>
-          <p:cNvSpPr txBox="1"/>
-          <p:nvPr/>
-        </p:nvSpPr>
-        <p:spPr>
-          <a:xfrm>
-            <a:off x="1828800" y="3931920"/>
+              <a:t>설문</a:t>
+            </a:r>
+          </a:p>
+        </p:txBody>
+      </p:sp>
+      <p:sp>
+        <p:nvSpPr>
+          <p:cNvPr id="17" name="TextBox 16"/>
+          <p:cNvSpPr txBox="1"/>
+          <p:nvPr/>
+        </p:nvSpPr>
+        <p:spPr>
+          <a:xfrm>
+            <a:off x="1828800" y="2926080"/>
             <a:ext cx="9601200" cy="384048"/>
           </a:xfrm>
           <a:prstGeom prst="rect">
@@ -16574,20 +17304,20 @@
                 </a:solidFill>
                 <a:latin typeface="Apple SD Gothic Neo"/>
               </a:rPr>
-              <a:t>Vapvarun, CatDoes, Medium 2026 field report</a:t>
-            </a:r>
-          </a:p>
-        </p:txBody>
-      </p:sp>
-      <p:sp>
-        <p:nvSpPr>
-          <p:cNvPr id="24" name="Rounded Rectangle 23"/>
+              <a:t>JetBrains'26, digitalapplied, Ivern(312명), Stack Overflow'25</a:t>
+            </a:r>
+          </a:p>
+        </p:txBody>
+      </p:sp>
+      <p:sp>
+        <p:nvSpPr>
+          <p:cNvPr id="18" name="Rounded Rectangle 17"/>
           <p:cNvSpPr/>
           <p:nvPr/>
         </p:nvSpPr>
         <p:spPr>
           <a:xfrm>
-            <a:off x="640080" y="4434840"/>
+            <a:off x="640080" y="3429000"/>
             <a:ext cx="1005840" cy="384048"/>
           </a:xfrm>
           <a:prstGeom prst="roundRect">
@@ -16625,8 +17355,220 @@
       </p:sp>
       <p:sp>
         <p:nvSpPr>
-          <p:cNvPr id="25" name="TextBox 24"/>
-          <p:cNvSpPr txBox="1"/>
+          <p:cNvPr id="19" name="TextBox 18"/>
+          <p:cNvSpPr txBox="1"/>
+          <p:nvPr/>
+        </p:nvSpPr>
+        <p:spPr>
+          <a:xfrm>
+            <a:off x="640080" y="3429000"/>
+            <a:ext cx="1005840" cy="384048"/>
+          </a:xfrm>
+          <a:prstGeom prst="rect">
+            <a:avLst/>
+          </a:prstGeom>
+          <a:noFill/>
+        </p:spPr>
+        <p:txBody>
+          <a:bodyPr wrap="square" anchor="ctr">
+            <a:spAutoFit/>
+          </a:bodyPr>
+          <a:lstStyle/>
+          <a:p>
+            <a:pPr algn="ctr">
+              <a:lnSpc>
+                <a:spcPct val="100000"/>
+              </a:lnSpc>
+              <a:spcAft>
+                <a:spcPts val="400"/>
+              </a:spcAft>
+            </a:pPr>
+            <a:r>
+              <a:rPr sz="1100" b="1">
+                <a:solidFill>
+                  <a:srgbClr val="FFFFFF"/>
+                </a:solidFill>
+                <a:latin typeface="Apple SD Gothic Neo"/>
+              </a:rPr>
+              <a:t>Slack·Discord</a:t>
+            </a:r>
+          </a:p>
+        </p:txBody>
+      </p:sp>
+      <p:sp>
+        <p:nvSpPr>
+          <p:cNvPr id="20" name="TextBox 19"/>
+          <p:cNvSpPr txBox="1"/>
+          <p:nvPr/>
+        </p:nvSpPr>
+        <p:spPr>
+          <a:xfrm>
+            <a:off x="1828800" y="3429000"/>
+            <a:ext cx="9601200" cy="384048"/>
+          </a:xfrm>
+          <a:prstGeom prst="rect">
+            <a:avLst/>
+          </a:prstGeom>
+          <a:noFill/>
+        </p:spPr>
+        <p:txBody>
+          <a:bodyPr wrap="square" anchor="ctr">
+            <a:spAutoFit/>
+          </a:bodyPr>
+          <a:lstStyle/>
+          <a:p>
+            <a:pPr algn="l">
+              <a:lnSpc>
+                <a:spcPct val="100000"/>
+              </a:lnSpc>
+              <a:spcAft>
+                <a:spcPts val="400"/>
+              </a:spcAft>
+            </a:pPr>
+            <a:r>
+              <a:rPr sz="1200" b="0">
+                <a:solidFill>
+                  <a:srgbClr val="444A55"/>
+                </a:solidFill>
+                <a:latin typeface="Apple SD Gothic Neo"/>
+              </a:rPr>
+              <a:t>editorialge, blockchain-council, State of AI Coding 2026</a:t>
+            </a:r>
+          </a:p>
+        </p:txBody>
+      </p:sp>
+      <p:sp>
+        <p:nvSpPr>
+          <p:cNvPr id="21" name="Rounded Rectangle 20"/>
+          <p:cNvSpPr/>
+          <p:nvPr/>
+        </p:nvSpPr>
+        <p:spPr>
+          <a:xfrm>
+            <a:off x="640080" y="3931920"/>
+            <a:ext cx="1005840" cy="384048"/>
+          </a:xfrm>
+          <a:prstGeom prst="roundRect">
+            <a:avLst/>
+          </a:prstGeom>
+          <a:solidFill>
+            <a:srgbClr val="F27E2E"/>
+          </a:solidFill>
+          <a:ln>
+            <a:noFill/>
+          </a:ln>
+          <a:effectLst/>
+        </p:spPr>
+        <p:style>
+          <a:lnRef idx="1">
+            <a:schemeClr val="accent1"/>
+          </a:lnRef>
+          <a:fillRef idx="3">
+            <a:schemeClr val="accent1"/>
+          </a:fillRef>
+          <a:effectRef idx="2">
+            <a:schemeClr val="accent1"/>
+          </a:effectRef>
+          <a:fontRef idx="minor">
+            <a:schemeClr val="lt1"/>
+          </a:fontRef>
+        </p:style>
+        <p:txBody>
+          <a:bodyPr rtlCol="0" anchor="ctr"/>
+          <a:lstStyle/>
+          <a:p>
+            <a:pPr algn="ctr"/>
+          </a:p>
+        </p:txBody>
+      </p:sp>
+      <p:sp>
+        <p:nvSpPr>
+          <p:cNvPr id="22" name="TextBox 21"/>
+          <p:cNvSpPr txBox="1"/>
+          <p:nvPr/>
+        </p:nvSpPr>
+        <p:spPr>
+          <a:xfrm>
+            <a:off x="640080" y="3931920"/>
+            <a:ext cx="1005840" cy="384048"/>
+          </a:xfrm>
+          <a:prstGeom prst="rect">
+            <a:avLst/>
+          </a:prstGeom>
+          <a:noFill/>
+        </p:spPr>
+        <p:txBody>
+          <a:bodyPr wrap="square" anchor="ctr">
+            <a:spAutoFit/>
+          </a:bodyPr>
+          <a:lstStyle/>
+          <a:p>
+            <a:pPr algn="ctr">
+              <a:lnSpc>
+                <a:spcPct val="100000"/>
+              </a:lnSpc>
+              <a:spcAft>
+                <a:spcPts val="400"/>
+              </a:spcAft>
+            </a:pPr>
+            <a:r>
+              <a:rPr sz="1100" b="1">
+                <a:solidFill>
+                  <a:srgbClr val="FFFFFF"/>
+                </a:solidFill>
+                <a:latin typeface="Apple SD Gothic Neo"/>
+              </a:rPr>
+              <a:t>중국 LLM</a:t>
+            </a:r>
+          </a:p>
+        </p:txBody>
+      </p:sp>
+      <p:sp>
+        <p:nvSpPr>
+          <p:cNvPr id="23" name="TextBox 22"/>
+          <p:cNvSpPr txBox="1"/>
+          <p:nvPr/>
+        </p:nvSpPr>
+        <p:spPr>
+          <a:xfrm>
+            <a:off x="1828800" y="3931920"/>
+            <a:ext cx="9601200" cy="384048"/>
+          </a:xfrm>
+          <a:prstGeom prst="rect">
+            <a:avLst/>
+          </a:prstGeom>
+          <a:noFill/>
+        </p:spPr>
+        <p:txBody>
+          <a:bodyPr wrap="square" anchor="ctr">
+            <a:spAutoFit/>
+          </a:bodyPr>
+          <a:lstStyle/>
+          <a:p>
+            <a:pPr algn="l">
+              <a:lnSpc>
+                <a:spcPct val="100000"/>
+              </a:lnSpc>
+              <a:spcAft>
+                <a:spcPts val="400"/>
+              </a:spcAft>
+            </a:pPr>
+            <a:r>
+              <a:rPr sz="1200" b="0">
+                <a:solidFill>
+                  <a:srgbClr val="444A55"/>
+                </a:solidFill>
+                <a:latin typeface="Apple SD Gothic Neo"/>
+              </a:rPr>
+              <a:t>aimlapi, benchlm.ai, qwen3lm, techjacksolutions, DataCamp</a:t>
+            </a:r>
+          </a:p>
+        </p:txBody>
+      </p:sp>
+      <p:sp>
+        <p:nvSpPr>
+          <p:cNvPr id="24" name="Rounded Rectangle 23"/>
+          <p:cNvSpPr/>
           <p:nvPr/>
         </p:nvSpPr>
         <p:spPr>
@@ -16634,6 +17576,50 @@
             <a:off x="640080" y="4434840"/>
             <a:ext cx="1005840" cy="384048"/>
           </a:xfrm>
+          <a:prstGeom prst="roundRect">
+            <a:avLst/>
+          </a:prstGeom>
+          <a:solidFill>
+            <a:srgbClr val="F27E2E"/>
+          </a:solidFill>
+          <a:ln>
+            <a:noFill/>
+          </a:ln>
+          <a:effectLst/>
+        </p:spPr>
+        <p:style>
+          <a:lnRef idx="1">
+            <a:schemeClr val="accent1"/>
+          </a:lnRef>
+          <a:fillRef idx="3">
+            <a:schemeClr val="accent1"/>
+          </a:fillRef>
+          <a:effectRef idx="2">
+            <a:schemeClr val="accent1"/>
+          </a:effectRef>
+          <a:fontRef idx="minor">
+            <a:schemeClr val="lt1"/>
+          </a:fontRef>
+        </p:style>
+        <p:txBody>
+          <a:bodyPr rtlCol="0" anchor="ctr"/>
+          <a:lstStyle/>
+          <a:p>
+            <a:pPr algn="ctr"/>
+          </a:p>
+        </p:txBody>
+      </p:sp>
+      <p:sp>
+        <p:nvSpPr>
+          <p:cNvPr id="25" name="TextBox 24"/>
+          <p:cNvSpPr txBox="1"/>
+          <p:nvPr/>
+        </p:nvSpPr>
+        <p:spPr>
+          <a:xfrm>
+            <a:off x="640080" y="4434840"/>
+            <a:ext cx="1005840" cy="384048"/>
+          </a:xfrm>
           <a:prstGeom prst="rect">
             <a:avLst/>
           </a:prstGeom>
@@ -16805,7 +17791,7 @@
                 </a:solidFill>
                 <a:latin typeface="Apple SD Gothic Neo"/>
               </a:rPr>
-              <a:t>17</a:t>
+              <a:t>18</a:t>
             </a:r>
           </a:p>
         </p:txBody>
@@ -16961,7 +17947,7 @@
                 </a:solidFill>
                 <a:latin typeface="Apple SD Gothic Neo"/>
               </a:rPr>
-              <a:t>외부 AI 3종 비교  (1/16)</a:t>
+              <a:t>외부 AI 3종 비교  (1/17)</a:t>
             </a:r>
           </a:p>
         </p:txBody>
@@ -18164,7 +19150,7 @@
                 </a:solidFill>
                 <a:latin typeface="Apple SD Gothic Neo"/>
               </a:rPr>
-              <a:t>외부 AI 3종 비교  (2/16)</a:t>
+              <a:t>외부 AI 3종 비교  (2/17)</a:t>
             </a:r>
           </a:p>
         </p:txBody>
@@ -19917,7 +20903,7 @@
                 </a:solidFill>
                 <a:latin typeface="Apple SD Gothic Neo"/>
               </a:rPr>
-              <a:t>외부 AI 3종 비교  (3/16)</a:t>
+              <a:t>외부 AI 3종 비교  (3/17)</a:t>
             </a:r>
           </a:p>
         </p:txBody>
@@ -20818,7 +21804,7 @@
                 </a:solidFill>
                 <a:latin typeface="Apple SD Gothic Neo"/>
               </a:rPr>
-              <a:t>외부 AI 3종 비교  (4/16)</a:t>
+              <a:t>외부 AI 3종 비교  (4/17)</a:t>
             </a:r>
           </a:p>
         </p:txBody>
@@ -21719,7 +22705,7 @@
                 </a:solidFill>
                 <a:latin typeface="Apple SD Gothic Neo"/>
               </a:rPr>
-              <a:t>외부 AI 3종 비교  (5/16)</a:t>
+              <a:t>외부 AI 3종 비교  (5/17)</a:t>
             </a:r>
           </a:p>
         </p:txBody>
@@ -22620,7 +23606,7 @@
                 </a:solidFill>
                 <a:latin typeface="Apple SD Gothic Neo"/>
               </a:rPr>
-              <a:t>외부 AI 3종 비교  (6/16)</a:t>
+              <a:t>외부 AI 3종 비교  (6/17)</a:t>
             </a:r>
           </a:p>
         </p:txBody>
@@ -25718,7 +26704,7 @@
                 </a:solidFill>
                 <a:latin typeface="Apple SD Gothic Neo"/>
               </a:rPr>
-              <a:t>유저 평가 기반 비교  (7/16)</a:t>
+              <a:t>유저 평가 기반 비교  (7/17)</a:t>
             </a:r>
           </a:p>
         </p:txBody>
@@ -26511,7 +27497,7 @@
                 </a:solidFill>
                 <a:latin typeface="Apple SD Gothic Neo"/>
               </a:rPr>
-              <a:t>유저 평가 기반 비교  (8/16)</a:t>
+              <a:t>유저 평가 기반 비교  (8/17)</a:t>
             </a:r>
           </a:p>
         </p:txBody>

</xml_diff>

<commit_message>
Add ChatGPT comparison to Chinese LLM page; center-align all table cells
- China slide now compares DeepSeek/Qwen vs ChatGPT (benchmarks, cost,
  license) and adds an output-difference (code/Korean/stability) section
- Center-align all table cell contents across the deck
- Tidy China slide left-margin alignment; mirror comparison in source markdown

Co-authored-by: Cursor <cursoragent@cursor.com>
</commit_message>
<xml_diff>
--- a/외부AI_3종_비교조사.pptx
+++ b/외부AI_3종_비교조사.pptx
@@ -3765,7 +3765,7 @@
           <a:p>
             <a:pPr algn="ctr">
               <a:lnSpc>
-                <a:spcPct val="92000"/>
+                <a:spcPct val="95000"/>
               </a:lnSpc>
               <a:spcAft>
                 <a:spcPts val="400"/>
@@ -3851,9 +3851,9 @@
           </a:bodyPr>
           <a:lstStyle/>
           <a:p>
-            <a:pPr algn="l">
-              <a:lnSpc>
-                <a:spcPct val="92000"/>
+            <a:pPr algn="ctr">
+              <a:lnSpc>
+                <a:spcPct val="95000"/>
               </a:lnSpc>
               <a:spcAft>
                 <a:spcPts val="400"/>
@@ -3941,7 +3941,7 @@
           <a:p>
             <a:pPr algn="ctr">
               <a:lnSpc>
-                <a:spcPct val="92000"/>
+                <a:spcPct val="95000"/>
               </a:lnSpc>
               <a:spcAft>
                 <a:spcPts val="400"/>
@@ -4027,9 +4027,9 @@
           </a:bodyPr>
           <a:lstStyle/>
           <a:p>
-            <a:pPr algn="l">
-              <a:lnSpc>
-                <a:spcPct val="92000"/>
+            <a:pPr algn="ctr">
+              <a:lnSpc>
+                <a:spcPct val="95000"/>
               </a:lnSpc>
               <a:spcAft>
                 <a:spcPts val="400"/>
@@ -4117,7 +4117,7 @@
           <a:p>
             <a:pPr algn="ctr">
               <a:lnSpc>
-                <a:spcPct val="92000"/>
+                <a:spcPct val="95000"/>
               </a:lnSpc>
               <a:spcAft>
                 <a:spcPts val="400"/>
@@ -4203,9 +4203,9 @@
           </a:bodyPr>
           <a:lstStyle/>
           <a:p>
-            <a:pPr algn="l">
-              <a:lnSpc>
-                <a:spcPct val="92000"/>
+            <a:pPr algn="ctr">
+              <a:lnSpc>
+                <a:spcPct val="95000"/>
               </a:lnSpc>
               <a:spcAft>
                 <a:spcPts val="400"/>
@@ -4293,7 +4293,7 @@
           <a:p>
             <a:pPr algn="ctr">
               <a:lnSpc>
-                <a:spcPct val="92000"/>
+                <a:spcPct val="95000"/>
               </a:lnSpc>
               <a:spcAft>
                 <a:spcPts val="400"/>
@@ -4379,9 +4379,9 @@
           </a:bodyPr>
           <a:lstStyle/>
           <a:p>
-            <a:pPr algn="l">
-              <a:lnSpc>
-                <a:spcPct val="92000"/>
+            <a:pPr algn="ctr">
+              <a:lnSpc>
+                <a:spcPct val="95000"/>
               </a:lnSpc>
               <a:spcAft>
                 <a:spcPts val="400"/>
@@ -4469,7 +4469,7 @@
           <a:p>
             <a:pPr algn="ctr">
               <a:lnSpc>
-                <a:spcPct val="92000"/>
+                <a:spcPct val="95000"/>
               </a:lnSpc>
               <a:spcAft>
                 <a:spcPts val="400"/>
@@ -4555,9 +4555,9 @@
           </a:bodyPr>
           <a:lstStyle/>
           <a:p>
-            <a:pPr algn="l">
-              <a:lnSpc>
-                <a:spcPct val="92000"/>
+            <a:pPr algn="ctr">
+              <a:lnSpc>
+                <a:spcPct val="95000"/>
               </a:lnSpc>
               <a:spcAft>
                 <a:spcPts val="400"/>
@@ -5273,7 +5273,7 @@
           <a:p>
             <a:pPr algn="ctr">
               <a:lnSpc>
-                <a:spcPct val="92000"/>
+                <a:spcPct val="95000"/>
               </a:lnSpc>
               <a:spcAft>
                 <a:spcPts val="400"/>
@@ -5359,9 +5359,9 @@
           </a:bodyPr>
           <a:lstStyle/>
           <a:p>
-            <a:pPr algn="l">
-              <a:lnSpc>
-                <a:spcPct val="92000"/>
+            <a:pPr algn="ctr">
+              <a:lnSpc>
+                <a:spcPct val="95000"/>
               </a:lnSpc>
               <a:spcAft>
                 <a:spcPts val="400"/>
@@ -5447,9 +5447,9 @@
           </a:bodyPr>
           <a:lstStyle/>
           <a:p>
-            <a:pPr algn="l">
-              <a:lnSpc>
-                <a:spcPct val="92000"/>
+            <a:pPr algn="ctr">
+              <a:lnSpc>
+                <a:spcPct val="95000"/>
               </a:lnSpc>
               <a:spcAft>
                 <a:spcPts val="400"/>
@@ -5537,7 +5537,7 @@
           <a:p>
             <a:pPr algn="ctr">
               <a:lnSpc>
-                <a:spcPct val="92000"/>
+                <a:spcPct val="95000"/>
               </a:lnSpc>
               <a:spcAft>
                 <a:spcPts val="400"/>
@@ -5623,9 +5623,9 @@
           </a:bodyPr>
           <a:lstStyle/>
           <a:p>
-            <a:pPr algn="l">
-              <a:lnSpc>
-                <a:spcPct val="92000"/>
+            <a:pPr algn="ctr">
+              <a:lnSpc>
+                <a:spcPct val="95000"/>
               </a:lnSpc>
               <a:spcAft>
                 <a:spcPts val="400"/>
@@ -5711,9 +5711,9 @@
           </a:bodyPr>
           <a:lstStyle/>
           <a:p>
-            <a:pPr algn="l">
-              <a:lnSpc>
-                <a:spcPct val="92000"/>
+            <a:pPr algn="ctr">
+              <a:lnSpc>
+                <a:spcPct val="95000"/>
               </a:lnSpc>
               <a:spcAft>
                 <a:spcPts val="400"/>
@@ -5801,7 +5801,7 @@
           <a:p>
             <a:pPr algn="ctr">
               <a:lnSpc>
-                <a:spcPct val="92000"/>
+                <a:spcPct val="95000"/>
               </a:lnSpc>
               <a:spcAft>
                 <a:spcPts val="400"/>
@@ -5887,9 +5887,9 @@
           </a:bodyPr>
           <a:lstStyle/>
           <a:p>
-            <a:pPr algn="l">
-              <a:lnSpc>
-                <a:spcPct val="92000"/>
+            <a:pPr algn="ctr">
+              <a:lnSpc>
+                <a:spcPct val="95000"/>
               </a:lnSpc>
               <a:spcAft>
                 <a:spcPts val="400"/>
@@ -5975,9 +5975,9 @@
           </a:bodyPr>
           <a:lstStyle/>
           <a:p>
-            <a:pPr algn="l">
-              <a:lnSpc>
-                <a:spcPct val="92000"/>
+            <a:pPr algn="ctr">
+              <a:lnSpc>
+                <a:spcPct val="95000"/>
               </a:lnSpc>
               <a:spcAft>
                 <a:spcPts val="400"/>
@@ -6065,7 +6065,7 @@
           <a:p>
             <a:pPr algn="ctr">
               <a:lnSpc>
-                <a:spcPct val="92000"/>
+                <a:spcPct val="95000"/>
               </a:lnSpc>
               <a:spcAft>
                 <a:spcPts val="400"/>
@@ -6151,9 +6151,9 @@
           </a:bodyPr>
           <a:lstStyle/>
           <a:p>
-            <a:pPr algn="l">
-              <a:lnSpc>
-                <a:spcPct val="92000"/>
+            <a:pPr algn="ctr">
+              <a:lnSpc>
+                <a:spcPct val="95000"/>
               </a:lnSpc>
               <a:spcAft>
                 <a:spcPts val="400"/>
@@ -6239,9 +6239,9 @@
           </a:bodyPr>
           <a:lstStyle/>
           <a:p>
-            <a:pPr algn="l">
-              <a:lnSpc>
-                <a:spcPct val="92000"/>
+            <a:pPr algn="ctr">
+              <a:lnSpc>
+                <a:spcPct val="95000"/>
               </a:lnSpc>
               <a:spcAft>
                 <a:spcPts val="400"/>
@@ -6329,7 +6329,7 @@
           <a:p>
             <a:pPr algn="ctr">
               <a:lnSpc>
-                <a:spcPct val="92000"/>
+                <a:spcPct val="95000"/>
               </a:lnSpc>
               <a:spcAft>
                 <a:spcPts val="400"/>
@@ -6415,9 +6415,9 @@
           </a:bodyPr>
           <a:lstStyle/>
           <a:p>
-            <a:pPr algn="l">
-              <a:lnSpc>
-                <a:spcPct val="92000"/>
+            <a:pPr algn="ctr">
+              <a:lnSpc>
+                <a:spcPct val="95000"/>
               </a:lnSpc>
               <a:spcAft>
                 <a:spcPts val="400"/>
@@ -6503,9 +6503,9 @@
           </a:bodyPr>
           <a:lstStyle/>
           <a:p>
-            <a:pPr algn="l">
-              <a:lnSpc>
-                <a:spcPct val="92000"/>
+            <a:pPr algn="ctr">
+              <a:lnSpc>
+                <a:spcPct val="95000"/>
               </a:lnSpc>
               <a:spcAft>
                 <a:spcPts val="400"/>
@@ -6593,7 +6593,7 @@
           <a:p>
             <a:pPr algn="ctr">
               <a:lnSpc>
-                <a:spcPct val="92000"/>
+                <a:spcPct val="95000"/>
               </a:lnSpc>
               <a:spcAft>
                 <a:spcPts val="400"/>
@@ -6679,9 +6679,9 @@
           </a:bodyPr>
           <a:lstStyle/>
           <a:p>
-            <a:pPr algn="l">
-              <a:lnSpc>
-                <a:spcPct val="92000"/>
+            <a:pPr algn="ctr">
+              <a:lnSpc>
+                <a:spcPct val="95000"/>
               </a:lnSpc>
               <a:spcAft>
                 <a:spcPts val="400"/>
@@ -6767,9 +6767,9 @@
           </a:bodyPr>
           <a:lstStyle/>
           <a:p>
-            <a:pPr algn="l">
-              <a:lnSpc>
-                <a:spcPct val="92000"/>
+            <a:pPr algn="ctr">
+              <a:lnSpc>
+                <a:spcPct val="95000"/>
               </a:lnSpc>
               <a:spcAft>
                 <a:spcPts val="400"/>
@@ -8839,7 +8839,7 @@
           <a:p>
             <a:pPr algn="ctr">
               <a:lnSpc>
-                <a:spcPct val="92000"/>
+                <a:spcPct val="95000"/>
               </a:lnSpc>
               <a:spcAft>
                 <a:spcPts val="400"/>
@@ -8925,9 +8925,9 @@
           </a:bodyPr>
           <a:lstStyle/>
           <a:p>
-            <a:pPr algn="l">
-              <a:lnSpc>
-                <a:spcPct val="92000"/>
+            <a:pPr algn="ctr">
+              <a:lnSpc>
+                <a:spcPct val="95000"/>
               </a:lnSpc>
               <a:spcAft>
                 <a:spcPts val="400"/>
@@ -9013,9 +9013,9 @@
           </a:bodyPr>
           <a:lstStyle/>
           <a:p>
-            <a:pPr algn="l">
-              <a:lnSpc>
-                <a:spcPct val="92000"/>
+            <a:pPr algn="ctr">
+              <a:lnSpc>
+                <a:spcPct val="95000"/>
               </a:lnSpc>
               <a:spcAft>
                 <a:spcPts val="400"/>
@@ -9101,9 +9101,9 @@
           </a:bodyPr>
           <a:lstStyle/>
           <a:p>
-            <a:pPr algn="l">
-              <a:lnSpc>
-                <a:spcPct val="92000"/>
+            <a:pPr algn="ctr">
+              <a:lnSpc>
+                <a:spcPct val="95000"/>
               </a:lnSpc>
               <a:spcAft>
                 <a:spcPts val="400"/>
@@ -9191,7 +9191,7 @@
           <a:p>
             <a:pPr algn="ctr">
               <a:lnSpc>
-                <a:spcPct val="92000"/>
+                <a:spcPct val="95000"/>
               </a:lnSpc>
               <a:spcAft>
                 <a:spcPts val="400"/>
@@ -9277,9 +9277,9 @@
           </a:bodyPr>
           <a:lstStyle/>
           <a:p>
-            <a:pPr algn="l">
-              <a:lnSpc>
-                <a:spcPct val="92000"/>
+            <a:pPr algn="ctr">
+              <a:lnSpc>
+                <a:spcPct val="95000"/>
               </a:lnSpc>
               <a:spcAft>
                 <a:spcPts val="400"/>
@@ -9365,9 +9365,9 @@
           </a:bodyPr>
           <a:lstStyle/>
           <a:p>
-            <a:pPr algn="l">
-              <a:lnSpc>
-                <a:spcPct val="92000"/>
+            <a:pPr algn="ctr">
+              <a:lnSpc>
+                <a:spcPct val="95000"/>
               </a:lnSpc>
               <a:spcAft>
                 <a:spcPts val="400"/>
@@ -9453,9 +9453,9 @@
           </a:bodyPr>
           <a:lstStyle/>
           <a:p>
-            <a:pPr algn="l">
-              <a:lnSpc>
-                <a:spcPct val="92000"/>
+            <a:pPr algn="ctr">
+              <a:lnSpc>
+                <a:spcPct val="95000"/>
               </a:lnSpc>
               <a:spcAft>
                 <a:spcPts val="400"/>
@@ -9543,7 +9543,7 @@
           <a:p>
             <a:pPr algn="ctr">
               <a:lnSpc>
-                <a:spcPct val="92000"/>
+                <a:spcPct val="95000"/>
               </a:lnSpc>
               <a:spcAft>
                 <a:spcPts val="400"/>
@@ -9629,9 +9629,9 @@
           </a:bodyPr>
           <a:lstStyle/>
           <a:p>
-            <a:pPr algn="l">
-              <a:lnSpc>
-                <a:spcPct val="92000"/>
+            <a:pPr algn="ctr">
+              <a:lnSpc>
+                <a:spcPct val="95000"/>
               </a:lnSpc>
               <a:spcAft>
                 <a:spcPts val="400"/>
@@ -9717,9 +9717,9 @@
           </a:bodyPr>
           <a:lstStyle/>
           <a:p>
-            <a:pPr algn="l">
-              <a:lnSpc>
-                <a:spcPct val="92000"/>
+            <a:pPr algn="ctr">
+              <a:lnSpc>
+                <a:spcPct val="95000"/>
               </a:lnSpc>
               <a:spcAft>
                 <a:spcPts val="400"/>
@@ -9805,9 +9805,9 @@
           </a:bodyPr>
           <a:lstStyle/>
           <a:p>
-            <a:pPr algn="l">
-              <a:lnSpc>
-                <a:spcPct val="92000"/>
+            <a:pPr algn="ctr">
+              <a:lnSpc>
+                <a:spcPct val="95000"/>
               </a:lnSpc>
               <a:spcAft>
                 <a:spcPts val="400"/>
@@ -9895,7 +9895,7 @@
           <a:p>
             <a:pPr algn="ctr">
               <a:lnSpc>
-                <a:spcPct val="92000"/>
+                <a:spcPct val="95000"/>
               </a:lnSpc>
               <a:spcAft>
                 <a:spcPts val="400"/>
@@ -9981,9 +9981,9 @@
           </a:bodyPr>
           <a:lstStyle/>
           <a:p>
-            <a:pPr algn="l">
-              <a:lnSpc>
-                <a:spcPct val="92000"/>
+            <a:pPr algn="ctr">
+              <a:lnSpc>
+                <a:spcPct val="95000"/>
               </a:lnSpc>
               <a:spcAft>
                 <a:spcPts val="400"/>
@@ -10069,9 +10069,9 @@
           </a:bodyPr>
           <a:lstStyle/>
           <a:p>
-            <a:pPr algn="l">
-              <a:lnSpc>
-                <a:spcPct val="92000"/>
+            <a:pPr algn="ctr">
+              <a:lnSpc>
+                <a:spcPct val="95000"/>
               </a:lnSpc>
               <a:spcAft>
                 <a:spcPts val="400"/>
@@ -10157,9 +10157,9 @@
           </a:bodyPr>
           <a:lstStyle/>
           <a:p>
-            <a:pPr algn="l">
-              <a:lnSpc>
-                <a:spcPct val="92000"/>
+            <a:pPr algn="ctr">
+              <a:lnSpc>
+                <a:spcPct val="95000"/>
               </a:lnSpc>
               <a:spcAft>
                 <a:spcPts val="400"/>
@@ -10247,7 +10247,7 @@
           <a:p>
             <a:pPr algn="ctr">
               <a:lnSpc>
-                <a:spcPct val="92000"/>
+                <a:spcPct val="95000"/>
               </a:lnSpc>
               <a:spcAft>
                 <a:spcPts val="400"/>
@@ -10333,9 +10333,9 @@
           </a:bodyPr>
           <a:lstStyle/>
           <a:p>
-            <a:pPr algn="l">
-              <a:lnSpc>
-                <a:spcPct val="92000"/>
+            <a:pPr algn="ctr">
+              <a:lnSpc>
+                <a:spcPct val="95000"/>
               </a:lnSpc>
               <a:spcAft>
                 <a:spcPts val="400"/>
@@ -10421,9 +10421,9 @@
           </a:bodyPr>
           <a:lstStyle/>
           <a:p>
-            <a:pPr algn="l">
-              <a:lnSpc>
-                <a:spcPct val="92000"/>
+            <a:pPr algn="ctr">
+              <a:lnSpc>
+                <a:spcPct val="95000"/>
               </a:lnSpc>
               <a:spcAft>
                 <a:spcPts val="400"/>
@@ -10509,9 +10509,9 @@
           </a:bodyPr>
           <a:lstStyle/>
           <a:p>
-            <a:pPr algn="l">
-              <a:lnSpc>
-                <a:spcPct val="92000"/>
+            <a:pPr algn="ctr">
+              <a:lnSpc>
+                <a:spcPct val="95000"/>
               </a:lnSpc>
               <a:spcAft>
                 <a:spcPts val="400"/>
@@ -11269,7 +11269,7 @@
           <a:p>
             <a:pPr algn="ctr">
               <a:lnSpc>
-                <a:spcPct val="92000"/>
+                <a:spcPct val="95000"/>
               </a:lnSpc>
               <a:spcAft>
                 <a:spcPts val="400"/>
@@ -11355,9 +11355,9 @@
           </a:bodyPr>
           <a:lstStyle/>
           <a:p>
-            <a:pPr algn="l">
-              <a:lnSpc>
-                <a:spcPct val="92000"/>
+            <a:pPr algn="ctr">
+              <a:lnSpc>
+                <a:spcPct val="95000"/>
               </a:lnSpc>
               <a:spcAft>
                 <a:spcPts val="400"/>
@@ -11443,9 +11443,9 @@
           </a:bodyPr>
           <a:lstStyle/>
           <a:p>
-            <a:pPr algn="l">
-              <a:lnSpc>
-                <a:spcPct val="92000"/>
+            <a:pPr algn="ctr">
+              <a:lnSpc>
+                <a:spcPct val="95000"/>
               </a:lnSpc>
               <a:spcAft>
                 <a:spcPts val="400"/>
@@ -11533,7 +11533,7 @@
           <a:p>
             <a:pPr algn="ctr">
               <a:lnSpc>
-                <a:spcPct val="92000"/>
+                <a:spcPct val="95000"/>
               </a:lnSpc>
               <a:spcAft>
                 <a:spcPts val="400"/>
@@ -11619,9 +11619,9 @@
           </a:bodyPr>
           <a:lstStyle/>
           <a:p>
-            <a:pPr algn="l">
-              <a:lnSpc>
-                <a:spcPct val="92000"/>
+            <a:pPr algn="ctr">
+              <a:lnSpc>
+                <a:spcPct val="95000"/>
               </a:lnSpc>
               <a:spcAft>
                 <a:spcPts val="400"/>
@@ -11707,9 +11707,9 @@
           </a:bodyPr>
           <a:lstStyle/>
           <a:p>
-            <a:pPr algn="l">
-              <a:lnSpc>
-                <a:spcPct val="92000"/>
+            <a:pPr algn="ctr">
+              <a:lnSpc>
+                <a:spcPct val="95000"/>
               </a:lnSpc>
               <a:spcAft>
                 <a:spcPts val="400"/>
@@ -11797,7 +11797,7 @@
           <a:p>
             <a:pPr algn="ctr">
               <a:lnSpc>
-                <a:spcPct val="92000"/>
+                <a:spcPct val="95000"/>
               </a:lnSpc>
               <a:spcAft>
                 <a:spcPts val="400"/>
@@ -11883,9 +11883,9 @@
           </a:bodyPr>
           <a:lstStyle/>
           <a:p>
-            <a:pPr algn="l">
-              <a:lnSpc>
-                <a:spcPct val="92000"/>
+            <a:pPr algn="ctr">
+              <a:lnSpc>
+                <a:spcPct val="95000"/>
               </a:lnSpc>
               <a:spcAft>
                 <a:spcPts val="400"/>
@@ -11971,9 +11971,9 @@
           </a:bodyPr>
           <a:lstStyle/>
           <a:p>
-            <a:pPr algn="l">
-              <a:lnSpc>
-                <a:spcPct val="92000"/>
+            <a:pPr algn="ctr">
+              <a:lnSpc>
+                <a:spcPct val="95000"/>
               </a:lnSpc>
               <a:spcAft>
                 <a:spcPts val="400"/>
@@ -12710,7 +12710,7 @@
           <a:p>
             <a:pPr algn="ctr">
               <a:lnSpc>
-                <a:spcPct val="92000"/>
+                <a:spcPct val="95000"/>
               </a:lnSpc>
               <a:spcAft>
                 <a:spcPts val="400"/>
@@ -12796,9 +12796,9 @@
           </a:bodyPr>
           <a:lstStyle/>
           <a:p>
-            <a:pPr algn="l">
-              <a:lnSpc>
-                <a:spcPct val="92000"/>
+            <a:pPr algn="ctr">
+              <a:lnSpc>
+                <a:spcPct val="95000"/>
               </a:lnSpc>
               <a:spcAft>
                 <a:spcPts val="400"/>
@@ -12884,9 +12884,9 @@
           </a:bodyPr>
           <a:lstStyle/>
           <a:p>
-            <a:pPr algn="l">
-              <a:lnSpc>
-                <a:spcPct val="92000"/>
+            <a:pPr algn="ctr">
+              <a:lnSpc>
+                <a:spcPct val="95000"/>
               </a:lnSpc>
               <a:spcAft>
                 <a:spcPts val="400"/>
@@ -12974,7 +12974,7 @@
           <a:p>
             <a:pPr algn="ctr">
               <a:lnSpc>
-                <a:spcPct val="92000"/>
+                <a:spcPct val="95000"/>
               </a:lnSpc>
               <a:spcAft>
                 <a:spcPts val="400"/>
@@ -13060,9 +13060,9 @@
           </a:bodyPr>
           <a:lstStyle/>
           <a:p>
-            <a:pPr algn="l">
-              <a:lnSpc>
-                <a:spcPct val="92000"/>
+            <a:pPr algn="ctr">
+              <a:lnSpc>
+                <a:spcPct val="95000"/>
               </a:lnSpc>
               <a:spcAft>
                 <a:spcPts val="400"/>
@@ -13148,9 +13148,9 @@
           </a:bodyPr>
           <a:lstStyle/>
           <a:p>
-            <a:pPr algn="l">
-              <a:lnSpc>
-                <a:spcPct val="92000"/>
+            <a:pPr algn="ctr">
+              <a:lnSpc>
+                <a:spcPct val="95000"/>
               </a:lnSpc>
               <a:spcAft>
                 <a:spcPts val="400"/>
@@ -13238,7 +13238,7 @@
           <a:p>
             <a:pPr algn="ctr">
               <a:lnSpc>
-                <a:spcPct val="92000"/>
+                <a:spcPct val="95000"/>
               </a:lnSpc>
               <a:spcAft>
                 <a:spcPts val="400"/>
@@ -13324,9 +13324,9 @@
           </a:bodyPr>
           <a:lstStyle/>
           <a:p>
-            <a:pPr algn="l">
-              <a:lnSpc>
-                <a:spcPct val="92000"/>
+            <a:pPr algn="ctr">
+              <a:lnSpc>
+                <a:spcPct val="95000"/>
               </a:lnSpc>
               <a:spcAft>
                 <a:spcPts val="400"/>
@@ -13412,9 +13412,9 @@
           </a:bodyPr>
           <a:lstStyle/>
           <a:p>
-            <a:pPr algn="l">
-              <a:lnSpc>
-                <a:spcPct val="92000"/>
+            <a:pPr algn="ctr">
+              <a:lnSpc>
+                <a:spcPct val="95000"/>
               </a:lnSpc>
               <a:spcAft>
                 <a:spcPts val="400"/>
@@ -13502,7 +13502,7 @@
           <a:p>
             <a:pPr algn="ctr">
               <a:lnSpc>
-                <a:spcPct val="92000"/>
+                <a:spcPct val="95000"/>
               </a:lnSpc>
               <a:spcAft>
                 <a:spcPts val="400"/>
@@ -13588,9 +13588,9 @@
           </a:bodyPr>
           <a:lstStyle/>
           <a:p>
-            <a:pPr algn="l">
-              <a:lnSpc>
-                <a:spcPct val="92000"/>
+            <a:pPr algn="ctr">
+              <a:lnSpc>
+                <a:spcPct val="95000"/>
               </a:lnSpc>
               <a:spcAft>
                 <a:spcPts val="400"/>
@@ -13676,9 +13676,9 @@
           </a:bodyPr>
           <a:lstStyle/>
           <a:p>
-            <a:pPr algn="l">
-              <a:lnSpc>
-                <a:spcPct val="92000"/>
+            <a:pPr algn="ctr">
+              <a:lnSpc>
+                <a:spcPct val="95000"/>
               </a:lnSpc>
               <a:spcAft>
                 <a:spcPts val="400"/>
@@ -13766,7 +13766,7 @@
           <a:p>
             <a:pPr algn="ctr">
               <a:lnSpc>
-                <a:spcPct val="92000"/>
+                <a:spcPct val="95000"/>
               </a:lnSpc>
               <a:spcAft>
                 <a:spcPts val="400"/>
@@ -13852,9 +13852,9 @@
           </a:bodyPr>
           <a:lstStyle/>
           <a:p>
-            <a:pPr algn="l">
-              <a:lnSpc>
-                <a:spcPct val="92000"/>
+            <a:pPr algn="ctr">
+              <a:lnSpc>
+                <a:spcPct val="95000"/>
               </a:lnSpc>
               <a:spcAft>
                 <a:spcPts val="400"/>
@@ -13940,9 +13940,9 @@
           </a:bodyPr>
           <a:lstStyle/>
           <a:p>
-            <a:pPr algn="l">
-              <a:lnSpc>
-                <a:spcPct val="92000"/>
+            <a:pPr algn="ctr">
+              <a:lnSpc>
+                <a:spcPct val="95000"/>
               </a:lnSpc>
               <a:spcAft>
                 <a:spcPts val="400"/>
@@ -14030,7 +14030,7 @@
           <a:p>
             <a:pPr algn="ctr">
               <a:lnSpc>
-                <a:spcPct val="92000"/>
+                <a:spcPct val="95000"/>
               </a:lnSpc>
               <a:spcAft>
                 <a:spcPts val="400"/>
@@ -14116,9 +14116,9 @@
           </a:bodyPr>
           <a:lstStyle/>
           <a:p>
-            <a:pPr algn="l">
-              <a:lnSpc>
-                <a:spcPct val="92000"/>
+            <a:pPr algn="ctr">
+              <a:lnSpc>
+                <a:spcPct val="95000"/>
               </a:lnSpc>
               <a:spcAft>
                 <a:spcPts val="400"/>
@@ -14204,9 +14204,9 @@
           </a:bodyPr>
           <a:lstStyle/>
           <a:p>
-            <a:pPr algn="l">
-              <a:lnSpc>
-                <a:spcPct val="92000"/>
+            <a:pPr algn="ctr">
+              <a:lnSpc>
+                <a:spcPct val="95000"/>
               </a:lnSpc>
               <a:spcAft>
                 <a:spcPts val="400"/>
@@ -15807,29 +15807,381 @@
                 </a:solidFill>
                 <a:latin typeface="Apple SD Gothic Neo"/>
               </a:rPr>
-              <a:t>중국 LLM 상위 2종 — 강점 및 평가</a:t>
-            </a:r>
-          </a:p>
-        </p:txBody>
-      </p:sp>
-      <p:sp>
-        <p:nvSpPr>
-          <p:cNvPr id="6" name="Rounded Rectangle 5"/>
+              <a:t>중국 LLM 상위 2종 vs ChatGPT — 성능·결과물 비교</a:t>
+            </a:r>
+          </a:p>
+        </p:txBody>
+      </p:sp>
+      <p:sp>
+        <p:nvSpPr>
+          <p:cNvPr id="6" name="Rectangle 5"/>
           <p:cNvSpPr/>
           <p:nvPr/>
         </p:nvSpPr>
         <p:spPr>
           <a:xfrm>
-            <a:off x="502920" y="1234440"/>
-            <a:ext cx="5486400" cy="2788920"/>
-          </a:xfrm>
-          <a:prstGeom prst="roundRect">
+            <a:off x="457200" y="1170432"/>
+            <a:ext cx="2468880" cy="420624"/>
+          </a:xfrm>
+          <a:prstGeom prst="rect">
             <a:avLst/>
           </a:prstGeom>
           <a:solidFill>
-            <a:srgbClr val="E8F1FA"/>
+            <a:srgbClr val="1F6FB2"/>
           </a:solidFill>
           <a:ln w="12700">
+            <a:solidFill>
+              <a:srgbClr val="FFFFFF"/>
+            </a:solidFill>
+          </a:ln>
+          <a:effectLst/>
+        </p:spPr>
+        <p:style>
+          <a:lnRef idx="1">
+            <a:schemeClr val="accent1"/>
+          </a:lnRef>
+          <a:fillRef idx="3">
+            <a:schemeClr val="accent1"/>
+          </a:fillRef>
+          <a:effectRef idx="2">
+            <a:schemeClr val="accent1"/>
+          </a:effectRef>
+          <a:fontRef idx="minor">
+            <a:schemeClr val="lt1"/>
+          </a:fontRef>
+        </p:style>
+        <p:txBody>
+          <a:bodyPr rtlCol="0" anchor="ctr"/>
+          <a:lstStyle/>
+          <a:p>
+            <a:pPr algn="ctr"/>
+          </a:p>
+        </p:txBody>
+      </p:sp>
+      <p:sp>
+        <p:nvSpPr>
+          <p:cNvPr id="7" name="TextBox 6"/>
+          <p:cNvSpPr txBox="1"/>
+          <p:nvPr/>
+        </p:nvSpPr>
+        <p:spPr>
+          <a:xfrm>
+            <a:off x="457200" y="1170432"/>
+            <a:ext cx="2468880" cy="420624"/>
+          </a:xfrm>
+          <a:prstGeom prst="rect">
+            <a:avLst/>
+          </a:prstGeom>
+          <a:noFill/>
+        </p:spPr>
+        <p:txBody>
+          <a:bodyPr wrap="square" anchor="ctr">
+            <a:spAutoFit/>
+          </a:bodyPr>
+          <a:lstStyle/>
+          <a:p>
+            <a:pPr algn="ctr">
+              <a:lnSpc>
+                <a:spcPct val="100000"/>
+              </a:lnSpc>
+              <a:spcAft>
+                <a:spcPts val="400"/>
+              </a:spcAft>
+            </a:pPr>
+            <a:r>
+              <a:rPr sz="1100" b="1">
+                <a:solidFill>
+                  <a:srgbClr val="FFFFFF"/>
+                </a:solidFill>
+                <a:latin typeface="Apple SD Gothic Neo"/>
+              </a:rPr>
+              <a:t>비교 항목</a:t>
+            </a:r>
+          </a:p>
+        </p:txBody>
+      </p:sp>
+      <p:sp>
+        <p:nvSpPr>
+          <p:cNvPr id="8" name="Rectangle 7"/>
+          <p:cNvSpPr/>
+          <p:nvPr/>
+        </p:nvSpPr>
+        <p:spPr>
+          <a:xfrm>
+            <a:off x="2926080" y="1170432"/>
+            <a:ext cx="2926080" cy="420624"/>
+          </a:xfrm>
+          <a:prstGeom prst="rect">
+            <a:avLst/>
+          </a:prstGeom>
+          <a:solidFill>
+            <a:srgbClr val="1F6FB2"/>
+          </a:solidFill>
+          <a:ln w="12700">
+            <a:solidFill>
+              <a:srgbClr val="FFFFFF"/>
+            </a:solidFill>
+          </a:ln>
+          <a:effectLst/>
+        </p:spPr>
+        <p:style>
+          <a:lnRef idx="1">
+            <a:schemeClr val="accent1"/>
+          </a:lnRef>
+          <a:fillRef idx="3">
+            <a:schemeClr val="accent1"/>
+          </a:fillRef>
+          <a:effectRef idx="2">
+            <a:schemeClr val="accent1"/>
+          </a:effectRef>
+          <a:fontRef idx="minor">
+            <a:schemeClr val="lt1"/>
+          </a:fontRef>
+        </p:style>
+        <p:txBody>
+          <a:bodyPr rtlCol="0" anchor="ctr"/>
+          <a:lstStyle/>
+          <a:p>
+            <a:pPr algn="ctr"/>
+          </a:p>
+        </p:txBody>
+      </p:sp>
+      <p:sp>
+        <p:nvSpPr>
+          <p:cNvPr id="9" name="TextBox 8"/>
+          <p:cNvSpPr txBox="1"/>
+          <p:nvPr/>
+        </p:nvSpPr>
+        <p:spPr>
+          <a:xfrm>
+            <a:off x="2926080" y="1170432"/>
+            <a:ext cx="2926080" cy="420624"/>
+          </a:xfrm>
+          <a:prstGeom prst="rect">
+            <a:avLst/>
+          </a:prstGeom>
+          <a:noFill/>
+        </p:spPr>
+        <p:txBody>
+          <a:bodyPr wrap="square" anchor="ctr">
+            <a:spAutoFit/>
+          </a:bodyPr>
+          <a:lstStyle/>
+          <a:p>
+            <a:pPr algn="ctr">
+              <a:lnSpc>
+                <a:spcPct val="100000"/>
+              </a:lnSpc>
+              <a:spcAft>
+                <a:spcPts val="400"/>
+              </a:spcAft>
+            </a:pPr>
+            <a:r>
+              <a:rPr sz="1100" b="1">
+                <a:solidFill>
+                  <a:srgbClr val="FFFFFF"/>
+                </a:solidFill>
+                <a:latin typeface="Apple SD Gothic Neo"/>
+              </a:rPr>
+              <a:t>ChatGPT (GPT-5.5)</a:t>
+            </a:r>
+          </a:p>
+        </p:txBody>
+      </p:sp>
+      <p:sp>
+        <p:nvSpPr>
+          <p:cNvPr id="10" name="Rectangle 9"/>
+          <p:cNvSpPr/>
+          <p:nvPr/>
+        </p:nvSpPr>
+        <p:spPr>
+          <a:xfrm>
+            <a:off x="5852160" y="1170432"/>
+            <a:ext cx="2971800" cy="420624"/>
+          </a:xfrm>
+          <a:prstGeom prst="rect">
+            <a:avLst/>
+          </a:prstGeom>
+          <a:solidFill>
+            <a:srgbClr val="1F6FB2"/>
+          </a:solidFill>
+          <a:ln w="12700">
+            <a:solidFill>
+              <a:srgbClr val="FFFFFF"/>
+            </a:solidFill>
+          </a:ln>
+          <a:effectLst/>
+        </p:spPr>
+        <p:style>
+          <a:lnRef idx="1">
+            <a:schemeClr val="accent1"/>
+          </a:lnRef>
+          <a:fillRef idx="3">
+            <a:schemeClr val="accent1"/>
+          </a:fillRef>
+          <a:effectRef idx="2">
+            <a:schemeClr val="accent1"/>
+          </a:effectRef>
+          <a:fontRef idx="minor">
+            <a:schemeClr val="lt1"/>
+          </a:fontRef>
+        </p:style>
+        <p:txBody>
+          <a:bodyPr rtlCol="0" anchor="ctr"/>
+          <a:lstStyle/>
+          <a:p>
+            <a:pPr algn="ctr"/>
+          </a:p>
+        </p:txBody>
+      </p:sp>
+      <p:sp>
+        <p:nvSpPr>
+          <p:cNvPr id="11" name="TextBox 10"/>
+          <p:cNvSpPr txBox="1"/>
+          <p:nvPr/>
+        </p:nvSpPr>
+        <p:spPr>
+          <a:xfrm>
+            <a:off x="5852160" y="1170432"/>
+            <a:ext cx="2971800" cy="420624"/>
+          </a:xfrm>
+          <a:prstGeom prst="rect">
+            <a:avLst/>
+          </a:prstGeom>
+          <a:noFill/>
+        </p:spPr>
+        <p:txBody>
+          <a:bodyPr wrap="square" anchor="ctr">
+            <a:spAutoFit/>
+          </a:bodyPr>
+          <a:lstStyle/>
+          <a:p>
+            <a:pPr algn="ctr">
+              <a:lnSpc>
+                <a:spcPct val="100000"/>
+              </a:lnSpc>
+              <a:spcAft>
+                <a:spcPts val="400"/>
+              </a:spcAft>
+            </a:pPr>
+            <a:r>
+              <a:rPr sz="1100" b="1">
+                <a:solidFill>
+                  <a:srgbClr val="FFFFFF"/>
+                </a:solidFill>
+                <a:latin typeface="Apple SD Gothic Neo"/>
+              </a:rPr>
+              <a:t>DeepSeek V4 Pro</a:t>
+            </a:r>
+          </a:p>
+        </p:txBody>
+      </p:sp>
+      <p:sp>
+        <p:nvSpPr>
+          <p:cNvPr id="12" name="Rectangle 11"/>
+          <p:cNvSpPr/>
+          <p:nvPr/>
+        </p:nvSpPr>
+        <p:spPr>
+          <a:xfrm>
+            <a:off x="8823960" y="1170432"/>
+            <a:ext cx="2926080" cy="420624"/>
+          </a:xfrm>
+          <a:prstGeom prst="rect">
+            <a:avLst/>
+          </a:prstGeom>
+          <a:solidFill>
+            <a:srgbClr val="1F6FB2"/>
+          </a:solidFill>
+          <a:ln w="12700">
+            <a:solidFill>
+              <a:srgbClr val="FFFFFF"/>
+            </a:solidFill>
+          </a:ln>
+          <a:effectLst/>
+        </p:spPr>
+        <p:style>
+          <a:lnRef idx="1">
+            <a:schemeClr val="accent1"/>
+          </a:lnRef>
+          <a:fillRef idx="3">
+            <a:schemeClr val="accent1"/>
+          </a:fillRef>
+          <a:effectRef idx="2">
+            <a:schemeClr val="accent1"/>
+          </a:effectRef>
+          <a:fontRef idx="minor">
+            <a:schemeClr val="lt1"/>
+          </a:fontRef>
+        </p:style>
+        <p:txBody>
+          <a:bodyPr rtlCol="0" anchor="ctr"/>
+          <a:lstStyle/>
+          <a:p>
+            <a:pPr algn="ctr"/>
+          </a:p>
+        </p:txBody>
+      </p:sp>
+      <p:sp>
+        <p:nvSpPr>
+          <p:cNvPr id="13" name="TextBox 12"/>
+          <p:cNvSpPr txBox="1"/>
+          <p:nvPr/>
+        </p:nvSpPr>
+        <p:spPr>
+          <a:xfrm>
+            <a:off x="8823960" y="1170432"/>
+            <a:ext cx="2926080" cy="420624"/>
+          </a:xfrm>
+          <a:prstGeom prst="rect">
+            <a:avLst/>
+          </a:prstGeom>
+          <a:noFill/>
+        </p:spPr>
+        <p:txBody>
+          <a:bodyPr wrap="square" anchor="ctr">
+            <a:spAutoFit/>
+          </a:bodyPr>
+          <a:lstStyle/>
+          <a:p>
+            <a:pPr algn="ctr">
+              <a:lnSpc>
+                <a:spcPct val="100000"/>
+              </a:lnSpc>
+              <a:spcAft>
+                <a:spcPts val="400"/>
+              </a:spcAft>
+            </a:pPr>
+            <a:r>
+              <a:rPr sz="1100" b="1">
+                <a:solidFill>
+                  <a:srgbClr val="FFFFFF"/>
+                </a:solidFill>
+                <a:latin typeface="Apple SD Gothic Neo"/>
+              </a:rPr>
+              <a:t>Qwen3.7-Max</a:t>
+            </a:r>
+          </a:p>
+        </p:txBody>
+      </p:sp>
+      <p:sp>
+        <p:nvSpPr>
+          <p:cNvPr id="14" name="Rectangle 13"/>
+          <p:cNvSpPr/>
+          <p:nvPr/>
+        </p:nvSpPr>
+        <p:spPr>
+          <a:xfrm>
+            <a:off x="457200" y="1591056"/>
+            <a:ext cx="2468880" cy="420624"/>
+          </a:xfrm>
+          <a:prstGeom prst="rect">
+            <a:avLst/>
+          </a:prstGeom>
+          <a:solidFill>
+            <a:srgbClr val="FFFFFF"/>
+          </a:solidFill>
+          <a:ln w="9525">
             <a:solidFill>
               <a:srgbClr val="D5DDE6"/>
             </a:solidFill>
@@ -15860,14 +16212,1728 @@
       </p:sp>
       <p:sp>
         <p:nvSpPr>
-          <p:cNvPr id="7" name="Rectangle 6"/>
+          <p:cNvPr id="15" name="TextBox 14"/>
+          <p:cNvSpPr txBox="1"/>
+          <p:nvPr/>
+        </p:nvSpPr>
+        <p:spPr>
+          <a:xfrm>
+            <a:off x="495300" y="1591056"/>
+            <a:ext cx="2392680" cy="420624"/>
+          </a:xfrm>
+          <a:prstGeom prst="rect">
+            <a:avLst/>
+          </a:prstGeom>
+          <a:noFill/>
+        </p:spPr>
+        <p:txBody>
+          <a:bodyPr wrap="square" anchor="ctr">
+            <a:spAutoFit/>
+          </a:bodyPr>
+          <a:lstStyle/>
+          <a:p>
+            <a:pPr algn="ctr">
+              <a:lnSpc>
+                <a:spcPct val="95000"/>
+              </a:lnSpc>
+              <a:spcAft>
+                <a:spcPts val="400"/>
+              </a:spcAft>
+            </a:pPr>
+            <a:r>
+              <a:rPr sz="1050" b="0">
+                <a:solidFill>
+                  <a:srgbClr val="444A55"/>
+                </a:solidFill>
+                <a:latin typeface="Apple SD Gothic Neo"/>
+              </a:rPr>
+              <a:t>실무 코딩 (SWE-Bench)</a:t>
+            </a:r>
+          </a:p>
+        </p:txBody>
+      </p:sp>
+      <p:sp>
+        <p:nvSpPr>
+          <p:cNvPr id="16" name="Rectangle 15"/>
           <p:cNvSpPr/>
           <p:nvPr/>
         </p:nvSpPr>
         <p:spPr>
           <a:xfrm>
-            <a:off x="502920" y="1234440"/>
-            <a:ext cx="76200" cy="2788920"/>
+            <a:off x="2926080" y="1591056"/>
+            <a:ext cx="2926080" cy="420624"/>
+          </a:xfrm>
+          <a:prstGeom prst="rect">
+            <a:avLst/>
+          </a:prstGeom>
+          <a:solidFill>
+            <a:srgbClr val="FFFFFF"/>
+          </a:solidFill>
+          <a:ln w="9525">
+            <a:solidFill>
+              <a:srgbClr val="D5DDE6"/>
+            </a:solidFill>
+          </a:ln>
+          <a:effectLst/>
+        </p:spPr>
+        <p:style>
+          <a:lnRef idx="1">
+            <a:schemeClr val="accent1"/>
+          </a:lnRef>
+          <a:fillRef idx="3">
+            <a:schemeClr val="accent1"/>
+          </a:fillRef>
+          <a:effectRef idx="2">
+            <a:schemeClr val="accent1"/>
+          </a:effectRef>
+          <a:fontRef idx="minor">
+            <a:schemeClr val="lt1"/>
+          </a:fontRef>
+        </p:style>
+        <p:txBody>
+          <a:bodyPr rtlCol="0" anchor="ctr"/>
+          <a:lstStyle/>
+          <a:p>
+            <a:pPr algn="ctr"/>
+          </a:p>
+        </p:txBody>
+      </p:sp>
+      <p:sp>
+        <p:nvSpPr>
+          <p:cNvPr id="17" name="TextBox 16"/>
+          <p:cNvSpPr txBox="1"/>
+          <p:nvPr/>
+        </p:nvSpPr>
+        <p:spPr>
+          <a:xfrm>
+            <a:off x="2964180" y="1591056"/>
+            <a:ext cx="2849880" cy="420624"/>
+          </a:xfrm>
+          <a:prstGeom prst="rect">
+            <a:avLst/>
+          </a:prstGeom>
+          <a:noFill/>
+        </p:spPr>
+        <p:txBody>
+          <a:bodyPr wrap="square" anchor="ctr">
+            <a:spAutoFit/>
+          </a:bodyPr>
+          <a:lstStyle/>
+          <a:p>
+            <a:pPr algn="ctr">
+              <a:lnSpc>
+                <a:spcPct val="95000"/>
+              </a:lnSpc>
+              <a:spcAft>
+                <a:spcPts val="400"/>
+              </a:spcAft>
+            </a:pPr>
+            <a:r>
+              <a:rPr sz="1050" b="0">
+                <a:solidFill>
+                  <a:srgbClr val="444A55"/>
+                </a:solidFill>
+                <a:latin typeface="Apple SD Gothic Neo"/>
+              </a:rPr>
+              <a:t>최상위권 (프런티어)</a:t>
+            </a:r>
+          </a:p>
+        </p:txBody>
+      </p:sp>
+      <p:sp>
+        <p:nvSpPr>
+          <p:cNvPr id="18" name="Rectangle 17"/>
+          <p:cNvSpPr/>
+          <p:nvPr/>
+        </p:nvSpPr>
+        <p:spPr>
+          <a:xfrm>
+            <a:off x="5852160" y="1591056"/>
+            <a:ext cx="2971800" cy="420624"/>
+          </a:xfrm>
+          <a:prstGeom prst="rect">
+            <a:avLst/>
+          </a:prstGeom>
+          <a:solidFill>
+            <a:srgbClr val="FFFFFF"/>
+          </a:solidFill>
+          <a:ln w="9525">
+            <a:solidFill>
+              <a:srgbClr val="D5DDE6"/>
+            </a:solidFill>
+          </a:ln>
+          <a:effectLst/>
+        </p:spPr>
+        <p:style>
+          <a:lnRef idx="1">
+            <a:schemeClr val="accent1"/>
+          </a:lnRef>
+          <a:fillRef idx="3">
+            <a:schemeClr val="accent1"/>
+          </a:fillRef>
+          <a:effectRef idx="2">
+            <a:schemeClr val="accent1"/>
+          </a:effectRef>
+          <a:fontRef idx="minor">
+            <a:schemeClr val="lt1"/>
+          </a:fontRef>
+        </p:style>
+        <p:txBody>
+          <a:bodyPr rtlCol="0" anchor="ctr"/>
+          <a:lstStyle/>
+          <a:p>
+            <a:pPr algn="ctr"/>
+          </a:p>
+        </p:txBody>
+      </p:sp>
+      <p:sp>
+        <p:nvSpPr>
+          <p:cNvPr id="19" name="TextBox 18"/>
+          <p:cNvSpPr txBox="1"/>
+          <p:nvPr/>
+        </p:nvSpPr>
+        <p:spPr>
+          <a:xfrm>
+            <a:off x="5890260" y="1591056"/>
+            <a:ext cx="2895600" cy="420624"/>
+          </a:xfrm>
+          <a:prstGeom prst="rect">
+            <a:avLst/>
+          </a:prstGeom>
+          <a:noFill/>
+        </p:spPr>
+        <p:txBody>
+          <a:bodyPr wrap="square" anchor="ctr">
+            <a:spAutoFit/>
+          </a:bodyPr>
+          <a:lstStyle/>
+          <a:p>
+            <a:pPr algn="ctr">
+              <a:lnSpc>
+                <a:spcPct val="95000"/>
+              </a:lnSpc>
+              <a:spcAft>
+                <a:spcPts val="400"/>
+              </a:spcAft>
+            </a:pPr>
+            <a:r>
+              <a:rPr sz="1050" b="0">
+                <a:solidFill>
+                  <a:srgbClr val="444A55"/>
+                </a:solidFill>
+                <a:latin typeface="Apple SD Gothic Neo"/>
+              </a:rPr>
+              <a:t>80.6% (근접)</a:t>
+            </a:r>
+          </a:p>
+        </p:txBody>
+      </p:sp>
+      <p:sp>
+        <p:nvSpPr>
+          <p:cNvPr id="20" name="Rectangle 19"/>
+          <p:cNvSpPr/>
+          <p:nvPr/>
+        </p:nvSpPr>
+        <p:spPr>
+          <a:xfrm>
+            <a:off x="8823960" y="1591056"/>
+            <a:ext cx="2926080" cy="420624"/>
+          </a:xfrm>
+          <a:prstGeom prst="rect">
+            <a:avLst/>
+          </a:prstGeom>
+          <a:solidFill>
+            <a:srgbClr val="FFFFFF"/>
+          </a:solidFill>
+          <a:ln w="9525">
+            <a:solidFill>
+              <a:srgbClr val="D5DDE6"/>
+            </a:solidFill>
+          </a:ln>
+          <a:effectLst/>
+        </p:spPr>
+        <p:style>
+          <a:lnRef idx="1">
+            <a:schemeClr val="accent1"/>
+          </a:lnRef>
+          <a:fillRef idx="3">
+            <a:schemeClr val="accent1"/>
+          </a:fillRef>
+          <a:effectRef idx="2">
+            <a:schemeClr val="accent1"/>
+          </a:effectRef>
+          <a:fontRef idx="minor">
+            <a:schemeClr val="lt1"/>
+          </a:fontRef>
+        </p:style>
+        <p:txBody>
+          <a:bodyPr rtlCol="0" anchor="ctr"/>
+          <a:lstStyle/>
+          <a:p>
+            <a:pPr algn="ctr"/>
+          </a:p>
+        </p:txBody>
+      </p:sp>
+      <p:sp>
+        <p:nvSpPr>
+          <p:cNvPr id="21" name="TextBox 20"/>
+          <p:cNvSpPr txBox="1"/>
+          <p:nvPr/>
+        </p:nvSpPr>
+        <p:spPr>
+          <a:xfrm>
+            <a:off x="8862060" y="1591056"/>
+            <a:ext cx="2849880" cy="420624"/>
+          </a:xfrm>
+          <a:prstGeom prst="rect">
+            <a:avLst/>
+          </a:prstGeom>
+          <a:noFill/>
+        </p:spPr>
+        <p:txBody>
+          <a:bodyPr wrap="square" anchor="ctr">
+            <a:spAutoFit/>
+          </a:bodyPr>
+          <a:lstStyle/>
+          <a:p>
+            <a:pPr algn="ctr">
+              <a:lnSpc>
+                <a:spcPct val="95000"/>
+              </a:lnSpc>
+              <a:spcAft>
+                <a:spcPts val="400"/>
+              </a:spcAft>
+            </a:pPr>
+            <a:r>
+              <a:rPr sz="1050" b="0">
+                <a:solidFill>
+                  <a:srgbClr val="444A55"/>
+                </a:solidFill>
+                <a:latin typeface="Apple SD Gothic Neo"/>
+              </a:rPr>
+              <a:t>Pro 60.6% · Term 69.7%</a:t>
+            </a:r>
+          </a:p>
+        </p:txBody>
+      </p:sp>
+      <p:sp>
+        <p:nvSpPr>
+          <p:cNvPr id="22" name="Rectangle 21"/>
+          <p:cNvSpPr/>
+          <p:nvPr/>
+        </p:nvSpPr>
+        <p:spPr>
+          <a:xfrm>
+            <a:off x="457200" y="2011680"/>
+            <a:ext cx="2468880" cy="420624"/>
+          </a:xfrm>
+          <a:prstGeom prst="rect">
+            <a:avLst/>
+          </a:prstGeom>
+          <a:solidFill>
+            <a:srgbClr val="E8F1FA"/>
+          </a:solidFill>
+          <a:ln w="9525">
+            <a:solidFill>
+              <a:srgbClr val="D5DDE6"/>
+            </a:solidFill>
+          </a:ln>
+          <a:effectLst/>
+        </p:spPr>
+        <p:style>
+          <a:lnRef idx="1">
+            <a:schemeClr val="accent1"/>
+          </a:lnRef>
+          <a:fillRef idx="3">
+            <a:schemeClr val="accent1"/>
+          </a:fillRef>
+          <a:effectRef idx="2">
+            <a:schemeClr val="accent1"/>
+          </a:effectRef>
+          <a:fontRef idx="minor">
+            <a:schemeClr val="lt1"/>
+          </a:fontRef>
+        </p:style>
+        <p:txBody>
+          <a:bodyPr rtlCol="0" anchor="ctr"/>
+          <a:lstStyle/>
+          <a:p>
+            <a:pPr algn="ctr"/>
+          </a:p>
+        </p:txBody>
+      </p:sp>
+      <p:sp>
+        <p:nvSpPr>
+          <p:cNvPr id="23" name="TextBox 22"/>
+          <p:cNvSpPr txBox="1"/>
+          <p:nvPr/>
+        </p:nvSpPr>
+        <p:spPr>
+          <a:xfrm>
+            <a:off x="495300" y="2011680"/>
+            <a:ext cx="2392680" cy="420624"/>
+          </a:xfrm>
+          <a:prstGeom prst="rect">
+            <a:avLst/>
+          </a:prstGeom>
+          <a:noFill/>
+        </p:spPr>
+        <p:txBody>
+          <a:bodyPr wrap="square" anchor="ctr">
+            <a:spAutoFit/>
+          </a:bodyPr>
+          <a:lstStyle/>
+          <a:p>
+            <a:pPr algn="ctr">
+              <a:lnSpc>
+                <a:spcPct val="95000"/>
+              </a:lnSpc>
+              <a:spcAft>
+                <a:spcPts val="400"/>
+              </a:spcAft>
+            </a:pPr>
+            <a:r>
+              <a:rPr sz="1050" b="0">
+                <a:solidFill>
+                  <a:srgbClr val="444A55"/>
+                </a:solidFill>
+                <a:latin typeface="Apple SD Gothic Neo"/>
+              </a:rPr>
+              <a:t>과학 추론 (GPQA)</a:t>
+            </a:r>
+          </a:p>
+        </p:txBody>
+      </p:sp>
+      <p:sp>
+        <p:nvSpPr>
+          <p:cNvPr id="24" name="Rectangle 23"/>
+          <p:cNvSpPr/>
+          <p:nvPr/>
+        </p:nvSpPr>
+        <p:spPr>
+          <a:xfrm>
+            <a:off x="2926080" y="2011680"/>
+            <a:ext cx="2926080" cy="420624"/>
+          </a:xfrm>
+          <a:prstGeom prst="rect">
+            <a:avLst/>
+          </a:prstGeom>
+          <a:solidFill>
+            <a:srgbClr val="E8F1FA"/>
+          </a:solidFill>
+          <a:ln w="9525">
+            <a:solidFill>
+              <a:srgbClr val="D5DDE6"/>
+            </a:solidFill>
+          </a:ln>
+          <a:effectLst/>
+        </p:spPr>
+        <p:style>
+          <a:lnRef idx="1">
+            <a:schemeClr val="accent1"/>
+          </a:lnRef>
+          <a:fillRef idx="3">
+            <a:schemeClr val="accent1"/>
+          </a:fillRef>
+          <a:effectRef idx="2">
+            <a:schemeClr val="accent1"/>
+          </a:effectRef>
+          <a:fontRef idx="minor">
+            <a:schemeClr val="lt1"/>
+          </a:fontRef>
+        </p:style>
+        <p:txBody>
+          <a:bodyPr rtlCol="0" anchor="ctr"/>
+          <a:lstStyle/>
+          <a:p>
+            <a:pPr algn="ctr"/>
+          </a:p>
+        </p:txBody>
+      </p:sp>
+      <p:sp>
+        <p:nvSpPr>
+          <p:cNvPr id="25" name="TextBox 24"/>
+          <p:cNvSpPr txBox="1"/>
+          <p:nvPr/>
+        </p:nvSpPr>
+        <p:spPr>
+          <a:xfrm>
+            <a:off x="2964180" y="2011680"/>
+            <a:ext cx="2849880" cy="420624"/>
+          </a:xfrm>
+          <a:prstGeom prst="rect">
+            <a:avLst/>
+          </a:prstGeom>
+          <a:noFill/>
+        </p:spPr>
+        <p:txBody>
+          <a:bodyPr wrap="square" anchor="ctr">
+            <a:spAutoFit/>
+          </a:bodyPr>
+          <a:lstStyle/>
+          <a:p>
+            <a:pPr algn="ctr">
+              <a:lnSpc>
+                <a:spcPct val="95000"/>
+              </a:lnSpc>
+              <a:spcAft>
+                <a:spcPts val="400"/>
+              </a:spcAft>
+            </a:pPr>
+            <a:r>
+              <a:rPr sz="1050" b="0">
+                <a:solidFill>
+                  <a:srgbClr val="444A55"/>
+                </a:solidFill>
+                <a:latin typeface="Apple SD Gothic Neo"/>
+              </a:rPr>
+              <a:t>상위권</a:t>
+            </a:r>
+          </a:p>
+        </p:txBody>
+      </p:sp>
+      <p:sp>
+        <p:nvSpPr>
+          <p:cNvPr id="26" name="Rectangle 25"/>
+          <p:cNvSpPr/>
+          <p:nvPr/>
+        </p:nvSpPr>
+        <p:spPr>
+          <a:xfrm>
+            <a:off x="5852160" y="2011680"/>
+            <a:ext cx="2971800" cy="420624"/>
+          </a:xfrm>
+          <a:prstGeom prst="rect">
+            <a:avLst/>
+          </a:prstGeom>
+          <a:solidFill>
+            <a:srgbClr val="E8F1FA"/>
+          </a:solidFill>
+          <a:ln w="9525">
+            <a:solidFill>
+              <a:srgbClr val="D5DDE6"/>
+            </a:solidFill>
+          </a:ln>
+          <a:effectLst/>
+        </p:spPr>
+        <p:style>
+          <a:lnRef idx="1">
+            <a:schemeClr val="accent1"/>
+          </a:lnRef>
+          <a:fillRef idx="3">
+            <a:schemeClr val="accent1"/>
+          </a:fillRef>
+          <a:effectRef idx="2">
+            <a:schemeClr val="accent1"/>
+          </a:effectRef>
+          <a:fontRef idx="minor">
+            <a:schemeClr val="lt1"/>
+          </a:fontRef>
+        </p:style>
+        <p:txBody>
+          <a:bodyPr rtlCol="0" anchor="ctr"/>
+          <a:lstStyle/>
+          <a:p>
+            <a:pPr algn="ctr"/>
+          </a:p>
+        </p:txBody>
+      </p:sp>
+      <p:sp>
+        <p:nvSpPr>
+          <p:cNvPr id="27" name="TextBox 26"/>
+          <p:cNvSpPr txBox="1"/>
+          <p:nvPr/>
+        </p:nvSpPr>
+        <p:spPr>
+          <a:xfrm>
+            <a:off x="5890260" y="2011680"/>
+            <a:ext cx="2895600" cy="420624"/>
+          </a:xfrm>
+          <a:prstGeom prst="rect">
+            <a:avLst/>
+          </a:prstGeom>
+          <a:noFill/>
+        </p:spPr>
+        <p:txBody>
+          <a:bodyPr wrap="square" anchor="ctr">
+            <a:spAutoFit/>
+          </a:bodyPr>
+          <a:lstStyle/>
+          <a:p>
+            <a:pPr algn="ctr">
+              <a:lnSpc>
+                <a:spcPct val="95000"/>
+              </a:lnSpc>
+              <a:spcAft>
+                <a:spcPts val="400"/>
+              </a:spcAft>
+            </a:pPr>
+            <a:r>
+              <a:rPr sz="1050" b="0">
+                <a:solidFill>
+                  <a:srgbClr val="444A55"/>
+                </a:solidFill>
+                <a:latin typeface="Apple SD Gothic Neo"/>
+              </a:rPr>
+              <a:t>90.1%</a:t>
+            </a:r>
+          </a:p>
+        </p:txBody>
+      </p:sp>
+      <p:sp>
+        <p:nvSpPr>
+          <p:cNvPr id="28" name="Rectangle 27"/>
+          <p:cNvSpPr/>
+          <p:nvPr/>
+        </p:nvSpPr>
+        <p:spPr>
+          <a:xfrm>
+            <a:off x="8823960" y="2011680"/>
+            <a:ext cx="2926080" cy="420624"/>
+          </a:xfrm>
+          <a:prstGeom prst="rect">
+            <a:avLst/>
+          </a:prstGeom>
+          <a:solidFill>
+            <a:srgbClr val="E8F1FA"/>
+          </a:solidFill>
+          <a:ln w="9525">
+            <a:solidFill>
+              <a:srgbClr val="D5DDE6"/>
+            </a:solidFill>
+          </a:ln>
+          <a:effectLst/>
+        </p:spPr>
+        <p:style>
+          <a:lnRef idx="1">
+            <a:schemeClr val="accent1"/>
+          </a:lnRef>
+          <a:fillRef idx="3">
+            <a:schemeClr val="accent1"/>
+          </a:fillRef>
+          <a:effectRef idx="2">
+            <a:schemeClr val="accent1"/>
+          </a:effectRef>
+          <a:fontRef idx="minor">
+            <a:schemeClr val="lt1"/>
+          </a:fontRef>
+        </p:style>
+        <p:txBody>
+          <a:bodyPr rtlCol="0" anchor="ctr"/>
+          <a:lstStyle/>
+          <a:p>
+            <a:pPr algn="ctr"/>
+          </a:p>
+        </p:txBody>
+      </p:sp>
+      <p:sp>
+        <p:nvSpPr>
+          <p:cNvPr id="29" name="TextBox 28"/>
+          <p:cNvSpPr txBox="1"/>
+          <p:nvPr/>
+        </p:nvSpPr>
+        <p:spPr>
+          <a:xfrm>
+            <a:off x="8862060" y="2011680"/>
+            <a:ext cx="2849880" cy="420624"/>
+          </a:xfrm>
+          <a:prstGeom prst="rect">
+            <a:avLst/>
+          </a:prstGeom>
+          <a:noFill/>
+        </p:spPr>
+        <p:txBody>
+          <a:bodyPr wrap="square" anchor="ctr">
+            <a:spAutoFit/>
+          </a:bodyPr>
+          <a:lstStyle/>
+          <a:p>
+            <a:pPr algn="ctr">
+              <a:lnSpc>
+                <a:spcPct val="95000"/>
+              </a:lnSpc>
+              <a:spcAft>
+                <a:spcPts val="400"/>
+              </a:spcAft>
+            </a:pPr>
+            <a:r>
+              <a:rPr sz="1050" b="0">
+                <a:solidFill>
+                  <a:srgbClr val="444A55"/>
+                </a:solidFill>
+                <a:latin typeface="Apple SD Gothic Neo"/>
+              </a:rPr>
+              <a:t>92.4% (최고급)</a:t>
+            </a:r>
+          </a:p>
+        </p:txBody>
+      </p:sp>
+      <p:sp>
+        <p:nvSpPr>
+          <p:cNvPr id="30" name="Rectangle 29"/>
+          <p:cNvSpPr/>
+          <p:nvPr/>
+        </p:nvSpPr>
+        <p:spPr>
+          <a:xfrm>
+            <a:off x="457200" y="2432304"/>
+            <a:ext cx="2468880" cy="420624"/>
+          </a:xfrm>
+          <a:prstGeom prst="rect">
+            <a:avLst/>
+          </a:prstGeom>
+          <a:solidFill>
+            <a:srgbClr val="FFFFFF"/>
+          </a:solidFill>
+          <a:ln w="9525">
+            <a:solidFill>
+              <a:srgbClr val="D5DDE6"/>
+            </a:solidFill>
+          </a:ln>
+          <a:effectLst/>
+        </p:spPr>
+        <p:style>
+          <a:lnRef idx="1">
+            <a:schemeClr val="accent1"/>
+          </a:lnRef>
+          <a:fillRef idx="3">
+            <a:schemeClr val="accent1"/>
+          </a:fillRef>
+          <a:effectRef idx="2">
+            <a:schemeClr val="accent1"/>
+          </a:effectRef>
+          <a:fontRef idx="minor">
+            <a:schemeClr val="lt1"/>
+          </a:fontRef>
+        </p:style>
+        <p:txBody>
+          <a:bodyPr rtlCol="0" anchor="ctr"/>
+          <a:lstStyle/>
+          <a:p>
+            <a:pPr algn="ctr"/>
+          </a:p>
+        </p:txBody>
+      </p:sp>
+      <p:sp>
+        <p:nvSpPr>
+          <p:cNvPr id="31" name="TextBox 30"/>
+          <p:cNvSpPr txBox="1"/>
+          <p:nvPr/>
+        </p:nvSpPr>
+        <p:spPr>
+          <a:xfrm>
+            <a:off x="495300" y="2432304"/>
+            <a:ext cx="2392680" cy="420624"/>
+          </a:xfrm>
+          <a:prstGeom prst="rect">
+            <a:avLst/>
+          </a:prstGeom>
+          <a:noFill/>
+        </p:spPr>
+        <p:txBody>
+          <a:bodyPr wrap="square" anchor="ctr">
+            <a:spAutoFit/>
+          </a:bodyPr>
+          <a:lstStyle/>
+          <a:p>
+            <a:pPr algn="ctr">
+              <a:lnSpc>
+                <a:spcPct val="95000"/>
+              </a:lnSpc>
+              <a:spcAft>
+                <a:spcPts val="400"/>
+              </a:spcAft>
+            </a:pPr>
+            <a:r>
+              <a:rPr sz="1050" b="0">
+                <a:solidFill>
+                  <a:srgbClr val="444A55"/>
+                </a:solidFill>
+                <a:latin typeface="Apple SD Gothic Neo"/>
+              </a:rPr>
+              <a:t>맥락 길이</a:t>
+            </a:r>
+          </a:p>
+        </p:txBody>
+      </p:sp>
+      <p:sp>
+        <p:nvSpPr>
+          <p:cNvPr id="32" name="Rectangle 31"/>
+          <p:cNvSpPr/>
+          <p:nvPr/>
+        </p:nvSpPr>
+        <p:spPr>
+          <a:xfrm>
+            <a:off x="2926080" y="2432304"/>
+            <a:ext cx="2926080" cy="420624"/>
+          </a:xfrm>
+          <a:prstGeom prst="rect">
+            <a:avLst/>
+          </a:prstGeom>
+          <a:solidFill>
+            <a:srgbClr val="FFFFFF"/>
+          </a:solidFill>
+          <a:ln w="9525">
+            <a:solidFill>
+              <a:srgbClr val="D5DDE6"/>
+            </a:solidFill>
+          </a:ln>
+          <a:effectLst/>
+        </p:spPr>
+        <p:style>
+          <a:lnRef idx="1">
+            <a:schemeClr val="accent1"/>
+          </a:lnRef>
+          <a:fillRef idx="3">
+            <a:schemeClr val="accent1"/>
+          </a:fillRef>
+          <a:effectRef idx="2">
+            <a:schemeClr val="accent1"/>
+          </a:effectRef>
+          <a:fontRef idx="minor">
+            <a:schemeClr val="lt1"/>
+          </a:fontRef>
+        </p:style>
+        <p:txBody>
+          <a:bodyPr rtlCol="0" anchor="ctr"/>
+          <a:lstStyle/>
+          <a:p>
+            <a:pPr algn="ctr"/>
+          </a:p>
+        </p:txBody>
+      </p:sp>
+      <p:sp>
+        <p:nvSpPr>
+          <p:cNvPr id="33" name="TextBox 32"/>
+          <p:cNvSpPr txBox="1"/>
+          <p:nvPr/>
+        </p:nvSpPr>
+        <p:spPr>
+          <a:xfrm>
+            <a:off x="2964180" y="2432304"/>
+            <a:ext cx="2849880" cy="420624"/>
+          </a:xfrm>
+          <a:prstGeom prst="rect">
+            <a:avLst/>
+          </a:prstGeom>
+          <a:noFill/>
+        </p:spPr>
+        <p:txBody>
+          <a:bodyPr wrap="square" anchor="ctr">
+            <a:spAutoFit/>
+          </a:bodyPr>
+          <a:lstStyle/>
+          <a:p>
+            <a:pPr algn="ctr">
+              <a:lnSpc>
+                <a:spcPct val="95000"/>
+              </a:lnSpc>
+              <a:spcAft>
+                <a:spcPts val="400"/>
+              </a:spcAft>
+            </a:pPr>
+            <a:r>
+              <a:rPr sz="1050" b="0">
+                <a:solidFill>
+                  <a:srgbClr val="444A55"/>
+                </a:solidFill>
+                <a:latin typeface="Apple SD Gothic Neo"/>
+              </a:rPr>
+              <a:t>수십만 토큰</a:t>
+            </a:r>
+          </a:p>
+        </p:txBody>
+      </p:sp>
+      <p:sp>
+        <p:nvSpPr>
+          <p:cNvPr id="34" name="Rectangle 33"/>
+          <p:cNvSpPr/>
+          <p:nvPr/>
+        </p:nvSpPr>
+        <p:spPr>
+          <a:xfrm>
+            <a:off x="5852160" y="2432304"/>
+            <a:ext cx="2971800" cy="420624"/>
+          </a:xfrm>
+          <a:prstGeom prst="rect">
+            <a:avLst/>
+          </a:prstGeom>
+          <a:solidFill>
+            <a:srgbClr val="FFFFFF"/>
+          </a:solidFill>
+          <a:ln w="9525">
+            <a:solidFill>
+              <a:srgbClr val="D5DDE6"/>
+            </a:solidFill>
+          </a:ln>
+          <a:effectLst/>
+        </p:spPr>
+        <p:style>
+          <a:lnRef idx="1">
+            <a:schemeClr val="accent1"/>
+          </a:lnRef>
+          <a:fillRef idx="3">
+            <a:schemeClr val="accent1"/>
+          </a:fillRef>
+          <a:effectRef idx="2">
+            <a:schemeClr val="accent1"/>
+          </a:effectRef>
+          <a:fontRef idx="minor">
+            <a:schemeClr val="lt1"/>
+          </a:fontRef>
+        </p:style>
+        <p:txBody>
+          <a:bodyPr rtlCol="0" anchor="ctr"/>
+          <a:lstStyle/>
+          <a:p>
+            <a:pPr algn="ctr"/>
+          </a:p>
+        </p:txBody>
+      </p:sp>
+      <p:sp>
+        <p:nvSpPr>
+          <p:cNvPr id="35" name="TextBox 34"/>
+          <p:cNvSpPr txBox="1"/>
+          <p:nvPr/>
+        </p:nvSpPr>
+        <p:spPr>
+          <a:xfrm>
+            <a:off x="5890260" y="2432304"/>
+            <a:ext cx="2895600" cy="420624"/>
+          </a:xfrm>
+          <a:prstGeom prst="rect">
+            <a:avLst/>
+          </a:prstGeom>
+          <a:noFill/>
+        </p:spPr>
+        <p:txBody>
+          <a:bodyPr wrap="square" anchor="ctr">
+            <a:spAutoFit/>
+          </a:bodyPr>
+          <a:lstStyle/>
+          <a:p>
+            <a:pPr algn="ctr">
+              <a:lnSpc>
+                <a:spcPct val="95000"/>
+              </a:lnSpc>
+              <a:spcAft>
+                <a:spcPts val="400"/>
+              </a:spcAft>
+            </a:pPr>
+            <a:r>
+              <a:rPr sz="1050" b="0">
+                <a:solidFill>
+                  <a:srgbClr val="444A55"/>
+                </a:solidFill>
+                <a:latin typeface="Apple SD Gothic Neo"/>
+              </a:rPr>
+              <a:t>100만 토큰</a:t>
+            </a:r>
+          </a:p>
+        </p:txBody>
+      </p:sp>
+      <p:sp>
+        <p:nvSpPr>
+          <p:cNvPr id="36" name="Rectangle 35"/>
+          <p:cNvSpPr/>
+          <p:nvPr/>
+        </p:nvSpPr>
+        <p:spPr>
+          <a:xfrm>
+            <a:off x="8823960" y="2432304"/>
+            <a:ext cx="2926080" cy="420624"/>
+          </a:xfrm>
+          <a:prstGeom prst="rect">
+            <a:avLst/>
+          </a:prstGeom>
+          <a:solidFill>
+            <a:srgbClr val="FFFFFF"/>
+          </a:solidFill>
+          <a:ln w="9525">
+            <a:solidFill>
+              <a:srgbClr val="D5DDE6"/>
+            </a:solidFill>
+          </a:ln>
+          <a:effectLst/>
+        </p:spPr>
+        <p:style>
+          <a:lnRef idx="1">
+            <a:schemeClr val="accent1"/>
+          </a:lnRef>
+          <a:fillRef idx="3">
+            <a:schemeClr val="accent1"/>
+          </a:fillRef>
+          <a:effectRef idx="2">
+            <a:schemeClr val="accent1"/>
+          </a:effectRef>
+          <a:fontRef idx="minor">
+            <a:schemeClr val="lt1"/>
+          </a:fontRef>
+        </p:style>
+        <p:txBody>
+          <a:bodyPr rtlCol="0" anchor="ctr"/>
+          <a:lstStyle/>
+          <a:p>
+            <a:pPr algn="ctr"/>
+          </a:p>
+        </p:txBody>
+      </p:sp>
+      <p:sp>
+        <p:nvSpPr>
+          <p:cNvPr id="37" name="TextBox 36"/>
+          <p:cNvSpPr txBox="1"/>
+          <p:nvPr/>
+        </p:nvSpPr>
+        <p:spPr>
+          <a:xfrm>
+            <a:off x="8862060" y="2432304"/>
+            <a:ext cx="2849880" cy="420624"/>
+          </a:xfrm>
+          <a:prstGeom prst="rect">
+            <a:avLst/>
+          </a:prstGeom>
+          <a:noFill/>
+        </p:spPr>
+        <p:txBody>
+          <a:bodyPr wrap="square" anchor="ctr">
+            <a:spAutoFit/>
+          </a:bodyPr>
+          <a:lstStyle/>
+          <a:p>
+            <a:pPr algn="ctr">
+              <a:lnSpc>
+                <a:spcPct val="95000"/>
+              </a:lnSpc>
+              <a:spcAft>
+                <a:spcPts val="400"/>
+              </a:spcAft>
+            </a:pPr>
+            <a:r>
+              <a:rPr sz="1050" b="0">
+                <a:solidFill>
+                  <a:srgbClr val="444A55"/>
+                </a:solidFill>
+                <a:latin typeface="Apple SD Gothic Neo"/>
+              </a:rPr>
+              <a:t>100만 토큰</a:t>
+            </a:r>
+          </a:p>
+        </p:txBody>
+      </p:sp>
+      <p:sp>
+        <p:nvSpPr>
+          <p:cNvPr id="38" name="Rectangle 37"/>
+          <p:cNvSpPr/>
+          <p:nvPr/>
+        </p:nvSpPr>
+        <p:spPr>
+          <a:xfrm>
+            <a:off x="457200" y="2852928"/>
+            <a:ext cx="2468880" cy="420624"/>
+          </a:xfrm>
+          <a:prstGeom prst="rect">
+            <a:avLst/>
+          </a:prstGeom>
+          <a:solidFill>
+            <a:srgbClr val="E8F1FA"/>
+          </a:solidFill>
+          <a:ln w="9525">
+            <a:solidFill>
+              <a:srgbClr val="D5DDE6"/>
+            </a:solidFill>
+          </a:ln>
+          <a:effectLst/>
+        </p:spPr>
+        <p:style>
+          <a:lnRef idx="1">
+            <a:schemeClr val="accent1"/>
+          </a:lnRef>
+          <a:fillRef idx="3">
+            <a:schemeClr val="accent1"/>
+          </a:fillRef>
+          <a:effectRef idx="2">
+            <a:schemeClr val="accent1"/>
+          </a:effectRef>
+          <a:fontRef idx="minor">
+            <a:schemeClr val="lt1"/>
+          </a:fontRef>
+        </p:style>
+        <p:txBody>
+          <a:bodyPr rtlCol="0" anchor="ctr"/>
+          <a:lstStyle/>
+          <a:p>
+            <a:pPr algn="ctr"/>
+          </a:p>
+        </p:txBody>
+      </p:sp>
+      <p:sp>
+        <p:nvSpPr>
+          <p:cNvPr id="39" name="TextBox 38"/>
+          <p:cNvSpPr txBox="1"/>
+          <p:nvPr/>
+        </p:nvSpPr>
+        <p:spPr>
+          <a:xfrm>
+            <a:off x="495300" y="2852928"/>
+            <a:ext cx="2392680" cy="420624"/>
+          </a:xfrm>
+          <a:prstGeom prst="rect">
+            <a:avLst/>
+          </a:prstGeom>
+          <a:noFill/>
+        </p:spPr>
+        <p:txBody>
+          <a:bodyPr wrap="square" anchor="ctr">
+            <a:spAutoFit/>
+          </a:bodyPr>
+          <a:lstStyle/>
+          <a:p>
+            <a:pPr algn="ctr">
+              <a:lnSpc>
+                <a:spcPct val="95000"/>
+              </a:lnSpc>
+              <a:spcAft>
+                <a:spcPts val="400"/>
+              </a:spcAft>
+            </a:pPr>
+            <a:r>
+              <a:rPr sz="1050" b="0">
+                <a:solidFill>
+                  <a:srgbClr val="444A55"/>
+                </a:solidFill>
+                <a:latin typeface="Apple SD Gothic Neo"/>
+              </a:rPr>
+              <a:t>출력 비용</a:t>
+            </a:r>
+          </a:p>
+        </p:txBody>
+      </p:sp>
+      <p:sp>
+        <p:nvSpPr>
+          <p:cNvPr id="40" name="Rectangle 39"/>
+          <p:cNvSpPr/>
+          <p:nvPr/>
+        </p:nvSpPr>
+        <p:spPr>
+          <a:xfrm>
+            <a:off x="2926080" y="2852928"/>
+            <a:ext cx="2926080" cy="420624"/>
+          </a:xfrm>
+          <a:prstGeom prst="rect">
+            <a:avLst/>
+          </a:prstGeom>
+          <a:solidFill>
+            <a:srgbClr val="E8F1FA"/>
+          </a:solidFill>
+          <a:ln w="9525">
+            <a:solidFill>
+              <a:srgbClr val="D5DDE6"/>
+            </a:solidFill>
+          </a:ln>
+          <a:effectLst/>
+        </p:spPr>
+        <p:style>
+          <a:lnRef idx="1">
+            <a:schemeClr val="accent1"/>
+          </a:lnRef>
+          <a:fillRef idx="3">
+            <a:schemeClr val="accent1"/>
+          </a:fillRef>
+          <a:effectRef idx="2">
+            <a:schemeClr val="accent1"/>
+          </a:effectRef>
+          <a:fontRef idx="minor">
+            <a:schemeClr val="lt1"/>
+          </a:fontRef>
+        </p:style>
+        <p:txBody>
+          <a:bodyPr rtlCol="0" anchor="ctr"/>
+          <a:lstStyle/>
+          <a:p>
+            <a:pPr algn="ctr"/>
+          </a:p>
+        </p:txBody>
+      </p:sp>
+      <p:sp>
+        <p:nvSpPr>
+          <p:cNvPr id="41" name="TextBox 40"/>
+          <p:cNvSpPr txBox="1"/>
+          <p:nvPr/>
+        </p:nvSpPr>
+        <p:spPr>
+          <a:xfrm>
+            <a:off x="2964180" y="2852928"/>
+            <a:ext cx="2849880" cy="420624"/>
+          </a:xfrm>
+          <a:prstGeom prst="rect">
+            <a:avLst/>
+          </a:prstGeom>
+          <a:noFill/>
+        </p:spPr>
+        <p:txBody>
+          <a:bodyPr wrap="square" anchor="ctr">
+            <a:spAutoFit/>
+          </a:bodyPr>
+          <a:lstStyle/>
+          <a:p>
+            <a:pPr algn="ctr">
+              <a:lnSpc>
+                <a:spcPct val="95000"/>
+              </a:lnSpc>
+              <a:spcAft>
+                <a:spcPts val="400"/>
+              </a:spcAft>
+            </a:pPr>
+            <a:r>
+              <a:rPr sz="1050" b="0">
+                <a:solidFill>
+                  <a:srgbClr val="444A55"/>
+                </a:solidFill>
+                <a:latin typeface="Apple SD Gothic Neo"/>
+              </a:rPr>
+              <a:t>기준 (1x)</a:t>
+            </a:r>
+          </a:p>
+        </p:txBody>
+      </p:sp>
+      <p:sp>
+        <p:nvSpPr>
+          <p:cNvPr id="42" name="Rectangle 41"/>
+          <p:cNvSpPr/>
+          <p:nvPr/>
+        </p:nvSpPr>
+        <p:spPr>
+          <a:xfrm>
+            <a:off x="5852160" y="2852928"/>
+            <a:ext cx="2971800" cy="420624"/>
+          </a:xfrm>
+          <a:prstGeom prst="rect">
+            <a:avLst/>
+          </a:prstGeom>
+          <a:solidFill>
+            <a:srgbClr val="E8F1FA"/>
+          </a:solidFill>
+          <a:ln w="9525">
+            <a:solidFill>
+              <a:srgbClr val="D5DDE6"/>
+            </a:solidFill>
+          </a:ln>
+          <a:effectLst/>
+        </p:spPr>
+        <p:style>
+          <a:lnRef idx="1">
+            <a:schemeClr val="accent1"/>
+          </a:lnRef>
+          <a:fillRef idx="3">
+            <a:schemeClr val="accent1"/>
+          </a:fillRef>
+          <a:effectRef idx="2">
+            <a:schemeClr val="accent1"/>
+          </a:effectRef>
+          <a:fontRef idx="minor">
+            <a:schemeClr val="lt1"/>
+          </a:fontRef>
+        </p:style>
+        <p:txBody>
+          <a:bodyPr rtlCol="0" anchor="ctr"/>
+          <a:lstStyle/>
+          <a:p>
+            <a:pPr algn="ctr"/>
+          </a:p>
+        </p:txBody>
+      </p:sp>
+      <p:sp>
+        <p:nvSpPr>
+          <p:cNvPr id="43" name="TextBox 42"/>
+          <p:cNvSpPr txBox="1"/>
+          <p:nvPr/>
+        </p:nvSpPr>
+        <p:spPr>
+          <a:xfrm>
+            <a:off x="5890260" y="2852928"/>
+            <a:ext cx="2895600" cy="420624"/>
+          </a:xfrm>
+          <a:prstGeom prst="rect">
+            <a:avLst/>
+          </a:prstGeom>
+          <a:noFill/>
+        </p:spPr>
+        <p:txBody>
+          <a:bodyPr wrap="square" anchor="ctr">
+            <a:spAutoFit/>
+          </a:bodyPr>
+          <a:lstStyle/>
+          <a:p>
+            <a:pPr algn="ctr">
+              <a:lnSpc>
+                <a:spcPct val="95000"/>
+              </a:lnSpc>
+              <a:spcAft>
+                <a:spcPts val="400"/>
+              </a:spcAft>
+            </a:pPr>
+            <a:r>
+              <a:rPr sz="1050" b="0">
+                <a:solidFill>
+                  <a:srgbClr val="444A55"/>
+                </a:solidFill>
+                <a:latin typeface="Apple SD Gothic Neo"/>
+              </a:rPr>
+              <a:t>약 1/34 수준</a:t>
+            </a:r>
+          </a:p>
+        </p:txBody>
+      </p:sp>
+      <p:sp>
+        <p:nvSpPr>
+          <p:cNvPr id="44" name="Rectangle 43"/>
+          <p:cNvSpPr/>
+          <p:nvPr/>
+        </p:nvSpPr>
+        <p:spPr>
+          <a:xfrm>
+            <a:off x="8823960" y="2852928"/>
+            <a:ext cx="2926080" cy="420624"/>
+          </a:xfrm>
+          <a:prstGeom prst="rect">
+            <a:avLst/>
+          </a:prstGeom>
+          <a:solidFill>
+            <a:srgbClr val="E8F1FA"/>
+          </a:solidFill>
+          <a:ln w="9525">
+            <a:solidFill>
+              <a:srgbClr val="D5DDE6"/>
+            </a:solidFill>
+          </a:ln>
+          <a:effectLst/>
+        </p:spPr>
+        <p:style>
+          <a:lnRef idx="1">
+            <a:schemeClr val="accent1"/>
+          </a:lnRef>
+          <a:fillRef idx="3">
+            <a:schemeClr val="accent1"/>
+          </a:fillRef>
+          <a:effectRef idx="2">
+            <a:schemeClr val="accent1"/>
+          </a:effectRef>
+          <a:fontRef idx="minor">
+            <a:schemeClr val="lt1"/>
+          </a:fontRef>
+        </p:style>
+        <p:txBody>
+          <a:bodyPr rtlCol="0" anchor="ctr"/>
+          <a:lstStyle/>
+          <a:p>
+            <a:pPr algn="ctr"/>
+          </a:p>
+        </p:txBody>
+      </p:sp>
+      <p:sp>
+        <p:nvSpPr>
+          <p:cNvPr id="45" name="TextBox 44"/>
+          <p:cNvSpPr txBox="1"/>
+          <p:nvPr/>
+        </p:nvSpPr>
+        <p:spPr>
+          <a:xfrm>
+            <a:off x="8862060" y="2852928"/>
+            <a:ext cx="2849880" cy="420624"/>
+          </a:xfrm>
+          <a:prstGeom prst="rect">
+            <a:avLst/>
+          </a:prstGeom>
+          <a:noFill/>
+        </p:spPr>
+        <p:txBody>
+          <a:bodyPr wrap="square" anchor="ctr">
+            <a:spAutoFit/>
+          </a:bodyPr>
+          <a:lstStyle/>
+          <a:p>
+            <a:pPr algn="ctr">
+              <a:lnSpc>
+                <a:spcPct val="95000"/>
+              </a:lnSpc>
+              <a:spcAft>
+                <a:spcPts val="400"/>
+              </a:spcAft>
+            </a:pPr>
+            <a:r>
+              <a:rPr sz="1050" b="0">
+                <a:solidFill>
+                  <a:srgbClr val="444A55"/>
+                </a:solidFill>
+                <a:latin typeface="Apple SD Gothic Neo"/>
+              </a:rPr>
+              <a:t>ChatGPT보다 저렴</a:t>
+            </a:r>
+          </a:p>
+        </p:txBody>
+      </p:sp>
+      <p:sp>
+        <p:nvSpPr>
+          <p:cNvPr id="46" name="Rectangle 45"/>
+          <p:cNvSpPr/>
+          <p:nvPr/>
+        </p:nvSpPr>
+        <p:spPr>
+          <a:xfrm>
+            <a:off x="457200" y="3273552"/>
+            <a:ext cx="2468880" cy="420624"/>
+          </a:xfrm>
+          <a:prstGeom prst="rect">
+            <a:avLst/>
+          </a:prstGeom>
+          <a:solidFill>
+            <a:srgbClr val="FFFFFF"/>
+          </a:solidFill>
+          <a:ln w="9525">
+            <a:solidFill>
+              <a:srgbClr val="D5DDE6"/>
+            </a:solidFill>
+          </a:ln>
+          <a:effectLst/>
+        </p:spPr>
+        <p:style>
+          <a:lnRef idx="1">
+            <a:schemeClr val="accent1"/>
+          </a:lnRef>
+          <a:fillRef idx="3">
+            <a:schemeClr val="accent1"/>
+          </a:fillRef>
+          <a:effectRef idx="2">
+            <a:schemeClr val="accent1"/>
+          </a:effectRef>
+          <a:fontRef idx="minor">
+            <a:schemeClr val="lt1"/>
+          </a:fontRef>
+        </p:style>
+        <p:txBody>
+          <a:bodyPr rtlCol="0" anchor="ctr"/>
+          <a:lstStyle/>
+          <a:p>
+            <a:pPr algn="ctr"/>
+          </a:p>
+        </p:txBody>
+      </p:sp>
+      <p:sp>
+        <p:nvSpPr>
+          <p:cNvPr id="47" name="TextBox 46"/>
+          <p:cNvSpPr txBox="1"/>
+          <p:nvPr/>
+        </p:nvSpPr>
+        <p:spPr>
+          <a:xfrm>
+            <a:off x="495300" y="3273552"/>
+            <a:ext cx="2392680" cy="420624"/>
+          </a:xfrm>
+          <a:prstGeom prst="rect">
+            <a:avLst/>
+          </a:prstGeom>
+          <a:noFill/>
+        </p:spPr>
+        <p:txBody>
+          <a:bodyPr wrap="square" anchor="ctr">
+            <a:spAutoFit/>
+          </a:bodyPr>
+          <a:lstStyle/>
+          <a:p>
+            <a:pPr algn="ctr">
+              <a:lnSpc>
+                <a:spcPct val="95000"/>
+              </a:lnSpc>
+              <a:spcAft>
+                <a:spcPts val="400"/>
+              </a:spcAft>
+            </a:pPr>
+            <a:r>
+              <a:rPr sz="1050" b="0">
+                <a:solidFill>
+                  <a:srgbClr val="444A55"/>
+                </a:solidFill>
+                <a:latin typeface="Apple SD Gothic Neo"/>
+              </a:rPr>
+              <a:t>라이선스</a:t>
+            </a:r>
+          </a:p>
+        </p:txBody>
+      </p:sp>
+      <p:sp>
+        <p:nvSpPr>
+          <p:cNvPr id="48" name="Rectangle 47"/>
+          <p:cNvSpPr/>
+          <p:nvPr/>
+        </p:nvSpPr>
+        <p:spPr>
+          <a:xfrm>
+            <a:off x="2926080" y="3273552"/>
+            <a:ext cx="2926080" cy="420624"/>
+          </a:xfrm>
+          <a:prstGeom prst="rect">
+            <a:avLst/>
+          </a:prstGeom>
+          <a:solidFill>
+            <a:srgbClr val="FFFFFF"/>
+          </a:solidFill>
+          <a:ln w="9525">
+            <a:solidFill>
+              <a:srgbClr val="D5DDE6"/>
+            </a:solidFill>
+          </a:ln>
+          <a:effectLst/>
+        </p:spPr>
+        <p:style>
+          <a:lnRef idx="1">
+            <a:schemeClr val="accent1"/>
+          </a:lnRef>
+          <a:fillRef idx="3">
+            <a:schemeClr val="accent1"/>
+          </a:fillRef>
+          <a:effectRef idx="2">
+            <a:schemeClr val="accent1"/>
+          </a:effectRef>
+          <a:fontRef idx="minor">
+            <a:schemeClr val="lt1"/>
+          </a:fontRef>
+        </p:style>
+        <p:txBody>
+          <a:bodyPr rtlCol="0" anchor="ctr"/>
+          <a:lstStyle/>
+          <a:p>
+            <a:pPr algn="ctr"/>
+          </a:p>
+        </p:txBody>
+      </p:sp>
+      <p:sp>
+        <p:nvSpPr>
+          <p:cNvPr id="49" name="TextBox 48"/>
+          <p:cNvSpPr txBox="1"/>
+          <p:nvPr/>
+        </p:nvSpPr>
+        <p:spPr>
+          <a:xfrm>
+            <a:off x="2964180" y="3273552"/>
+            <a:ext cx="2849880" cy="420624"/>
+          </a:xfrm>
+          <a:prstGeom prst="rect">
+            <a:avLst/>
+          </a:prstGeom>
+          <a:noFill/>
+        </p:spPr>
+        <p:txBody>
+          <a:bodyPr wrap="square" anchor="ctr">
+            <a:spAutoFit/>
+          </a:bodyPr>
+          <a:lstStyle/>
+          <a:p>
+            <a:pPr algn="ctr">
+              <a:lnSpc>
+                <a:spcPct val="95000"/>
+              </a:lnSpc>
+              <a:spcAft>
+                <a:spcPts val="400"/>
+              </a:spcAft>
+            </a:pPr>
+            <a:r>
+              <a:rPr sz="1050" b="0">
+                <a:solidFill>
+                  <a:srgbClr val="444A55"/>
+                </a:solidFill>
+                <a:latin typeface="Apple SD Gothic Neo"/>
+              </a:rPr>
+              <a:t>클로즈드 API</a:t>
+            </a:r>
+          </a:p>
+        </p:txBody>
+      </p:sp>
+      <p:sp>
+        <p:nvSpPr>
+          <p:cNvPr id="50" name="Rectangle 49"/>
+          <p:cNvSpPr/>
+          <p:nvPr/>
+        </p:nvSpPr>
+        <p:spPr>
+          <a:xfrm>
+            <a:off x="5852160" y="3273552"/>
+            <a:ext cx="2971800" cy="420624"/>
+          </a:xfrm>
+          <a:prstGeom prst="rect">
+            <a:avLst/>
+          </a:prstGeom>
+          <a:solidFill>
+            <a:srgbClr val="FFFFFF"/>
+          </a:solidFill>
+          <a:ln w="9525">
+            <a:solidFill>
+              <a:srgbClr val="D5DDE6"/>
+            </a:solidFill>
+          </a:ln>
+          <a:effectLst/>
+        </p:spPr>
+        <p:style>
+          <a:lnRef idx="1">
+            <a:schemeClr val="accent1"/>
+          </a:lnRef>
+          <a:fillRef idx="3">
+            <a:schemeClr val="accent1"/>
+          </a:fillRef>
+          <a:effectRef idx="2">
+            <a:schemeClr val="accent1"/>
+          </a:effectRef>
+          <a:fontRef idx="minor">
+            <a:schemeClr val="lt1"/>
+          </a:fontRef>
+        </p:style>
+        <p:txBody>
+          <a:bodyPr rtlCol="0" anchor="ctr"/>
+          <a:lstStyle/>
+          <a:p>
+            <a:pPr algn="ctr"/>
+          </a:p>
+        </p:txBody>
+      </p:sp>
+      <p:sp>
+        <p:nvSpPr>
+          <p:cNvPr id="51" name="TextBox 50"/>
+          <p:cNvSpPr txBox="1"/>
+          <p:nvPr/>
+        </p:nvSpPr>
+        <p:spPr>
+          <a:xfrm>
+            <a:off x="5890260" y="3273552"/>
+            <a:ext cx="2895600" cy="420624"/>
+          </a:xfrm>
+          <a:prstGeom prst="rect">
+            <a:avLst/>
+          </a:prstGeom>
+          <a:noFill/>
+        </p:spPr>
+        <p:txBody>
+          <a:bodyPr wrap="square" anchor="ctr">
+            <a:spAutoFit/>
+          </a:bodyPr>
+          <a:lstStyle/>
+          <a:p>
+            <a:pPr algn="ctr">
+              <a:lnSpc>
+                <a:spcPct val="95000"/>
+              </a:lnSpc>
+              <a:spcAft>
+                <a:spcPts val="400"/>
+              </a:spcAft>
+            </a:pPr>
+            <a:r>
+              <a:rPr sz="1050" b="0">
+                <a:solidFill>
+                  <a:srgbClr val="444A55"/>
+                </a:solidFill>
+                <a:latin typeface="Apple SD Gothic Neo"/>
+              </a:rPr>
+              <a:t>오픈웨이트 (MIT)</a:t>
+            </a:r>
+          </a:p>
+        </p:txBody>
+      </p:sp>
+      <p:sp>
+        <p:nvSpPr>
+          <p:cNvPr id="52" name="Rectangle 51"/>
+          <p:cNvSpPr/>
+          <p:nvPr/>
+        </p:nvSpPr>
+        <p:spPr>
+          <a:xfrm>
+            <a:off x="8823960" y="3273552"/>
+            <a:ext cx="2926080" cy="420624"/>
+          </a:xfrm>
+          <a:prstGeom prst="rect">
+            <a:avLst/>
+          </a:prstGeom>
+          <a:solidFill>
+            <a:srgbClr val="FFFFFF"/>
+          </a:solidFill>
+          <a:ln w="9525">
+            <a:solidFill>
+              <a:srgbClr val="D5DDE6"/>
+            </a:solidFill>
+          </a:ln>
+          <a:effectLst/>
+        </p:spPr>
+        <p:style>
+          <a:lnRef idx="1">
+            <a:schemeClr val="accent1"/>
+          </a:lnRef>
+          <a:fillRef idx="3">
+            <a:schemeClr val="accent1"/>
+          </a:fillRef>
+          <a:effectRef idx="2">
+            <a:schemeClr val="accent1"/>
+          </a:effectRef>
+          <a:fontRef idx="minor">
+            <a:schemeClr val="lt1"/>
+          </a:fontRef>
+        </p:style>
+        <p:txBody>
+          <a:bodyPr rtlCol="0" anchor="ctr"/>
+          <a:lstStyle/>
+          <a:p>
+            <a:pPr algn="ctr"/>
+          </a:p>
+        </p:txBody>
+      </p:sp>
+      <p:sp>
+        <p:nvSpPr>
+          <p:cNvPr id="53" name="TextBox 52"/>
+          <p:cNvSpPr txBox="1"/>
+          <p:nvPr/>
+        </p:nvSpPr>
+        <p:spPr>
+          <a:xfrm>
+            <a:off x="8862060" y="3273552"/>
+            <a:ext cx="2849880" cy="420624"/>
+          </a:xfrm>
+          <a:prstGeom prst="rect">
+            <a:avLst/>
+          </a:prstGeom>
+          <a:noFill/>
+        </p:spPr>
+        <p:txBody>
+          <a:bodyPr wrap="square" anchor="ctr">
+            <a:spAutoFit/>
+          </a:bodyPr>
+          <a:lstStyle/>
+          <a:p>
+            <a:pPr algn="ctr">
+              <a:lnSpc>
+                <a:spcPct val="95000"/>
+              </a:lnSpc>
+              <a:spcAft>
+                <a:spcPts val="400"/>
+              </a:spcAft>
+            </a:pPr>
+            <a:r>
+              <a:rPr sz="1050" b="0">
+                <a:solidFill>
+                  <a:srgbClr val="444A55"/>
+                </a:solidFill>
+                <a:latin typeface="Apple SD Gothic Neo"/>
+              </a:rPr>
+              <a:t>클로즈드 API</a:t>
+            </a:r>
+          </a:p>
+        </p:txBody>
+      </p:sp>
+      <p:sp>
+        <p:nvSpPr>
+          <p:cNvPr id="54" name="Rectangle 53"/>
+          <p:cNvSpPr/>
+          <p:nvPr/>
+        </p:nvSpPr>
+        <p:spPr>
+          <a:xfrm>
+            <a:off x="457200" y="3822191"/>
+            <a:ext cx="63500" cy="292608"/>
           </a:xfrm>
           <a:prstGeom prst="rect">
             <a:avLst/>
@@ -15904,14 +17970,14 @@
       </p:sp>
       <p:sp>
         <p:nvSpPr>
-          <p:cNvPr id="8" name="TextBox 7"/>
-          <p:cNvSpPr txBox="1"/>
-          <p:nvPr/>
-        </p:nvSpPr>
-        <p:spPr>
-          <a:xfrm>
-            <a:off x="685800" y="1325880"/>
-            <a:ext cx="5120640" cy="320040"/>
+          <p:cNvPr id="55" name="TextBox 54"/>
+          <p:cNvSpPr txBox="1"/>
+          <p:nvPr/>
+        </p:nvSpPr>
+        <p:spPr>
+          <a:xfrm>
+            <a:off x="566928" y="3803903"/>
+            <a:ext cx="10972800" cy="329184"/>
           </a:xfrm>
           <a:prstGeom prst="rect">
             <a:avLst/>
@@ -15933,27 +17999,27 @@
               </a:spcAft>
             </a:pPr>
             <a:r>
-              <a:rPr sz="1300" b="1">
-                <a:solidFill>
-                  <a:srgbClr val="1F6FB2"/>
-                </a:solidFill>
-                <a:latin typeface="Apple SD Gothic Neo"/>
-              </a:rPr>
-              <a:t>DeepSeek V4 Pro (오픈웨이트·MIT)</a:t>
-            </a:r>
-          </a:p>
-        </p:txBody>
-      </p:sp>
-      <p:sp>
-        <p:nvSpPr>
-          <p:cNvPr id="9" name="TextBox 8"/>
-          <p:cNvSpPr txBox="1"/>
-          <p:nvPr/>
-        </p:nvSpPr>
-        <p:spPr>
-          <a:xfrm>
-            <a:off x="731520" y="1673352"/>
-            <a:ext cx="5074920" cy="347472"/>
+              <a:rPr sz="1450" b="1">
+                <a:solidFill>
+                  <a:srgbClr val="142A4A"/>
+                </a:solidFill>
+                <a:latin typeface="Apple SD Gothic Neo"/>
+              </a:rPr>
+              <a:t>ChatGPT 대비 결과물 차이 (실사용 평가)</a:t>
+            </a:r>
+          </a:p>
+        </p:txBody>
+      </p:sp>
+      <p:sp>
+        <p:nvSpPr>
+          <p:cNvPr id="56" name="TextBox 55"/>
+          <p:cNvSpPr txBox="1"/>
+          <p:nvPr/>
+        </p:nvSpPr>
+        <p:spPr>
+          <a:xfrm>
+            <a:off x="566928" y="4206240"/>
+            <a:ext cx="11155680" cy="1143000"/>
           </a:xfrm>
           <a:prstGeom prst="rect">
             <a:avLst/>
@@ -15968,10 +18034,10 @@
           <a:p>
             <a:pPr algn="l">
               <a:lnSpc>
-                <a:spcPct val="100000"/>
-              </a:lnSpc>
-              <a:spcAft>
-                <a:spcPts val="400"/>
+                <a:spcPct val="118000"/>
+              </a:lnSpc>
+              <a:spcAft>
+                <a:spcPts val="300"/>
               </a:spcAft>
             </a:pPr>
             <a:r>
@@ -15981,39 +18047,16 @@
                 </a:solidFill>
                 <a:latin typeface="Apple SD Gothic Neo"/>
               </a:rPr>
-              <a:t>• 오픈웨이트(MIT)·1M 맥락 → 자체 호스팅 가능</a:t>
-            </a:r>
-          </a:p>
-        </p:txBody>
-      </p:sp>
-      <p:sp>
-        <p:nvSpPr>
-          <p:cNvPr id="10" name="TextBox 9"/>
-          <p:cNvSpPr txBox="1"/>
-          <p:nvPr/>
-        </p:nvSpPr>
-        <p:spPr>
-          <a:xfrm>
-            <a:off x="731520" y="2039112"/>
-            <a:ext cx="5074920" cy="347472"/>
-          </a:xfrm>
-          <a:prstGeom prst="rect">
-            <a:avLst/>
-          </a:prstGeom>
-          <a:noFill/>
-        </p:spPr>
-        <p:txBody>
-          <a:bodyPr wrap="square" anchor="t">
-            <a:spAutoFit/>
-          </a:bodyPr>
-          <a:lstStyle/>
+              <a:t>• 코드: ChatGPT는 설명·주석이 친절한 범용형 / DeepSeek은 간결·고효율 코드와 수학·알고리즘 우위 / Qwen은 장기 에이전트·멀티스텝 일관성</a:t>
+            </a:r>
+          </a:p>
           <a:p>
             <a:pPr algn="l">
               <a:lnSpc>
-                <a:spcPct val="100000"/>
-              </a:lnSpc>
-              <a:spcAft>
-                <a:spcPts val="400"/>
+                <a:spcPct val="118000"/>
+              </a:lnSpc>
+              <a:spcAft>
+                <a:spcPts val="300"/>
               </a:spcAft>
             </a:pPr>
             <a:r>
@@ -16023,39 +18066,16 @@
                 </a:solidFill>
                 <a:latin typeface="Apple SD Gothic Neo"/>
               </a:rPr>
-              <a:t>• 코딩·수학 최강 오픈모델: LiveCodeBench 93.5%, SWE-Bench Verified 80.6%</a:t>
-            </a:r>
-          </a:p>
-        </p:txBody>
-      </p:sp>
-      <p:sp>
-        <p:nvSpPr>
-          <p:cNvPr id="11" name="TextBox 10"/>
-          <p:cNvSpPr txBox="1"/>
-          <p:nvPr/>
-        </p:nvSpPr>
-        <p:spPr>
-          <a:xfrm>
-            <a:off x="731520" y="2404872"/>
-            <a:ext cx="5074920" cy="347472"/>
-          </a:xfrm>
-          <a:prstGeom prst="rect">
-            <a:avLst/>
-          </a:prstGeom>
-          <a:noFill/>
-        </p:spPr>
-        <p:txBody>
-          <a:bodyPr wrap="square" anchor="t">
-            <a:spAutoFit/>
-          </a:bodyPr>
-          <a:lstStyle/>
+              <a:t>• 한국어·문장: ChatGPT가 자연스러움·맥락 유지에서 우위 / 중국 모델은 영어·중국어가 강하고 한국어 미세 표현은 상대적 약세 가능</a:t>
+            </a:r>
+          </a:p>
           <a:p>
             <a:pPr algn="l">
               <a:lnSpc>
-                <a:spcPct val="100000"/>
-              </a:lnSpc>
-              <a:spcAft>
-                <a:spcPts val="400"/>
+                <a:spcPct val="118000"/>
+              </a:lnSpc>
+              <a:spcAft>
+                <a:spcPts val="300"/>
               </a:spcAft>
             </a:pPr>
             <a:r>
@@ -16065,73 +18085,31 @@
                 </a:solidFill>
                 <a:latin typeface="Apple SD Gothic Neo"/>
               </a:rPr>
-              <a:t>• 출력 비용 GPT-5.5 대비 약 1/34 ($0.44/$0.87 per M)</a:t>
-            </a:r>
-          </a:p>
-        </p:txBody>
-      </p:sp>
-      <p:sp>
-        <p:nvSpPr>
-          <p:cNvPr id="12" name="TextBox 11"/>
-          <p:cNvSpPr txBox="1"/>
-          <p:nvPr/>
-        </p:nvSpPr>
-        <p:spPr>
-          <a:xfrm>
-            <a:off x="731520" y="2770632"/>
-            <a:ext cx="5074920" cy="347472"/>
-          </a:xfrm>
-          <a:prstGeom prst="rect">
-            <a:avLst/>
-          </a:prstGeom>
-          <a:noFill/>
-        </p:spPr>
-        <p:txBody>
-          <a:bodyPr wrap="square" anchor="t">
-            <a:spAutoFit/>
-          </a:bodyPr>
-          <a:lstStyle/>
-          <a:p>
-            <a:pPr algn="l">
-              <a:lnSpc>
-                <a:spcPct val="100000"/>
-              </a:lnSpc>
-              <a:spcAft>
-                <a:spcPts val="400"/>
-              </a:spcAft>
-            </a:pPr>
-            <a:r>
-              <a:rPr sz="1100" b="0">
-                <a:solidFill>
-                  <a:srgbClr val="444A55"/>
-                </a:solidFill>
-                <a:latin typeface="Apple SD Gothic Neo"/>
-              </a:rPr>
-              <a:t>• 평가: '가성비 1위', 수학·코드 특화 / BenchLM 중국모델 1위(88점)</a:t>
-            </a:r>
-          </a:p>
-        </p:txBody>
-      </p:sp>
-      <p:sp>
-        <p:nvSpPr>
-          <p:cNvPr id="13" name="Rounded Rectangle 12"/>
+              <a:t>• 안정성: ChatGPT는 생태계·안전장치가 성숙 / 중국 모델은 환각률 개선(Qwen 22.9%)이나 정책·검열 편향 가능성</a:t>
+            </a:r>
+          </a:p>
+        </p:txBody>
+      </p:sp>
+      <p:sp>
+        <p:nvSpPr>
+          <p:cNvPr id="57" name="Rounded Rectangle 56"/>
           <p:cNvSpPr/>
           <p:nvPr/>
         </p:nvSpPr>
         <p:spPr>
           <a:xfrm>
-            <a:off x="6172200" y="1234440"/>
-            <a:ext cx="5532120" cy="2788920"/>
+            <a:off x="457200" y="5440680"/>
+            <a:ext cx="11292840" cy="868680"/>
           </a:xfrm>
           <a:prstGeom prst="roundRect">
             <a:avLst/>
           </a:prstGeom>
           <a:solidFill>
-            <a:srgbClr val="E8F1FA"/>
+            <a:srgbClr val="FEF1E6"/>
           </a:solidFill>
-          <a:ln w="12700">
+          <a:ln w="15240">
             <a:solidFill>
-              <a:srgbClr val="D5DDE6"/>
+              <a:srgbClr val="F27E2E"/>
             </a:solidFill>
           </a:ln>
           <a:effectLst/>
@@ -16160,118 +18138,51 @@
       </p:sp>
       <p:sp>
         <p:nvSpPr>
-          <p:cNvPr id="14" name="Rectangle 13"/>
-          <p:cNvSpPr/>
-          <p:nvPr/>
-        </p:nvSpPr>
-        <p:spPr>
-          <a:xfrm>
-            <a:off x="6172200" y="1234440"/>
-            <a:ext cx="76200" cy="2788920"/>
-          </a:xfrm>
-          <a:prstGeom prst="rect">
-            <a:avLst/>
-          </a:prstGeom>
-          <a:solidFill>
-            <a:srgbClr val="F27E2E"/>
-          </a:solidFill>
-          <a:ln>
-            <a:noFill/>
-          </a:ln>
-          <a:effectLst/>
-        </p:spPr>
-        <p:style>
-          <a:lnRef idx="1">
-            <a:schemeClr val="accent1"/>
-          </a:lnRef>
-          <a:fillRef idx="3">
-            <a:schemeClr val="accent1"/>
-          </a:fillRef>
-          <a:effectRef idx="2">
-            <a:schemeClr val="accent1"/>
-          </a:effectRef>
-          <a:fontRef idx="minor">
-            <a:schemeClr val="lt1"/>
-          </a:fontRef>
-        </p:style>
-        <p:txBody>
-          <a:bodyPr rtlCol="0" anchor="ctr"/>
-          <a:lstStyle/>
-          <a:p>
-            <a:pPr algn="ctr"/>
-          </a:p>
-        </p:txBody>
-      </p:sp>
-      <p:sp>
-        <p:nvSpPr>
-          <p:cNvPr id="15" name="TextBox 14"/>
-          <p:cNvSpPr txBox="1"/>
-          <p:nvPr/>
-        </p:nvSpPr>
-        <p:spPr>
-          <a:xfrm>
-            <a:off x="6355080" y="1325880"/>
-            <a:ext cx="5166360" cy="320040"/>
-          </a:xfrm>
-          <a:prstGeom prst="rect">
-            <a:avLst/>
-          </a:prstGeom>
-          <a:noFill/>
-        </p:spPr>
-        <p:txBody>
-          <a:bodyPr wrap="square" anchor="t">
-            <a:spAutoFit/>
-          </a:bodyPr>
-          <a:lstStyle/>
-          <a:p>
-            <a:pPr algn="l">
-              <a:lnSpc>
-                <a:spcPct val="100000"/>
-              </a:lnSpc>
-              <a:spcAft>
-                <a:spcPts val="400"/>
-              </a:spcAft>
-            </a:pPr>
-            <a:r>
-              <a:rPr sz="1300" b="1">
-                <a:solidFill>
-                  <a:srgbClr val="F27E2E"/>
-                </a:solidFill>
-                <a:latin typeface="Apple SD Gothic Neo"/>
-              </a:rPr>
-              <a:t>Qwen3.7-Max (Alibaba·프로프라이어터리)</a:t>
-            </a:r>
-          </a:p>
-        </p:txBody>
-      </p:sp>
-      <p:sp>
-        <p:nvSpPr>
-          <p:cNvPr id="16" name="TextBox 15"/>
-          <p:cNvSpPr txBox="1"/>
-          <p:nvPr/>
-        </p:nvSpPr>
-        <p:spPr>
-          <a:xfrm>
-            <a:off x="6400800" y="1673352"/>
-            <a:ext cx="5120640" cy="347472"/>
-          </a:xfrm>
-          <a:prstGeom prst="rect">
-            <a:avLst/>
-          </a:prstGeom>
-          <a:noFill/>
-        </p:spPr>
-        <p:txBody>
-          <a:bodyPr wrap="square" anchor="t">
-            <a:spAutoFit/>
-          </a:bodyPr>
-          <a:lstStyle/>
-          <a:p>
-            <a:pPr algn="l">
-              <a:lnSpc>
-                <a:spcPct val="100000"/>
-              </a:lnSpc>
-              <a:spcAft>
-                <a:spcPts val="400"/>
+          <p:cNvPr id="58" name="TextBox 57"/>
+          <p:cNvSpPr txBox="1"/>
+          <p:nvPr/>
+        </p:nvSpPr>
+        <p:spPr>
+          <a:xfrm>
+            <a:off x="685800" y="5440680"/>
+            <a:ext cx="10835640" cy="868680"/>
+          </a:xfrm>
+          <a:prstGeom prst="rect">
+            <a:avLst/>
+          </a:prstGeom>
+          <a:noFill/>
+        </p:spPr>
+        <p:txBody>
+          <a:bodyPr wrap="square" anchor="ctr">
+            <a:spAutoFit/>
+          </a:bodyPr>
+          <a:lstStyle/>
+          <a:p>
+            <a:pPr algn="ctr">
+              <a:lnSpc>
+                <a:spcPct val="110000"/>
+              </a:lnSpc>
+              <a:spcAft>
+                <a:spcPts val="200"/>
+              </a:spcAft>
+            </a:pPr>
+            <a:r>
+              <a:rPr sz="1100" b="1">
+                <a:solidFill>
+                  <a:srgbClr val="C0392B"/>
+                </a:solidFill>
+                <a:latin typeface="Apple SD Gothic Neo"/>
+              </a:rPr>
+              <a:t>도입 주의: 데이터 레지던시(관할) 보장 미흡 → HW 설계·소스코드 등 민감정보 입력 금지·법무/보안 검토 필수.</a:t>
+            </a:r>
+          </a:p>
+          <a:p>
+            <a:pPr algn="ctr">
+              <a:lnSpc>
+                <a:spcPct val="110000"/>
+              </a:lnSpc>
+              <a:spcAft>
+                <a:spcPts val="200"/>
               </a:spcAft>
             </a:pPr>
             <a:r>
@@ -16281,285 +18192,14 @@
                 </a:solidFill>
                 <a:latin typeface="Apple SD Gothic Neo"/>
               </a:rPr>
-              <a:t>• 에이전트 특화 플래그십·1M 맥락·네이티브 확장 사고</a:t>
-            </a:r>
-          </a:p>
-        </p:txBody>
-      </p:sp>
-      <p:sp>
-        <p:nvSpPr>
-          <p:cNvPr id="17" name="TextBox 16"/>
-          <p:cNvSpPr txBox="1"/>
-          <p:nvPr/>
-        </p:nvSpPr>
-        <p:spPr>
-          <a:xfrm>
-            <a:off x="6400800" y="2039112"/>
-            <a:ext cx="5120640" cy="347472"/>
-          </a:xfrm>
-          <a:prstGeom prst="rect">
-            <a:avLst/>
-          </a:prstGeom>
-          <a:noFill/>
-        </p:spPr>
-        <p:txBody>
-          <a:bodyPr wrap="square" anchor="t">
-            <a:spAutoFit/>
-          </a:bodyPr>
-          <a:lstStyle/>
-          <a:p>
-            <a:pPr algn="l">
-              <a:lnSpc>
-                <a:spcPct val="100000"/>
-              </a:lnSpc>
-              <a:spcAft>
-                <a:spcPts val="400"/>
-              </a:spcAft>
-            </a:pPr>
-            <a:r>
-              <a:rPr sz="1100" b="0">
-                <a:solidFill>
-                  <a:srgbClr val="444A55"/>
-                </a:solidFill>
-                <a:latin typeface="Apple SD Gothic Neo"/>
-              </a:rPr>
-              <a:t>• SWE-Bench Pro 60.6%, Terminal-Bench 2.0 69.7%, GPQA 92.4%</a:t>
-            </a:r>
-          </a:p>
-        </p:txBody>
-      </p:sp>
-      <p:sp>
-        <p:nvSpPr>
-          <p:cNvPr id="18" name="TextBox 17"/>
-          <p:cNvSpPr txBox="1"/>
-          <p:nvPr/>
-        </p:nvSpPr>
-        <p:spPr>
-          <a:xfrm>
-            <a:off x="6400800" y="2404872"/>
-            <a:ext cx="5120640" cy="347472"/>
-          </a:xfrm>
-          <a:prstGeom prst="rect">
-            <a:avLst/>
-          </a:prstGeom>
-          <a:noFill/>
-        </p:spPr>
-        <p:txBody>
-          <a:bodyPr wrap="square" anchor="t">
-            <a:spAutoFit/>
-          </a:bodyPr>
-          <a:lstStyle/>
-          <a:p>
-            <a:pPr algn="l">
-              <a:lnSpc>
-                <a:spcPct val="100000"/>
-              </a:lnSpc>
-              <a:spcAft>
-                <a:spcPts val="400"/>
-              </a:spcAft>
-            </a:pPr>
-            <a:r>
-              <a:rPr sz="1100" b="0">
-                <a:solidFill>
-                  <a:srgbClr val="444A55"/>
-                </a:solidFill>
-                <a:latin typeface="Apple SD Gothic Neo"/>
-              </a:rPr>
-              <a:t>• 프런티어 중 최저 환각률 22.9% 보고</a:t>
-            </a:r>
-          </a:p>
-        </p:txBody>
-      </p:sp>
-      <p:sp>
-        <p:nvSpPr>
-          <p:cNvPr id="19" name="TextBox 18"/>
-          <p:cNvSpPr txBox="1"/>
-          <p:nvPr/>
-        </p:nvSpPr>
-        <p:spPr>
-          <a:xfrm>
-            <a:off x="6400800" y="2770632"/>
-            <a:ext cx="5120640" cy="347472"/>
-          </a:xfrm>
-          <a:prstGeom prst="rect">
-            <a:avLst/>
-          </a:prstGeom>
-          <a:noFill/>
-        </p:spPr>
-        <p:txBody>
-          <a:bodyPr wrap="square" anchor="t">
-            <a:spAutoFit/>
-          </a:bodyPr>
-          <a:lstStyle/>
-          <a:p>
-            <a:pPr algn="l">
-              <a:lnSpc>
-                <a:spcPct val="100000"/>
-              </a:lnSpc>
-              <a:spcAft>
-                <a:spcPts val="400"/>
-              </a:spcAft>
-            </a:pPr>
-            <a:r>
-              <a:rPr sz="1100" b="0">
-                <a:solidFill>
-                  <a:srgbClr val="444A55"/>
-                </a:solidFill>
-                <a:latin typeface="Apple SD Gothic Neo"/>
-              </a:rPr>
-              <a:t>• 평가: 'Agent·멀티스텝 벤치 SOTA' / 장기 코딩 에이전트 우위</a:t>
-            </a:r>
-          </a:p>
-        </p:txBody>
-      </p:sp>
-      <p:sp>
-        <p:nvSpPr>
-          <p:cNvPr id="20" name="Rounded Rectangle 19"/>
-          <p:cNvSpPr/>
-          <p:nvPr/>
-        </p:nvSpPr>
-        <p:spPr>
-          <a:xfrm>
-            <a:off x="502920" y="4251960"/>
-            <a:ext cx="11201400" cy="1874519"/>
-          </a:xfrm>
-          <a:prstGeom prst="roundRect">
-            <a:avLst/>
-          </a:prstGeom>
-          <a:solidFill>
-            <a:srgbClr val="FEF1E6"/>
-          </a:solidFill>
-          <a:ln w="17780">
-            <a:solidFill>
-              <a:srgbClr val="F27E2E"/>
-            </a:solidFill>
-          </a:ln>
-          <a:effectLst/>
-        </p:spPr>
-        <p:style>
-          <a:lnRef idx="1">
-            <a:schemeClr val="accent1"/>
-          </a:lnRef>
-          <a:fillRef idx="3">
-            <a:schemeClr val="accent1"/>
-          </a:fillRef>
-          <a:effectRef idx="2">
-            <a:schemeClr val="accent1"/>
-          </a:effectRef>
-          <a:fontRef idx="minor">
-            <a:schemeClr val="lt1"/>
-          </a:fontRef>
-        </p:style>
-        <p:txBody>
-          <a:bodyPr rtlCol="0" anchor="ctr"/>
-          <a:lstStyle/>
-          <a:p>
-            <a:pPr algn="ctr"/>
-          </a:p>
-        </p:txBody>
-      </p:sp>
-      <p:sp>
-        <p:nvSpPr>
-          <p:cNvPr id="21" name="TextBox 20"/>
-          <p:cNvSpPr txBox="1"/>
-          <p:nvPr/>
-        </p:nvSpPr>
-        <p:spPr>
-          <a:xfrm>
-            <a:off x="731520" y="4370832"/>
-            <a:ext cx="10835640" cy="1645920"/>
-          </a:xfrm>
-          <a:prstGeom prst="rect">
-            <a:avLst/>
-          </a:prstGeom>
-          <a:noFill/>
-        </p:spPr>
-        <p:txBody>
-          <a:bodyPr wrap="square" anchor="t">
-            <a:spAutoFit/>
-          </a:bodyPr>
-          <a:lstStyle/>
-          <a:p>
-            <a:pPr algn="l">
-              <a:lnSpc>
-                <a:spcPct val="110000"/>
-              </a:lnSpc>
-              <a:spcAft>
-                <a:spcPts val="200"/>
-              </a:spcAft>
-            </a:pPr>
-            <a:r>
-              <a:rPr sz="1400" b="1">
-                <a:solidFill>
-                  <a:srgbClr val="F27E2E"/>
-                </a:solidFill>
-                <a:latin typeface="Apple SD Gothic Neo"/>
-              </a:rPr>
-              <a:t>도입 주의 (HW팀 보안 관점)</a:t>
-            </a:r>
-          </a:p>
-          <a:p>
-            <a:pPr algn="l">
-              <a:lnSpc>
-                <a:spcPct val="110000"/>
-              </a:lnSpc>
-              <a:spcAft>
-                <a:spcPts val="200"/>
-              </a:spcAft>
-            </a:pPr>
-            <a:r>
-              <a:rPr sz="1200" b="1">
-                <a:solidFill>
-                  <a:srgbClr val="C0392B"/>
-                </a:solidFill>
-                <a:latin typeface="Apple SD Gothic Neo"/>
-              </a:rPr>
-              <a:t>• 데이터 거버넌스: 미국·국내 관할 데이터 레지던시 보장 미흡 → 사내 보안·법무 검토 필수</a:t>
-            </a:r>
-          </a:p>
-          <a:p>
-            <a:pPr algn="l">
-              <a:lnSpc>
-                <a:spcPct val="110000"/>
-              </a:lnSpc>
-              <a:spcAft>
-                <a:spcPts val="200"/>
-              </a:spcAft>
-            </a:pPr>
-            <a:r>
-              <a:rPr sz="1200" b="0">
-                <a:solidFill>
-                  <a:srgbClr val="444A55"/>
-                </a:solidFill>
-                <a:latin typeface="Apple SD Gothic Neo"/>
-              </a:rPr>
-              <a:t>• HW 설계·소스코드 등 민감 정보 입력 금지 권고 (외부 전송 위험)</a:t>
-            </a:r>
-          </a:p>
-          <a:p>
-            <a:pPr algn="l">
-              <a:lnSpc>
-                <a:spcPct val="110000"/>
-              </a:lnSpc>
-              <a:spcAft>
-                <a:spcPts val="200"/>
-              </a:spcAft>
-            </a:pPr>
-            <a:r>
-              <a:rPr sz="1200" b="0">
-                <a:solidFill>
-                  <a:srgbClr val="444A55"/>
-                </a:solidFill>
-                <a:latin typeface="Apple SD Gothic Neo"/>
-              </a:rPr>
-              <a:t>• 수치는 자가보고·제3자 벤치 혼재 → 도입 전 사내 PoC로 재검증 (Gauss 보조 용도)</a:t>
-            </a:r>
-          </a:p>
-        </p:txBody>
-      </p:sp>
-      <p:sp>
-        <p:nvSpPr>
-          <p:cNvPr id="22" name="TextBox 21"/>
+              <a:t>수치는 자가보고·제3자 벤치가 혼재 → 도입 전 사내 PoC로 재검증 (사내 Gauss 보조 용도로 한정 검토).</a:t>
+            </a:r>
+          </a:p>
+        </p:txBody>
+      </p:sp>
+      <p:sp>
+        <p:nvSpPr>
+          <p:cNvPr id="59" name="TextBox 58"/>
           <p:cNvSpPr txBox="1"/>
           <p:nvPr/>
         </p:nvSpPr>
@@ -19619,7 +21259,7 @@
           <a:p>
             <a:pPr algn="ctr">
               <a:lnSpc>
-                <a:spcPct val="92000"/>
+                <a:spcPct val="95000"/>
               </a:lnSpc>
               <a:spcAft>
                 <a:spcPts val="400"/>
@@ -19705,9 +21345,9 @@
           </a:bodyPr>
           <a:lstStyle/>
           <a:p>
-            <a:pPr algn="l">
-              <a:lnSpc>
-                <a:spcPct val="92000"/>
+            <a:pPr algn="ctr">
+              <a:lnSpc>
+                <a:spcPct val="95000"/>
               </a:lnSpc>
               <a:spcAft>
                 <a:spcPts val="400"/>
@@ -19793,9 +21433,9 @@
           </a:bodyPr>
           <a:lstStyle/>
           <a:p>
-            <a:pPr algn="l">
-              <a:lnSpc>
-                <a:spcPct val="92000"/>
+            <a:pPr algn="ctr">
+              <a:lnSpc>
+                <a:spcPct val="95000"/>
               </a:lnSpc>
               <a:spcAft>
                 <a:spcPts val="400"/>
@@ -19881,9 +21521,9 @@
           </a:bodyPr>
           <a:lstStyle/>
           <a:p>
-            <a:pPr algn="l">
-              <a:lnSpc>
-                <a:spcPct val="92000"/>
+            <a:pPr algn="ctr">
+              <a:lnSpc>
+                <a:spcPct val="95000"/>
               </a:lnSpc>
               <a:spcAft>
                 <a:spcPts val="400"/>
@@ -19971,7 +21611,7 @@
           <a:p>
             <a:pPr algn="ctr">
               <a:lnSpc>
-                <a:spcPct val="92000"/>
+                <a:spcPct val="95000"/>
               </a:lnSpc>
               <a:spcAft>
                 <a:spcPts val="400"/>
@@ -20057,9 +21697,9 @@
           </a:bodyPr>
           <a:lstStyle/>
           <a:p>
-            <a:pPr algn="l">
-              <a:lnSpc>
-                <a:spcPct val="92000"/>
+            <a:pPr algn="ctr">
+              <a:lnSpc>
+                <a:spcPct val="95000"/>
               </a:lnSpc>
               <a:spcAft>
                 <a:spcPts val="400"/>
@@ -20145,9 +21785,9 @@
           </a:bodyPr>
           <a:lstStyle/>
           <a:p>
-            <a:pPr algn="l">
-              <a:lnSpc>
-                <a:spcPct val="92000"/>
+            <a:pPr algn="ctr">
+              <a:lnSpc>
+                <a:spcPct val="95000"/>
               </a:lnSpc>
               <a:spcAft>
                 <a:spcPts val="400"/>
@@ -20233,9 +21873,9 @@
           </a:bodyPr>
           <a:lstStyle/>
           <a:p>
-            <a:pPr algn="l">
-              <a:lnSpc>
-                <a:spcPct val="92000"/>
+            <a:pPr algn="ctr">
+              <a:lnSpc>
+                <a:spcPct val="95000"/>
               </a:lnSpc>
               <a:spcAft>
                 <a:spcPts val="400"/>
@@ -20323,7 +21963,7 @@
           <a:p>
             <a:pPr algn="ctr">
               <a:lnSpc>
-                <a:spcPct val="92000"/>
+                <a:spcPct val="95000"/>
               </a:lnSpc>
               <a:spcAft>
                 <a:spcPts val="400"/>
@@ -20409,9 +22049,9 @@
           </a:bodyPr>
           <a:lstStyle/>
           <a:p>
-            <a:pPr algn="l">
-              <a:lnSpc>
-                <a:spcPct val="92000"/>
+            <a:pPr algn="ctr">
+              <a:lnSpc>
+                <a:spcPct val="95000"/>
               </a:lnSpc>
               <a:spcAft>
                 <a:spcPts val="400"/>
@@ -20497,9 +22137,9 @@
           </a:bodyPr>
           <a:lstStyle/>
           <a:p>
-            <a:pPr algn="l">
-              <a:lnSpc>
-                <a:spcPct val="92000"/>
+            <a:pPr algn="ctr">
+              <a:lnSpc>
+                <a:spcPct val="95000"/>
               </a:lnSpc>
               <a:spcAft>
                 <a:spcPts val="400"/>
@@ -20585,9 +22225,9 @@
           </a:bodyPr>
           <a:lstStyle/>
           <a:p>
-            <a:pPr algn="l">
-              <a:lnSpc>
-                <a:spcPct val="92000"/>
+            <a:pPr algn="ctr">
+              <a:lnSpc>
+                <a:spcPct val="95000"/>
               </a:lnSpc>
               <a:spcAft>
                 <a:spcPts val="400"/>
@@ -24075,7 +25715,7 @@
           <a:p>
             <a:pPr algn="ctr">
               <a:lnSpc>
-                <a:spcPct val="92000"/>
+                <a:spcPct val="95000"/>
               </a:lnSpc>
               <a:spcAft>
                 <a:spcPts val="400"/>
@@ -24161,9 +25801,9 @@
           </a:bodyPr>
           <a:lstStyle/>
           <a:p>
-            <a:pPr algn="l">
-              <a:lnSpc>
-                <a:spcPct val="92000"/>
+            <a:pPr algn="ctr">
+              <a:lnSpc>
+                <a:spcPct val="95000"/>
               </a:lnSpc>
               <a:spcAft>
                 <a:spcPts val="400"/>
@@ -24249,9 +25889,9 @@
           </a:bodyPr>
           <a:lstStyle/>
           <a:p>
-            <a:pPr algn="l">
-              <a:lnSpc>
-                <a:spcPct val="92000"/>
+            <a:pPr algn="ctr">
+              <a:lnSpc>
+                <a:spcPct val="95000"/>
               </a:lnSpc>
               <a:spcAft>
                 <a:spcPts val="400"/>
@@ -24337,9 +25977,9 @@
           </a:bodyPr>
           <a:lstStyle/>
           <a:p>
-            <a:pPr algn="l">
-              <a:lnSpc>
-                <a:spcPct val="92000"/>
+            <a:pPr algn="ctr">
+              <a:lnSpc>
+                <a:spcPct val="95000"/>
               </a:lnSpc>
               <a:spcAft>
                 <a:spcPts val="400"/>
@@ -24427,7 +26067,7 @@
           <a:p>
             <a:pPr algn="ctr">
               <a:lnSpc>
-                <a:spcPct val="92000"/>
+                <a:spcPct val="95000"/>
               </a:lnSpc>
               <a:spcAft>
                 <a:spcPts val="400"/>
@@ -24513,9 +26153,9 @@
           </a:bodyPr>
           <a:lstStyle/>
           <a:p>
-            <a:pPr algn="l">
-              <a:lnSpc>
-                <a:spcPct val="92000"/>
+            <a:pPr algn="ctr">
+              <a:lnSpc>
+                <a:spcPct val="95000"/>
               </a:lnSpc>
               <a:spcAft>
                 <a:spcPts val="400"/>
@@ -24601,9 +26241,9 @@
           </a:bodyPr>
           <a:lstStyle/>
           <a:p>
-            <a:pPr algn="l">
-              <a:lnSpc>
-                <a:spcPct val="92000"/>
+            <a:pPr algn="ctr">
+              <a:lnSpc>
+                <a:spcPct val="95000"/>
               </a:lnSpc>
               <a:spcAft>
                 <a:spcPts val="400"/>
@@ -24689,9 +26329,9 @@
           </a:bodyPr>
           <a:lstStyle/>
           <a:p>
-            <a:pPr algn="l">
-              <a:lnSpc>
-                <a:spcPct val="92000"/>
+            <a:pPr algn="ctr">
+              <a:lnSpc>
+                <a:spcPct val="95000"/>
               </a:lnSpc>
               <a:spcAft>
                 <a:spcPts val="400"/>
@@ -24779,7 +26419,7 @@
           <a:p>
             <a:pPr algn="ctr">
               <a:lnSpc>
-                <a:spcPct val="92000"/>
+                <a:spcPct val="95000"/>
               </a:lnSpc>
               <a:spcAft>
                 <a:spcPts val="400"/>
@@ -24865,9 +26505,9 @@
           </a:bodyPr>
           <a:lstStyle/>
           <a:p>
-            <a:pPr algn="l">
-              <a:lnSpc>
-                <a:spcPct val="92000"/>
+            <a:pPr algn="ctr">
+              <a:lnSpc>
+                <a:spcPct val="95000"/>
               </a:lnSpc>
               <a:spcAft>
                 <a:spcPts val="400"/>
@@ -24953,9 +26593,9 @@
           </a:bodyPr>
           <a:lstStyle/>
           <a:p>
-            <a:pPr algn="l">
-              <a:lnSpc>
-                <a:spcPct val="92000"/>
+            <a:pPr algn="ctr">
+              <a:lnSpc>
+                <a:spcPct val="95000"/>
               </a:lnSpc>
               <a:spcAft>
                 <a:spcPts val="400"/>
@@ -25041,9 +26681,9 @@
           </a:bodyPr>
           <a:lstStyle/>
           <a:p>
-            <a:pPr algn="l">
-              <a:lnSpc>
-                <a:spcPct val="92000"/>
+            <a:pPr algn="ctr">
+              <a:lnSpc>
+                <a:spcPct val="95000"/>
               </a:lnSpc>
               <a:spcAft>
                 <a:spcPts val="400"/>
@@ -25131,7 +26771,7 @@
           <a:p>
             <a:pPr algn="ctr">
               <a:lnSpc>
-                <a:spcPct val="92000"/>
+                <a:spcPct val="95000"/>
               </a:lnSpc>
               <a:spcAft>
                 <a:spcPts val="400"/>
@@ -25217,9 +26857,9 @@
           </a:bodyPr>
           <a:lstStyle/>
           <a:p>
-            <a:pPr algn="l">
-              <a:lnSpc>
-                <a:spcPct val="92000"/>
+            <a:pPr algn="ctr">
+              <a:lnSpc>
+                <a:spcPct val="95000"/>
               </a:lnSpc>
               <a:spcAft>
                 <a:spcPts val="400"/>
@@ -25305,9 +26945,9 @@
           </a:bodyPr>
           <a:lstStyle/>
           <a:p>
-            <a:pPr algn="l">
-              <a:lnSpc>
-                <a:spcPct val="92000"/>
+            <a:pPr algn="ctr">
+              <a:lnSpc>
+                <a:spcPct val="95000"/>
               </a:lnSpc>
               <a:spcAft>
                 <a:spcPts val="400"/>
@@ -25393,9 +27033,9 @@
           </a:bodyPr>
           <a:lstStyle/>
           <a:p>
-            <a:pPr algn="l">
-              <a:lnSpc>
-                <a:spcPct val="92000"/>
+            <a:pPr algn="ctr">
+              <a:lnSpc>
+                <a:spcPct val="95000"/>
               </a:lnSpc>
               <a:spcAft>
                 <a:spcPts val="400"/>
@@ -25483,7 +27123,7 @@
           <a:p>
             <a:pPr algn="ctr">
               <a:lnSpc>
-                <a:spcPct val="92000"/>
+                <a:spcPct val="95000"/>
               </a:lnSpc>
               <a:spcAft>
                 <a:spcPts val="400"/>
@@ -25569,9 +27209,9 @@
           </a:bodyPr>
           <a:lstStyle/>
           <a:p>
-            <a:pPr algn="l">
-              <a:lnSpc>
-                <a:spcPct val="92000"/>
+            <a:pPr algn="ctr">
+              <a:lnSpc>
+                <a:spcPct val="95000"/>
               </a:lnSpc>
               <a:spcAft>
                 <a:spcPts val="400"/>
@@ -25657,9 +27297,9 @@
           </a:bodyPr>
           <a:lstStyle/>
           <a:p>
-            <a:pPr algn="l">
-              <a:lnSpc>
-                <a:spcPct val="92000"/>
+            <a:pPr algn="ctr">
+              <a:lnSpc>
+                <a:spcPct val="95000"/>
               </a:lnSpc>
               <a:spcAft>
                 <a:spcPts val="400"/>
@@ -25745,9 +27385,9 @@
           </a:bodyPr>
           <a:lstStyle/>
           <a:p>
-            <a:pPr algn="l">
-              <a:lnSpc>
-                <a:spcPct val="92000"/>
+            <a:pPr algn="ctr">
+              <a:lnSpc>
+                <a:spcPct val="95000"/>
               </a:lnSpc>
               <a:spcAft>
                 <a:spcPts val="400"/>
@@ -25835,7 +27475,7 @@
           <a:p>
             <a:pPr algn="ctr">
               <a:lnSpc>
-                <a:spcPct val="92000"/>
+                <a:spcPct val="95000"/>
               </a:lnSpc>
               <a:spcAft>
                 <a:spcPts val="400"/>
@@ -25921,9 +27561,9 @@
           </a:bodyPr>
           <a:lstStyle/>
           <a:p>
-            <a:pPr algn="l">
-              <a:lnSpc>
-                <a:spcPct val="92000"/>
+            <a:pPr algn="ctr">
+              <a:lnSpc>
+                <a:spcPct val="95000"/>
               </a:lnSpc>
               <a:spcAft>
                 <a:spcPts val="400"/>
@@ -26009,9 +27649,9 @@
           </a:bodyPr>
           <a:lstStyle/>
           <a:p>
-            <a:pPr algn="l">
-              <a:lnSpc>
-                <a:spcPct val="92000"/>
+            <a:pPr algn="ctr">
+              <a:lnSpc>
+                <a:spcPct val="95000"/>
               </a:lnSpc>
               <a:spcAft>
                 <a:spcPts val="400"/>
@@ -26097,9 +27737,9 @@
           </a:bodyPr>
           <a:lstStyle/>
           <a:p>
-            <a:pPr algn="l">
-              <a:lnSpc>
-                <a:spcPct val="92000"/>
+            <a:pPr algn="ctr">
+              <a:lnSpc>
+                <a:spcPct val="95000"/>
               </a:lnSpc>
               <a:spcAft>
                 <a:spcPts val="400"/>
@@ -26187,7 +27827,7 @@
           <a:p>
             <a:pPr algn="ctr">
               <a:lnSpc>
-                <a:spcPct val="92000"/>
+                <a:spcPct val="95000"/>
               </a:lnSpc>
               <a:spcAft>
                 <a:spcPts val="400"/>
@@ -26273,9 +27913,9 @@
           </a:bodyPr>
           <a:lstStyle/>
           <a:p>
-            <a:pPr algn="l">
-              <a:lnSpc>
-                <a:spcPct val="92000"/>
+            <a:pPr algn="ctr">
+              <a:lnSpc>
+                <a:spcPct val="95000"/>
               </a:lnSpc>
               <a:spcAft>
                 <a:spcPts val="400"/>
@@ -26361,9 +28001,9 @@
           </a:bodyPr>
           <a:lstStyle/>
           <a:p>
-            <a:pPr algn="l">
-              <a:lnSpc>
-                <a:spcPct val="92000"/>
+            <a:pPr algn="ctr">
+              <a:lnSpc>
+                <a:spcPct val="95000"/>
               </a:lnSpc>
               <a:spcAft>
                 <a:spcPts val="400"/>
@@ -26449,9 +28089,9 @@
           </a:bodyPr>
           <a:lstStyle/>
           <a:p>
-            <a:pPr algn="l">
-              <a:lnSpc>
-                <a:spcPct val="92000"/>
+            <a:pPr algn="ctr">
+              <a:lnSpc>
+                <a:spcPct val="95000"/>
               </a:lnSpc>
               <a:spcAft>
                 <a:spcPts val="400"/>
@@ -27966,7 +29606,7 @@
           <a:p>
             <a:pPr algn="ctr">
               <a:lnSpc>
-                <a:spcPct val="92000"/>
+                <a:spcPct val="95000"/>
               </a:lnSpc>
               <a:spcAft>
                 <a:spcPts val="400"/>
@@ -28052,9 +29692,9 @@
           </a:bodyPr>
           <a:lstStyle/>
           <a:p>
-            <a:pPr algn="l">
-              <a:lnSpc>
-                <a:spcPct val="92000"/>
+            <a:pPr algn="ctr">
+              <a:lnSpc>
+                <a:spcPct val="95000"/>
               </a:lnSpc>
               <a:spcAft>
                 <a:spcPts val="400"/>
@@ -28140,9 +29780,9 @@
           </a:bodyPr>
           <a:lstStyle/>
           <a:p>
-            <a:pPr algn="l">
-              <a:lnSpc>
-                <a:spcPct val="92000"/>
+            <a:pPr algn="ctr">
+              <a:lnSpc>
+                <a:spcPct val="95000"/>
               </a:lnSpc>
               <a:spcAft>
                 <a:spcPts val="400"/>
@@ -28228,9 +29868,9 @@
           </a:bodyPr>
           <a:lstStyle/>
           <a:p>
-            <a:pPr algn="l">
-              <a:lnSpc>
-                <a:spcPct val="92000"/>
+            <a:pPr algn="ctr">
+              <a:lnSpc>
+                <a:spcPct val="95000"/>
               </a:lnSpc>
               <a:spcAft>
                 <a:spcPts val="400"/>
@@ -28318,7 +29958,7 @@
           <a:p>
             <a:pPr algn="ctr">
               <a:lnSpc>
-                <a:spcPct val="92000"/>
+                <a:spcPct val="95000"/>
               </a:lnSpc>
               <a:spcAft>
                 <a:spcPts val="400"/>
@@ -28404,9 +30044,9 @@
           </a:bodyPr>
           <a:lstStyle/>
           <a:p>
-            <a:pPr algn="l">
-              <a:lnSpc>
-                <a:spcPct val="92000"/>
+            <a:pPr algn="ctr">
+              <a:lnSpc>
+                <a:spcPct val="95000"/>
               </a:lnSpc>
               <a:spcAft>
                 <a:spcPts val="400"/>
@@ -28492,9 +30132,9 @@
           </a:bodyPr>
           <a:lstStyle/>
           <a:p>
-            <a:pPr algn="l">
-              <a:lnSpc>
-                <a:spcPct val="92000"/>
+            <a:pPr algn="ctr">
+              <a:lnSpc>
+                <a:spcPct val="95000"/>
               </a:lnSpc>
               <a:spcAft>
                 <a:spcPts val="400"/>
@@ -28580,9 +30220,9 @@
           </a:bodyPr>
           <a:lstStyle/>
           <a:p>
-            <a:pPr algn="l">
-              <a:lnSpc>
-                <a:spcPct val="92000"/>
+            <a:pPr algn="ctr">
+              <a:lnSpc>
+                <a:spcPct val="95000"/>
               </a:lnSpc>
               <a:spcAft>
                 <a:spcPts val="400"/>
@@ -28670,7 +30310,7 @@
           <a:p>
             <a:pPr algn="ctr">
               <a:lnSpc>
-                <a:spcPct val="92000"/>
+                <a:spcPct val="95000"/>
               </a:lnSpc>
               <a:spcAft>
                 <a:spcPts val="400"/>
@@ -28756,9 +30396,9 @@
           </a:bodyPr>
           <a:lstStyle/>
           <a:p>
-            <a:pPr algn="l">
-              <a:lnSpc>
-                <a:spcPct val="92000"/>
+            <a:pPr algn="ctr">
+              <a:lnSpc>
+                <a:spcPct val="95000"/>
               </a:lnSpc>
               <a:spcAft>
                 <a:spcPts val="400"/>
@@ -28844,9 +30484,9 @@
           </a:bodyPr>
           <a:lstStyle/>
           <a:p>
-            <a:pPr algn="l">
-              <a:lnSpc>
-                <a:spcPct val="92000"/>
+            <a:pPr algn="ctr">
+              <a:lnSpc>
+                <a:spcPct val="95000"/>
               </a:lnSpc>
               <a:spcAft>
                 <a:spcPts val="400"/>
@@ -28932,9 +30572,9 @@
           </a:bodyPr>
           <a:lstStyle/>
           <a:p>
-            <a:pPr algn="l">
-              <a:lnSpc>
-                <a:spcPct val="92000"/>
+            <a:pPr algn="ctr">
+              <a:lnSpc>
+                <a:spcPct val="95000"/>
               </a:lnSpc>
               <a:spcAft>
                 <a:spcPts val="400"/>
@@ -29022,7 +30662,7 @@
           <a:p>
             <a:pPr algn="ctr">
               <a:lnSpc>
-                <a:spcPct val="92000"/>
+                <a:spcPct val="95000"/>
               </a:lnSpc>
               <a:spcAft>
                 <a:spcPts val="400"/>
@@ -29108,9 +30748,9 @@
           </a:bodyPr>
           <a:lstStyle/>
           <a:p>
-            <a:pPr algn="l">
-              <a:lnSpc>
-                <a:spcPct val="92000"/>
+            <a:pPr algn="ctr">
+              <a:lnSpc>
+                <a:spcPct val="95000"/>
               </a:lnSpc>
               <a:spcAft>
                 <a:spcPts val="400"/>
@@ -29196,9 +30836,9 @@
           </a:bodyPr>
           <a:lstStyle/>
           <a:p>
-            <a:pPr algn="l">
-              <a:lnSpc>
-                <a:spcPct val="92000"/>
+            <a:pPr algn="ctr">
+              <a:lnSpc>
+                <a:spcPct val="95000"/>
               </a:lnSpc>
               <a:spcAft>
                 <a:spcPts val="400"/>
@@ -29284,9 +30924,9 @@
           </a:bodyPr>
           <a:lstStyle/>
           <a:p>
-            <a:pPr algn="l">
-              <a:lnSpc>
-                <a:spcPct val="92000"/>
+            <a:pPr algn="ctr">
+              <a:lnSpc>
+                <a:spcPct val="95000"/>
               </a:lnSpc>
               <a:spcAft>
                 <a:spcPts val="400"/>
@@ -29374,7 +31014,7 @@
           <a:p>
             <a:pPr algn="ctr">
               <a:lnSpc>
-                <a:spcPct val="92000"/>
+                <a:spcPct val="95000"/>
               </a:lnSpc>
               <a:spcAft>
                 <a:spcPts val="400"/>
@@ -29460,9 +31100,9 @@
           </a:bodyPr>
           <a:lstStyle/>
           <a:p>
-            <a:pPr algn="l">
-              <a:lnSpc>
-                <a:spcPct val="92000"/>
+            <a:pPr algn="ctr">
+              <a:lnSpc>
+                <a:spcPct val="95000"/>
               </a:lnSpc>
               <a:spcAft>
                 <a:spcPts val="400"/>
@@ -29548,9 +31188,9 @@
           </a:bodyPr>
           <a:lstStyle/>
           <a:p>
-            <a:pPr algn="l">
-              <a:lnSpc>
-                <a:spcPct val="92000"/>
+            <a:pPr algn="ctr">
+              <a:lnSpc>
+                <a:spcPct val="95000"/>
               </a:lnSpc>
               <a:spcAft>
                 <a:spcPts val="400"/>
@@ -29636,9 +31276,9 @@
           </a:bodyPr>
           <a:lstStyle/>
           <a:p>
-            <a:pPr algn="l">
-              <a:lnSpc>
-                <a:spcPct val="92000"/>
+            <a:pPr algn="ctr">
+              <a:lnSpc>
+                <a:spcPct val="95000"/>
               </a:lnSpc>
               <a:spcAft>
                 <a:spcPts val="400"/>

</xml_diff>

<commit_message>
Refine deck: target/criteria page, fix table-box overlaps, rework conclusion, formal tone
- Slide 2 retitled '평가 대상 및 평가 기준' with explicit 3 targets (ChatGPT/Gemini/Claude)
- Increase spacing so bottom text boxes no longer overlap tables (slides 3·9·9c·10·11·12)
- Replace conclusion's 3 status boxes with per-LLM in-house usage plans + summary
- Formalize titles/subtitles/wording for an IT HW-developer audience

Co-authored-by: Cursor <cursoragent@cursor.com>
</commit_message>
<xml_diff>
--- a/외부AI_3종_비교조사.pptx
+++ b/외부AI_3종_비교조사.pptx
@@ -3274,7 +3274,7 @@
                 </a:solidFill>
                 <a:latin typeface="Apple SD Gothic Neo"/>
               </a:rPr>
-              <a:t>공식 문서 + 웹 사용기 교차 검증</a:t>
+              <a:t>공식 문서 및 웹 사용자 평가 교차 검증</a:t>
             </a:r>
           </a:p>
         </p:txBody>
@@ -3472,7 +3472,7 @@
                 </a:solidFill>
                 <a:latin typeface="Apple SD Gothic Neo"/>
               </a:rPr>
-              <a:t>유저 평가 기반 비교  (9/17)</a:t>
+              <a:t>사용자 평가 기반 비교  (9/17)</a:t>
             </a:r>
           </a:p>
         </p:txBody>
@@ -3514,7 +3514,7 @@
                 </a:solidFill>
                 <a:latin typeface="Apple SD Gothic Neo"/>
               </a:rPr>
-              <a:t>커뮤니티 사용기 (Reddit·X·GitHub·Slack·Discord)</a:t>
+              <a:t>커뮤니티 사용자 평가 (Reddit·X·GitHub·Slack·Discord)</a:t>
             </a:r>
           </a:p>
         </p:txBody>
@@ -4583,8 +4583,8 @@
         </p:nvSpPr>
         <p:spPr>
           <a:xfrm>
-            <a:off x="457200" y="4983480"/>
-            <a:ext cx="11247120" cy="1143000"/>
+            <a:off x="457200" y="5102352"/>
+            <a:ext cx="11247120" cy="1115568"/>
           </a:xfrm>
           <a:prstGeom prst="roundRect">
             <a:avLst/>
@@ -4627,7 +4627,7 @@
         </p:nvSpPr>
         <p:spPr>
           <a:xfrm>
-            <a:off x="685800" y="5102352"/>
+            <a:off x="685800" y="5202936"/>
             <a:ext cx="10835640" cy="914400"/>
           </a:xfrm>
           <a:prstGeom prst="rect">
@@ -4656,7 +4656,7 @@
                 </a:solidFill>
                 <a:latin typeface="Apple SD Gothic Neo"/>
               </a:rPr>
-              <a:t>HW팀 시사점</a:t>
+              <a:t>HW 개발 시사점</a:t>
             </a:r>
           </a:p>
           <a:p>
@@ -4675,7 +4675,7 @@
                 </a:solidFill>
                 <a:latin typeface="Apple SD Gothic Neo"/>
               </a:rPr>
-              <a:t>• 공통 결론: '하나만'이 아니라 업무별 스택 사용 — Reddit·X·GitHub 모두 도구 갈아타기를 권장</a:t>
+              <a:t>• 공통 결론: 단일 모델이 아닌 업무별 병행 사용 — Reddit·X·GitHub 모두 도구 병행을 권장</a:t>
             </a:r>
           </a:p>
           <a:p>
@@ -4694,7 +4694,7 @@
                 </a:solidFill>
                 <a:latin typeface="Apple SD Gothic Neo"/>
               </a:rPr>
-              <a:t>• 팀 활용은 Slack 요약부터, Discord·MCP 원격 제어는 사내 보안 검토 후 (외부 연동 주의)</a:t>
+              <a:t>• 팀 활용은 Slack 요약부터, Discord·MCP 원격 제어는 사내 보안 검토 후 적용 (외부 연동 주의)</a:t>
             </a:r>
           </a:p>
         </p:txBody>
@@ -4892,7 +4892,7 @@
                 </a:solidFill>
                 <a:latin typeface="Apple SD Gothic Neo"/>
               </a:rPr>
-              <a:t>유저 평가 기반 비교  (10/17)</a:t>
+              <a:t>사용자 평가 기반 비교  (10/17)</a:t>
             </a:r>
           </a:p>
         </p:txBody>
@@ -6795,8 +6795,8 @@
         </p:nvSpPr>
         <p:spPr>
           <a:xfrm>
-            <a:off x="457200" y="5029200"/>
-            <a:ext cx="11247120" cy="1097280"/>
+            <a:off x="457200" y="5166360"/>
+            <a:ext cx="11247120" cy="1051560"/>
           </a:xfrm>
           <a:prstGeom prst="roundRect">
             <a:avLst/>
@@ -6841,8 +6841,8 @@
         </p:nvSpPr>
         <p:spPr>
           <a:xfrm>
-            <a:off x="685800" y="5138928"/>
-            <a:ext cx="10789920" cy="914400"/>
+            <a:off x="685800" y="5266944"/>
+            <a:ext cx="10789920" cy="868680"/>
           </a:xfrm>
           <a:prstGeom prst="rect">
             <a:avLst/>
@@ -6857,7 +6857,7 @@
           <a:p>
             <a:pPr algn="l">
               <a:lnSpc>
-                <a:spcPct val="108000"/>
+                <a:spcPct val="106000"/>
               </a:lnSpc>
               <a:spcAft>
                 <a:spcPts val="200"/>
@@ -6870,13 +6870,13 @@
                 </a:solidFill>
                 <a:latin typeface="Apple SD Gothic Neo"/>
               </a:rPr>
-              <a:t>읽는 법 (주의)</a:t>
+              <a:t>해석 시 유의사항</a:t>
             </a:r>
           </a:p>
           <a:p>
             <a:pPr algn="l">
               <a:lnSpc>
-                <a:spcPct val="108000"/>
+                <a:spcPct val="106000"/>
               </a:lnSpc>
               <a:spcAft>
                 <a:spcPts val="200"/>
@@ -6889,13 +6889,13 @@
                 </a:solidFill>
                 <a:latin typeface="Apple SD Gothic Neo"/>
               </a:rPr>
-              <a:t>표본·방법이 서로 다른 제3자 설문 → '순위'보다 '경향'으로 해석. </a:t>
+              <a:t>표본·방법이 상이한 제3자 설문이므로 '순위'보다 '경향'으로 해석. </a:t>
             </a:r>
           </a:p>
           <a:p>
             <a:pPr algn="l">
               <a:lnSpc>
-                <a:spcPct val="108000"/>
+                <a:spcPct val="106000"/>
               </a:lnSpc>
               <a:spcAft>
                 <a:spcPts val="200"/>
@@ -7106,7 +7106,7 @@
                 </a:solidFill>
                 <a:latin typeface="Apple SD Gothic Neo"/>
               </a:rPr>
-              <a:t>유저 평가 기반 비교  (11/17)</a:t>
+              <a:t>사용자 평가 기반 비교  (11/17)</a:t>
             </a:r>
           </a:p>
         </p:txBody>
@@ -7148,7 +7148,7 @@
                 </a:solidFill>
                 <a:latin typeface="Apple SD Gothic Neo"/>
               </a:rPr>
-              <a:t>AI별 실사용 불만 (상세)</a:t>
+              <a:t>LLM별 주요 제약 및 불만 사항</a:t>
             </a:r>
           </a:p>
         </p:txBody>
@@ -8134,7 +8134,7 @@
                 </a:solidFill>
                 <a:latin typeface="Apple SD Gothic Neo"/>
               </a:rPr>
-              <a:t>HW팀 시사점</a:t>
+              <a:t>HW 개발 시사점</a:t>
             </a:r>
           </a:p>
           <a:p>
@@ -8153,7 +8153,7 @@
                 </a:solidFill>
                 <a:latin typeface="Apple SD Gothic Neo"/>
               </a:rPr>
-              <a:t>사내 Gauss의 '분당 3~4회 제한'처럼, 외부 AI도 '사용 한도'가 실무 병목이 됩니다.</a:t>
+              <a:t>사내 Gauss의 분당 3~4회 호출 제한과 마찬가지로, 외부 LLM도 사용 한도가 실무 병목 요인입니다.</a:t>
             </a:r>
           </a:p>
           <a:p>
@@ -8172,7 +8172,7 @@
                 </a:solidFill>
                 <a:latin typeface="Apple SD Gothic Neo"/>
               </a:rPr>
-              <a:t>→ PoC에서 한도·속도·코드 신뢰도(틀린 코드 비율)를 반드시 직접 측정하세요.</a:t>
+              <a:t>→ PoC 단계에서 사용 한도·응답 속도·코드 신뢰도(오류율)를 정량 측정 권장.</a:t>
             </a:r>
           </a:p>
         </p:txBody>
@@ -8370,7 +8370,7 @@
                 </a:solidFill>
                 <a:latin typeface="Apple SD Gothic Neo"/>
               </a:rPr>
-              <a:t>유저 평가 기반 비교  (12/17)</a:t>
+              <a:t>사용자 평가 기반 비교  (12/17)</a:t>
             </a:r>
           </a:p>
         </p:txBody>
@@ -8412,7 +8412,7 @@
                 </a:solidFill>
                 <a:latin typeface="Apple SD Gothic Neo"/>
               </a:rPr>
-              <a:t>업무별 유저 평가 (HW 관점)</a:t>
+              <a:t>업무별 사용자 평가 (HW 개발 관점)</a:t>
             </a:r>
           </a:p>
         </p:txBody>
@@ -10537,8 +10537,8 @@
         </p:nvSpPr>
         <p:spPr>
           <a:xfrm>
-            <a:off x="502920" y="4617720"/>
-            <a:ext cx="11201400" cy="411480"/>
+            <a:off x="502920" y="4828032"/>
+            <a:ext cx="11201400" cy="365760"/>
           </a:xfrm>
           <a:prstGeom prst="rect">
             <a:avLst/>
@@ -10566,7 +10566,7 @@
                 </a:solidFill>
                 <a:latin typeface="Apple SD Gothic Neo"/>
               </a:rPr>
-              <a:t>◎ = 유저 후기에서 상대적 강점으로 자주 언급 (공식 벤치 아님)</a:t>
+              <a:t>◎ = 사용자 평가에서 상대적 강점으로 자주 언급 (공식 벤치마크 아님)</a:t>
             </a:r>
           </a:p>
         </p:txBody>
@@ -10579,8 +10579,8 @@
         </p:nvSpPr>
         <p:spPr>
           <a:xfrm>
-            <a:off x="502920" y="5074920"/>
-            <a:ext cx="11201400" cy="1234440"/>
+            <a:off x="502920" y="5230368"/>
+            <a:ext cx="11201400" cy="1078992"/>
           </a:xfrm>
           <a:prstGeom prst="roundRect">
             <a:avLst/>
@@ -10623,8 +10623,8 @@
         </p:nvSpPr>
         <p:spPr>
           <a:xfrm>
-            <a:off x="731520" y="5212080"/>
-            <a:ext cx="10789920" cy="960120"/>
+            <a:off x="731520" y="5321808"/>
+            <a:ext cx="10789920" cy="914400"/>
           </a:xfrm>
           <a:prstGeom prst="rect">
             <a:avLst/>
@@ -10639,7 +10639,7 @@
           <a:p>
             <a:pPr algn="l">
               <a:lnSpc>
-                <a:spcPct val="110000"/>
+                <a:spcPct val="108000"/>
               </a:lnSpc>
               <a:spcAft>
                 <a:spcPts val="200"/>
@@ -10652,13 +10652,13 @@
                 </a:solidFill>
                 <a:latin typeface="Apple SD Gothic Neo"/>
               </a:rPr>
-              <a:t>유저 추천 스택 (참고)</a:t>
+              <a:t>권장 조합 (참고)</a:t>
             </a:r>
           </a:p>
           <a:p>
             <a:pPr algn="l">
               <a:lnSpc>
-                <a:spcPct val="110000"/>
+                <a:spcPct val="108000"/>
               </a:lnSpc>
               <a:spcAft>
                 <a:spcPts val="200"/>
@@ -10671,13 +10671,13 @@
                 </a:solidFill>
                 <a:latin typeface="Apple SD Gothic Neo"/>
               </a:rPr>
-              <a:t>Claude Code(코딩) + Gemini(긴 사양서·OCR) + ChatGPT(만능·음성·빠른 질문)</a:t>
+              <a:t>Claude Code(코딩) + Gemini(장문 사양서·OCR) + ChatGPT(범용·음성·신속 질의)</a:t>
             </a:r>
           </a:p>
           <a:p>
             <a:pPr algn="l">
               <a:lnSpc>
-                <a:spcPct val="110000"/>
+                <a:spcPct val="108000"/>
               </a:lnSpc>
               <a:spcAft>
                 <a:spcPts val="200"/>
@@ -10690,7 +10690,7 @@
                 </a:solidFill>
                 <a:latin typeface="Apple SD Gothic Neo"/>
               </a:rPr>
-              <a:t>HW팀 PoC: 업무별로 2주씩 써 보고 한도·속도·실수율을 직접 측정 권장</a:t>
+              <a:t>PoC 권장: 업무별 2주 시범 운영 후 사용 한도·속도·오류율을 정량 측정</a:t>
             </a:r>
           </a:p>
         </p:txBody>
@@ -10888,7 +10888,7 @@
                 </a:solidFill>
                 <a:latin typeface="Apple SD Gothic Neo"/>
               </a:rPr>
-              <a:t>유저 평가 기반 비교  (13/17)</a:t>
+              <a:t>사용자 평가 기반 비교  (13/17)</a:t>
             </a:r>
           </a:p>
         </p:txBody>
@@ -10930,7 +10930,7 @@
                 </a:solidFill>
                 <a:latin typeface="Apple SD Gothic Neo"/>
               </a:rPr>
-              <a:t>공식 소개 vs 유저 평가 — 차이</a:t>
+              <a:t>공식 자료 vs 사용자 평가 비교</a:t>
             </a:r>
           </a:p>
         </p:txBody>
@@ -11018,7 +11018,7 @@
                 </a:solidFill>
                 <a:latin typeface="Apple SD Gothic Neo"/>
               </a:rPr>
-              <a:t>AI</a:t>
+              <a:t>LLM</a:t>
             </a:r>
           </a:p>
         </p:txBody>
@@ -11106,7 +11106,7 @@
                 </a:solidFill>
                 <a:latin typeface="Apple SD Gothic Neo"/>
               </a:rPr>
-              <a:t>공식이 말하는 것</a:t>
+              <a:t>공식 자료 요지</a:t>
             </a:r>
           </a:p>
         </p:txBody>
@@ -11194,7 +11194,7 @@
                 </a:solidFill>
                 <a:latin typeface="Apple SD Gothic Neo"/>
               </a:rPr>
-              <a:t>유저가 추가로 말하는 것</a:t>
+              <a:t>사용자 평가 추가 지적</a:t>
             </a:r>
           </a:p>
         </p:txBody>
@@ -11999,8 +11999,8 @@
         </p:nvSpPr>
         <p:spPr>
           <a:xfrm>
-            <a:off x="502920" y="4709160"/>
-            <a:ext cx="11201400" cy="1600200"/>
+            <a:off x="502920" y="4956048"/>
+            <a:ext cx="11201400" cy="1353312"/>
           </a:xfrm>
           <a:prstGeom prst="roundRect">
             <a:avLst/>
@@ -12045,8 +12045,8 @@
         </p:nvSpPr>
         <p:spPr>
           <a:xfrm>
-            <a:off x="731520" y="4846320"/>
-            <a:ext cx="10789920" cy="1325880"/>
+            <a:off x="731520" y="5029200"/>
+            <a:ext cx="10789920" cy="1207008"/>
           </a:xfrm>
           <a:prstGeom prst="rect">
             <a:avLst/>
@@ -12061,77 +12061,58 @@
           <a:p>
             <a:pPr algn="l">
               <a:lnSpc>
-                <a:spcPct val="110000"/>
+                <a:spcPct val="112000"/>
               </a:lnSpc>
               <a:spcAft>
                 <a:spcPts val="200"/>
               </a:spcAft>
             </a:pPr>
             <a:r>
-              <a:rPr sz="1400" b="1">
+              <a:rPr sz="1350" b="1">
                 <a:solidFill>
                   <a:srgbClr val="F27E2E"/>
                 </a:solidFill>
                 <a:latin typeface="Apple SD Gothic Neo"/>
               </a:rPr>
-              <a:t>도입 시 체크리스트</a:t>
+              <a:t>도입 검토 체크리스트</a:t>
             </a:r>
           </a:p>
           <a:p>
             <a:pPr algn="l">
               <a:lnSpc>
-                <a:spcPct val="110000"/>
+                <a:spcPct val="112000"/>
               </a:lnSpc>
               <a:spcAft>
                 <a:spcPts val="200"/>
               </a:spcAft>
             </a:pPr>
             <a:r>
-              <a:rPr sz="1200" b="0">
+              <a:rPr sz="1150" b="0">
                 <a:solidFill>
                   <a:srgbClr val="444A55"/>
                 </a:solidFill>
                 <a:latin typeface="Apple SD Gothic Neo"/>
               </a:rPr>
-              <a:t>1. 공식 문서로 '기능이 되는지' 확인</a:t>
+              <a:t>1. 공식 문서로 기능 지원 여부 확인  2. PoC로 일상 사용 시 제약(한도·속도·코드 품질) 검증</a:t>
             </a:r>
           </a:p>
           <a:p>
             <a:pPr algn="l">
               <a:lnSpc>
-                <a:spcPct val="110000"/>
+                <a:spcPct val="112000"/>
               </a:lnSpc>
               <a:spcAft>
                 <a:spcPts val="200"/>
               </a:spcAft>
             </a:pPr>
             <a:r>
-              <a:rPr sz="1200" b="0">
+              <a:rPr sz="1150" b="0">
                 <a:solidFill>
                   <a:srgbClr val="444A55"/>
                 </a:solidFill>
                 <a:latin typeface="Apple SD Gothic Neo"/>
               </a:rPr>
-              <a:t>2. 유저 후기로 '매일 쓸 때 불편한지' PoC에서 확인 (한도·속도·코드 검증)</a:t>
-            </a:r>
-          </a:p>
-          <a:p>
-            <a:pPr algn="l">
-              <a:lnSpc>
-                <a:spcPct val="110000"/>
-              </a:lnSpc>
-              <a:spcAft>
-                <a:spcPts val="200"/>
-              </a:spcAft>
-            </a:pPr>
-            <a:r>
-              <a:rPr sz="1200" b="0">
-                <a:solidFill>
-                  <a:srgbClr val="444A55"/>
-                </a:solidFill>
-                <a:latin typeface="Apple SD Gothic Neo"/>
-              </a:rPr>
-              <a:t>3. 사내 Gauss와 역할 분리 — 외부는 보안 승인 후 고급 보조</a:t>
+              <a:t>3. 사내 Gauss와 역할 분리 — 외부 LLM은 보안 승인 후 고급 보조 수단으로 운용</a:t>
             </a:r>
           </a:p>
         </p:txBody>
@@ -12371,7 +12352,7 @@
                 </a:solidFill>
                 <a:latin typeface="Apple SD Gothic Neo"/>
               </a:rPr>
-              <a:t>HW 개발팀 적용 및 선택 가이드</a:t>
+              <a:t>HW 개발 업무별 적용 가이드</a:t>
             </a:r>
           </a:p>
         </p:txBody>
@@ -12547,7 +12528,7 @@
                 </a:solidFill>
                 <a:latin typeface="Apple SD Gothic Neo"/>
               </a:rPr>
-              <a:t>우선 검토</a:t>
+              <a:t>우선 검토 모델</a:t>
             </a:r>
           </a:p>
         </p:txBody>
@@ -12635,7 +12616,7 @@
                 </a:solidFill>
                 <a:latin typeface="Apple SD Gothic Neo"/>
               </a:rPr>
-              <a:t>이유 (쉬운 말)</a:t>
+              <a:t>선정 근거</a:t>
             </a:r>
           </a:p>
         </p:txBody>
@@ -12899,7 +12880,7 @@
                 </a:solidFill>
                 <a:latin typeface="Apple SD Gothic Neo"/>
               </a:rPr>
-              <a:t>코드 구조·주석 품질 평가 높음</a:t>
+              <a:t>코드 구조·주석 품질 평가 우수</a:t>
             </a:r>
           </a:p>
         </p:txBody>
@@ -12987,7 +12968,7 @@
                 </a:solidFill>
                 <a:latin typeface="Apple SD Gothic Neo"/>
               </a:rPr>
-              <a:t>긴 데이터시트 요약</a:t>
+              <a:t>장문 데이터시트 요약</a:t>
             </a:r>
           </a:p>
         </p:txBody>
@@ -13163,7 +13144,7 @@
                 </a:solidFill>
                 <a:latin typeface="Apple SD Gothic Neo"/>
               </a:rPr>
-              <a:t>긴 문서·검색이 공식 강점</a:t>
+              <a:t>장문 문서·검색 연동이 공식 강점</a:t>
             </a:r>
           </a:p>
         </p:txBody>
@@ -13339,7 +13320,7 @@
                 </a:solidFill>
                 <a:latin typeface="Apple SD Gothic Neo"/>
               </a:rPr>
-              <a:t>3종 모두</a:t>
+              <a:t>3종 공통</a:t>
             </a:r>
           </a:p>
         </p:txBody>
@@ -13427,7 +13408,7 @@
                 </a:solidFill>
                 <a:latin typeface="Apple SD Gothic Neo"/>
               </a:rPr>
-              <a:t>반복 정리는 모두 활용 가능</a:t>
+              <a:t>반복 정형화 작업에 모두 활용 가능</a:t>
             </a:r>
           </a:p>
         </p:txBody>
@@ -13691,7 +13672,7 @@
                 </a:solidFill>
                 <a:latin typeface="Apple SD Gothic Neo"/>
               </a:rPr>
-              <a:t>문서·이미지 추론 공식 사례</a:t>
+              <a:t>문서·이미지 추론 공식 사례 보유</a:t>
             </a:r>
           </a:p>
         </p:txBody>
@@ -13955,7 +13936,7 @@
                 </a:solidFill>
                 <a:latin typeface="Apple SD Gothic Neo"/>
               </a:rPr>
-              <a:t>AgentKit / Claude Code</a:t>
+              <a:t>AgentKit / Claude Code 기반</a:t>
             </a:r>
           </a:p>
         </p:txBody>
@@ -14131,7 +14112,7 @@
                 </a:solidFill>
                 <a:latin typeface="Apple SD Gothic Neo"/>
               </a:rPr>
-              <a:t>사람</a:t>
+              <a:t>엔지니어</a:t>
             </a:r>
           </a:p>
         </p:txBody>
@@ -14219,7 +14200,7 @@
                 </a:solidFill>
                 <a:latin typeface="Apple SD Gothic Neo"/>
               </a:rPr>
-              <a:t>AI는 보조, 실측 필수</a:t>
+              <a:t>AI는 보조 수단, 실측 검증 필수</a:t>
             </a:r>
           </a:p>
         </p:txBody>
@@ -14232,8 +14213,8 @@
         </p:nvSpPr>
         <p:spPr>
           <a:xfrm>
-            <a:off x="502920" y="4892040"/>
-            <a:ext cx="11201400" cy="1234440"/>
+            <a:off x="502920" y="5029200"/>
+            <a:ext cx="11201400" cy="1143000"/>
           </a:xfrm>
           <a:prstGeom prst="roundRect">
             <a:avLst/>
@@ -14278,7 +14259,7 @@
         </p:nvSpPr>
         <p:spPr>
           <a:xfrm>
-            <a:off x="731520" y="5029200"/>
+            <a:off x="731520" y="5120640"/>
             <a:ext cx="10789920" cy="960120"/>
           </a:xfrm>
           <a:prstGeom prst="rect">
@@ -14294,7 +14275,7 @@
           <a:p>
             <a:pPr algn="l">
               <a:lnSpc>
-                <a:spcPct val="110000"/>
+                <a:spcPct val="108000"/>
               </a:lnSpc>
               <a:spcAft>
                 <a:spcPts val="200"/>
@@ -14307,13 +14288,13 @@
                 </a:solidFill>
                 <a:latin typeface="Apple SD Gothic Neo"/>
               </a:rPr>
-              <a:t>선택 가이드</a:t>
+              <a:t>선정 가이드</a:t>
             </a:r>
           </a:p>
           <a:p>
             <a:pPr algn="l">
               <a:lnSpc>
-                <a:spcPct val="110000"/>
+                <a:spcPct val="108000"/>
               </a:lnSpc>
               <a:spcAft>
                 <a:spcPts val="200"/>
@@ -14326,13 +14307,13 @@
                 </a:solidFill>
                 <a:latin typeface="Apple SD Gothic Neo"/>
               </a:rPr>
-              <a:t>코딩 중심 → Claude  |  긴 사양서·검색 → Gemini  |  범용·도구 연결 → ChatGPT</a:t>
+              <a:t>코딩 중심 → Claude  |  장문 사양서·검색 → Gemini  |  범용·도구 연동 → ChatGPT</a:t>
             </a:r>
           </a:p>
           <a:p>
             <a:pPr algn="l">
               <a:lnSpc>
-                <a:spcPct val="110000"/>
+                <a:spcPct val="108000"/>
               </a:lnSpc>
               <a:spcAft>
                 <a:spcPts val="200"/>
@@ -14345,7 +14326,7 @@
                 </a:solidFill>
                 <a:latin typeface="Apple SD Gothic Neo"/>
               </a:rPr>
-              <a:t>복수 도입·역할 분담 권장 (예: Claude 코딩 + Gemini 문서)</a:t>
+              <a:t>복수 도입·역할 분담 권장 (예: Claude 코딩 + Gemini 문서 처리)</a:t>
             </a:r>
           </a:p>
         </p:txBody>
@@ -14585,21 +14566,579 @@
                 </a:solidFill>
                 <a:latin typeface="Apple SD Gothic Neo"/>
               </a:rPr>
-              <a:t>결론 및 제언</a:t>
-            </a:r>
-          </a:p>
-        </p:txBody>
-      </p:sp>
-      <p:sp>
-        <p:nvSpPr>
-          <p:cNvPr id="6" name="Rounded Rectangle 5"/>
+              <a:t>결론: LLM별 사내 활용 방안</a:t>
+            </a:r>
+          </a:p>
+        </p:txBody>
+      </p:sp>
+      <p:sp>
+        <p:nvSpPr>
+          <p:cNvPr id="6" name="TextBox 5"/>
+          <p:cNvSpPr txBox="1"/>
+          <p:nvPr/>
+        </p:nvSpPr>
+        <p:spPr>
+          <a:xfrm>
+            <a:off x="502920" y="1078992"/>
+            <a:ext cx="11247120" cy="384048"/>
+          </a:xfrm>
+          <a:prstGeom prst="rect">
+            <a:avLst/>
+          </a:prstGeom>
+          <a:noFill/>
+        </p:spPr>
+        <p:txBody>
+          <a:bodyPr wrap="square" anchor="t">
+            <a:spAutoFit/>
+          </a:bodyPr>
+          <a:lstStyle/>
+          <a:p>
+            <a:pPr algn="l">
+              <a:lnSpc>
+                <a:spcPct val="100000"/>
+              </a:lnSpc>
+              <a:spcAft>
+                <a:spcPts val="400"/>
+              </a:spcAft>
+            </a:pPr>
+            <a:r>
+              <a:rPr sz="1200" b="0">
+                <a:solidFill>
+                  <a:srgbClr val="444A55"/>
+                </a:solidFill>
+                <a:latin typeface="Apple SD Gothic Neo"/>
+              </a:rPr>
+              <a:t>공식 자료와 사용자 사용 사례를 종합한, HW 개발 업무에서의 효율적 활용 방안입니다.</a:t>
+            </a:r>
+          </a:p>
+        </p:txBody>
+      </p:sp>
+      <p:sp>
+        <p:nvSpPr>
+          <p:cNvPr id="7" name="Rounded Rectangle 6"/>
           <p:cNvSpPr/>
           <p:nvPr/>
         </p:nvSpPr>
         <p:spPr>
           <a:xfrm>
-            <a:off x="594360" y="1325880"/>
-            <a:ext cx="3611880" cy="2926080"/>
+            <a:off x="502920" y="1572768"/>
+            <a:ext cx="3675887" cy="2468880"/>
+          </a:xfrm>
+          <a:prstGeom prst="roundRect">
+            <a:avLst/>
+          </a:prstGeom>
+          <a:solidFill>
+            <a:srgbClr val="FFFFFF"/>
+          </a:solidFill>
+          <a:ln w="22860">
+            <a:solidFill>
+              <a:srgbClr val="1F6FB2"/>
+            </a:solidFill>
+          </a:ln>
+          <a:effectLst/>
+        </p:spPr>
+        <p:style>
+          <a:lnRef idx="1">
+            <a:schemeClr val="accent1"/>
+          </a:lnRef>
+          <a:fillRef idx="3">
+            <a:schemeClr val="accent1"/>
+          </a:fillRef>
+          <a:effectRef idx="2">
+            <a:schemeClr val="accent1"/>
+          </a:effectRef>
+          <a:fontRef idx="minor">
+            <a:schemeClr val="lt1"/>
+          </a:fontRef>
+        </p:style>
+        <p:txBody>
+          <a:bodyPr rtlCol="0" anchor="ctr"/>
+          <a:lstStyle/>
+          <a:p>
+            <a:pPr algn="ctr"/>
+          </a:p>
+        </p:txBody>
+      </p:sp>
+      <p:sp>
+        <p:nvSpPr>
+          <p:cNvPr id="8" name="Rounded Rectangle 7"/>
+          <p:cNvSpPr/>
+          <p:nvPr/>
+        </p:nvSpPr>
+        <p:spPr>
+          <a:xfrm>
+            <a:off x="502920" y="1572768"/>
+            <a:ext cx="3675887" cy="475488"/>
+          </a:xfrm>
+          <a:prstGeom prst="roundRect">
+            <a:avLst/>
+          </a:prstGeom>
+          <a:solidFill>
+            <a:srgbClr val="1F6FB2"/>
+          </a:solidFill>
+          <a:ln>
+            <a:noFill/>
+          </a:ln>
+          <a:effectLst/>
+        </p:spPr>
+        <p:style>
+          <a:lnRef idx="1">
+            <a:schemeClr val="accent1"/>
+          </a:lnRef>
+          <a:fillRef idx="3">
+            <a:schemeClr val="accent1"/>
+          </a:fillRef>
+          <a:effectRef idx="2">
+            <a:schemeClr val="accent1"/>
+          </a:effectRef>
+          <a:fontRef idx="minor">
+            <a:schemeClr val="lt1"/>
+          </a:fontRef>
+        </p:style>
+        <p:txBody>
+          <a:bodyPr rtlCol="0" anchor="ctr"/>
+          <a:lstStyle/>
+          <a:p>
+            <a:pPr algn="ctr"/>
+          </a:p>
+        </p:txBody>
+      </p:sp>
+      <p:sp>
+        <p:nvSpPr>
+          <p:cNvPr id="9" name="TextBox 8"/>
+          <p:cNvSpPr txBox="1"/>
+          <p:nvPr/>
+        </p:nvSpPr>
+        <p:spPr>
+          <a:xfrm>
+            <a:off x="502920" y="1572768"/>
+            <a:ext cx="3675887" cy="475488"/>
+          </a:xfrm>
+          <a:prstGeom prst="rect">
+            <a:avLst/>
+          </a:prstGeom>
+          <a:noFill/>
+        </p:spPr>
+        <p:txBody>
+          <a:bodyPr wrap="square" anchor="ctr">
+            <a:spAutoFit/>
+          </a:bodyPr>
+          <a:lstStyle/>
+          <a:p>
+            <a:pPr algn="ctr">
+              <a:lnSpc>
+                <a:spcPct val="100000"/>
+              </a:lnSpc>
+              <a:spcAft>
+                <a:spcPts val="400"/>
+              </a:spcAft>
+            </a:pPr>
+            <a:r>
+              <a:rPr sz="1400" b="1">
+                <a:solidFill>
+                  <a:srgbClr val="FFFFFF"/>
+                </a:solidFill>
+                <a:latin typeface="Apple SD Gothic Neo"/>
+              </a:rPr>
+              <a:t>ChatGPT</a:t>
+            </a:r>
+          </a:p>
+        </p:txBody>
+      </p:sp>
+      <p:sp>
+        <p:nvSpPr>
+          <p:cNvPr id="10" name="TextBox 9"/>
+          <p:cNvSpPr txBox="1"/>
+          <p:nvPr/>
+        </p:nvSpPr>
+        <p:spPr>
+          <a:xfrm>
+            <a:off x="704088" y="2212848"/>
+            <a:ext cx="3291839" cy="548640"/>
+          </a:xfrm>
+          <a:prstGeom prst="rect">
+            <a:avLst/>
+          </a:prstGeom>
+          <a:noFill/>
+        </p:spPr>
+        <p:txBody>
+          <a:bodyPr wrap="square" anchor="t">
+            <a:spAutoFit/>
+          </a:bodyPr>
+          <a:lstStyle/>
+          <a:p>
+            <a:pPr algn="l">
+              <a:lnSpc>
+                <a:spcPct val="102000"/>
+              </a:lnSpc>
+              <a:spcAft>
+                <a:spcPts val="400"/>
+              </a:spcAft>
+            </a:pPr>
+            <a:r>
+              <a:rPr sz="1100" b="0">
+                <a:solidFill>
+                  <a:srgbClr val="444A55"/>
+                </a:solidFill>
+                <a:latin typeface="Apple SD Gothic Neo"/>
+              </a:rPr>
+              <a:t>• 측정 자동화·CI/CD 로그 분석 스크립트 초안 작성</a:t>
+            </a:r>
+          </a:p>
+        </p:txBody>
+      </p:sp>
+      <p:sp>
+        <p:nvSpPr>
+          <p:cNvPr id="11" name="TextBox 10"/>
+          <p:cNvSpPr txBox="1"/>
+          <p:nvPr/>
+        </p:nvSpPr>
+        <p:spPr>
+          <a:xfrm>
+            <a:off x="704088" y="2779776"/>
+            <a:ext cx="3291839" cy="548640"/>
+          </a:xfrm>
+          <a:prstGeom prst="rect">
+            <a:avLst/>
+          </a:prstGeom>
+          <a:noFill/>
+        </p:spPr>
+        <p:txBody>
+          <a:bodyPr wrap="square" anchor="t">
+            <a:spAutoFit/>
+          </a:bodyPr>
+          <a:lstStyle/>
+          <a:p>
+            <a:pPr algn="l">
+              <a:lnSpc>
+                <a:spcPct val="102000"/>
+              </a:lnSpc>
+              <a:spcAft>
+                <a:spcPts val="400"/>
+              </a:spcAft>
+            </a:pPr>
+            <a:r>
+              <a:rPr sz="1100" b="0">
+                <a:solidFill>
+                  <a:srgbClr val="444A55"/>
+                </a:solidFill>
+                <a:latin typeface="Apple SD Gothic Neo"/>
+              </a:rPr>
+              <a:t>• 회의록·시험 보고서 등 문서 초안 신속 생성</a:t>
+            </a:r>
+          </a:p>
+        </p:txBody>
+      </p:sp>
+      <p:sp>
+        <p:nvSpPr>
+          <p:cNvPr id="12" name="TextBox 11"/>
+          <p:cNvSpPr txBox="1"/>
+          <p:nvPr/>
+        </p:nvSpPr>
+        <p:spPr>
+          <a:xfrm>
+            <a:off x="704088" y="3346704"/>
+            <a:ext cx="3291839" cy="548640"/>
+          </a:xfrm>
+          <a:prstGeom prst="rect">
+            <a:avLst/>
+          </a:prstGeom>
+          <a:noFill/>
+        </p:spPr>
+        <p:txBody>
+          <a:bodyPr wrap="square" anchor="t">
+            <a:spAutoFit/>
+          </a:bodyPr>
+          <a:lstStyle/>
+          <a:p>
+            <a:pPr algn="l">
+              <a:lnSpc>
+                <a:spcPct val="102000"/>
+              </a:lnSpc>
+              <a:spcAft>
+                <a:spcPts val="400"/>
+              </a:spcAft>
+            </a:pPr>
+            <a:r>
+              <a:rPr sz="1100" b="0">
+                <a:solidFill>
+                  <a:srgbClr val="444A55"/>
+                </a:solidFill>
+                <a:latin typeface="Apple SD Gothic Neo"/>
+              </a:rPr>
+              <a:t>• AgentKit·MCP 기반 사내 도구 연동 (보안 승인 후)</a:t>
+            </a:r>
+          </a:p>
+        </p:txBody>
+      </p:sp>
+      <p:sp>
+        <p:nvSpPr>
+          <p:cNvPr id="13" name="Rounded Rectangle 12"/>
+          <p:cNvSpPr/>
+          <p:nvPr/>
+        </p:nvSpPr>
+        <p:spPr>
+          <a:xfrm>
+            <a:off x="4343399" y="1572768"/>
+            <a:ext cx="3675887" cy="2468880"/>
+          </a:xfrm>
+          <a:prstGeom prst="roundRect">
+            <a:avLst/>
+          </a:prstGeom>
+          <a:solidFill>
+            <a:srgbClr val="FFFFFF"/>
+          </a:solidFill>
+          <a:ln w="22860">
+            <a:solidFill>
+              <a:srgbClr val="F27E2E"/>
+            </a:solidFill>
+          </a:ln>
+          <a:effectLst/>
+        </p:spPr>
+        <p:style>
+          <a:lnRef idx="1">
+            <a:schemeClr val="accent1"/>
+          </a:lnRef>
+          <a:fillRef idx="3">
+            <a:schemeClr val="accent1"/>
+          </a:fillRef>
+          <a:effectRef idx="2">
+            <a:schemeClr val="accent1"/>
+          </a:effectRef>
+          <a:fontRef idx="minor">
+            <a:schemeClr val="lt1"/>
+          </a:fontRef>
+        </p:style>
+        <p:txBody>
+          <a:bodyPr rtlCol="0" anchor="ctr"/>
+          <a:lstStyle/>
+          <a:p>
+            <a:pPr algn="ctr"/>
+          </a:p>
+        </p:txBody>
+      </p:sp>
+      <p:sp>
+        <p:nvSpPr>
+          <p:cNvPr id="14" name="Rounded Rectangle 13"/>
+          <p:cNvSpPr/>
+          <p:nvPr/>
+        </p:nvSpPr>
+        <p:spPr>
+          <a:xfrm>
+            <a:off x="4343399" y="1572768"/>
+            <a:ext cx="3675887" cy="475488"/>
+          </a:xfrm>
+          <a:prstGeom prst="roundRect">
+            <a:avLst/>
+          </a:prstGeom>
+          <a:solidFill>
+            <a:srgbClr val="F27E2E"/>
+          </a:solidFill>
+          <a:ln>
+            <a:noFill/>
+          </a:ln>
+          <a:effectLst/>
+        </p:spPr>
+        <p:style>
+          <a:lnRef idx="1">
+            <a:schemeClr val="accent1"/>
+          </a:lnRef>
+          <a:fillRef idx="3">
+            <a:schemeClr val="accent1"/>
+          </a:fillRef>
+          <a:effectRef idx="2">
+            <a:schemeClr val="accent1"/>
+          </a:effectRef>
+          <a:fontRef idx="minor">
+            <a:schemeClr val="lt1"/>
+          </a:fontRef>
+        </p:style>
+        <p:txBody>
+          <a:bodyPr rtlCol="0" anchor="ctr"/>
+          <a:lstStyle/>
+          <a:p>
+            <a:pPr algn="ctr"/>
+          </a:p>
+        </p:txBody>
+      </p:sp>
+      <p:sp>
+        <p:nvSpPr>
+          <p:cNvPr id="15" name="TextBox 14"/>
+          <p:cNvSpPr txBox="1"/>
+          <p:nvPr/>
+        </p:nvSpPr>
+        <p:spPr>
+          <a:xfrm>
+            <a:off x="4343399" y="1572768"/>
+            <a:ext cx="3675887" cy="475488"/>
+          </a:xfrm>
+          <a:prstGeom prst="rect">
+            <a:avLst/>
+          </a:prstGeom>
+          <a:noFill/>
+        </p:spPr>
+        <p:txBody>
+          <a:bodyPr wrap="square" anchor="ctr">
+            <a:spAutoFit/>
+          </a:bodyPr>
+          <a:lstStyle/>
+          <a:p>
+            <a:pPr algn="ctr">
+              <a:lnSpc>
+                <a:spcPct val="100000"/>
+              </a:lnSpc>
+              <a:spcAft>
+                <a:spcPts val="400"/>
+              </a:spcAft>
+            </a:pPr>
+            <a:r>
+              <a:rPr sz="1400" b="1">
+                <a:solidFill>
+                  <a:srgbClr val="FFFFFF"/>
+                </a:solidFill>
+                <a:latin typeface="Apple SD Gothic Neo"/>
+              </a:rPr>
+              <a:t>Gemini</a:t>
+            </a:r>
+          </a:p>
+        </p:txBody>
+      </p:sp>
+      <p:sp>
+        <p:nvSpPr>
+          <p:cNvPr id="16" name="TextBox 15"/>
+          <p:cNvSpPr txBox="1"/>
+          <p:nvPr/>
+        </p:nvSpPr>
+        <p:spPr>
+          <a:xfrm>
+            <a:off x="4544567" y="2212848"/>
+            <a:ext cx="3291839" cy="548640"/>
+          </a:xfrm>
+          <a:prstGeom prst="rect">
+            <a:avLst/>
+          </a:prstGeom>
+          <a:noFill/>
+        </p:spPr>
+        <p:txBody>
+          <a:bodyPr wrap="square" anchor="t">
+            <a:spAutoFit/>
+          </a:bodyPr>
+          <a:lstStyle/>
+          <a:p>
+            <a:pPr algn="l">
+              <a:lnSpc>
+                <a:spcPct val="102000"/>
+              </a:lnSpc>
+              <a:spcAft>
+                <a:spcPts val="400"/>
+              </a:spcAft>
+            </a:pPr>
+            <a:r>
+              <a:rPr sz="1100" b="0">
+                <a:solidFill>
+                  <a:srgbClr val="444A55"/>
+                </a:solidFill>
+                <a:latin typeface="Apple SD Gothic Neo"/>
+              </a:rPr>
+              <a:t>• 수백 페이지 데이터시트·사양서 요약 및 검색</a:t>
+            </a:r>
+          </a:p>
+        </p:txBody>
+      </p:sp>
+      <p:sp>
+        <p:nvSpPr>
+          <p:cNvPr id="17" name="TextBox 16"/>
+          <p:cNvSpPr txBox="1"/>
+          <p:nvPr/>
+        </p:nvSpPr>
+        <p:spPr>
+          <a:xfrm>
+            <a:off x="4544567" y="2779776"/>
+            <a:ext cx="3291839" cy="548640"/>
+          </a:xfrm>
+          <a:prstGeom prst="rect">
+            <a:avLst/>
+          </a:prstGeom>
+          <a:noFill/>
+        </p:spPr>
+        <p:txBody>
+          <a:bodyPr wrap="square" anchor="t">
+            <a:spAutoFit/>
+          </a:bodyPr>
+          <a:lstStyle/>
+          <a:p>
+            <a:pPr algn="l">
+              <a:lnSpc>
+                <a:spcPct val="102000"/>
+              </a:lnSpc>
+              <a:spcAft>
+                <a:spcPts val="400"/>
+              </a:spcAft>
+            </a:pPr>
+            <a:r>
+              <a:rPr sz="1100" b="0">
+                <a:solidFill>
+                  <a:srgbClr val="444A55"/>
+                </a:solidFill>
+                <a:latin typeface="Apple SD Gothic Neo"/>
+              </a:rPr>
+              <a:t>• 스캔 PDF·회로도 캡처 OCR 후 텍스트화</a:t>
+            </a:r>
+          </a:p>
+        </p:txBody>
+      </p:sp>
+      <p:sp>
+        <p:nvSpPr>
+          <p:cNvPr id="18" name="TextBox 17"/>
+          <p:cNvSpPr txBox="1"/>
+          <p:nvPr/>
+        </p:nvSpPr>
+        <p:spPr>
+          <a:xfrm>
+            <a:off x="4544567" y="3346704"/>
+            <a:ext cx="3291839" cy="548640"/>
+          </a:xfrm>
+          <a:prstGeom prst="rect">
+            <a:avLst/>
+          </a:prstGeom>
+          <a:noFill/>
+        </p:spPr>
+        <p:txBody>
+          <a:bodyPr wrap="square" anchor="t">
+            <a:spAutoFit/>
+          </a:bodyPr>
+          <a:lstStyle/>
+          <a:p>
+            <a:pPr algn="l">
+              <a:lnSpc>
+                <a:spcPct val="102000"/>
+              </a:lnSpc>
+              <a:spcAft>
+                <a:spcPts val="400"/>
+              </a:spcAft>
+            </a:pPr>
+            <a:r>
+              <a:rPr sz="1100" b="0">
+                <a:solidFill>
+                  <a:srgbClr val="444A55"/>
+                </a:solidFill>
+                <a:latin typeface="Apple SD Gothic Neo"/>
+              </a:rPr>
+              <a:t>• Google Workspace 기반 문서·협업 연계</a:t>
+            </a:r>
+          </a:p>
+        </p:txBody>
+      </p:sp>
+      <p:sp>
+        <p:nvSpPr>
+          <p:cNvPr id="19" name="Rounded Rectangle 18"/>
+          <p:cNvSpPr/>
+          <p:nvPr/>
+        </p:nvSpPr>
+        <p:spPr>
+          <a:xfrm>
+            <a:off x="8183878" y="1572768"/>
+            <a:ext cx="3675887" cy="2468880"/>
           </a:xfrm>
           <a:prstGeom prst="roundRect">
             <a:avLst/>
@@ -14638,14 +15177,14 @@
       </p:sp>
       <p:sp>
         <p:nvSpPr>
-          <p:cNvPr id="7" name="Rounded Rectangle 6"/>
+          <p:cNvPr id="20" name="Rounded Rectangle 19"/>
           <p:cNvSpPr/>
           <p:nvPr/>
         </p:nvSpPr>
         <p:spPr>
           <a:xfrm>
-            <a:off x="594360" y="1325880"/>
-            <a:ext cx="3611880" cy="502920"/>
+            <a:off x="8183878" y="1572768"/>
+            <a:ext cx="3675887" cy="475488"/>
           </a:xfrm>
           <a:prstGeom prst="roundRect">
             <a:avLst/>
@@ -14682,14 +15221,14 @@
       </p:sp>
       <p:sp>
         <p:nvSpPr>
-          <p:cNvPr id="8" name="TextBox 7"/>
-          <p:cNvSpPr txBox="1"/>
-          <p:nvPr/>
-        </p:nvSpPr>
-        <p:spPr>
-          <a:xfrm>
-            <a:off x="594360" y="1325880"/>
-            <a:ext cx="3611880" cy="502920"/>
+          <p:cNvPr id="21" name="TextBox 20"/>
+          <p:cNvSpPr txBox="1"/>
+          <p:nvPr/>
+        </p:nvSpPr>
+        <p:spPr>
+          <a:xfrm>
+            <a:off x="8183878" y="1572768"/>
+            <a:ext cx="3675887" cy="475488"/>
           </a:xfrm>
           <a:prstGeom prst="rect">
             <a:avLst/>
@@ -14717,21 +15256,21 @@
                 </a:solidFill>
                 <a:latin typeface="Apple SD Gothic Neo"/>
               </a:rPr>
-              <a:t>당장 PoC 가능</a:t>
-            </a:r>
-          </a:p>
-        </p:txBody>
-      </p:sp>
-      <p:sp>
-        <p:nvSpPr>
-          <p:cNvPr id="9" name="TextBox 8"/>
-          <p:cNvSpPr txBox="1"/>
-          <p:nvPr/>
-        </p:nvSpPr>
-        <p:spPr>
-          <a:xfrm>
-            <a:off x="822960" y="2011680"/>
-            <a:ext cx="3154680" cy="320040"/>
+              <a:t>Claude</a:t>
+            </a:r>
+          </a:p>
+        </p:txBody>
+      </p:sp>
+      <p:sp>
+        <p:nvSpPr>
+          <p:cNvPr id="22" name="TextBox 21"/>
+          <p:cNvSpPr txBox="1"/>
+          <p:nvPr/>
+        </p:nvSpPr>
+        <p:spPr>
+          <a:xfrm>
+            <a:off x="8385046" y="2212848"/>
+            <a:ext cx="3291839" cy="548640"/>
           </a:xfrm>
           <a:prstGeom prst="rect">
             <a:avLst/>
@@ -14746,34 +15285,34 @@
           <a:p>
             <a:pPr algn="l">
               <a:lnSpc>
-                <a:spcPct val="100000"/>
-              </a:lnSpc>
-              <a:spcAft>
-                <a:spcPts val="400"/>
-              </a:spcAft>
-            </a:pPr>
-            <a:r>
-              <a:rPr sz="1150" b="0">
+                <a:spcPct val="102000"/>
+              </a:lnSpc>
+              <a:spcAft>
+                <a:spcPts val="400"/>
+              </a:spcAft>
+            </a:pPr>
+            <a:r>
+              <a:rPr sz="1100" b="0">
                 <a:solidFill>
                   <a:srgbClr val="444A55"/>
                 </a:solidFill>
                 <a:latin typeface="Apple SD Gothic Neo"/>
               </a:rPr>
-              <a:t>- 코드·문서 초안</a:t>
-            </a:r>
-          </a:p>
-        </p:txBody>
-      </p:sp>
-      <p:sp>
-        <p:nvSpPr>
-          <p:cNvPr id="10" name="TextBox 9"/>
-          <p:cNvSpPr txBox="1"/>
-          <p:nvPr/>
-        </p:nvSpPr>
-        <p:spPr>
-          <a:xfrm>
-            <a:off x="822960" y="2468880"/>
-            <a:ext cx="3154680" cy="320040"/>
+              <a:t>• 펌웨어·드라이버 코드 초안 및 리팩터링</a:t>
+            </a:r>
+          </a:p>
+        </p:txBody>
+      </p:sp>
+      <p:sp>
+        <p:nvSpPr>
+          <p:cNvPr id="23" name="TextBox 22"/>
+          <p:cNvSpPr txBox="1"/>
+          <p:nvPr/>
+        </p:nvSpPr>
+        <p:spPr>
+          <a:xfrm>
+            <a:off x="8385046" y="2779776"/>
+            <a:ext cx="3291839" cy="548640"/>
           </a:xfrm>
           <a:prstGeom prst="rect">
             <a:avLst/>
@@ -14788,34 +15327,34 @@
           <a:p>
             <a:pPr algn="l">
               <a:lnSpc>
-                <a:spcPct val="100000"/>
-              </a:lnSpc>
-              <a:spcAft>
-                <a:spcPts val="400"/>
-              </a:spcAft>
-            </a:pPr>
-            <a:r>
-              <a:rPr sz="1150" b="0">
+                <a:spcPct val="102000"/>
+              </a:lnSpc>
+              <a:spcAft>
+                <a:spcPts val="400"/>
+              </a:spcAft>
+            </a:pPr>
+            <a:r>
+              <a:rPr sz="1100" b="0">
                 <a:solidFill>
                   <a:srgbClr val="444A55"/>
                 </a:solidFill>
                 <a:latin typeface="Apple SD Gothic Neo"/>
               </a:rPr>
-              <a:t>- 측정 데이터 정리</a:t>
-            </a:r>
-          </a:p>
-        </p:txBody>
-      </p:sp>
-      <p:sp>
-        <p:nvSpPr>
-          <p:cNvPr id="11" name="TextBox 10"/>
-          <p:cNvSpPr txBox="1"/>
-          <p:nvPr/>
-        </p:nvSpPr>
-        <p:spPr>
-          <a:xfrm>
-            <a:off x="822960" y="2926080"/>
-            <a:ext cx="3154680" cy="320040"/>
+              <a:t>• 레거시 코드 분석·인수인계 문서화</a:t>
+            </a:r>
+          </a:p>
+        </p:txBody>
+      </p:sp>
+      <p:sp>
+        <p:nvSpPr>
+          <p:cNvPr id="24" name="TextBox 23"/>
+          <p:cNvSpPr txBox="1"/>
+          <p:nvPr/>
+        </p:nvSpPr>
+        <p:spPr>
+          <a:xfrm>
+            <a:off x="8385046" y="3346704"/>
+            <a:ext cx="3291839" cy="548640"/>
           </a:xfrm>
           <a:prstGeom prst="rect">
             <a:avLst/>
@@ -14830,634 +15369,34 @@
           <a:p>
             <a:pPr algn="l">
               <a:lnSpc>
-                <a:spcPct val="100000"/>
-              </a:lnSpc>
-              <a:spcAft>
-                <a:spcPts val="400"/>
-              </a:spcAft>
-            </a:pPr>
-            <a:r>
-              <a:rPr sz="1150" b="0">
+                <a:spcPct val="102000"/>
+              </a:lnSpc>
+              <a:spcAft>
+                <a:spcPts val="400"/>
+              </a:spcAft>
+            </a:pPr>
+            <a:r>
+              <a:rPr sz="1100" b="0">
                 <a:solidFill>
                   <a:srgbClr val="444A55"/>
                 </a:solidFill>
                 <a:latin typeface="Apple SD Gothic Neo"/>
               </a:rPr>
-              <a:t>- 로그 분석</a:t>
-            </a:r>
-          </a:p>
-        </p:txBody>
-      </p:sp>
-      <p:sp>
-        <p:nvSpPr>
-          <p:cNvPr id="12" name="TextBox 11"/>
-          <p:cNvSpPr txBox="1"/>
-          <p:nvPr/>
-        </p:nvSpPr>
-        <p:spPr>
-          <a:xfrm>
-            <a:off x="822960" y="3383280"/>
-            <a:ext cx="3154680" cy="320040"/>
-          </a:xfrm>
-          <a:prstGeom prst="rect">
-            <a:avLst/>
-          </a:prstGeom>
-          <a:noFill/>
-        </p:spPr>
-        <p:txBody>
-          <a:bodyPr wrap="square" anchor="t">
-            <a:spAutoFit/>
-          </a:bodyPr>
-          <a:lstStyle/>
-          <a:p>
-            <a:pPr algn="l">
-              <a:lnSpc>
-                <a:spcPct val="100000"/>
-              </a:lnSpc>
-              <a:spcAft>
-                <a:spcPts val="400"/>
-              </a:spcAft>
-            </a:pPr>
-            <a:r>
-              <a:rPr sz="1150" b="0">
-                <a:solidFill>
-                  <a:srgbClr val="444A55"/>
-                </a:solidFill>
-                <a:latin typeface="Apple SD Gothic Neo"/>
-              </a:rPr>
-              <a:t>- 반복 업무 자동화</a:t>
-            </a:r>
-          </a:p>
-        </p:txBody>
-      </p:sp>
-      <p:sp>
-        <p:nvSpPr>
-          <p:cNvPr id="13" name="Rounded Rectangle 12"/>
+              <a:t>• Claude Code 기반 장기 다단계 작업 수행</a:t>
+            </a:r>
+          </a:p>
+        </p:txBody>
+      </p:sp>
+      <p:sp>
+        <p:nvSpPr>
+          <p:cNvPr id="25" name="Rounded Rectangle 24"/>
           <p:cNvSpPr/>
           <p:nvPr/>
         </p:nvSpPr>
         <p:spPr>
           <a:xfrm>
-            <a:off x="4434840" y="1325880"/>
-            <a:ext cx="3611880" cy="2926080"/>
-          </a:xfrm>
-          <a:prstGeom prst="roundRect">
-            <a:avLst/>
-          </a:prstGeom>
-          <a:solidFill>
-            <a:srgbClr val="FFFFFF"/>
-          </a:solidFill>
-          <a:ln w="22860">
-            <a:solidFill>
-              <a:srgbClr val="F27E2E"/>
-            </a:solidFill>
-          </a:ln>
-          <a:effectLst/>
-        </p:spPr>
-        <p:style>
-          <a:lnRef idx="1">
-            <a:schemeClr val="accent1"/>
-          </a:lnRef>
-          <a:fillRef idx="3">
-            <a:schemeClr val="accent1"/>
-          </a:fillRef>
-          <a:effectRef idx="2">
-            <a:schemeClr val="accent1"/>
-          </a:effectRef>
-          <a:fontRef idx="minor">
-            <a:schemeClr val="lt1"/>
-          </a:fontRef>
-        </p:style>
-        <p:txBody>
-          <a:bodyPr rtlCol="0" anchor="ctr"/>
-          <a:lstStyle/>
-          <a:p>
-            <a:pPr algn="ctr"/>
-          </a:p>
-        </p:txBody>
-      </p:sp>
-      <p:sp>
-        <p:nvSpPr>
-          <p:cNvPr id="14" name="Rounded Rectangle 13"/>
-          <p:cNvSpPr/>
-          <p:nvPr/>
-        </p:nvSpPr>
-        <p:spPr>
-          <a:xfrm>
-            <a:off x="4434840" y="1325880"/>
-            <a:ext cx="3611880" cy="502920"/>
-          </a:xfrm>
-          <a:prstGeom prst="roundRect">
-            <a:avLst/>
-          </a:prstGeom>
-          <a:solidFill>
-            <a:srgbClr val="F27E2E"/>
-          </a:solidFill>
-          <a:ln>
-            <a:noFill/>
-          </a:ln>
-          <a:effectLst/>
-        </p:spPr>
-        <p:style>
-          <a:lnRef idx="1">
-            <a:schemeClr val="accent1"/>
-          </a:lnRef>
-          <a:fillRef idx="3">
-            <a:schemeClr val="accent1"/>
-          </a:fillRef>
-          <a:effectRef idx="2">
-            <a:schemeClr val="accent1"/>
-          </a:effectRef>
-          <a:fontRef idx="minor">
-            <a:schemeClr val="lt1"/>
-          </a:fontRef>
-        </p:style>
-        <p:txBody>
-          <a:bodyPr rtlCol="0" anchor="ctr"/>
-          <a:lstStyle/>
-          <a:p>
-            <a:pPr algn="ctr"/>
-          </a:p>
-        </p:txBody>
-      </p:sp>
-      <p:sp>
-        <p:nvSpPr>
-          <p:cNvPr id="15" name="TextBox 14"/>
-          <p:cNvSpPr txBox="1"/>
-          <p:nvPr/>
-        </p:nvSpPr>
-        <p:spPr>
-          <a:xfrm>
-            <a:off x="4434840" y="1325880"/>
-            <a:ext cx="3611880" cy="502920"/>
-          </a:xfrm>
-          <a:prstGeom prst="rect">
-            <a:avLst/>
-          </a:prstGeom>
-          <a:noFill/>
-        </p:spPr>
-        <p:txBody>
-          <a:bodyPr wrap="square" anchor="ctr">
-            <a:spAutoFit/>
-          </a:bodyPr>
-          <a:lstStyle/>
-          <a:p>
-            <a:pPr algn="ctr">
-              <a:lnSpc>
-                <a:spcPct val="100000"/>
-              </a:lnSpc>
-              <a:spcAft>
-                <a:spcPts val="400"/>
-              </a:spcAft>
-            </a:pPr>
-            <a:r>
-              <a:rPr sz="1400" b="1">
-                <a:solidFill>
-                  <a:srgbClr val="FFFFFF"/>
-                </a:solidFill>
-                <a:latin typeface="Apple SD Gothic Neo"/>
-              </a:rPr>
-              <a:t>신중 적용</a:t>
-            </a:r>
-          </a:p>
-        </p:txBody>
-      </p:sp>
-      <p:sp>
-        <p:nvSpPr>
-          <p:cNvPr id="16" name="TextBox 15"/>
-          <p:cNvSpPr txBox="1"/>
-          <p:nvPr/>
-        </p:nvSpPr>
-        <p:spPr>
-          <a:xfrm>
-            <a:off x="4663440" y="2011680"/>
-            <a:ext cx="3154680" cy="320040"/>
-          </a:xfrm>
-          <a:prstGeom prst="rect">
-            <a:avLst/>
-          </a:prstGeom>
-          <a:noFill/>
-        </p:spPr>
-        <p:txBody>
-          <a:bodyPr wrap="square" anchor="t">
-            <a:spAutoFit/>
-          </a:bodyPr>
-          <a:lstStyle/>
-          <a:p>
-            <a:pPr algn="l">
-              <a:lnSpc>
-                <a:spcPct val="100000"/>
-              </a:lnSpc>
-              <a:spcAft>
-                <a:spcPts val="400"/>
-              </a:spcAft>
-            </a:pPr>
-            <a:r>
-              <a:rPr sz="1150" b="0">
-                <a:solidFill>
-                  <a:srgbClr val="444A55"/>
-                </a:solidFill>
-                <a:latin typeface="Apple SD Gothic Neo"/>
-              </a:rPr>
-              <a:t>- 회로·부품 최종 판단</a:t>
-            </a:r>
-          </a:p>
-        </p:txBody>
-      </p:sp>
-      <p:sp>
-        <p:nvSpPr>
-          <p:cNvPr id="17" name="TextBox 16"/>
-          <p:cNvSpPr txBox="1"/>
-          <p:nvPr/>
-        </p:nvSpPr>
-        <p:spPr>
-          <a:xfrm>
-            <a:off x="4663440" y="2468880"/>
-            <a:ext cx="3154680" cy="320040"/>
-          </a:xfrm>
-          <a:prstGeom prst="rect">
-            <a:avLst/>
-          </a:prstGeom>
-          <a:noFill/>
-        </p:spPr>
-        <p:txBody>
-          <a:bodyPr wrap="square" anchor="t">
-            <a:spAutoFit/>
-          </a:bodyPr>
-          <a:lstStyle/>
-          <a:p>
-            <a:pPr algn="l">
-              <a:lnSpc>
-                <a:spcPct val="100000"/>
-              </a:lnSpc>
-              <a:spcAft>
-                <a:spcPts val="400"/>
-              </a:spcAft>
-            </a:pPr>
-            <a:r>
-              <a:rPr sz="1150" b="0">
-                <a:solidFill>
-                  <a:srgbClr val="444A55"/>
-                </a:solidFill>
-                <a:latin typeface="Apple SD Gothic Neo"/>
-              </a:rPr>
-              <a:t>- 불량 원인 확정</a:t>
-            </a:r>
-          </a:p>
-        </p:txBody>
-      </p:sp>
-      <p:sp>
-        <p:nvSpPr>
-          <p:cNvPr id="18" name="TextBox 17"/>
-          <p:cNvSpPr txBox="1"/>
-          <p:nvPr/>
-        </p:nvSpPr>
-        <p:spPr>
-          <a:xfrm>
-            <a:off x="4663440" y="2926080"/>
-            <a:ext cx="3154680" cy="320040"/>
-          </a:xfrm>
-          <a:prstGeom prst="rect">
-            <a:avLst/>
-          </a:prstGeom>
-          <a:noFill/>
-        </p:spPr>
-        <p:txBody>
-          <a:bodyPr wrap="square" anchor="t">
-            <a:spAutoFit/>
-          </a:bodyPr>
-          <a:lstStyle/>
-          <a:p>
-            <a:pPr algn="l">
-              <a:lnSpc>
-                <a:spcPct val="100000"/>
-              </a:lnSpc>
-              <a:spcAft>
-                <a:spcPts val="400"/>
-              </a:spcAft>
-            </a:pPr>
-            <a:r>
-              <a:rPr sz="1150" b="0">
-                <a:solidFill>
-                  <a:srgbClr val="444A55"/>
-                </a:solidFill>
-                <a:latin typeface="Apple SD Gothic Neo"/>
-              </a:rPr>
-              <a:t>- 양산 영향 평가</a:t>
-            </a:r>
-          </a:p>
-        </p:txBody>
-      </p:sp>
-      <p:sp>
-        <p:nvSpPr>
-          <p:cNvPr id="19" name="Rounded Rectangle 18"/>
-          <p:cNvSpPr/>
-          <p:nvPr/>
-        </p:nvSpPr>
-        <p:spPr>
-          <a:xfrm>
-            <a:off x="8275320" y="1325880"/>
-            <a:ext cx="3611880" cy="2926080"/>
-          </a:xfrm>
-          <a:prstGeom prst="roundRect">
-            <a:avLst/>
-          </a:prstGeom>
-          <a:solidFill>
-            <a:srgbClr val="FFFFFF"/>
-          </a:solidFill>
-          <a:ln w="22860">
-            <a:solidFill>
-              <a:srgbClr val="C0392B"/>
-            </a:solidFill>
-          </a:ln>
-          <a:effectLst/>
-        </p:spPr>
-        <p:style>
-          <a:lnRef idx="1">
-            <a:schemeClr val="accent1"/>
-          </a:lnRef>
-          <a:fillRef idx="3">
-            <a:schemeClr val="accent1"/>
-          </a:fillRef>
-          <a:effectRef idx="2">
-            <a:schemeClr val="accent1"/>
-          </a:effectRef>
-          <a:fontRef idx="minor">
-            <a:schemeClr val="lt1"/>
-          </a:fontRef>
-        </p:style>
-        <p:txBody>
-          <a:bodyPr rtlCol="0" anchor="ctr"/>
-          <a:lstStyle/>
-          <a:p>
-            <a:pPr algn="ctr"/>
-          </a:p>
-        </p:txBody>
-      </p:sp>
-      <p:sp>
-        <p:nvSpPr>
-          <p:cNvPr id="20" name="Rounded Rectangle 19"/>
-          <p:cNvSpPr/>
-          <p:nvPr/>
-        </p:nvSpPr>
-        <p:spPr>
-          <a:xfrm>
-            <a:off x="8275320" y="1325880"/>
-            <a:ext cx="3611880" cy="502920"/>
-          </a:xfrm>
-          <a:prstGeom prst="roundRect">
-            <a:avLst/>
-          </a:prstGeom>
-          <a:solidFill>
-            <a:srgbClr val="C0392B"/>
-          </a:solidFill>
-          <a:ln>
-            <a:noFill/>
-          </a:ln>
-          <a:effectLst/>
-        </p:spPr>
-        <p:style>
-          <a:lnRef idx="1">
-            <a:schemeClr val="accent1"/>
-          </a:lnRef>
-          <a:fillRef idx="3">
-            <a:schemeClr val="accent1"/>
-          </a:fillRef>
-          <a:effectRef idx="2">
-            <a:schemeClr val="accent1"/>
-          </a:effectRef>
-          <a:fontRef idx="minor">
-            <a:schemeClr val="lt1"/>
-          </a:fontRef>
-        </p:style>
-        <p:txBody>
-          <a:bodyPr rtlCol="0" anchor="ctr"/>
-          <a:lstStyle/>
-          <a:p>
-            <a:pPr algn="ctr"/>
-          </a:p>
-        </p:txBody>
-      </p:sp>
-      <p:sp>
-        <p:nvSpPr>
-          <p:cNvPr id="21" name="TextBox 20"/>
-          <p:cNvSpPr txBox="1"/>
-          <p:nvPr/>
-        </p:nvSpPr>
-        <p:spPr>
-          <a:xfrm>
-            <a:off x="8275320" y="1325880"/>
-            <a:ext cx="3611880" cy="502920"/>
-          </a:xfrm>
-          <a:prstGeom prst="rect">
-            <a:avLst/>
-          </a:prstGeom>
-          <a:noFill/>
-        </p:spPr>
-        <p:txBody>
-          <a:bodyPr wrap="square" anchor="ctr">
-            <a:spAutoFit/>
-          </a:bodyPr>
-          <a:lstStyle/>
-          <a:p>
-            <a:pPr algn="ctr">
-              <a:lnSpc>
-                <a:spcPct val="100000"/>
-              </a:lnSpc>
-              <a:spcAft>
-                <a:spcPts val="400"/>
-              </a:spcAft>
-            </a:pPr>
-            <a:r>
-              <a:rPr sz="1400" b="1">
-                <a:solidFill>
-                  <a:srgbClr val="FFFFFF"/>
-                </a:solidFill>
-                <a:latin typeface="Apple SD Gothic Neo"/>
-              </a:rPr>
-              <a:t>개선·검토 과제</a:t>
-            </a:r>
-          </a:p>
-        </p:txBody>
-      </p:sp>
-      <p:sp>
-        <p:nvSpPr>
-          <p:cNvPr id="22" name="TextBox 21"/>
-          <p:cNvSpPr txBox="1"/>
-          <p:nvPr/>
-        </p:nvSpPr>
-        <p:spPr>
-          <a:xfrm>
-            <a:off x="8503920" y="2011680"/>
-            <a:ext cx="3154680" cy="320040"/>
-          </a:xfrm>
-          <a:prstGeom prst="rect">
-            <a:avLst/>
-          </a:prstGeom>
-          <a:noFill/>
-        </p:spPr>
-        <p:txBody>
-          <a:bodyPr wrap="square" anchor="t">
-            <a:spAutoFit/>
-          </a:bodyPr>
-          <a:lstStyle/>
-          <a:p>
-            <a:pPr algn="l">
-              <a:lnSpc>
-                <a:spcPct val="100000"/>
-              </a:lnSpc>
-              <a:spcAft>
-                <a:spcPts val="400"/>
-              </a:spcAft>
-            </a:pPr>
-            <a:r>
-              <a:rPr sz="1150" b="0">
-                <a:solidFill>
-                  <a:srgbClr val="444A55"/>
-                </a:solidFill>
-                <a:latin typeface="Apple SD Gothic Neo"/>
-              </a:rPr>
-              <a:t>- 보안·법무 승인</a:t>
-            </a:r>
-          </a:p>
-        </p:txBody>
-      </p:sp>
-      <p:sp>
-        <p:nvSpPr>
-          <p:cNvPr id="23" name="TextBox 22"/>
-          <p:cNvSpPr txBox="1"/>
-          <p:nvPr/>
-        </p:nvSpPr>
-        <p:spPr>
-          <a:xfrm>
-            <a:off x="8503920" y="2468880"/>
-            <a:ext cx="3154680" cy="320040"/>
-          </a:xfrm>
-          <a:prstGeom prst="rect">
-            <a:avLst/>
-          </a:prstGeom>
-          <a:noFill/>
-        </p:spPr>
-        <p:txBody>
-          <a:bodyPr wrap="square" anchor="t">
-            <a:spAutoFit/>
-          </a:bodyPr>
-          <a:lstStyle/>
-          <a:p>
-            <a:pPr algn="l">
-              <a:lnSpc>
-                <a:spcPct val="100000"/>
-              </a:lnSpc>
-              <a:spcAft>
-                <a:spcPts val="400"/>
-              </a:spcAft>
-            </a:pPr>
-            <a:r>
-              <a:rPr sz="1150" b="0">
-                <a:solidFill>
-                  <a:srgbClr val="444A55"/>
-                </a:solidFill>
-                <a:latin typeface="Apple SD Gothic Neo"/>
-              </a:rPr>
-              <a:t>- 사내 Gauss와 역할 분리</a:t>
-            </a:r>
-          </a:p>
-        </p:txBody>
-      </p:sp>
-      <p:sp>
-        <p:nvSpPr>
-          <p:cNvPr id="24" name="TextBox 23"/>
-          <p:cNvSpPr txBox="1"/>
-          <p:nvPr/>
-        </p:nvSpPr>
-        <p:spPr>
-          <a:xfrm>
-            <a:off x="8503920" y="2926080"/>
-            <a:ext cx="3154680" cy="320040"/>
-          </a:xfrm>
-          <a:prstGeom prst="rect">
-            <a:avLst/>
-          </a:prstGeom>
-          <a:noFill/>
-        </p:spPr>
-        <p:txBody>
-          <a:bodyPr wrap="square" anchor="t">
-            <a:spAutoFit/>
-          </a:bodyPr>
-          <a:lstStyle/>
-          <a:p>
-            <a:pPr algn="l">
-              <a:lnSpc>
-                <a:spcPct val="100000"/>
-              </a:lnSpc>
-              <a:spcAft>
-                <a:spcPts val="400"/>
-              </a:spcAft>
-            </a:pPr>
-            <a:r>
-              <a:rPr sz="1150" b="0">
-                <a:solidFill>
-                  <a:srgbClr val="444A55"/>
-                </a:solidFill>
-                <a:latin typeface="Apple SD Gothic Neo"/>
-              </a:rPr>
-              <a:t>- 팀 공통 가이드</a:t>
-            </a:r>
-          </a:p>
-        </p:txBody>
-      </p:sp>
-      <p:sp>
-        <p:nvSpPr>
-          <p:cNvPr id="25" name="TextBox 24"/>
-          <p:cNvSpPr txBox="1"/>
-          <p:nvPr/>
-        </p:nvSpPr>
-        <p:spPr>
-          <a:xfrm>
-            <a:off x="8503920" y="3383280"/>
-            <a:ext cx="3154680" cy="320040"/>
-          </a:xfrm>
-          <a:prstGeom prst="rect">
-            <a:avLst/>
-          </a:prstGeom>
-          <a:noFill/>
-        </p:spPr>
-        <p:txBody>
-          <a:bodyPr wrap="square" anchor="t">
-            <a:spAutoFit/>
-          </a:bodyPr>
-          <a:lstStyle/>
-          <a:p>
-            <a:pPr algn="l">
-              <a:lnSpc>
-                <a:spcPct val="100000"/>
-              </a:lnSpc>
-              <a:spcAft>
-                <a:spcPts val="400"/>
-              </a:spcAft>
-            </a:pPr>
-            <a:r>
-              <a:rPr sz="1150" b="0">
-                <a:solidFill>
-                  <a:srgbClr val="444A55"/>
-                </a:solidFill>
-                <a:latin typeface="Apple SD Gothic Neo"/>
-              </a:rPr>
-              <a:t>- 도구별 라이선스</a:t>
-            </a:r>
-          </a:p>
-        </p:txBody>
-      </p:sp>
-      <p:sp>
-        <p:nvSpPr>
-          <p:cNvPr id="26" name="Rounded Rectangle 25"/>
-          <p:cNvSpPr/>
-          <p:nvPr/>
-        </p:nvSpPr>
-        <p:spPr>
-          <a:xfrm>
-            <a:off x="594360" y="4526280"/>
-            <a:ext cx="11018520" cy="1417320"/>
+            <a:off x="502920" y="4315968"/>
+            <a:ext cx="11247120" cy="1627632"/>
           </a:xfrm>
           <a:prstGeom prst="roundRect">
             <a:avLst/>
@@ -15494,87 +15433,87 @@
       </p:sp>
       <p:sp>
         <p:nvSpPr>
+          <p:cNvPr id="26" name="TextBox 25"/>
+          <p:cNvSpPr txBox="1"/>
+          <p:nvPr/>
+        </p:nvSpPr>
+        <p:spPr>
+          <a:xfrm>
+            <a:off x="777240" y="4462272"/>
+            <a:ext cx="10698480" cy="1371600"/>
+          </a:xfrm>
+          <a:prstGeom prst="rect">
+            <a:avLst/>
+          </a:prstGeom>
+          <a:noFill/>
+        </p:spPr>
+        <p:txBody>
+          <a:bodyPr wrap="square" anchor="t">
+            <a:spAutoFit/>
+          </a:bodyPr>
+          <a:lstStyle/>
+          <a:p>
+            <a:pPr algn="l">
+              <a:lnSpc>
+                <a:spcPct val="114000"/>
+              </a:lnSpc>
+              <a:spcAft>
+                <a:spcPts val="200"/>
+              </a:spcAft>
+            </a:pPr>
+            <a:r>
+              <a:rPr sz="1500" b="1">
+                <a:solidFill>
+                  <a:srgbClr val="9FC4E8"/>
+                </a:solidFill>
+                <a:latin typeface="Apple SD Gothic Neo"/>
+              </a:rPr>
+              <a:t>종합 결론 및 도입 제언</a:t>
+            </a:r>
+          </a:p>
+          <a:p>
+            <a:pPr algn="l">
+              <a:lnSpc>
+                <a:spcPct val="114000"/>
+              </a:lnSpc>
+              <a:spcAft>
+                <a:spcPts val="200"/>
+              </a:spcAft>
+            </a:pPr>
+            <a:r>
+              <a:rPr sz="1200" b="0">
+                <a:solidFill>
+                  <a:srgbClr val="FFFFFF"/>
+                </a:solidFill>
+                <a:latin typeface="Apple SD Gothic Neo"/>
+              </a:rPr>
+              <a:t>· 외부 LLM은 사내 Gauss(망분리 보조)를 대체하지 않고, 보안 검토 후 고급 보조 수단으로 역할을 분담합니다.</a:t>
+            </a:r>
+          </a:p>
+          <a:p>
+            <a:pPr algn="l">
+              <a:lnSpc>
+                <a:spcPct val="114000"/>
+              </a:lnSpc>
+              <a:spcAft>
+                <a:spcPts val="200"/>
+              </a:spcAft>
+            </a:pPr>
+            <a:r>
+              <a:rPr sz="1200" b="0">
+                <a:solidFill>
+                  <a:srgbClr val="FFFFFF"/>
+                </a:solidFill>
+                <a:latin typeface="Apple SD Gothic Neo"/>
+              </a:rPr>
+              <a:t>· 권장안: 업무별 PoC 1~2건 선정 → 효과·보안·사용 한도 정량 측정 → 팀 표준 활용 가이드 수립.</a:t>
+            </a:r>
+          </a:p>
+        </p:txBody>
+      </p:sp>
+      <p:sp>
+        <p:nvSpPr>
           <p:cNvPr id="27" name="TextBox 26"/>
-          <p:cNvSpPr txBox="1"/>
-          <p:nvPr/>
-        </p:nvSpPr>
-        <p:spPr>
-          <a:xfrm>
-            <a:off x="822960" y="4663440"/>
-            <a:ext cx="10515600" cy="1143000"/>
-          </a:xfrm>
-          <a:prstGeom prst="rect">
-            <a:avLst/>
-          </a:prstGeom>
-          <a:noFill/>
-        </p:spPr>
-        <p:txBody>
-          <a:bodyPr wrap="square" anchor="t">
-            <a:spAutoFit/>
-          </a:bodyPr>
-          <a:lstStyle/>
-          <a:p>
-            <a:pPr algn="l">
-              <a:lnSpc>
-                <a:spcPct val="110000"/>
-              </a:lnSpc>
-              <a:spcAft>
-                <a:spcPts val="200"/>
-              </a:spcAft>
-            </a:pPr>
-            <a:r>
-              <a:rPr sz="1500" b="1">
-                <a:solidFill>
-                  <a:srgbClr val="9FC4E8"/>
-                </a:solidFill>
-                <a:latin typeface="Apple SD Gothic Neo"/>
-              </a:rPr>
-              <a:t>최종 결론</a:t>
-            </a:r>
-          </a:p>
-          <a:p>
-            <a:pPr algn="l">
-              <a:lnSpc>
-                <a:spcPct val="110000"/>
-              </a:lnSpc>
-              <a:spcAft>
-                <a:spcPts val="200"/>
-              </a:spcAft>
-            </a:pPr>
-            <a:r>
-              <a:rPr sz="1250" b="0">
-                <a:solidFill>
-                  <a:srgbClr val="FFFFFF"/>
-                </a:solidFill>
-                <a:latin typeface="Apple SD Gothic Neo"/>
-              </a:rPr>
-              <a:t>외부 AI는 사내 Gauss를 대체하기보다, 보안 검토 후 '고급 보조'로 쓰는 것이 현실적입니다.</a:t>
-            </a:r>
-          </a:p>
-          <a:p>
-            <a:pPr algn="l">
-              <a:lnSpc>
-                <a:spcPct val="110000"/>
-              </a:lnSpc>
-              <a:spcAft>
-                <a:spcPts val="200"/>
-              </a:spcAft>
-            </a:pPr>
-            <a:r>
-              <a:rPr sz="1250" b="0">
-                <a:solidFill>
-                  <a:srgbClr val="FFFFFF"/>
-                </a:solidFill>
-                <a:latin typeface="Apple SD Gothic Neo"/>
-              </a:rPr>
-              <a:t>6월 도입 전: 업무별 PoC 1~2건 선정 → 효과·보안 측정 → 팀 표준 가이드화를 제안합니다.</a:t>
-            </a:r>
-          </a:p>
-        </p:txBody>
-      </p:sp>
-      <p:sp>
-        <p:nvSpPr>
-          <p:cNvPr id="28" name="TextBox 27"/>
           <p:cNvSpPr txBox="1"/>
           <p:nvPr/>
         </p:nvSpPr>
@@ -19629,7 +19568,7 @@
                 </a:solidFill>
                 <a:latin typeface="Apple SD Gothic Neo"/>
               </a:rPr>
-              <a:t>보고 목적 및 평가 기준</a:t>
+              <a:t>평가 대상 및 평가 기준</a:t>
             </a:r>
           </a:p>
         </p:txBody>
@@ -19642,7 +19581,7 @@
         </p:nvSpPr>
         <p:spPr>
           <a:xfrm>
-            <a:off x="502920" y="1097280"/>
+            <a:off x="502920" y="1143000"/>
             <a:ext cx="63500" cy="292608"/>
           </a:xfrm>
           <a:prstGeom prst="rect">
@@ -19686,7 +19625,7 @@
         </p:nvSpPr>
         <p:spPr>
           <a:xfrm>
-            <a:off x="612648" y="1078992"/>
+            <a:off x="612648" y="1124712"/>
             <a:ext cx="5486400" cy="329184"/>
           </a:xfrm>
           <a:prstGeom prst="rect">
@@ -19715,168 +19654,21 @@
                 </a:solidFill>
                 <a:latin typeface="Apple SD Gothic Neo"/>
               </a:rPr>
-              <a:t>왜 지금 비교하나</a:t>
-            </a:r>
-          </a:p>
-        </p:txBody>
-      </p:sp>
-      <p:sp>
-        <p:nvSpPr>
-          <p:cNvPr id="8" name="TextBox 7"/>
-          <p:cNvSpPr txBox="1"/>
-          <p:nvPr/>
-        </p:nvSpPr>
-        <p:spPr>
-          <a:xfrm>
-            <a:off x="640080" y="1508760"/>
-            <a:ext cx="10972800" cy="914400"/>
-          </a:xfrm>
-          <a:prstGeom prst="rect">
-            <a:avLst/>
-          </a:prstGeom>
-          <a:noFill/>
-        </p:spPr>
-        <p:txBody>
-          <a:bodyPr wrap="square" anchor="t">
-            <a:spAutoFit/>
-          </a:bodyPr>
-          <a:lstStyle/>
-          <a:p>
-            <a:pPr algn="l">
-              <a:lnSpc>
-                <a:spcPct val="112000"/>
-              </a:lnSpc>
-              <a:spcAft>
-                <a:spcPts val="400"/>
-              </a:spcAft>
-            </a:pPr>
-            <a:r>
-              <a:rPr sz="1300" b="0">
-                <a:solidFill>
-                  <a:srgbClr val="444A55"/>
-                </a:solidFill>
-                <a:latin typeface="Apple SD Gothic Neo"/>
-              </a:rPr>
-              <a:t>2026년 6월부터 외부 AI 도입을 검토합니다. 도입 전 ChatGPT·Gemini·Claude 각각의</a:t>
-            </a:r>
-          </a:p>
-          <a:p>
-            <a:pPr algn="l">
-              <a:lnSpc>
-                <a:spcPct val="112000"/>
-              </a:lnSpc>
-              <a:spcAft>
-                <a:spcPts val="400"/>
-              </a:spcAft>
-            </a:pPr>
-            <a:r>
-              <a:rPr sz="1300" b="0">
-                <a:solidFill>
-                  <a:srgbClr val="444A55"/>
-                </a:solidFill>
-                <a:latin typeface="Apple SD Gothic Neo"/>
-              </a:rPr>
-              <a:t>강점과 차이를 알아두어, 우리 팀 업무에 맞는 도구를 고르기 위한 조사입니다.</a:t>
-            </a:r>
-          </a:p>
-        </p:txBody>
-      </p:sp>
-      <p:sp>
-        <p:nvSpPr>
-          <p:cNvPr id="9" name="Rectangle 8"/>
+              <a:t>평가 대상 (3종)</a:t>
+            </a:r>
+          </a:p>
+        </p:txBody>
+      </p:sp>
+      <p:sp>
+        <p:nvSpPr>
+          <p:cNvPr id="8" name="Rounded Rectangle 7"/>
           <p:cNvSpPr/>
           <p:nvPr/>
         </p:nvSpPr>
         <p:spPr>
           <a:xfrm>
-            <a:off x="502920" y="2606040"/>
-            <a:ext cx="63500" cy="292608"/>
-          </a:xfrm>
-          <a:prstGeom prst="rect">
-            <a:avLst/>
-          </a:prstGeom>
-          <a:solidFill>
-            <a:srgbClr val="1F6FB2"/>
-          </a:solidFill>
-          <a:ln>
-            <a:noFill/>
-          </a:ln>
-          <a:effectLst/>
-        </p:spPr>
-        <p:style>
-          <a:lnRef idx="1">
-            <a:schemeClr val="accent1"/>
-          </a:lnRef>
-          <a:fillRef idx="3">
-            <a:schemeClr val="accent1"/>
-          </a:fillRef>
-          <a:effectRef idx="2">
-            <a:schemeClr val="accent1"/>
-          </a:effectRef>
-          <a:fontRef idx="minor">
-            <a:schemeClr val="lt1"/>
-          </a:fontRef>
-        </p:style>
-        <p:txBody>
-          <a:bodyPr rtlCol="0" anchor="ctr"/>
-          <a:lstStyle/>
-          <a:p>
-            <a:pPr algn="ctr"/>
-          </a:p>
-        </p:txBody>
-      </p:sp>
-      <p:sp>
-        <p:nvSpPr>
-          <p:cNvPr id="10" name="TextBox 9"/>
-          <p:cNvSpPr txBox="1"/>
-          <p:nvPr/>
-        </p:nvSpPr>
-        <p:spPr>
-          <a:xfrm>
-            <a:off x="612648" y="2587752"/>
-            <a:ext cx="5486400" cy="329184"/>
-          </a:xfrm>
-          <a:prstGeom prst="rect">
-            <a:avLst/>
-          </a:prstGeom>
-          <a:noFill/>
-        </p:spPr>
-        <p:txBody>
-          <a:bodyPr wrap="square" anchor="t">
-            <a:spAutoFit/>
-          </a:bodyPr>
-          <a:lstStyle/>
-          <a:p>
-            <a:pPr algn="l">
-              <a:lnSpc>
-                <a:spcPct val="100000"/>
-              </a:lnSpc>
-              <a:spcAft>
-                <a:spcPts val="400"/>
-              </a:spcAft>
-            </a:pPr>
-            <a:r>
-              <a:rPr sz="1450" b="1">
-                <a:solidFill>
-                  <a:srgbClr val="142A4A"/>
-                </a:solidFill>
-                <a:latin typeface="Apple SD Gothic Neo"/>
-              </a:rPr>
-              <a:t>평가 기준 (6가지)</a:t>
-            </a:r>
-          </a:p>
-        </p:txBody>
-      </p:sp>
-      <p:sp>
-        <p:nvSpPr>
-          <p:cNvPr id="11" name="Rounded Rectangle 10"/>
-          <p:cNvSpPr/>
-          <p:nvPr/>
-        </p:nvSpPr>
-        <p:spPr>
-          <a:xfrm>
-            <a:off x="640080" y="3017520"/>
-            <a:ext cx="5303520" cy="438912"/>
+            <a:off x="548640" y="1572768"/>
+            <a:ext cx="5349240" cy="603504"/>
           </a:xfrm>
           <a:prstGeom prst="roundRect">
             <a:avLst/>
@@ -19915,14 +19707,14 @@
       </p:sp>
       <p:sp>
         <p:nvSpPr>
-          <p:cNvPr id="12" name="TextBox 11"/>
-          <p:cNvSpPr txBox="1"/>
-          <p:nvPr/>
-        </p:nvSpPr>
-        <p:spPr>
-          <a:xfrm>
-            <a:off x="822960" y="3017520"/>
-            <a:ext cx="5029200" cy="438912"/>
+          <p:cNvPr id="9" name="TextBox 8"/>
+          <p:cNvSpPr txBox="1"/>
+          <p:nvPr/>
+        </p:nvSpPr>
+        <p:spPr>
+          <a:xfrm>
+            <a:off x="731520" y="1572768"/>
+            <a:ext cx="1371600" cy="603504"/>
           </a:xfrm>
           <a:prstGeom prst="rect">
             <a:avLst/>
@@ -19944,27 +19736,69 @@
               </a:spcAft>
             </a:pPr>
             <a:r>
-              <a:rPr sz="1200" b="0">
+              <a:rPr sz="1300" b="1">
+                <a:solidFill>
+                  <a:srgbClr val="142A4A"/>
+                </a:solidFill>
+                <a:latin typeface="Apple SD Gothic Neo"/>
+              </a:rPr>
+              <a:t>ChatGPT</a:t>
+            </a:r>
+          </a:p>
+        </p:txBody>
+      </p:sp>
+      <p:sp>
+        <p:nvSpPr>
+          <p:cNvPr id="10" name="TextBox 9"/>
+          <p:cNvSpPr txBox="1"/>
+          <p:nvPr/>
+        </p:nvSpPr>
+        <p:spPr>
+          <a:xfrm>
+            <a:off x="2011680" y="1572768"/>
+            <a:ext cx="3749039" cy="603504"/>
+          </a:xfrm>
+          <a:prstGeom prst="rect">
+            <a:avLst/>
+          </a:prstGeom>
+          <a:noFill/>
+        </p:spPr>
+        <p:txBody>
+          <a:bodyPr wrap="square" anchor="ctr">
+            <a:spAutoFit/>
+          </a:bodyPr>
+          <a:lstStyle/>
+          <a:p>
+            <a:pPr algn="l">
+              <a:lnSpc>
+                <a:spcPct val="100000"/>
+              </a:lnSpc>
+              <a:spcAft>
+                <a:spcPts val="400"/>
+              </a:spcAft>
+            </a:pPr>
+            <a:r>
+              <a:rPr sz="1050" b="0">
                 <a:solidFill>
                   <a:srgbClr val="444A55"/>
                 </a:solidFill>
                 <a:latin typeface="Apple SD Gothic Neo"/>
               </a:rPr>
-              <a:t>• 생산성 (코딩·문서·반복 업무)</a:t>
-            </a:r>
-          </a:p>
-        </p:txBody>
-      </p:sp>
-      <p:sp>
-        <p:nvSpPr>
-          <p:cNvPr id="13" name="Rounded Rectangle 12"/>
+              <a:t>OpenAI · GPT-5.x · 범용 / 에이전트</a:t>
+            </a:r>
+          </a:p>
+        </p:txBody>
+      </p:sp>
+      <p:sp>
+        <p:nvSpPr>
+          <p:cNvPr id="11" name="Rounded Rectangle 10"/>
           <p:cNvSpPr/>
           <p:nvPr/>
         </p:nvSpPr>
         <p:spPr>
           <a:xfrm>
-            <a:off x="640080" y="3520440"/>
-            <a:ext cx="5303520" cy="438912"/>
+            <a:off x="548640" y="2286000"/>
+            <a:ext cx="5349240" cy="603504"/>
           </a:xfrm>
           <a:prstGeom prst="roundRect">
             <a:avLst/>
@@ -20003,14 +19837,14 @@
       </p:sp>
       <p:sp>
         <p:nvSpPr>
-          <p:cNvPr id="14" name="TextBox 13"/>
-          <p:cNvSpPr txBox="1"/>
-          <p:nvPr/>
-        </p:nvSpPr>
-        <p:spPr>
-          <a:xfrm>
-            <a:off x="822960" y="3520440"/>
-            <a:ext cx="5029200" cy="438912"/>
+          <p:cNvPr id="12" name="TextBox 11"/>
+          <p:cNvSpPr txBox="1"/>
+          <p:nvPr/>
+        </p:nvSpPr>
+        <p:spPr>
+          <a:xfrm>
+            <a:off x="731520" y="2286000"/>
+            <a:ext cx="1371600" cy="603504"/>
           </a:xfrm>
           <a:prstGeom prst="rect">
             <a:avLst/>
@@ -20032,27 +19866,69 @@
               </a:spcAft>
             </a:pPr>
             <a:r>
-              <a:rPr sz="1200" b="0">
+              <a:rPr sz="1300" b="1">
+                <a:solidFill>
+                  <a:srgbClr val="142A4A"/>
+                </a:solidFill>
+                <a:latin typeface="Apple SD Gothic Neo"/>
+              </a:rPr>
+              <a:t>Gemini</a:t>
+            </a:r>
+          </a:p>
+        </p:txBody>
+      </p:sp>
+      <p:sp>
+        <p:nvSpPr>
+          <p:cNvPr id="13" name="TextBox 12"/>
+          <p:cNvSpPr txBox="1"/>
+          <p:nvPr/>
+        </p:nvSpPr>
+        <p:spPr>
+          <a:xfrm>
+            <a:off x="2011680" y="2286000"/>
+            <a:ext cx="3749039" cy="603504"/>
+          </a:xfrm>
+          <a:prstGeom prst="rect">
+            <a:avLst/>
+          </a:prstGeom>
+          <a:noFill/>
+        </p:spPr>
+        <p:txBody>
+          <a:bodyPr wrap="square" anchor="ctr">
+            <a:spAutoFit/>
+          </a:bodyPr>
+          <a:lstStyle/>
+          <a:p>
+            <a:pPr algn="l">
+              <a:lnSpc>
+                <a:spcPct val="100000"/>
+              </a:lnSpc>
+              <a:spcAft>
+                <a:spcPts val="400"/>
+              </a:spcAft>
+            </a:pPr>
+            <a:r>
+              <a:rPr sz="1050" b="0">
                 <a:solidFill>
                   <a:srgbClr val="444A55"/>
                 </a:solidFill>
                 <a:latin typeface="Apple SD Gothic Neo"/>
               </a:rPr>
-              <a:t>• 에이전트 (자동으로 여러 단계 수행)</a:t>
-            </a:r>
-          </a:p>
-        </p:txBody>
-      </p:sp>
-      <p:sp>
-        <p:nvSpPr>
-          <p:cNvPr id="15" name="Rounded Rectangle 14"/>
+              <a:t>Google · 3.5 Flash · 장문 / 멀티모달</a:t>
+            </a:r>
+          </a:p>
+        </p:txBody>
+      </p:sp>
+      <p:sp>
+        <p:nvSpPr>
+          <p:cNvPr id="14" name="Rounded Rectangle 13"/>
           <p:cNvSpPr/>
           <p:nvPr/>
         </p:nvSpPr>
         <p:spPr>
           <a:xfrm>
-            <a:off x="640080" y="4023360"/>
-            <a:ext cx="5303520" cy="438912"/>
+            <a:off x="548640" y="2999232"/>
+            <a:ext cx="5349240" cy="603504"/>
           </a:xfrm>
           <a:prstGeom prst="roundRect">
             <a:avLst/>
@@ -20091,14 +19967,56 @@
       </p:sp>
       <p:sp>
         <p:nvSpPr>
+          <p:cNvPr id="15" name="TextBox 14"/>
+          <p:cNvSpPr txBox="1"/>
+          <p:nvPr/>
+        </p:nvSpPr>
+        <p:spPr>
+          <a:xfrm>
+            <a:off x="731520" y="2999232"/>
+            <a:ext cx="1371600" cy="603504"/>
+          </a:xfrm>
+          <a:prstGeom prst="rect">
+            <a:avLst/>
+          </a:prstGeom>
+          <a:noFill/>
+        </p:spPr>
+        <p:txBody>
+          <a:bodyPr wrap="square" anchor="ctr">
+            <a:spAutoFit/>
+          </a:bodyPr>
+          <a:lstStyle/>
+          <a:p>
+            <a:pPr algn="l">
+              <a:lnSpc>
+                <a:spcPct val="100000"/>
+              </a:lnSpc>
+              <a:spcAft>
+                <a:spcPts val="400"/>
+              </a:spcAft>
+            </a:pPr>
+            <a:r>
+              <a:rPr sz="1300" b="1">
+                <a:solidFill>
+                  <a:srgbClr val="142A4A"/>
+                </a:solidFill>
+                <a:latin typeface="Apple SD Gothic Neo"/>
+              </a:rPr>
+              <a:t>Claude</a:t>
+            </a:r>
+          </a:p>
+        </p:txBody>
+      </p:sp>
+      <p:sp>
+        <p:nvSpPr>
           <p:cNvPr id="16" name="TextBox 15"/>
           <p:cNvSpPr txBox="1"/>
           <p:nvPr/>
         </p:nvSpPr>
         <p:spPr>
           <a:xfrm>
-            <a:off x="822960" y="4023360"/>
-            <a:ext cx="5029200" cy="438912"/>
+            <a:off x="2011680" y="2999232"/>
+            <a:ext cx="3749039" cy="603504"/>
           </a:xfrm>
           <a:prstGeom prst="rect">
             <a:avLst/>
@@ -20120,27 +20038,113 @@
               </a:spcAft>
             </a:pPr>
             <a:r>
-              <a:rPr sz="1200" b="0">
+              <a:rPr sz="1050" b="0">
                 <a:solidFill>
                   <a:srgbClr val="444A55"/>
                 </a:solidFill>
                 <a:latin typeface="Apple SD Gothic Neo"/>
               </a:rPr>
-              <a:t>• 문서·지식 (긴 사양서·검색·OCR)</a:t>
-            </a:r>
-          </a:p>
-        </p:txBody>
-      </p:sp>
-      <p:sp>
-        <p:nvSpPr>
-          <p:cNvPr id="17" name="Rounded Rectangle 16"/>
+              <a:t>Anthropic · Opus/Sonnet · 코딩 / 장기 에이전트</a:t>
+            </a:r>
+          </a:p>
+        </p:txBody>
+      </p:sp>
+      <p:sp>
+        <p:nvSpPr>
+          <p:cNvPr id="17" name="Rectangle 16"/>
           <p:cNvSpPr/>
           <p:nvPr/>
         </p:nvSpPr>
         <p:spPr>
           <a:xfrm>
-            <a:off x="640080" y="4526280"/>
-            <a:ext cx="5303520" cy="438912"/>
+            <a:off x="6309360" y="1143000"/>
+            <a:ext cx="63500" cy="292608"/>
+          </a:xfrm>
+          <a:prstGeom prst="rect">
+            <a:avLst/>
+          </a:prstGeom>
+          <a:solidFill>
+            <a:srgbClr val="1F6FB2"/>
+          </a:solidFill>
+          <a:ln>
+            <a:noFill/>
+          </a:ln>
+          <a:effectLst/>
+        </p:spPr>
+        <p:style>
+          <a:lnRef idx="1">
+            <a:schemeClr val="accent1"/>
+          </a:lnRef>
+          <a:fillRef idx="3">
+            <a:schemeClr val="accent1"/>
+          </a:fillRef>
+          <a:effectRef idx="2">
+            <a:schemeClr val="accent1"/>
+          </a:effectRef>
+          <a:fontRef idx="minor">
+            <a:schemeClr val="lt1"/>
+          </a:fontRef>
+        </p:style>
+        <p:txBody>
+          <a:bodyPr rtlCol="0" anchor="ctr"/>
+          <a:lstStyle/>
+          <a:p>
+            <a:pPr algn="ctr"/>
+          </a:p>
+        </p:txBody>
+      </p:sp>
+      <p:sp>
+        <p:nvSpPr>
+          <p:cNvPr id="18" name="TextBox 17"/>
+          <p:cNvSpPr txBox="1"/>
+          <p:nvPr/>
+        </p:nvSpPr>
+        <p:spPr>
+          <a:xfrm>
+            <a:off x="6419088" y="1124712"/>
+            <a:ext cx="5486400" cy="329184"/>
+          </a:xfrm>
+          <a:prstGeom prst="rect">
+            <a:avLst/>
+          </a:prstGeom>
+          <a:noFill/>
+        </p:spPr>
+        <p:txBody>
+          <a:bodyPr wrap="square" anchor="t">
+            <a:spAutoFit/>
+          </a:bodyPr>
+          <a:lstStyle/>
+          <a:p>
+            <a:pPr algn="l">
+              <a:lnSpc>
+                <a:spcPct val="100000"/>
+              </a:lnSpc>
+              <a:spcAft>
+                <a:spcPts val="400"/>
+              </a:spcAft>
+            </a:pPr>
+            <a:r>
+              <a:rPr sz="1450" b="1">
+                <a:solidFill>
+                  <a:srgbClr val="142A4A"/>
+                </a:solidFill>
+                <a:latin typeface="Apple SD Gothic Neo"/>
+              </a:rPr>
+              <a:t>평가 기준 (6개 항목)</a:t>
+            </a:r>
+          </a:p>
+        </p:txBody>
+      </p:sp>
+      <p:sp>
+        <p:nvSpPr>
+          <p:cNvPr id="19" name="Rounded Rectangle 18"/>
+          <p:cNvSpPr/>
+          <p:nvPr/>
+        </p:nvSpPr>
+        <p:spPr>
+          <a:xfrm>
+            <a:off x="6355080" y="1554480"/>
+            <a:ext cx="5349240" cy="384048"/>
           </a:xfrm>
           <a:prstGeom prst="roundRect">
             <a:avLst/>
@@ -20179,14 +20183,14 @@
       </p:sp>
       <p:sp>
         <p:nvSpPr>
-          <p:cNvPr id="18" name="TextBox 17"/>
-          <p:cNvSpPr txBox="1"/>
-          <p:nvPr/>
-        </p:nvSpPr>
-        <p:spPr>
-          <a:xfrm>
-            <a:off x="822960" y="4526280"/>
-            <a:ext cx="5029200" cy="438912"/>
+          <p:cNvPr id="20" name="TextBox 19"/>
+          <p:cNvSpPr txBox="1"/>
+          <p:nvPr/>
+        </p:nvSpPr>
+        <p:spPr>
+          <a:xfrm>
+            <a:off x="6537960" y="1554480"/>
+            <a:ext cx="5029200" cy="384048"/>
           </a:xfrm>
           <a:prstGeom prst="rect">
             <a:avLst/>
@@ -20208,27 +20212,27 @@
               </a:spcAft>
             </a:pPr>
             <a:r>
-              <a:rPr sz="1200" b="0">
+              <a:rPr sz="1100" b="0">
                 <a:solidFill>
                   <a:srgbClr val="444A55"/>
                 </a:solidFill>
                 <a:latin typeface="Apple SD Gothic Neo"/>
               </a:rPr>
-              <a:t>• 멀티모달 (이미지·PDF 등)</a:t>
-            </a:r>
-          </a:p>
-        </p:txBody>
-      </p:sp>
-      <p:sp>
-        <p:nvSpPr>
-          <p:cNvPr id="19" name="Rounded Rectangle 18"/>
+              <a:t>• 생산성 (코딩·문서·반복 업무 자동화)</a:t>
+            </a:r>
+          </a:p>
+        </p:txBody>
+      </p:sp>
+      <p:sp>
+        <p:nvSpPr>
+          <p:cNvPr id="21" name="Rounded Rectangle 20"/>
           <p:cNvSpPr/>
           <p:nvPr/>
         </p:nvSpPr>
         <p:spPr>
           <a:xfrm>
-            <a:off x="640080" y="5029200"/>
-            <a:ext cx="5303520" cy="438912"/>
+            <a:off x="6355080" y="1993392"/>
+            <a:ext cx="5349240" cy="384048"/>
           </a:xfrm>
           <a:prstGeom prst="roundRect">
             <a:avLst/>
@@ -20267,14 +20271,14 @@
       </p:sp>
       <p:sp>
         <p:nvSpPr>
-          <p:cNvPr id="20" name="TextBox 19"/>
-          <p:cNvSpPr txBox="1"/>
-          <p:nvPr/>
-        </p:nvSpPr>
-        <p:spPr>
-          <a:xfrm>
-            <a:off x="822960" y="5029200"/>
-            <a:ext cx="5029200" cy="438912"/>
+          <p:cNvPr id="22" name="TextBox 21"/>
+          <p:cNvSpPr txBox="1"/>
+          <p:nvPr/>
+        </p:nvSpPr>
+        <p:spPr>
+          <a:xfrm>
+            <a:off x="6537960" y="1993392"/>
+            <a:ext cx="5029200" cy="384048"/>
           </a:xfrm>
           <a:prstGeom prst="rect">
             <a:avLst/>
@@ -20296,27 +20300,27 @@
               </a:spcAft>
             </a:pPr>
             <a:r>
-              <a:rPr sz="1200" b="0">
+              <a:rPr sz="1100" b="0">
                 <a:solidFill>
                   <a:srgbClr val="444A55"/>
                 </a:solidFill>
                 <a:latin typeface="Apple SD Gothic Neo"/>
               </a:rPr>
-              <a:t>• 엔터프라이즈 (관리·보안·연동)</a:t>
-            </a:r>
-          </a:p>
-        </p:txBody>
-      </p:sp>
-      <p:sp>
-        <p:nvSpPr>
-          <p:cNvPr id="21" name="Rounded Rectangle 20"/>
+              <a:t>• 에이전트 (다단계 작업 자동 수행)</a:t>
+            </a:r>
+          </a:p>
+        </p:txBody>
+      </p:sp>
+      <p:sp>
+        <p:nvSpPr>
+          <p:cNvPr id="23" name="Rounded Rectangle 22"/>
           <p:cNvSpPr/>
           <p:nvPr/>
         </p:nvSpPr>
         <p:spPr>
           <a:xfrm>
-            <a:off x="640080" y="5532120"/>
-            <a:ext cx="5303520" cy="438912"/>
+            <a:off x="6355080" y="2432304"/>
+            <a:ext cx="5349240" cy="384048"/>
           </a:xfrm>
           <a:prstGeom prst="roundRect">
             <a:avLst/>
@@ -20355,14 +20359,14 @@
       </p:sp>
       <p:sp>
         <p:nvSpPr>
-          <p:cNvPr id="22" name="TextBox 21"/>
-          <p:cNvSpPr txBox="1"/>
-          <p:nvPr/>
-        </p:nvSpPr>
-        <p:spPr>
-          <a:xfrm>
-            <a:off x="822960" y="5532120"/>
-            <a:ext cx="5029200" cy="438912"/>
+          <p:cNvPr id="24" name="TextBox 23"/>
+          <p:cNvSpPr txBox="1"/>
+          <p:nvPr/>
+        </p:nvSpPr>
+        <p:spPr>
+          <a:xfrm>
+            <a:off x="6537960" y="2432304"/>
+            <a:ext cx="5029200" cy="384048"/>
           </a:xfrm>
           <a:prstGeom prst="rect">
             <a:avLst/>
@@ -20384,27 +20388,291 @@
               </a:spcAft>
             </a:pPr>
             <a:r>
-              <a:rPr sz="1200" b="0">
+              <a:rPr sz="1100" b="0">
                 <a:solidFill>
                   <a:srgbClr val="444A55"/>
                 </a:solidFill>
                 <a:latin typeface="Apple SD Gothic Neo"/>
               </a:rPr>
-              <a:t>• 비용·속도 (API·사용 제한)</a:t>
-            </a:r>
-          </a:p>
-        </p:txBody>
-      </p:sp>
-      <p:sp>
-        <p:nvSpPr>
-          <p:cNvPr id="23" name="Rounded Rectangle 22"/>
+              <a:t>• 문서·지식 (장문 사양서·검색·OCR)</a:t>
+            </a:r>
+          </a:p>
+        </p:txBody>
+      </p:sp>
+      <p:sp>
+        <p:nvSpPr>
+          <p:cNvPr id="25" name="Rounded Rectangle 24"/>
           <p:cNvSpPr/>
           <p:nvPr/>
         </p:nvSpPr>
         <p:spPr>
           <a:xfrm>
-            <a:off x="6400800" y="2606040"/>
-            <a:ext cx="5257800" cy="3200400"/>
+            <a:off x="6355080" y="2871216"/>
+            <a:ext cx="5349240" cy="384048"/>
+          </a:xfrm>
+          <a:prstGeom prst="roundRect">
+            <a:avLst/>
+          </a:prstGeom>
+          <a:solidFill>
+            <a:srgbClr val="E8F1FA"/>
+          </a:solidFill>
+          <a:ln w="10160">
+            <a:solidFill>
+              <a:srgbClr val="D5DDE6"/>
+            </a:solidFill>
+          </a:ln>
+          <a:effectLst/>
+        </p:spPr>
+        <p:style>
+          <a:lnRef idx="1">
+            <a:schemeClr val="accent1"/>
+          </a:lnRef>
+          <a:fillRef idx="3">
+            <a:schemeClr val="accent1"/>
+          </a:fillRef>
+          <a:effectRef idx="2">
+            <a:schemeClr val="accent1"/>
+          </a:effectRef>
+          <a:fontRef idx="minor">
+            <a:schemeClr val="lt1"/>
+          </a:fontRef>
+        </p:style>
+        <p:txBody>
+          <a:bodyPr rtlCol="0" anchor="ctr"/>
+          <a:lstStyle/>
+          <a:p>
+            <a:pPr algn="ctr"/>
+          </a:p>
+        </p:txBody>
+      </p:sp>
+      <p:sp>
+        <p:nvSpPr>
+          <p:cNvPr id="26" name="TextBox 25"/>
+          <p:cNvSpPr txBox="1"/>
+          <p:nvPr/>
+        </p:nvSpPr>
+        <p:spPr>
+          <a:xfrm>
+            <a:off x="6537960" y="2871216"/>
+            <a:ext cx="5029200" cy="384048"/>
+          </a:xfrm>
+          <a:prstGeom prst="rect">
+            <a:avLst/>
+          </a:prstGeom>
+          <a:noFill/>
+        </p:spPr>
+        <p:txBody>
+          <a:bodyPr wrap="square" anchor="ctr">
+            <a:spAutoFit/>
+          </a:bodyPr>
+          <a:lstStyle/>
+          <a:p>
+            <a:pPr algn="l">
+              <a:lnSpc>
+                <a:spcPct val="100000"/>
+              </a:lnSpc>
+              <a:spcAft>
+                <a:spcPts val="400"/>
+              </a:spcAft>
+            </a:pPr>
+            <a:r>
+              <a:rPr sz="1100" b="0">
+                <a:solidFill>
+                  <a:srgbClr val="444A55"/>
+                </a:solidFill>
+                <a:latin typeface="Apple SD Gothic Neo"/>
+              </a:rPr>
+              <a:t>• 멀티모달 (이미지·PDF 처리)</a:t>
+            </a:r>
+          </a:p>
+        </p:txBody>
+      </p:sp>
+      <p:sp>
+        <p:nvSpPr>
+          <p:cNvPr id="27" name="Rounded Rectangle 26"/>
+          <p:cNvSpPr/>
+          <p:nvPr/>
+        </p:nvSpPr>
+        <p:spPr>
+          <a:xfrm>
+            <a:off x="6355080" y="3310128"/>
+            <a:ext cx="5349240" cy="384048"/>
+          </a:xfrm>
+          <a:prstGeom prst="roundRect">
+            <a:avLst/>
+          </a:prstGeom>
+          <a:solidFill>
+            <a:srgbClr val="E8F1FA"/>
+          </a:solidFill>
+          <a:ln w="10160">
+            <a:solidFill>
+              <a:srgbClr val="D5DDE6"/>
+            </a:solidFill>
+          </a:ln>
+          <a:effectLst/>
+        </p:spPr>
+        <p:style>
+          <a:lnRef idx="1">
+            <a:schemeClr val="accent1"/>
+          </a:lnRef>
+          <a:fillRef idx="3">
+            <a:schemeClr val="accent1"/>
+          </a:fillRef>
+          <a:effectRef idx="2">
+            <a:schemeClr val="accent1"/>
+          </a:effectRef>
+          <a:fontRef idx="minor">
+            <a:schemeClr val="lt1"/>
+          </a:fontRef>
+        </p:style>
+        <p:txBody>
+          <a:bodyPr rtlCol="0" anchor="ctr"/>
+          <a:lstStyle/>
+          <a:p>
+            <a:pPr algn="ctr"/>
+          </a:p>
+        </p:txBody>
+      </p:sp>
+      <p:sp>
+        <p:nvSpPr>
+          <p:cNvPr id="28" name="TextBox 27"/>
+          <p:cNvSpPr txBox="1"/>
+          <p:nvPr/>
+        </p:nvSpPr>
+        <p:spPr>
+          <a:xfrm>
+            <a:off x="6537960" y="3310128"/>
+            <a:ext cx="5029200" cy="384048"/>
+          </a:xfrm>
+          <a:prstGeom prst="rect">
+            <a:avLst/>
+          </a:prstGeom>
+          <a:noFill/>
+        </p:spPr>
+        <p:txBody>
+          <a:bodyPr wrap="square" anchor="ctr">
+            <a:spAutoFit/>
+          </a:bodyPr>
+          <a:lstStyle/>
+          <a:p>
+            <a:pPr algn="l">
+              <a:lnSpc>
+                <a:spcPct val="100000"/>
+              </a:lnSpc>
+              <a:spcAft>
+                <a:spcPts val="400"/>
+              </a:spcAft>
+            </a:pPr>
+            <a:r>
+              <a:rPr sz="1100" b="0">
+                <a:solidFill>
+                  <a:srgbClr val="444A55"/>
+                </a:solidFill>
+                <a:latin typeface="Apple SD Gothic Neo"/>
+              </a:rPr>
+              <a:t>• 엔터프라이즈 (관리·보안·연동)</a:t>
+            </a:r>
+          </a:p>
+        </p:txBody>
+      </p:sp>
+      <p:sp>
+        <p:nvSpPr>
+          <p:cNvPr id="29" name="Rounded Rectangle 28"/>
+          <p:cNvSpPr/>
+          <p:nvPr/>
+        </p:nvSpPr>
+        <p:spPr>
+          <a:xfrm>
+            <a:off x="6355080" y="3749040"/>
+            <a:ext cx="5349240" cy="384048"/>
+          </a:xfrm>
+          <a:prstGeom prst="roundRect">
+            <a:avLst/>
+          </a:prstGeom>
+          <a:solidFill>
+            <a:srgbClr val="E8F1FA"/>
+          </a:solidFill>
+          <a:ln w="10160">
+            <a:solidFill>
+              <a:srgbClr val="D5DDE6"/>
+            </a:solidFill>
+          </a:ln>
+          <a:effectLst/>
+        </p:spPr>
+        <p:style>
+          <a:lnRef idx="1">
+            <a:schemeClr val="accent1"/>
+          </a:lnRef>
+          <a:fillRef idx="3">
+            <a:schemeClr val="accent1"/>
+          </a:fillRef>
+          <a:effectRef idx="2">
+            <a:schemeClr val="accent1"/>
+          </a:effectRef>
+          <a:fontRef idx="minor">
+            <a:schemeClr val="lt1"/>
+          </a:fontRef>
+        </p:style>
+        <p:txBody>
+          <a:bodyPr rtlCol="0" anchor="ctr"/>
+          <a:lstStyle/>
+          <a:p>
+            <a:pPr algn="ctr"/>
+          </a:p>
+        </p:txBody>
+      </p:sp>
+      <p:sp>
+        <p:nvSpPr>
+          <p:cNvPr id="30" name="TextBox 29"/>
+          <p:cNvSpPr txBox="1"/>
+          <p:nvPr/>
+        </p:nvSpPr>
+        <p:spPr>
+          <a:xfrm>
+            <a:off x="6537960" y="3749040"/>
+            <a:ext cx="5029200" cy="384048"/>
+          </a:xfrm>
+          <a:prstGeom prst="rect">
+            <a:avLst/>
+          </a:prstGeom>
+          <a:noFill/>
+        </p:spPr>
+        <p:txBody>
+          <a:bodyPr wrap="square" anchor="ctr">
+            <a:spAutoFit/>
+          </a:bodyPr>
+          <a:lstStyle/>
+          <a:p>
+            <a:pPr algn="l">
+              <a:lnSpc>
+                <a:spcPct val="100000"/>
+              </a:lnSpc>
+              <a:spcAft>
+                <a:spcPts val="400"/>
+              </a:spcAft>
+            </a:pPr>
+            <a:r>
+              <a:rPr sz="1100" b="0">
+                <a:solidFill>
+                  <a:srgbClr val="444A55"/>
+                </a:solidFill>
+                <a:latin typeface="Apple SD Gothic Neo"/>
+              </a:rPr>
+              <a:t>• 비용·속도 (API·사용 한도)</a:t>
+            </a:r>
+          </a:p>
+        </p:txBody>
+      </p:sp>
+      <p:sp>
+        <p:nvSpPr>
+          <p:cNvPr id="31" name="Rounded Rectangle 30"/>
+          <p:cNvSpPr/>
+          <p:nvPr/>
+        </p:nvSpPr>
+        <p:spPr>
+          <a:xfrm>
+            <a:off x="502920" y="4315968"/>
+            <a:ext cx="11247120" cy="1600200"/>
           </a:xfrm>
           <a:prstGeom prst="roundRect">
             <a:avLst/>
@@ -20443,14 +20711,14 @@
       </p:sp>
       <p:sp>
         <p:nvSpPr>
-          <p:cNvPr id="24" name="TextBox 23"/>
-          <p:cNvSpPr txBox="1"/>
-          <p:nvPr/>
-        </p:nvSpPr>
-        <p:spPr>
-          <a:xfrm>
-            <a:off x="6629400" y="2743200"/>
-            <a:ext cx="4846320" cy="2743200"/>
+          <p:cNvPr id="32" name="TextBox 31"/>
+          <p:cNvSpPr txBox="1"/>
+          <p:nvPr/>
+        </p:nvSpPr>
+        <p:spPr>
+          <a:xfrm>
+            <a:off x="731520" y="4443984"/>
+            <a:ext cx="10835640" cy="1371600"/>
           </a:xfrm>
           <a:prstGeom prst="rect">
             <a:avLst/>
@@ -20465,10 +20733,10 @@
           <a:p>
             <a:pPr algn="l">
               <a:lnSpc>
-                <a:spcPct val="108000"/>
-              </a:lnSpc>
-              <a:spcAft>
-                <a:spcPts val="200"/>
+                <a:spcPct val="114000"/>
+              </a:lnSpc>
+              <a:spcAft>
+                <a:spcPts val="300"/>
               </a:spcAft>
             </a:pPr>
             <a:r>
@@ -20478,16 +20746,16 @@
                 </a:solidFill>
                 <a:latin typeface="Apple SD Gothic Neo"/>
               </a:rPr>
-              <a:t>조사 방법</a:t>
+              <a:t>조사 방법 및 유의사항</a:t>
             </a:r>
           </a:p>
           <a:p>
             <a:pPr algn="l">
               <a:lnSpc>
-                <a:spcPct val="108000"/>
-              </a:lnSpc>
-              <a:spcAft>
-                <a:spcPts val="200"/>
+                <a:spcPct val="114000"/>
+              </a:lnSpc>
+              <a:spcAft>
+                <a:spcPts val="300"/>
               </a:spcAft>
             </a:pPr>
             <a:r>
@@ -20497,92 +20765,16 @@
                 </a:solidFill>
                 <a:latin typeface="Apple SD Gothic Neo"/>
               </a:rPr>
-              <a:t>1차: 각 회사 공식 문서</a:t>
+              <a:t>· 1차: 각 사 공식 문서  /  2차: 웹 사용자 평가·비교 리뷰 (참고로 표기)</a:t>
             </a:r>
           </a:p>
           <a:p>
             <a:pPr algn="l">
               <a:lnSpc>
-                <a:spcPct val="108000"/>
-              </a:lnSpc>
-              <a:spcAft>
-                <a:spcPts val="200"/>
-              </a:spcAft>
-            </a:pPr>
-            <a:r>
-              <a:rPr sz="1200" b="0">
-                <a:solidFill>
-                  <a:srgbClr val="444A55"/>
-                </a:solidFill>
-                <a:latin typeface="Apple SD Gothic Neo"/>
-              </a:rPr>
-              <a:t>2차: 웹 사용기·비교 리뷰</a:t>
-            </a:r>
-          </a:p>
-          <a:p>
-            <a:pPr algn="l">
-              <a:lnSpc>
-                <a:spcPct val="108000"/>
-              </a:lnSpc>
-              <a:spcAft>
-                <a:spcPts val="200"/>
-              </a:spcAft>
-            </a:pPr>
-            <a:r>
-              <a:rPr sz="1100" b="0">
-                <a:solidFill>
-                  <a:srgbClr val="8A929E"/>
-                </a:solidFill>
-                <a:latin typeface="Apple SD Gothic Neo"/>
-              </a:rPr>
-              <a:t>(참고로 표기)</a:t>
-            </a:r>
-          </a:p>
-          <a:p>
-            <a:pPr algn="l">
-              <a:lnSpc>
-                <a:spcPct val="108000"/>
-              </a:lnSpc>
-              <a:spcAft>
-                <a:spcPts val="200"/>
-              </a:spcAft>
-            </a:pPr>
-            <a:r>
-              <a:rPr sz="800" b="0">
-                <a:solidFill>
-                  <a:srgbClr val="444A55"/>
-                </a:solidFill>
-                <a:latin typeface="Apple SD Gothic Neo"/>
-              </a:rPr>
-              <a:t/>
-            </a:r>
-          </a:p>
-          <a:p>
-            <a:pPr algn="l">
-              <a:lnSpc>
-                <a:spcPct val="108000"/>
-              </a:lnSpc>
-              <a:spcAft>
-                <a:spcPts val="200"/>
-              </a:spcAft>
-            </a:pPr>
-            <a:r>
-              <a:rPr sz="1200" b="0">
-                <a:solidFill>
-                  <a:srgbClr val="444A55"/>
-                </a:solidFill>
-                <a:latin typeface="Apple SD Gothic Neo"/>
-              </a:rPr>
-              <a:t>주의: 보안·라이선스는</a:t>
-            </a:r>
-          </a:p>
-          <a:p>
-            <a:pPr algn="l">
-              <a:lnSpc>
-                <a:spcPct val="108000"/>
-              </a:lnSpc>
-              <a:spcAft>
-                <a:spcPts val="200"/>
+                <a:spcPct val="114000"/>
+              </a:lnSpc>
+              <a:spcAft>
+                <a:spcPts val="300"/>
               </a:spcAft>
             </a:pPr>
             <a:r>
@@ -20592,14 +20784,14 @@
                 </a:solidFill>
                 <a:latin typeface="Apple SD Gothic Neo"/>
               </a:rPr>
-              <a:t>별도 법무·보안 검토 필요</a:t>
-            </a:r>
-          </a:p>
-        </p:txBody>
-      </p:sp>
-      <p:sp>
-        <p:nvSpPr>
-          <p:cNvPr id="25" name="TextBox 24"/>
+              <a:t>· 보안·라이선스는 별도 법무·보안 검토가 필요하며, 본 자료는 도입 검토용 참고 자료임</a:t>
+            </a:r>
+          </a:p>
+        </p:txBody>
+      </p:sp>
+      <p:sp>
+        <p:nvSpPr>
+          <p:cNvPr id="33" name="TextBox 32"/>
           <p:cNvSpPr txBox="1"/>
           <p:nvPr/>
         </p:nvSpPr>
@@ -20832,7 +21024,7 @@
                 </a:solidFill>
                 <a:latin typeface="Apple SD Gothic Neo"/>
               </a:rPr>
-              <a:t>3종 한눈에 보기</a:t>
+              <a:t>LLM 3종 비교 개요</a:t>
             </a:r>
           </a:p>
         </p:txBody>
@@ -20920,7 +21112,7 @@
                 </a:solidFill>
                 <a:latin typeface="Apple SD Gothic Neo"/>
               </a:rPr>
-              <a:t>AI</a:t>
+              <a:t>LLM</a:t>
             </a:r>
           </a:p>
         </p:txBody>
@@ -21008,7 +21200,7 @@
                 </a:solidFill>
                 <a:latin typeface="Apple SD Gothic Neo"/>
               </a:rPr>
-              <a:t>한 줄 포지션</a:t>
+              <a:t>포지션</a:t>
             </a:r>
           </a:p>
         </p:txBody>
@@ -21184,7 +21376,7 @@
                 </a:solidFill>
                 <a:latin typeface="Apple SD Gothic Neo"/>
               </a:rPr>
-              <a:t>주의</a:t>
+              <a:t>유의점</a:t>
             </a:r>
           </a:p>
         </p:txBody>
@@ -21360,7 +21552,7 @@
                 </a:solidFill>
                 <a:latin typeface="Apple SD Gothic Neo"/>
               </a:rPr>
-              <a:t>만능형 올라운더</a:t>
+              <a:t>범용 올라운더</a:t>
             </a:r>
           </a:p>
         </p:txBody>
@@ -21536,7 +21728,7 @@
                 </a:solidFill>
                 <a:latin typeface="Apple SD Gothic Neo"/>
               </a:rPr>
-              <a:t>범용이라 업무별 최적은 다를 수 있음</a:t>
+              <a:t>범용형으로 업무별 최적 모델은 상이</a:t>
             </a:r>
           </a:p>
         </p:txBody>
@@ -21712,7 +21904,7 @@
                 </a:solidFill>
                 <a:latin typeface="Apple SD Gothic Neo"/>
               </a:rPr>
-              <a:t>Google 연동·긴 문서</a:t>
+              <a:t>Google 연동·장문</a:t>
             </a:r>
           </a:p>
         </p:txBody>
@@ -21888,7 +22080,7 @@
                 </a:solidFill>
                 <a:latin typeface="Apple SD Gothic Neo"/>
               </a:rPr>
-              <a:t>Google 생태계 의존</a:t>
+              <a:t>Google 생태계 의존도 높음</a:t>
             </a:r>
           </a:p>
         </p:txBody>
@@ -22253,8 +22445,8 @@
         </p:nvSpPr>
         <p:spPr>
           <a:xfrm>
-            <a:off x="502920" y="4572000"/>
-            <a:ext cx="11201400" cy="1371600"/>
+            <a:off x="502920" y="5074920"/>
+            <a:ext cx="11201400" cy="1234440"/>
           </a:xfrm>
           <a:prstGeom prst="roundRect">
             <a:avLst/>
@@ -22297,8 +22489,8 @@
         </p:nvSpPr>
         <p:spPr>
           <a:xfrm>
-            <a:off x="731520" y="4709160"/>
-            <a:ext cx="10789920" cy="1097280"/>
+            <a:off x="731520" y="5193792"/>
+            <a:ext cx="10789920" cy="1005840"/>
           </a:xfrm>
           <a:prstGeom prst="rect">
             <a:avLst/>
@@ -22326,7 +22518,7 @@
                 </a:solidFill>
                 <a:latin typeface="Apple SD Gothic Neo"/>
               </a:rPr>
-              <a:t>핵심 메시지</a:t>
+              <a:t>핵심 시사점</a:t>
             </a:r>
           </a:p>
           <a:p>
@@ -22345,7 +22537,7 @@
                 </a:solidFill>
                 <a:latin typeface="Apple SD Gothic Neo"/>
               </a:rPr>
-              <a:t>세 AI 모두 '최고 하나'가 아니라, 업무 유형별로 맞는 도구가 다릅니다. 실무에서는 복수 도입·역할 분담도 흔합니다.</a:t>
+              <a:t>단일 최우수 모델은 없으며, 업무 유형별 적합 모델이 상이합니다. 실무에서는 복수 도입·역할 분담이 일반적입니다.</a:t>
             </a:r>
           </a:p>
         </p:txBody>
@@ -23185,7 +23377,7 @@
                 </a:solidFill>
                 <a:latin typeface="Apple SD Gothic Neo"/>
               </a:rPr>
-              <a:t>HW 예시</a:t>
+              <a:t>HW 개발 활용 예시</a:t>
             </a:r>
           </a:p>
         </p:txBody>
@@ -24086,7 +24278,7 @@
                 </a:solidFill>
                 <a:latin typeface="Apple SD Gothic Neo"/>
               </a:rPr>
-              <a:t>HW 예시</a:t>
+              <a:t>HW 개발 활용 예시</a:t>
             </a:r>
           </a:p>
         </p:txBody>
@@ -24987,7 +25179,7 @@
                 </a:solidFill>
                 <a:latin typeface="Apple SD Gothic Neo"/>
               </a:rPr>
-              <a:t>HW 예시</a:t>
+              <a:t>HW 개발 활용 예시</a:t>
             </a:r>
           </a:p>
         </p:txBody>
@@ -28344,7 +28536,7 @@
                 </a:solidFill>
                 <a:latin typeface="Apple SD Gothic Neo"/>
               </a:rPr>
-              <a:t>유저 평가 기반 비교  (7/17)</a:t>
+              <a:t>사용자 평가 기반 비교  (7/17)</a:t>
             </a:r>
           </a:p>
         </p:txBody>
@@ -28678,7 +28870,7 @@
                 </a:solidFill>
                 <a:latin typeface="Apple SD Gothic Neo"/>
               </a:rPr>
-              <a:t>주의 (한계)</a:t>
+              <a:t>조사 한계</a:t>
             </a:r>
           </a:p>
           <a:p>
@@ -28697,7 +28889,7 @@
                 </a:solidFill>
                 <a:latin typeface="Apple SD Gothic Neo"/>
               </a:rPr>
-              <a:t>· API로 전체 수집한 것이 아님</a:t>
+              <a:t>· API 기반 전수 수집이 아님</a:t>
             </a:r>
           </a:p>
           <a:p>
@@ -28716,7 +28908,7 @@
                 </a:solidFill>
                 <a:latin typeface="Apple SD Gothic Neo"/>
               </a:rPr>
-              <a:t>· 개인 경험·버전·요금제에 따라 다름</a:t>
+              <a:t>· 개인 경험·버전·요금제에 따라 상이</a:t>
             </a:r>
           </a:p>
           <a:p>
@@ -28735,7 +28927,7 @@
                 </a:solidFill>
                 <a:latin typeface="Apple SD Gothic Neo"/>
               </a:rPr>
-              <a:t>· 홍보·제휴 글 혼재 가능</a:t>
+              <a:t>· 홍보·제휴성 게시물 혼재 가능</a:t>
             </a:r>
           </a:p>
           <a:p>
@@ -28773,7 +28965,7 @@
                 </a:solidFill>
                 <a:latin typeface="Apple SD Gothic Neo"/>
               </a:rPr>
-              <a:t>→ '반복되는 패턴'만 정리</a:t>
+              <a:t>→ 반복되는 평가 패턴 중심으로 정리</a:t>
             </a:r>
           </a:p>
         </p:txBody>
@@ -28859,7 +29051,7 @@
                 </a:solidFill>
                 <a:latin typeface="Apple SD Gothic Neo"/>
               </a:rPr>
-              <a:t>유저들이 공통으로 말하는 것</a:t>
+              <a:t>사용자 공통 평가</a:t>
             </a:r>
           </a:p>
         </p:txBody>
@@ -28901,7 +29093,7 @@
                 </a:solidFill>
                 <a:latin typeface="Apple SD Gothic Neo"/>
               </a:rPr>
-              <a:t>• '최고 하나'보다 업무별로 여러 AI를 스택으로 쓴다</a:t>
+              <a:t>• 단일 모델보다 업무별 복수 LLM 병행 사용이 일반적</a:t>
             </a:r>
           </a:p>
           <a:p>
@@ -28920,7 +29112,7 @@
                 </a:solidFill>
                 <a:latin typeface="Apple SD Gothic Neo"/>
               </a:rPr>
-              <a:t>• 공식 벤치보다 '매일 쓸 때 한도·속도·실수'가 더 중요하다</a:t>
+              <a:t>• 공식 벤치마크보다 실사용 시 사용 한도·속도·오류가 더 중요</a:t>
             </a:r>
           </a:p>
           <a:p>
@@ -28939,7 +29131,7 @@
                 </a:solidFill>
                 <a:latin typeface="Apple SD Gothic Neo"/>
               </a:rPr>
-              <a:t>• 코딩은 Claude, 긴 문서·Google 업무는 Gemini, 만능·음성은 ChatGPT</a:t>
+              <a:t>• 코딩은 Claude, 장문 문서·Google 연동은 Gemini, 범용·음성은 ChatGPT</a:t>
             </a:r>
           </a:p>
         </p:txBody>
@@ -29137,7 +29329,7 @@
                 </a:solidFill>
                 <a:latin typeface="Apple SD Gothic Neo"/>
               </a:rPr>
-              <a:t>유저 평가 기반 비교  (8/17)</a:t>
+              <a:t>사용자 평가 기반 비교  (8/17)</a:t>
             </a:r>
           </a:p>
         </p:txBody>
@@ -29179,7 +29371,7 @@
                 </a:solidFill>
                 <a:latin typeface="Apple SD Gothic Neo"/>
               </a:rPr>
-              <a:t>플랫폼별에서 들리는 목소리</a:t>
+              <a:t>플랫폼별 사용자 평가 요약</a:t>
             </a:r>
           </a:p>
         </p:txBody>
@@ -31304,8 +31496,8 @@
         </p:nvSpPr>
         <p:spPr>
           <a:xfrm>
-            <a:off x="502920" y="4434840"/>
-            <a:ext cx="11201400" cy="1691640"/>
+            <a:off x="502920" y="4681728"/>
+            <a:ext cx="11201400" cy="1554480"/>
           </a:xfrm>
           <a:prstGeom prst="roundRect">
             <a:avLst/>
@@ -31350,8 +31542,8 @@
         </p:nvSpPr>
         <p:spPr>
           <a:xfrm>
-            <a:off x="731520" y="4553712"/>
-            <a:ext cx="10789920" cy="1463040"/>
+            <a:off x="731520" y="4791456"/>
+            <a:ext cx="10789920" cy="1371600"/>
           </a:xfrm>
           <a:prstGeom prst="rect">
             <a:avLst/>

</xml_diff>

<commit_message>
Align eval criteria with comparison matrix; tidy box text on slides 12 & 16
- Make slide 2 evaluation criteria and slide 7 feature matrix use identical 6 items
- Vertically center and bullet-align text inside the callout boxes on pages 12 and 16

Co-authored-by: Cursor <cursoragent@cursor.com>
</commit_message>
<xml_diff>
--- a/외부AI_3종_비교조사.pptx
+++ b/외부AI_3종_비교조사.pptx
@@ -8105,26 +8105,26 @@
         </p:nvSpPr>
         <p:spPr>
           <a:xfrm>
-            <a:off x="640080" y="4937760"/>
-            <a:ext cx="10881360" cy="1051560"/>
-          </a:xfrm>
-          <a:prstGeom prst="rect">
-            <a:avLst/>
-          </a:prstGeom>
-          <a:noFill/>
-        </p:spPr>
-        <p:txBody>
-          <a:bodyPr wrap="square" anchor="t">
+            <a:off x="685800" y="4800600"/>
+            <a:ext cx="10835640" cy="1325880"/>
+          </a:xfrm>
+          <a:prstGeom prst="rect">
+            <a:avLst/>
+          </a:prstGeom>
+          <a:noFill/>
+        </p:spPr>
+        <p:txBody>
+          <a:bodyPr wrap="square" anchor="ctr">
             <a:spAutoFit/>
           </a:bodyPr>
           <a:lstStyle/>
           <a:p>
             <a:pPr algn="l">
               <a:lnSpc>
-                <a:spcPct val="110000"/>
-              </a:lnSpc>
-              <a:spcAft>
-                <a:spcPts val="200"/>
+                <a:spcPct val="122000"/>
+              </a:lnSpc>
+              <a:spcAft>
+                <a:spcPts val="300"/>
               </a:spcAft>
             </a:pPr>
             <a:r>
@@ -8140,10 +8140,10 @@
           <a:p>
             <a:pPr algn="l">
               <a:lnSpc>
-                <a:spcPct val="110000"/>
-              </a:lnSpc>
-              <a:spcAft>
-                <a:spcPts val="200"/>
+                <a:spcPct val="122000"/>
+              </a:lnSpc>
+              <a:spcAft>
+                <a:spcPts val="300"/>
               </a:spcAft>
             </a:pPr>
             <a:r>
@@ -8153,16 +8153,16 @@
                 </a:solidFill>
                 <a:latin typeface="Apple SD Gothic Neo"/>
               </a:rPr>
-              <a:t>사내 Gauss의 분당 3~4회 호출 제한과 마찬가지로, 외부 LLM도 사용 한도가 실무 병목 요인입니다.</a:t>
+              <a:t>• 사내 Gauss의 분당 3~4회 호출 제한과 마찬가지로, 외부 LLM도 사용 한도가 실무 병목 요인</a:t>
             </a:r>
           </a:p>
           <a:p>
             <a:pPr algn="l">
               <a:lnSpc>
-                <a:spcPct val="110000"/>
-              </a:lnSpc>
-              <a:spcAft>
-                <a:spcPts val="200"/>
+                <a:spcPct val="122000"/>
+              </a:lnSpc>
+              <a:spcAft>
+                <a:spcPts val="300"/>
               </a:spcAft>
             </a:pPr>
             <a:r>
@@ -8172,7 +8172,7 @@
                 </a:solidFill>
                 <a:latin typeface="Apple SD Gothic Neo"/>
               </a:rPr>
-              <a:t>→ PoC 단계에서 사용 한도·응답 속도·코드 신뢰도(오류율)를 정량 측정 권장.</a:t>
+              <a:t>• PoC 단계에서 사용 한도·응답 속도·코드 신뢰도(오류율)를 정량 측정 권장</a:t>
             </a:r>
           </a:p>
         </p:txBody>
@@ -15439,26 +15439,26 @@
         </p:nvSpPr>
         <p:spPr>
           <a:xfrm>
-            <a:off x="777240" y="4462272"/>
-            <a:ext cx="10698480" cy="1371600"/>
-          </a:xfrm>
-          <a:prstGeom prst="rect">
-            <a:avLst/>
-          </a:prstGeom>
-          <a:noFill/>
-        </p:spPr>
-        <p:txBody>
-          <a:bodyPr wrap="square" anchor="t">
+            <a:off x="777240" y="4315968"/>
+            <a:ext cx="10652760" cy="1627632"/>
+          </a:xfrm>
+          <a:prstGeom prst="rect">
+            <a:avLst/>
+          </a:prstGeom>
+          <a:noFill/>
+        </p:spPr>
+        <p:txBody>
+          <a:bodyPr wrap="square" anchor="ctr">
             <a:spAutoFit/>
           </a:bodyPr>
           <a:lstStyle/>
           <a:p>
             <a:pPr algn="l">
               <a:lnSpc>
-                <a:spcPct val="114000"/>
-              </a:lnSpc>
-              <a:spcAft>
-                <a:spcPts val="200"/>
+                <a:spcPct val="122000"/>
+              </a:lnSpc>
+              <a:spcAft>
+                <a:spcPts val="300"/>
               </a:spcAft>
             </a:pPr>
             <a:r>
@@ -15474,10 +15474,10 @@
           <a:p>
             <a:pPr algn="l">
               <a:lnSpc>
-                <a:spcPct val="114000"/>
-              </a:lnSpc>
-              <a:spcAft>
-                <a:spcPts val="200"/>
+                <a:spcPct val="122000"/>
+              </a:lnSpc>
+              <a:spcAft>
+                <a:spcPts val="300"/>
               </a:spcAft>
             </a:pPr>
             <a:r>
@@ -15487,16 +15487,16 @@
                 </a:solidFill>
                 <a:latin typeface="Apple SD Gothic Neo"/>
               </a:rPr>
-              <a:t>· 외부 LLM은 사내 Gauss(망분리 보조)를 대체하지 않고, 보안 검토 후 고급 보조 수단으로 역할을 분담합니다.</a:t>
+              <a:t>• 외부 LLM은 사내 Gauss(망분리 보조)를 대체하지 않고, 보안 검토 후 고급 보조 수단으로 역할 분담</a:t>
             </a:r>
           </a:p>
           <a:p>
             <a:pPr algn="l">
               <a:lnSpc>
-                <a:spcPct val="114000"/>
-              </a:lnSpc>
-              <a:spcAft>
-                <a:spcPts val="200"/>
+                <a:spcPct val="122000"/>
+              </a:lnSpc>
+              <a:spcAft>
+                <a:spcPts val="300"/>
               </a:spcAft>
             </a:pPr>
             <a:r>
@@ -15506,7 +15506,7 @@
                 </a:solidFill>
                 <a:latin typeface="Apple SD Gothic Neo"/>
               </a:rPr>
-              <a:t>· 권장안: 업무별 PoC 1~2건 선정 → 효과·보안·사용 한도 정량 측정 → 팀 표준 활용 가이드 수립.</a:t>
+              <a:t>• 권장안: 업무별 PoC 1~2건 선정 → 효과·보안·사용 한도 정량 측정 → 팀 표준 활용 가이드 수립</a:t>
             </a:r>
           </a:p>
         </p:txBody>
@@ -20218,7 +20218,7 @@
                 </a:solidFill>
                 <a:latin typeface="Apple SD Gothic Neo"/>
               </a:rPr>
-              <a:t>• 생산성 (코딩·문서·반복 업무 자동화)</a:t>
+              <a:t>• 생산성 (코딩·추론)</a:t>
             </a:r>
           </a:p>
         </p:txBody>
@@ -20306,7 +20306,7 @@
                 </a:solidFill>
                 <a:latin typeface="Apple SD Gothic Neo"/>
               </a:rPr>
-              <a:t>• 에이전트 (다단계 작업 자동 수행)</a:t>
+              <a:t>• 에이전트 (다단계 자동화)</a:t>
             </a:r>
           </a:p>
         </p:txBody>
@@ -20394,7 +20394,7 @@
                 </a:solidFill>
                 <a:latin typeface="Apple SD Gothic Neo"/>
               </a:rPr>
-              <a:t>• 문서·지식 (장문 사양서·검색·OCR)</a:t>
+              <a:t>• 문서·지식 (장문·검색·OCR)</a:t>
             </a:r>
           </a:p>
         </p:txBody>
@@ -20482,7 +20482,7 @@
                 </a:solidFill>
                 <a:latin typeface="Apple SD Gothic Neo"/>
               </a:rPr>
-              <a:t>• 멀티모달 (이미지·PDF 처리)</a:t>
+              <a:t>• 멀티모달 (이미지·PDF)</a:t>
             </a:r>
           </a:p>
         </p:txBody>
@@ -25494,7 +25494,7 @@
         <p:spPr>
           <a:xfrm>
             <a:off x="411480" y="1371600"/>
-            <a:ext cx="2286000" cy="530352"/>
+            <a:ext cx="3657600" cy="566928"/>
           </a:xfrm>
           <a:prstGeom prst="rect">
             <a:avLst/>
@@ -25540,7 +25540,7 @@
         <p:spPr>
           <a:xfrm>
             <a:off x="411480" y="1371600"/>
-            <a:ext cx="2286000" cy="530352"/>
+            <a:ext cx="3657600" cy="566928"/>
           </a:xfrm>
           <a:prstGeom prst="rect">
             <a:avLst/>
@@ -25568,7 +25568,7 @@
                 </a:solidFill>
                 <a:latin typeface="Apple SD Gothic Neo"/>
               </a:rPr>
-              <a:t>항목</a:t>
+              <a:t>평가 항목</a:t>
             </a:r>
           </a:p>
         </p:txBody>
@@ -25581,8 +25581,8 @@
         </p:nvSpPr>
         <p:spPr>
           <a:xfrm>
-            <a:off x="2697480" y="1371600"/>
-            <a:ext cx="2926080" cy="530352"/>
+            <a:off x="4069080" y="1371600"/>
+            <a:ext cx="2560320" cy="566928"/>
           </a:xfrm>
           <a:prstGeom prst="rect">
             <a:avLst/>
@@ -25627,8 +25627,8 @@
         </p:nvSpPr>
         <p:spPr>
           <a:xfrm>
-            <a:off x="2697480" y="1371600"/>
-            <a:ext cx="2926080" cy="530352"/>
+            <a:off x="4069080" y="1371600"/>
+            <a:ext cx="2560320" cy="566928"/>
           </a:xfrm>
           <a:prstGeom prst="rect">
             <a:avLst/>
@@ -25669,8 +25669,8 @@
         </p:nvSpPr>
         <p:spPr>
           <a:xfrm>
-            <a:off x="5623560" y="1371600"/>
-            <a:ext cx="2926080" cy="530352"/>
+            <a:off x="6629400" y="1371600"/>
+            <a:ext cx="2560320" cy="566928"/>
           </a:xfrm>
           <a:prstGeom prst="rect">
             <a:avLst/>
@@ -25715,8 +25715,8 @@
         </p:nvSpPr>
         <p:spPr>
           <a:xfrm>
-            <a:off x="5623560" y="1371600"/>
-            <a:ext cx="2926080" cy="530352"/>
+            <a:off x="6629400" y="1371600"/>
+            <a:ext cx="2560320" cy="566928"/>
           </a:xfrm>
           <a:prstGeom prst="rect">
             <a:avLst/>
@@ -25757,8 +25757,8 @@
         </p:nvSpPr>
         <p:spPr>
           <a:xfrm>
-            <a:off x="8549640" y="1371600"/>
-            <a:ext cx="2926080" cy="530352"/>
+            <a:off x="9189720" y="1371600"/>
+            <a:ext cx="2560320" cy="566928"/>
           </a:xfrm>
           <a:prstGeom prst="rect">
             <a:avLst/>
@@ -25803,8 +25803,8 @@
         </p:nvSpPr>
         <p:spPr>
           <a:xfrm>
-            <a:off x="8549640" y="1371600"/>
-            <a:ext cx="2926080" cy="530352"/>
+            <a:off x="9189720" y="1371600"/>
+            <a:ext cx="2560320" cy="566928"/>
           </a:xfrm>
           <a:prstGeom prst="rect">
             <a:avLst/>
@@ -25845,8 +25845,8 @@
         </p:nvSpPr>
         <p:spPr>
           <a:xfrm>
-            <a:off x="411480" y="1901952"/>
-            <a:ext cx="2286000" cy="530352"/>
+            <a:off x="411480" y="1938528"/>
+            <a:ext cx="3657600" cy="566928"/>
           </a:xfrm>
           <a:prstGeom prst="rect">
             <a:avLst/>
@@ -25891,8 +25891,8 @@
         </p:nvSpPr>
         <p:spPr>
           <a:xfrm>
-            <a:off x="449580" y="1901952"/>
-            <a:ext cx="2209800" cy="530352"/>
+            <a:off x="449580" y="1938528"/>
+            <a:ext cx="3581400" cy="566928"/>
           </a:xfrm>
           <a:prstGeom prst="rect">
             <a:avLst/>
@@ -25920,7 +25920,7 @@
                 </a:solidFill>
                 <a:latin typeface="Apple SD Gothic Neo"/>
               </a:rPr>
-              <a:t>코딩·추론</a:t>
+              <a:t>생산성 (코딩·추론)</a:t>
             </a:r>
           </a:p>
         </p:txBody>
@@ -25933,8 +25933,8 @@
         </p:nvSpPr>
         <p:spPr>
           <a:xfrm>
-            <a:off x="2697480" y="1901952"/>
-            <a:ext cx="2926080" cy="530352"/>
+            <a:off x="4069080" y="1938528"/>
+            <a:ext cx="2560320" cy="566928"/>
           </a:xfrm>
           <a:prstGeom prst="rect">
             <a:avLst/>
@@ -25979,8 +25979,8 @@
         </p:nvSpPr>
         <p:spPr>
           <a:xfrm>
-            <a:off x="2735580" y="1901952"/>
-            <a:ext cx="2849880" cy="530352"/>
+            <a:off x="4107180" y="1938528"/>
+            <a:ext cx="2484120" cy="566928"/>
           </a:xfrm>
           <a:prstGeom prst="rect">
             <a:avLst/>
@@ -26021,8 +26021,8 @@
         </p:nvSpPr>
         <p:spPr>
           <a:xfrm>
-            <a:off x="5623560" y="1901952"/>
-            <a:ext cx="2926080" cy="530352"/>
+            <a:off x="6629400" y="1938528"/>
+            <a:ext cx="2560320" cy="566928"/>
           </a:xfrm>
           <a:prstGeom prst="rect">
             <a:avLst/>
@@ -26067,8 +26067,8 @@
         </p:nvSpPr>
         <p:spPr>
           <a:xfrm>
-            <a:off x="5661660" y="1901952"/>
-            <a:ext cx="2849880" cy="530352"/>
+            <a:off x="6667500" y="1938528"/>
+            <a:ext cx="2484120" cy="566928"/>
           </a:xfrm>
           <a:prstGeom prst="rect">
             <a:avLst/>
@@ -26096,7 +26096,7 @@
                 </a:solidFill>
                 <a:latin typeface="Apple SD Gothic Neo"/>
               </a:rPr>
-              <a:t>◎</a:t>
+              <a:t>○</a:t>
             </a:r>
           </a:p>
         </p:txBody>
@@ -26109,8 +26109,8 @@
         </p:nvSpPr>
         <p:spPr>
           <a:xfrm>
-            <a:off x="8549640" y="1901952"/>
-            <a:ext cx="2926080" cy="530352"/>
+            <a:off x="9189720" y="1938528"/>
+            <a:ext cx="2560320" cy="566928"/>
           </a:xfrm>
           <a:prstGeom prst="rect">
             <a:avLst/>
@@ -26155,8 +26155,8 @@
         </p:nvSpPr>
         <p:spPr>
           <a:xfrm>
-            <a:off x="8587740" y="1901952"/>
-            <a:ext cx="2849880" cy="530352"/>
+            <a:off x="9227820" y="1938528"/>
+            <a:ext cx="2484120" cy="566928"/>
           </a:xfrm>
           <a:prstGeom prst="rect">
             <a:avLst/>
@@ -26197,8 +26197,8 @@
         </p:nvSpPr>
         <p:spPr>
           <a:xfrm>
-            <a:off x="411480" y="2432304"/>
-            <a:ext cx="2286000" cy="530352"/>
+            <a:off x="411480" y="2505456"/>
+            <a:ext cx="3657600" cy="566928"/>
           </a:xfrm>
           <a:prstGeom prst="rect">
             <a:avLst/>
@@ -26243,8 +26243,8 @@
         </p:nvSpPr>
         <p:spPr>
           <a:xfrm>
-            <a:off x="449580" y="2432304"/>
-            <a:ext cx="2209800" cy="530352"/>
+            <a:off x="449580" y="2505456"/>
+            <a:ext cx="3581400" cy="566928"/>
           </a:xfrm>
           <a:prstGeom prst="rect">
             <a:avLst/>
@@ -26272,7 +26272,7 @@
                 </a:solidFill>
                 <a:latin typeface="Apple SD Gothic Neo"/>
               </a:rPr>
-              <a:t>에이전트·MCP</a:t>
+              <a:t>에이전트 (다단계 자동화)</a:t>
             </a:r>
           </a:p>
         </p:txBody>
@@ -26285,8 +26285,8 @@
         </p:nvSpPr>
         <p:spPr>
           <a:xfrm>
-            <a:off x="2697480" y="2432304"/>
-            <a:ext cx="2926080" cy="530352"/>
+            <a:off x="4069080" y="2505456"/>
+            <a:ext cx="2560320" cy="566928"/>
           </a:xfrm>
           <a:prstGeom prst="rect">
             <a:avLst/>
@@ -26331,8 +26331,8 @@
         </p:nvSpPr>
         <p:spPr>
           <a:xfrm>
-            <a:off x="2735580" y="2432304"/>
-            <a:ext cx="2849880" cy="530352"/>
+            <a:off x="4107180" y="2505456"/>
+            <a:ext cx="2484120" cy="566928"/>
           </a:xfrm>
           <a:prstGeom prst="rect">
             <a:avLst/>
@@ -26373,8 +26373,8 @@
         </p:nvSpPr>
         <p:spPr>
           <a:xfrm>
-            <a:off x="5623560" y="2432304"/>
-            <a:ext cx="2926080" cy="530352"/>
+            <a:off x="6629400" y="2505456"/>
+            <a:ext cx="2560320" cy="566928"/>
           </a:xfrm>
           <a:prstGeom prst="rect">
             <a:avLst/>
@@ -26419,8 +26419,8 @@
         </p:nvSpPr>
         <p:spPr>
           <a:xfrm>
-            <a:off x="5661660" y="2432304"/>
-            <a:ext cx="2849880" cy="530352"/>
+            <a:off x="6667500" y="2505456"/>
+            <a:ext cx="2484120" cy="566928"/>
           </a:xfrm>
           <a:prstGeom prst="rect">
             <a:avLst/>
@@ -26461,8 +26461,8 @@
         </p:nvSpPr>
         <p:spPr>
           <a:xfrm>
-            <a:off x="8549640" y="2432304"/>
-            <a:ext cx="2926080" cy="530352"/>
+            <a:off x="9189720" y="2505456"/>
+            <a:ext cx="2560320" cy="566928"/>
           </a:xfrm>
           <a:prstGeom prst="rect">
             <a:avLst/>
@@ -26507,8 +26507,8 @@
         </p:nvSpPr>
         <p:spPr>
           <a:xfrm>
-            <a:off x="8587740" y="2432304"/>
-            <a:ext cx="2849880" cy="530352"/>
+            <a:off x="9227820" y="2505456"/>
+            <a:ext cx="2484120" cy="566928"/>
           </a:xfrm>
           <a:prstGeom prst="rect">
             <a:avLst/>
@@ -26549,8 +26549,8 @@
         </p:nvSpPr>
         <p:spPr>
           <a:xfrm>
-            <a:off x="411480" y="2962656"/>
-            <a:ext cx="2286000" cy="530352"/>
+            <a:off x="411480" y="3072384"/>
+            <a:ext cx="3657600" cy="566928"/>
           </a:xfrm>
           <a:prstGeom prst="rect">
             <a:avLst/>
@@ -26595,8 +26595,8 @@
         </p:nvSpPr>
         <p:spPr>
           <a:xfrm>
-            <a:off x="449580" y="2962656"/>
-            <a:ext cx="2209800" cy="530352"/>
+            <a:off x="449580" y="3072384"/>
+            <a:ext cx="3581400" cy="566928"/>
           </a:xfrm>
           <a:prstGeom prst="rect">
             <a:avLst/>
@@ -26624,7 +26624,7 @@
                 </a:solidFill>
                 <a:latin typeface="Apple SD Gothic Neo"/>
               </a:rPr>
-              <a:t>긴 문서·맥락</a:t>
+              <a:t>문서·지식 (장문·검색·OCR)</a:t>
             </a:r>
           </a:p>
         </p:txBody>
@@ -26637,8 +26637,8 @@
         </p:nvSpPr>
         <p:spPr>
           <a:xfrm>
-            <a:off x="2697480" y="2962656"/>
-            <a:ext cx="2926080" cy="530352"/>
+            <a:off x="4069080" y="3072384"/>
+            <a:ext cx="2560320" cy="566928"/>
           </a:xfrm>
           <a:prstGeom prst="rect">
             <a:avLst/>
@@ -26683,8 +26683,8 @@
         </p:nvSpPr>
         <p:spPr>
           <a:xfrm>
-            <a:off x="2735580" y="2962656"/>
-            <a:ext cx="2849880" cy="530352"/>
+            <a:off x="4107180" y="3072384"/>
+            <a:ext cx="2484120" cy="566928"/>
           </a:xfrm>
           <a:prstGeom prst="rect">
             <a:avLst/>
@@ -26725,8 +26725,8 @@
         </p:nvSpPr>
         <p:spPr>
           <a:xfrm>
-            <a:off x="5623560" y="2962656"/>
-            <a:ext cx="2926080" cy="530352"/>
+            <a:off x="6629400" y="3072384"/>
+            <a:ext cx="2560320" cy="566928"/>
           </a:xfrm>
           <a:prstGeom prst="rect">
             <a:avLst/>
@@ -26771,8 +26771,8 @@
         </p:nvSpPr>
         <p:spPr>
           <a:xfrm>
-            <a:off x="5661660" y="2962656"/>
-            <a:ext cx="2849880" cy="530352"/>
+            <a:off x="6667500" y="3072384"/>
+            <a:ext cx="2484120" cy="566928"/>
           </a:xfrm>
           <a:prstGeom prst="rect">
             <a:avLst/>
@@ -26813,8 +26813,8 @@
         </p:nvSpPr>
         <p:spPr>
           <a:xfrm>
-            <a:off x="8549640" y="2962656"/>
-            <a:ext cx="2926080" cy="530352"/>
+            <a:off x="9189720" y="3072384"/>
+            <a:ext cx="2560320" cy="566928"/>
           </a:xfrm>
           <a:prstGeom prst="rect">
             <a:avLst/>
@@ -26859,8 +26859,8 @@
         </p:nvSpPr>
         <p:spPr>
           <a:xfrm>
-            <a:off x="8587740" y="2962656"/>
-            <a:ext cx="2849880" cy="530352"/>
+            <a:off x="9227820" y="3072384"/>
+            <a:ext cx="2484120" cy="566928"/>
           </a:xfrm>
           <a:prstGeom prst="rect">
             <a:avLst/>
@@ -26888,7 +26888,7 @@
                 </a:solidFill>
                 <a:latin typeface="Apple SD Gothic Neo"/>
               </a:rPr>
-              <a:t>◎</a:t>
+              <a:t>○</a:t>
             </a:r>
           </a:p>
         </p:txBody>
@@ -26901,8 +26901,8 @@
         </p:nvSpPr>
         <p:spPr>
           <a:xfrm>
-            <a:off x="411480" y="3493008"/>
-            <a:ext cx="2286000" cy="530352"/>
+            <a:off x="411480" y="3639312"/>
+            <a:ext cx="3657600" cy="566928"/>
           </a:xfrm>
           <a:prstGeom prst="rect">
             <a:avLst/>
@@ -26947,8 +26947,8 @@
         </p:nvSpPr>
         <p:spPr>
           <a:xfrm>
-            <a:off x="449580" y="3493008"/>
-            <a:ext cx="2209800" cy="530352"/>
+            <a:off x="449580" y="3639312"/>
+            <a:ext cx="3581400" cy="566928"/>
           </a:xfrm>
           <a:prstGeom prst="rect">
             <a:avLst/>
@@ -26976,7 +26976,7 @@
                 </a:solidFill>
                 <a:latin typeface="Apple SD Gothic Neo"/>
               </a:rPr>
-              <a:t>검색·최신정보</a:t>
+              <a:t>멀티모달 (이미지·PDF)</a:t>
             </a:r>
           </a:p>
         </p:txBody>
@@ -26989,8 +26989,8 @@
         </p:nvSpPr>
         <p:spPr>
           <a:xfrm>
-            <a:off x="2697480" y="3493008"/>
-            <a:ext cx="2926080" cy="530352"/>
+            <a:off x="4069080" y="3639312"/>
+            <a:ext cx="2560320" cy="566928"/>
           </a:xfrm>
           <a:prstGeom prst="rect">
             <a:avLst/>
@@ -27035,8 +27035,8 @@
         </p:nvSpPr>
         <p:spPr>
           <a:xfrm>
-            <a:off x="2735580" y="3493008"/>
-            <a:ext cx="2849880" cy="530352"/>
+            <a:off x="4107180" y="3639312"/>
+            <a:ext cx="2484120" cy="566928"/>
           </a:xfrm>
           <a:prstGeom prst="rect">
             <a:avLst/>
@@ -27077,8 +27077,8 @@
         </p:nvSpPr>
         <p:spPr>
           <a:xfrm>
-            <a:off x="5623560" y="3493008"/>
-            <a:ext cx="2926080" cy="530352"/>
+            <a:off x="6629400" y="3639312"/>
+            <a:ext cx="2560320" cy="566928"/>
           </a:xfrm>
           <a:prstGeom prst="rect">
             <a:avLst/>
@@ -27123,8 +27123,8 @@
         </p:nvSpPr>
         <p:spPr>
           <a:xfrm>
-            <a:off x="5661660" y="3493008"/>
-            <a:ext cx="2849880" cy="530352"/>
+            <a:off x="6667500" y="3639312"/>
+            <a:ext cx="2484120" cy="566928"/>
           </a:xfrm>
           <a:prstGeom prst="rect">
             <a:avLst/>
@@ -27165,8 +27165,8 @@
         </p:nvSpPr>
         <p:spPr>
           <a:xfrm>
-            <a:off x="8549640" y="3493008"/>
-            <a:ext cx="2926080" cy="530352"/>
+            <a:off x="9189720" y="3639312"/>
+            <a:ext cx="2560320" cy="566928"/>
           </a:xfrm>
           <a:prstGeom prst="rect">
             <a:avLst/>
@@ -27211,8 +27211,8 @@
         </p:nvSpPr>
         <p:spPr>
           <a:xfrm>
-            <a:off x="8587740" y="3493008"/>
-            <a:ext cx="2849880" cy="530352"/>
+            <a:off x="9227820" y="3639312"/>
+            <a:ext cx="2484120" cy="566928"/>
           </a:xfrm>
           <a:prstGeom prst="rect">
             <a:avLst/>
@@ -27240,7 +27240,7 @@
                 </a:solidFill>
                 <a:latin typeface="Apple SD Gothic Neo"/>
               </a:rPr>
-              <a:t>△</a:t>
+              <a:t>○</a:t>
             </a:r>
           </a:p>
         </p:txBody>
@@ -27253,8 +27253,8 @@
         </p:nvSpPr>
         <p:spPr>
           <a:xfrm>
-            <a:off x="411480" y="4023360"/>
-            <a:ext cx="2286000" cy="530352"/>
+            <a:off x="411480" y="4206240"/>
+            <a:ext cx="3657600" cy="566928"/>
           </a:xfrm>
           <a:prstGeom prst="rect">
             <a:avLst/>
@@ -27299,8 +27299,8 @@
         </p:nvSpPr>
         <p:spPr>
           <a:xfrm>
-            <a:off x="449580" y="4023360"/>
-            <a:ext cx="2209800" cy="530352"/>
+            <a:off x="449580" y="4206240"/>
+            <a:ext cx="3581400" cy="566928"/>
           </a:xfrm>
           <a:prstGeom prst="rect">
             <a:avLst/>
@@ -27328,7 +27328,7 @@
                 </a:solidFill>
                 <a:latin typeface="Apple SD Gothic Neo"/>
               </a:rPr>
-              <a:t>멀티모달·OCR</a:t>
+              <a:t>엔터프라이즈 (관리·보안·연동)</a:t>
             </a:r>
           </a:p>
         </p:txBody>
@@ -27341,8 +27341,8 @@
         </p:nvSpPr>
         <p:spPr>
           <a:xfrm>
-            <a:off x="2697480" y="4023360"/>
-            <a:ext cx="2926080" cy="530352"/>
+            <a:off x="4069080" y="4206240"/>
+            <a:ext cx="2560320" cy="566928"/>
           </a:xfrm>
           <a:prstGeom prst="rect">
             <a:avLst/>
@@ -27387,8 +27387,8 @@
         </p:nvSpPr>
         <p:spPr>
           <a:xfrm>
-            <a:off x="2735580" y="4023360"/>
-            <a:ext cx="2849880" cy="530352"/>
+            <a:off x="4107180" y="4206240"/>
+            <a:ext cx="2484120" cy="566928"/>
           </a:xfrm>
           <a:prstGeom prst="rect">
             <a:avLst/>
@@ -27416,7 +27416,7 @@
                 </a:solidFill>
                 <a:latin typeface="Apple SD Gothic Neo"/>
               </a:rPr>
-              <a:t>○</a:t>
+              <a:t>◎</a:t>
             </a:r>
           </a:p>
         </p:txBody>
@@ -27429,8 +27429,8 @@
         </p:nvSpPr>
         <p:spPr>
           <a:xfrm>
-            <a:off x="5623560" y="4023360"/>
-            <a:ext cx="2926080" cy="530352"/>
+            <a:off x="6629400" y="4206240"/>
+            <a:ext cx="2560320" cy="566928"/>
           </a:xfrm>
           <a:prstGeom prst="rect">
             <a:avLst/>
@@ -27475,8 +27475,8 @@
         </p:nvSpPr>
         <p:spPr>
           <a:xfrm>
-            <a:off x="5661660" y="4023360"/>
-            <a:ext cx="2849880" cy="530352"/>
+            <a:off x="6667500" y="4206240"/>
+            <a:ext cx="2484120" cy="566928"/>
           </a:xfrm>
           <a:prstGeom prst="rect">
             <a:avLst/>
@@ -27517,8 +27517,8 @@
         </p:nvSpPr>
         <p:spPr>
           <a:xfrm>
-            <a:off x="8549640" y="4023360"/>
-            <a:ext cx="2926080" cy="530352"/>
+            <a:off x="9189720" y="4206240"/>
+            <a:ext cx="2560320" cy="566928"/>
           </a:xfrm>
           <a:prstGeom prst="rect">
             <a:avLst/>
@@ -27563,8 +27563,8 @@
         </p:nvSpPr>
         <p:spPr>
           <a:xfrm>
-            <a:off x="8587740" y="4023360"/>
-            <a:ext cx="2849880" cy="530352"/>
+            <a:off x="9227820" y="4206240"/>
+            <a:ext cx="2484120" cy="566928"/>
           </a:xfrm>
           <a:prstGeom prst="rect">
             <a:avLst/>
@@ -27605,8 +27605,8 @@
         </p:nvSpPr>
         <p:spPr>
           <a:xfrm>
-            <a:off x="411480" y="4553712"/>
-            <a:ext cx="2286000" cy="530352"/>
+            <a:off x="411480" y="4773168"/>
+            <a:ext cx="3657600" cy="566928"/>
           </a:xfrm>
           <a:prstGeom prst="rect">
             <a:avLst/>
@@ -27651,8 +27651,8 @@
         </p:nvSpPr>
         <p:spPr>
           <a:xfrm>
-            <a:off x="449580" y="4553712"/>
-            <a:ext cx="2209800" cy="530352"/>
+            <a:off x="449580" y="4773168"/>
+            <a:ext cx="3581400" cy="566928"/>
           </a:xfrm>
           <a:prstGeom prst="rect">
             <a:avLst/>
@@ -27680,7 +27680,7 @@
                 </a:solidFill>
                 <a:latin typeface="Apple SD Gothic Neo"/>
               </a:rPr>
-              <a:t>Google 연동</a:t>
+              <a:t>비용·속도 (API·사용 한도)</a:t>
             </a:r>
           </a:p>
         </p:txBody>
@@ -27693,8 +27693,8 @@
         </p:nvSpPr>
         <p:spPr>
           <a:xfrm>
-            <a:off x="2697480" y="4553712"/>
-            <a:ext cx="2926080" cy="530352"/>
+            <a:off x="4069080" y="4773168"/>
+            <a:ext cx="2560320" cy="566928"/>
           </a:xfrm>
           <a:prstGeom prst="rect">
             <a:avLst/>
@@ -27739,8 +27739,8 @@
         </p:nvSpPr>
         <p:spPr>
           <a:xfrm>
-            <a:off x="2735580" y="4553712"/>
-            <a:ext cx="2849880" cy="530352"/>
+            <a:off x="4107180" y="4773168"/>
+            <a:ext cx="2484120" cy="566928"/>
           </a:xfrm>
           <a:prstGeom prst="rect">
             <a:avLst/>
@@ -27768,7 +27768,7 @@
                 </a:solidFill>
                 <a:latin typeface="Apple SD Gothic Neo"/>
               </a:rPr>
-              <a:t>△</a:t>
+              <a:t>○</a:t>
             </a:r>
           </a:p>
         </p:txBody>
@@ -27781,8 +27781,8 @@
         </p:nvSpPr>
         <p:spPr>
           <a:xfrm>
-            <a:off x="5623560" y="4553712"/>
-            <a:ext cx="2926080" cy="530352"/>
+            <a:off x="6629400" y="4773168"/>
+            <a:ext cx="2560320" cy="566928"/>
           </a:xfrm>
           <a:prstGeom prst="rect">
             <a:avLst/>
@@ -27827,8 +27827,8 @@
         </p:nvSpPr>
         <p:spPr>
           <a:xfrm>
-            <a:off x="5661660" y="4553712"/>
-            <a:ext cx="2849880" cy="530352"/>
+            <a:off x="6667500" y="4773168"/>
+            <a:ext cx="2484120" cy="566928"/>
           </a:xfrm>
           <a:prstGeom prst="rect">
             <a:avLst/>
@@ -27869,8 +27869,8 @@
         </p:nvSpPr>
         <p:spPr>
           <a:xfrm>
-            <a:off x="8549640" y="4553712"/>
-            <a:ext cx="2926080" cy="530352"/>
+            <a:off x="9189720" y="4773168"/>
+            <a:ext cx="2560320" cy="566928"/>
           </a:xfrm>
           <a:prstGeom prst="rect">
             <a:avLst/>
@@ -27915,8 +27915,8 @@
         </p:nvSpPr>
         <p:spPr>
           <a:xfrm>
-            <a:off x="8587740" y="4553712"/>
-            <a:ext cx="2849880" cy="530352"/>
+            <a:off x="9227820" y="4773168"/>
+            <a:ext cx="2484120" cy="566928"/>
           </a:xfrm>
           <a:prstGeom prst="rect">
             <a:avLst/>
@@ -27951,401 +27951,49 @@
       </p:sp>
       <p:sp>
         <p:nvSpPr>
-          <p:cNvPr id="62" name="Rectangle 61"/>
-          <p:cNvSpPr/>
-          <p:nvPr/>
-        </p:nvSpPr>
-        <p:spPr>
-          <a:xfrm>
-            <a:off x="411480" y="5084064"/>
-            <a:ext cx="2286000" cy="530352"/>
-          </a:xfrm>
-          <a:prstGeom prst="rect">
-            <a:avLst/>
-          </a:prstGeom>
-          <a:solidFill>
-            <a:srgbClr val="FFFFFF"/>
-          </a:solidFill>
-          <a:ln w="9525">
-            <a:solidFill>
-              <a:srgbClr val="D5DDE6"/>
-            </a:solidFill>
-          </a:ln>
-          <a:effectLst/>
-        </p:spPr>
-        <p:style>
-          <a:lnRef idx="1">
-            <a:schemeClr val="accent1"/>
-          </a:lnRef>
-          <a:fillRef idx="3">
-            <a:schemeClr val="accent1"/>
-          </a:fillRef>
-          <a:effectRef idx="2">
-            <a:schemeClr val="accent1"/>
-          </a:effectRef>
-          <a:fontRef idx="minor">
-            <a:schemeClr val="lt1"/>
-          </a:fontRef>
-        </p:style>
-        <p:txBody>
-          <a:bodyPr rtlCol="0" anchor="ctr"/>
-          <a:lstStyle/>
-          <a:p>
-            <a:pPr algn="ctr"/>
+          <p:cNvPr id="62" name="TextBox 61"/>
+          <p:cNvSpPr txBox="1"/>
+          <p:nvPr/>
+        </p:nvSpPr>
+        <p:spPr>
+          <a:xfrm>
+            <a:off x="411480" y="5532120"/>
+            <a:ext cx="11338560" cy="457200"/>
+          </a:xfrm>
+          <a:prstGeom prst="rect">
+            <a:avLst/>
+          </a:prstGeom>
+          <a:noFill/>
+        </p:spPr>
+        <p:txBody>
+          <a:bodyPr wrap="square" anchor="t">
+            <a:spAutoFit/>
+          </a:bodyPr>
+          <a:lstStyle/>
+          <a:p>
+            <a:pPr algn="ctr">
+              <a:lnSpc>
+                <a:spcPct val="100000"/>
+              </a:lnSpc>
+              <a:spcAft>
+                <a:spcPts val="400"/>
+              </a:spcAft>
+            </a:pPr>
+            <a:r>
+              <a:rPr sz="1050" b="0">
+                <a:solidFill>
+                  <a:srgbClr val="8A929E"/>
+                </a:solidFill>
+                <a:latin typeface="Apple SD Gothic Neo"/>
+              </a:rPr>
+              <a:t>◎ 강함   ○ 보통   △ 상대적 약함   |   공식 자료 및 사용자 평가 종합 (정량 벤치마크 아님)</a:t>
+            </a:r>
           </a:p>
         </p:txBody>
       </p:sp>
       <p:sp>
         <p:nvSpPr>
           <p:cNvPr id="63" name="TextBox 62"/>
-          <p:cNvSpPr txBox="1"/>
-          <p:nvPr/>
-        </p:nvSpPr>
-        <p:spPr>
-          <a:xfrm>
-            <a:off x="449580" y="5084064"/>
-            <a:ext cx="2209800" cy="530352"/>
-          </a:xfrm>
-          <a:prstGeom prst="rect">
-            <a:avLst/>
-          </a:prstGeom>
-          <a:noFill/>
-        </p:spPr>
-        <p:txBody>
-          <a:bodyPr wrap="square" anchor="ctr">
-            <a:spAutoFit/>
-          </a:bodyPr>
-          <a:lstStyle/>
-          <a:p>
-            <a:pPr algn="ctr">
-              <a:lnSpc>
-                <a:spcPct val="95000"/>
-              </a:lnSpc>
-              <a:spcAft>
-                <a:spcPts val="400"/>
-              </a:spcAft>
-            </a:pPr>
-            <a:r>
-              <a:rPr sz="1200" b="0">
-                <a:solidFill>
-                  <a:srgbClr val="444A55"/>
-                </a:solidFill>
-                <a:latin typeface="Apple SD Gothic Neo"/>
-              </a:rPr>
-              <a:t>코드 품질(참고)</a:t>
-            </a:r>
-          </a:p>
-        </p:txBody>
-      </p:sp>
-      <p:sp>
-        <p:nvSpPr>
-          <p:cNvPr id="64" name="Rectangle 63"/>
-          <p:cNvSpPr/>
-          <p:nvPr/>
-        </p:nvSpPr>
-        <p:spPr>
-          <a:xfrm>
-            <a:off x="2697480" y="5084064"/>
-            <a:ext cx="2926080" cy="530352"/>
-          </a:xfrm>
-          <a:prstGeom prst="rect">
-            <a:avLst/>
-          </a:prstGeom>
-          <a:solidFill>
-            <a:srgbClr val="FFFFFF"/>
-          </a:solidFill>
-          <a:ln w="9525">
-            <a:solidFill>
-              <a:srgbClr val="D5DDE6"/>
-            </a:solidFill>
-          </a:ln>
-          <a:effectLst/>
-        </p:spPr>
-        <p:style>
-          <a:lnRef idx="1">
-            <a:schemeClr val="accent1"/>
-          </a:lnRef>
-          <a:fillRef idx="3">
-            <a:schemeClr val="accent1"/>
-          </a:fillRef>
-          <a:effectRef idx="2">
-            <a:schemeClr val="accent1"/>
-          </a:effectRef>
-          <a:fontRef idx="minor">
-            <a:schemeClr val="lt1"/>
-          </a:fontRef>
-        </p:style>
-        <p:txBody>
-          <a:bodyPr rtlCol="0" anchor="ctr"/>
-          <a:lstStyle/>
-          <a:p>
-            <a:pPr algn="ctr"/>
-          </a:p>
-        </p:txBody>
-      </p:sp>
-      <p:sp>
-        <p:nvSpPr>
-          <p:cNvPr id="65" name="TextBox 64"/>
-          <p:cNvSpPr txBox="1"/>
-          <p:nvPr/>
-        </p:nvSpPr>
-        <p:spPr>
-          <a:xfrm>
-            <a:off x="2735580" y="5084064"/>
-            <a:ext cx="2849880" cy="530352"/>
-          </a:xfrm>
-          <a:prstGeom prst="rect">
-            <a:avLst/>
-          </a:prstGeom>
-          <a:noFill/>
-        </p:spPr>
-        <p:txBody>
-          <a:bodyPr wrap="square" anchor="ctr">
-            <a:spAutoFit/>
-          </a:bodyPr>
-          <a:lstStyle/>
-          <a:p>
-            <a:pPr algn="ctr">
-              <a:lnSpc>
-                <a:spcPct val="95000"/>
-              </a:lnSpc>
-              <a:spcAft>
-                <a:spcPts val="400"/>
-              </a:spcAft>
-            </a:pPr>
-            <a:r>
-              <a:rPr sz="1200" b="0">
-                <a:solidFill>
-                  <a:srgbClr val="444A55"/>
-                </a:solidFill>
-                <a:latin typeface="Apple SD Gothic Neo"/>
-              </a:rPr>
-              <a:t>○</a:t>
-            </a:r>
-          </a:p>
-        </p:txBody>
-      </p:sp>
-      <p:sp>
-        <p:nvSpPr>
-          <p:cNvPr id="66" name="Rectangle 65"/>
-          <p:cNvSpPr/>
-          <p:nvPr/>
-        </p:nvSpPr>
-        <p:spPr>
-          <a:xfrm>
-            <a:off x="5623560" y="5084064"/>
-            <a:ext cx="2926080" cy="530352"/>
-          </a:xfrm>
-          <a:prstGeom prst="rect">
-            <a:avLst/>
-          </a:prstGeom>
-          <a:solidFill>
-            <a:srgbClr val="FFFFFF"/>
-          </a:solidFill>
-          <a:ln w="9525">
-            <a:solidFill>
-              <a:srgbClr val="D5DDE6"/>
-            </a:solidFill>
-          </a:ln>
-          <a:effectLst/>
-        </p:spPr>
-        <p:style>
-          <a:lnRef idx="1">
-            <a:schemeClr val="accent1"/>
-          </a:lnRef>
-          <a:fillRef idx="3">
-            <a:schemeClr val="accent1"/>
-          </a:fillRef>
-          <a:effectRef idx="2">
-            <a:schemeClr val="accent1"/>
-          </a:effectRef>
-          <a:fontRef idx="minor">
-            <a:schemeClr val="lt1"/>
-          </a:fontRef>
-        </p:style>
-        <p:txBody>
-          <a:bodyPr rtlCol="0" anchor="ctr"/>
-          <a:lstStyle/>
-          <a:p>
-            <a:pPr algn="ctr"/>
-          </a:p>
-        </p:txBody>
-      </p:sp>
-      <p:sp>
-        <p:nvSpPr>
-          <p:cNvPr id="67" name="TextBox 66"/>
-          <p:cNvSpPr txBox="1"/>
-          <p:nvPr/>
-        </p:nvSpPr>
-        <p:spPr>
-          <a:xfrm>
-            <a:off x="5661660" y="5084064"/>
-            <a:ext cx="2849880" cy="530352"/>
-          </a:xfrm>
-          <a:prstGeom prst="rect">
-            <a:avLst/>
-          </a:prstGeom>
-          <a:noFill/>
-        </p:spPr>
-        <p:txBody>
-          <a:bodyPr wrap="square" anchor="ctr">
-            <a:spAutoFit/>
-          </a:bodyPr>
-          <a:lstStyle/>
-          <a:p>
-            <a:pPr algn="ctr">
-              <a:lnSpc>
-                <a:spcPct val="95000"/>
-              </a:lnSpc>
-              <a:spcAft>
-                <a:spcPts val="400"/>
-              </a:spcAft>
-            </a:pPr>
-            <a:r>
-              <a:rPr sz="1200" b="0">
-                <a:solidFill>
-                  <a:srgbClr val="444A55"/>
-                </a:solidFill>
-                <a:latin typeface="Apple SD Gothic Neo"/>
-              </a:rPr>
-              <a:t>○</a:t>
-            </a:r>
-          </a:p>
-        </p:txBody>
-      </p:sp>
-      <p:sp>
-        <p:nvSpPr>
-          <p:cNvPr id="68" name="Rectangle 67"/>
-          <p:cNvSpPr/>
-          <p:nvPr/>
-        </p:nvSpPr>
-        <p:spPr>
-          <a:xfrm>
-            <a:off x="8549640" y="5084064"/>
-            <a:ext cx="2926080" cy="530352"/>
-          </a:xfrm>
-          <a:prstGeom prst="rect">
-            <a:avLst/>
-          </a:prstGeom>
-          <a:solidFill>
-            <a:srgbClr val="FFFFFF"/>
-          </a:solidFill>
-          <a:ln w="9525">
-            <a:solidFill>
-              <a:srgbClr val="D5DDE6"/>
-            </a:solidFill>
-          </a:ln>
-          <a:effectLst/>
-        </p:spPr>
-        <p:style>
-          <a:lnRef idx="1">
-            <a:schemeClr val="accent1"/>
-          </a:lnRef>
-          <a:fillRef idx="3">
-            <a:schemeClr val="accent1"/>
-          </a:fillRef>
-          <a:effectRef idx="2">
-            <a:schemeClr val="accent1"/>
-          </a:effectRef>
-          <a:fontRef idx="minor">
-            <a:schemeClr val="lt1"/>
-          </a:fontRef>
-        </p:style>
-        <p:txBody>
-          <a:bodyPr rtlCol="0" anchor="ctr"/>
-          <a:lstStyle/>
-          <a:p>
-            <a:pPr algn="ctr"/>
-          </a:p>
-        </p:txBody>
-      </p:sp>
-      <p:sp>
-        <p:nvSpPr>
-          <p:cNvPr id="69" name="TextBox 68"/>
-          <p:cNvSpPr txBox="1"/>
-          <p:nvPr/>
-        </p:nvSpPr>
-        <p:spPr>
-          <a:xfrm>
-            <a:off x="8587740" y="5084064"/>
-            <a:ext cx="2849880" cy="530352"/>
-          </a:xfrm>
-          <a:prstGeom prst="rect">
-            <a:avLst/>
-          </a:prstGeom>
-          <a:noFill/>
-        </p:spPr>
-        <p:txBody>
-          <a:bodyPr wrap="square" anchor="ctr">
-            <a:spAutoFit/>
-          </a:bodyPr>
-          <a:lstStyle/>
-          <a:p>
-            <a:pPr algn="ctr">
-              <a:lnSpc>
-                <a:spcPct val="95000"/>
-              </a:lnSpc>
-              <a:spcAft>
-                <a:spcPts val="400"/>
-              </a:spcAft>
-            </a:pPr>
-            <a:r>
-              <a:rPr sz="1200" b="0">
-                <a:solidFill>
-                  <a:srgbClr val="444A55"/>
-                </a:solidFill>
-                <a:latin typeface="Apple SD Gothic Neo"/>
-              </a:rPr>
-              <a:t>◎</a:t>
-            </a:r>
-          </a:p>
-        </p:txBody>
-      </p:sp>
-      <p:sp>
-        <p:nvSpPr>
-          <p:cNvPr id="70" name="TextBox 69"/>
-          <p:cNvSpPr txBox="1"/>
-          <p:nvPr/>
-        </p:nvSpPr>
-        <p:spPr>
-          <a:xfrm>
-            <a:off x="502920" y="5806440"/>
-            <a:ext cx="10972800" cy="457200"/>
-          </a:xfrm>
-          <a:prstGeom prst="rect">
-            <a:avLst/>
-          </a:prstGeom>
-          <a:noFill/>
-        </p:spPr>
-        <p:txBody>
-          <a:bodyPr wrap="square" anchor="t">
-            <a:spAutoFit/>
-          </a:bodyPr>
-          <a:lstStyle/>
-          <a:p>
-            <a:pPr algn="ctr">
-              <a:lnSpc>
-                <a:spcPct val="100000"/>
-              </a:lnSpc>
-              <a:spcAft>
-                <a:spcPts val="400"/>
-              </a:spcAft>
-            </a:pPr>
-            <a:r>
-              <a:rPr sz="1050" b="0">
-                <a:solidFill>
-                  <a:srgbClr val="8A929E"/>
-                </a:solidFill>
-                <a:latin typeface="Apple SD Gothic Neo"/>
-              </a:rPr>
-              <a:t>◎ 강함  ○ 보통  △ 상대적 약함  |  '코드 품질'은 웹 사용기 참고, 공식 벤치 아님</a:t>
-            </a:r>
-          </a:p>
-        </p:txBody>
-      </p:sp>
-      <p:sp>
-        <p:nvSpPr>
-          <p:cNvPr id="71" name="TextBox 70"/>
           <p:cNvSpPr txBox="1"/>
           <p:nvPr/>
         </p:nvSpPr>

</xml_diff>

<commit_message>
Update cover team name to NC HW 개발팀; tidy callout box wrapping (p12, p16)
- Rename cover from 삼성전자 스마트폰 HW 개발팀 to NC HW 개발팀
- Shorten and resize page 12/16 callout text so each bullet fits one line
  (avoids inconsistent single-character wrapping for executive report)

Co-authored-by: Cursor <cursoragent@cursor.com>
</commit_message>
<xml_diff>
--- a/외부AI_3종_비교조사.pptx
+++ b/외부AI_3종_비교조사.pptx
@@ -3255,7 +3255,7 @@
                 </a:solidFill>
                 <a:latin typeface="Apple SD Gothic Neo"/>
               </a:rPr>
-              <a:t>삼성전자 스마트폰 HW 개발팀  |  2026년 6월 외부 AI 도입 검토</a:t>
+              <a:t>NC HW 개발팀  |  2026년 6월 외부 AI 도입 검토</a:t>
             </a:r>
           </a:p>
           <a:p>
@@ -8105,8 +8105,8 @@
         </p:nvSpPr>
         <p:spPr>
           <a:xfrm>
-            <a:off x="685800" y="4800600"/>
-            <a:ext cx="10835640" cy="1325880"/>
+            <a:off x="731520" y="4800600"/>
+            <a:ext cx="10698480" cy="1325880"/>
           </a:xfrm>
           <a:prstGeom prst="rect">
             <a:avLst/>
@@ -8121,10 +8121,10 @@
           <a:p>
             <a:pPr algn="l">
               <a:lnSpc>
-                <a:spcPct val="122000"/>
-              </a:lnSpc>
-              <a:spcAft>
-                <a:spcPts val="300"/>
+                <a:spcPct val="125000"/>
+              </a:lnSpc>
+              <a:spcAft>
+                <a:spcPts val="400"/>
               </a:spcAft>
             </a:pPr>
             <a:r>
@@ -8140,39 +8140,39 @@
           <a:p>
             <a:pPr algn="l">
               <a:lnSpc>
-                <a:spcPct val="122000"/>
-              </a:lnSpc>
-              <a:spcAft>
-                <a:spcPts val="300"/>
-              </a:spcAft>
-            </a:pPr>
-            <a:r>
-              <a:rPr sz="1200" b="0">
+                <a:spcPct val="125000"/>
+              </a:lnSpc>
+              <a:spcAft>
+                <a:spcPts val="400"/>
+              </a:spcAft>
+            </a:pPr>
+            <a:r>
+              <a:rPr sz="1150" b="0">
                 <a:solidFill>
                   <a:srgbClr val="FFFFFF"/>
                 </a:solidFill>
                 <a:latin typeface="Apple SD Gothic Neo"/>
               </a:rPr>
-              <a:t>• 사내 Gauss의 분당 3~4회 호출 제한과 마찬가지로, 외부 LLM도 사용 한도가 실무 병목 요인</a:t>
+              <a:t>• 사내 Gauss(분당 3~4회 제한)처럼, 외부 LLM도 사용 한도가 실무 병목 요인</a:t>
             </a:r>
           </a:p>
           <a:p>
             <a:pPr algn="l">
               <a:lnSpc>
-                <a:spcPct val="122000"/>
-              </a:lnSpc>
-              <a:spcAft>
-                <a:spcPts val="300"/>
-              </a:spcAft>
-            </a:pPr>
-            <a:r>
-              <a:rPr sz="1200" b="0">
+                <a:spcPct val="125000"/>
+              </a:lnSpc>
+              <a:spcAft>
+                <a:spcPts val="400"/>
+              </a:spcAft>
+            </a:pPr>
+            <a:r>
+              <a:rPr sz="1150" b="0">
                 <a:solidFill>
                   <a:srgbClr val="FFFFFF"/>
                 </a:solidFill>
                 <a:latin typeface="Apple SD Gothic Neo"/>
               </a:rPr>
-              <a:t>• PoC 단계에서 사용 한도·응답 속도·코드 신뢰도(오류율)를 정량 측정 권장</a:t>
+              <a:t>• PoC 단계에서 사용 한도·응답 속도·코드 오류율을 정량 측정 권장</a:t>
             </a:r>
           </a:p>
         </p:txBody>
@@ -15440,7 +15440,7 @@
         <p:spPr>
           <a:xfrm>
             <a:off x="777240" y="4315968"/>
-            <a:ext cx="10652760" cy="1627632"/>
+            <a:ext cx="10607040" cy="1627632"/>
           </a:xfrm>
           <a:prstGeom prst="rect">
             <a:avLst/>
@@ -15455,10 +15455,10 @@
           <a:p>
             <a:pPr algn="l">
               <a:lnSpc>
-                <a:spcPct val="122000"/>
-              </a:lnSpc>
-              <a:spcAft>
-                <a:spcPts val="300"/>
+                <a:spcPct val="125000"/>
+              </a:lnSpc>
+              <a:spcAft>
+                <a:spcPts val="400"/>
               </a:spcAft>
             </a:pPr>
             <a:r>
@@ -15474,39 +15474,39 @@
           <a:p>
             <a:pPr algn="l">
               <a:lnSpc>
-                <a:spcPct val="122000"/>
-              </a:lnSpc>
-              <a:spcAft>
-                <a:spcPts val="300"/>
-              </a:spcAft>
-            </a:pPr>
-            <a:r>
-              <a:rPr sz="1200" b="0">
+                <a:spcPct val="125000"/>
+              </a:lnSpc>
+              <a:spcAft>
+                <a:spcPts val="400"/>
+              </a:spcAft>
+            </a:pPr>
+            <a:r>
+              <a:rPr sz="1150" b="0">
                 <a:solidFill>
                   <a:srgbClr val="FFFFFF"/>
                 </a:solidFill>
                 <a:latin typeface="Apple SD Gothic Neo"/>
               </a:rPr>
-              <a:t>• 외부 LLM은 사내 Gauss(망분리 보조)를 대체하지 않고, 보안 검토 후 고급 보조 수단으로 역할 분담</a:t>
+              <a:t>• 외부 LLM은 사내 Gauss를 대체하지 않고, 보안 검토 후 고급 보조 수단으로 역할 분담</a:t>
             </a:r>
           </a:p>
           <a:p>
             <a:pPr algn="l">
               <a:lnSpc>
-                <a:spcPct val="122000"/>
-              </a:lnSpc>
-              <a:spcAft>
-                <a:spcPts val="300"/>
-              </a:spcAft>
-            </a:pPr>
-            <a:r>
-              <a:rPr sz="1200" b="0">
+                <a:spcPct val="125000"/>
+              </a:lnSpc>
+              <a:spcAft>
+                <a:spcPts val="400"/>
+              </a:spcAft>
+            </a:pPr>
+            <a:r>
+              <a:rPr sz="1150" b="0">
                 <a:solidFill>
                   <a:srgbClr val="FFFFFF"/>
                 </a:solidFill>
                 <a:latin typeface="Apple SD Gothic Neo"/>
               </a:rPr>
-              <a:t>• 권장안: 업무별 PoC 1~2건 선정 → 효과·보안·사용 한도 정량 측정 → 팀 표준 활용 가이드 수립</a:t>
+              <a:t>• 업무별 PoC 1~2건 → 효과·보안·사용 한도 측정 → 팀 표준 활용 가이드 수립</a:t>
             </a:r>
           </a:p>
         </p:txBody>

</xml_diff>

<commit_message>
Reframe conclusion as per-AI adoption effects; drop manual-judgment row
- Page 16 bottom box now states each AI's expected in-house adoption effect,
  aligned with goal of maximizing AI-handled work
- Page 15 removes the '최종 회로·양산 판단' (human-only) row

Co-authored-by: Cursor <cursoragent@cursor.com>
</commit_message>
<xml_diff>
--- a/외부AI_3종_비교조사.pptx
+++ b/외부AI_3종_비교조사.pptx
@@ -12366,7 +12366,7 @@
         <p:spPr>
           <a:xfrm>
             <a:off x="502920" y="1371600"/>
-            <a:ext cx="2560320" cy="502920"/>
+            <a:ext cx="2560320" cy="585216"/>
           </a:xfrm>
           <a:prstGeom prst="rect">
             <a:avLst/>
@@ -12412,7 +12412,7 @@
         <p:spPr>
           <a:xfrm>
             <a:off x="502920" y="1371600"/>
-            <a:ext cx="2560320" cy="502920"/>
+            <a:ext cx="2560320" cy="585216"/>
           </a:xfrm>
           <a:prstGeom prst="rect">
             <a:avLst/>
@@ -12454,7 +12454,7 @@
         <p:spPr>
           <a:xfrm>
             <a:off x="3063240" y="1371600"/>
-            <a:ext cx="2286000" cy="502920"/>
+            <a:ext cx="2286000" cy="585216"/>
           </a:xfrm>
           <a:prstGeom prst="rect">
             <a:avLst/>
@@ -12500,7 +12500,7 @@
         <p:spPr>
           <a:xfrm>
             <a:off x="3063240" y="1371600"/>
-            <a:ext cx="2286000" cy="502920"/>
+            <a:ext cx="2286000" cy="585216"/>
           </a:xfrm>
           <a:prstGeom prst="rect">
             <a:avLst/>
@@ -12542,7 +12542,7 @@
         <p:spPr>
           <a:xfrm>
             <a:off x="5349240" y="1371600"/>
-            <a:ext cx="6355080" cy="502920"/>
+            <a:ext cx="6355080" cy="585216"/>
           </a:xfrm>
           <a:prstGeom prst="rect">
             <a:avLst/>
@@ -12588,7 +12588,7 @@
         <p:spPr>
           <a:xfrm>
             <a:off x="5349240" y="1371600"/>
-            <a:ext cx="6355080" cy="502920"/>
+            <a:ext cx="6355080" cy="585216"/>
           </a:xfrm>
           <a:prstGeom prst="rect">
             <a:avLst/>
@@ -12629,8 +12629,8 @@
         </p:nvSpPr>
         <p:spPr>
           <a:xfrm>
-            <a:off x="502920" y="1874520"/>
-            <a:ext cx="2560320" cy="502920"/>
+            <a:off x="502920" y="1956816"/>
+            <a:ext cx="2560320" cy="585216"/>
           </a:xfrm>
           <a:prstGeom prst="rect">
             <a:avLst/>
@@ -12675,8 +12675,8 @@
         </p:nvSpPr>
         <p:spPr>
           <a:xfrm>
-            <a:off x="541020" y="1874520"/>
-            <a:ext cx="2484120" cy="502920"/>
+            <a:off x="541020" y="1956816"/>
+            <a:ext cx="2484120" cy="585216"/>
           </a:xfrm>
           <a:prstGeom prst="rect">
             <a:avLst/>
@@ -12717,8 +12717,8 @@
         </p:nvSpPr>
         <p:spPr>
           <a:xfrm>
-            <a:off x="3063240" y="1874520"/>
-            <a:ext cx="2286000" cy="502920"/>
+            <a:off x="3063240" y="1956816"/>
+            <a:ext cx="2286000" cy="585216"/>
           </a:xfrm>
           <a:prstGeom prst="rect">
             <a:avLst/>
@@ -12763,8 +12763,8 @@
         </p:nvSpPr>
         <p:spPr>
           <a:xfrm>
-            <a:off x="3101340" y="1874520"/>
-            <a:ext cx="2209800" cy="502920"/>
+            <a:off x="3101340" y="1956816"/>
+            <a:ext cx="2209800" cy="585216"/>
           </a:xfrm>
           <a:prstGeom prst="rect">
             <a:avLst/>
@@ -12805,8 +12805,8 @@
         </p:nvSpPr>
         <p:spPr>
           <a:xfrm>
-            <a:off x="5349240" y="1874520"/>
-            <a:ext cx="6355080" cy="502920"/>
+            <a:off x="5349240" y="1956816"/>
+            <a:ext cx="6355080" cy="585216"/>
           </a:xfrm>
           <a:prstGeom prst="rect">
             <a:avLst/>
@@ -12851,8 +12851,8 @@
         </p:nvSpPr>
         <p:spPr>
           <a:xfrm>
-            <a:off x="5387340" y="1874520"/>
-            <a:ext cx="6278880" cy="502920"/>
+            <a:off x="5387340" y="1956816"/>
+            <a:ext cx="6278880" cy="585216"/>
           </a:xfrm>
           <a:prstGeom prst="rect">
             <a:avLst/>
@@ -12893,8 +12893,8 @@
         </p:nvSpPr>
         <p:spPr>
           <a:xfrm>
-            <a:off x="502920" y="2377440"/>
-            <a:ext cx="2560320" cy="502920"/>
+            <a:off x="502920" y="2542032"/>
+            <a:ext cx="2560320" cy="585216"/>
           </a:xfrm>
           <a:prstGeom prst="rect">
             <a:avLst/>
@@ -12939,8 +12939,8 @@
         </p:nvSpPr>
         <p:spPr>
           <a:xfrm>
-            <a:off x="541020" y="2377440"/>
-            <a:ext cx="2484120" cy="502920"/>
+            <a:off x="541020" y="2542032"/>
+            <a:ext cx="2484120" cy="585216"/>
           </a:xfrm>
           <a:prstGeom prst="rect">
             <a:avLst/>
@@ -12981,8 +12981,8 @@
         </p:nvSpPr>
         <p:spPr>
           <a:xfrm>
-            <a:off x="3063240" y="2377440"/>
-            <a:ext cx="2286000" cy="502920"/>
+            <a:off x="3063240" y="2542032"/>
+            <a:ext cx="2286000" cy="585216"/>
           </a:xfrm>
           <a:prstGeom prst="rect">
             <a:avLst/>
@@ -13027,8 +13027,8 @@
         </p:nvSpPr>
         <p:spPr>
           <a:xfrm>
-            <a:off x="3101340" y="2377440"/>
-            <a:ext cx="2209800" cy="502920"/>
+            <a:off x="3101340" y="2542032"/>
+            <a:ext cx="2209800" cy="585216"/>
           </a:xfrm>
           <a:prstGeom prst="rect">
             <a:avLst/>
@@ -13069,8 +13069,8 @@
         </p:nvSpPr>
         <p:spPr>
           <a:xfrm>
-            <a:off x="5349240" y="2377440"/>
-            <a:ext cx="6355080" cy="502920"/>
+            <a:off x="5349240" y="2542032"/>
+            <a:ext cx="6355080" cy="585216"/>
           </a:xfrm>
           <a:prstGeom prst="rect">
             <a:avLst/>
@@ -13115,8 +13115,8 @@
         </p:nvSpPr>
         <p:spPr>
           <a:xfrm>
-            <a:off x="5387340" y="2377440"/>
-            <a:ext cx="6278880" cy="502920"/>
+            <a:off x="5387340" y="2542032"/>
+            <a:ext cx="6278880" cy="585216"/>
           </a:xfrm>
           <a:prstGeom prst="rect">
             <a:avLst/>
@@ -13157,8 +13157,8 @@
         </p:nvSpPr>
         <p:spPr>
           <a:xfrm>
-            <a:off x="502920" y="2880360"/>
-            <a:ext cx="2560320" cy="502920"/>
+            <a:off x="502920" y="3127248"/>
+            <a:ext cx="2560320" cy="585216"/>
           </a:xfrm>
           <a:prstGeom prst="rect">
             <a:avLst/>
@@ -13203,8 +13203,8 @@
         </p:nvSpPr>
         <p:spPr>
           <a:xfrm>
-            <a:off x="541020" y="2880360"/>
-            <a:ext cx="2484120" cy="502920"/>
+            <a:off x="541020" y="3127248"/>
+            <a:ext cx="2484120" cy="585216"/>
           </a:xfrm>
           <a:prstGeom prst="rect">
             <a:avLst/>
@@ -13245,8 +13245,8 @@
         </p:nvSpPr>
         <p:spPr>
           <a:xfrm>
-            <a:off x="3063240" y="2880360"/>
-            <a:ext cx="2286000" cy="502920"/>
+            <a:off x="3063240" y="3127248"/>
+            <a:ext cx="2286000" cy="585216"/>
           </a:xfrm>
           <a:prstGeom prst="rect">
             <a:avLst/>
@@ -13291,8 +13291,8 @@
         </p:nvSpPr>
         <p:spPr>
           <a:xfrm>
-            <a:off x="3101340" y="2880360"/>
-            <a:ext cx="2209800" cy="502920"/>
+            <a:off x="3101340" y="3127248"/>
+            <a:ext cx="2209800" cy="585216"/>
           </a:xfrm>
           <a:prstGeom prst="rect">
             <a:avLst/>
@@ -13333,8 +13333,8 @@
         </p:nvSpPr>
         <p:spPr>
           <a:xfrm>
-            <a:off x="5349240" y="2880360"/>
-            <a:ext cx="6355080" cy="502920"/>
+            <a:off x="5349240" y="3127248"/>
+            <a:ext cx="6355080" cy="585216"/>
           </a:xfrm>
           <a:prstGeom prst="rect">
             <a:avLst/>
@@ -13379,8 +13379,8 @@
         </p:nvSpPr>
         <p:spPr>
           <a:xfrm>
-            <a:off x="5387340" y="2880360"/>
-            <a:ext cx="6278880" cy="502920"/>
+            <a:off x="5387340" y="3127248"/>
+            <a:ext cx="6278880" cy="585216"/>
           </a:xfrm>
           <a:prstGeom prst="rect">
             <a:avLst/>
@@ -13421,8 +13421,8 @@
         </p:nvSpPr>
         <p:spPr>
           <a:xfrm>
-            <a:off x="502920" y="3383280"/>
-            <a:ext cx="2560320" cy="502920"/>
+            <a:off x="502920" y="3712464"/>
+            <a:ext cx="2560320" cy="585216"/>
           </a:xfrm>
           <a:prstGeom prst="rect">
             <a:avLst/>
@@ -13467,8 +13467,8 @@
         </p:nvSpPr>
         <p:spPr>
           <a:xfrm>
-            <a:off x="541020" y="3383280"/>
-            <a:ext cx="2484120" cy="502920"/>
+            <a:off x="541020" y="3712464"/>
+            <a:ext cx="2484120" cy="585216"/>
           </a:xfrm>
           <a:prstGeom prst="rect">
             <a:avLst/>
@@ -13509,8 +13509,8 @@
         </p:nvSpPr>
         <p:spPr>
           <a:xfrm>
-            <a:off x="3063240" y="3383280"/>
-            <a:ext cx="2286000" cy="502920"/>
+            <a:off x="3063240" y="3712464"/>
+            <a:ext cx="2286000" cy="585216"/>
           </a:xfrm>
           <a:prstGeom prst="rect">
             <a:avLst/>
@@ -13555,8 +13555,8 @@
         </p:nvSpPr>
         <p:spPr>
           <a:xfrm>
-            <a:off x="3101340" y="3383280"/>
-            <a:ext cx="2209800" cy="502920"/>
+            <a:off x="3101340" y="3712464"/>
+            <a:ext cx="2209800" cy="585216"/>
           </a:xfrm>
           <a:prstGeom prst="rect">
             <a:avLst/>
@@ -13597,8 +13597,8 @@
         </p:nvSpPr>
         <p:spPr>
           <a:xfrm>
-            <a:off x="5349240" y="3383280"/>
-            <a:ext cx="6355080" cy="502920"/>
+            <a:off x="5349240" y="3712464"/>
+            <a:ext cx="6355080" cy="585216"/>
           </a:xfrm>
           <a:prstGeom prst="rect">
             <a:avLst/>
@@ -13643,8 +13643,8 @@
         </p:nvSpPr>
         <p:spPr>
           <a:xfrm>
-            <a:off x="5387340" y="3383280"/>
-            <a:ext cx="6278880" cy="502920"/>
+            <a:off x="5387340" y="3712464"/>
+            <a:ext cx="6278880" cy="585216"/>
           </a:xfrm>
           <a:prstGeom prst="rect">
             <a:avLst/>
@@ -13685,8 +13685,8 @@
         </p:nvSpPr>
         <p:spPr>
           <a:xfrm>
-            <a:off x="502920" y="3886200"/>
-            <a:ext cx="2560320" cy="502920"/>
+            <a:off x="502920" y="4297680"/>
+            <a:ext cx="2560320" cy="585216"/>
           </a:xfrm>
           <a:prstGeom prst="rect">
             <a:avLst/>
@@ -13731,8 +13731,8 @@
         </p:nvSpPr>
         <p:spPr>
           <a:xfrm>
-            <a:off x="541020" y="3886200"/>
-            <a:ext cx="2484120" cy="502920"/>
+            <a:off x="541020" y="4297680"/>
+            <a:ext cx="2484120" cy="585216"/>
           </a:xfrm>
           <a:prstGeom prst="rect">
             <a:avLst/>
@@ -13773,8 +13773,8 @@
         </p:nvSpPr>
         <p:spPr>
           <a:xfrm>
-            <a:off x="3063240" y="3886200"/>
-            <a:ext cx="2286000" cy="502920"/>
+            <a:off x="3063240" y="4297680"/>
+            <a:ext cx="2286000" cy="585216"/>
           </a:xfrm>
           <a:prstGeom prst="rect">
             <a:avLst/>
@@ -13819,8 +13819,8 @@
         </p:nvSpPr>
         <p:spPr>
           <a:xfrm>
-            <a:off x="3101340" y="3886200"/>
-            <a:ext cx="2209800" cy="502920"/>
+            <a:off x="3101340" y="4297680"/>
+            <a:ext cx="2209800" cy="585216"/>
           </a:xfrm>
           <a:prstGeom prst="rect">
             <a:avLst/>
@@ -13861,8 +13861,8 @@
         </p:nvSpPr>
         <p:spPr>
           <a:xfrm>
-            <a:off x="5349240" y="3886200"/>
-            <a:ext cx="6355080" cy="502920"/>
+            <a:off x="5349240" y="4297680"/>
+            <a:ext cx="6355080" cy="585216"/>
           </a:xfrm>
           <a:prstGeom prst="rect">
             <a:avLst/>
@@ -13907,8 +13907,8 @@
         </p:nvSpPr>
         <p:spPr>
           <a:xfrm>
-            <a:off x="5387340" y="3886200"/>
-            <a:ext cx="6278880" cy="502920"/>
+            <a:off x="5387340" y="4297680"/>
+            <a:ext cx="6278880" cy="585216"/>
           </a:xfrm>
           <a:prstGeom prst="rect">
             <a:avLst/>
@@ -13943,271 +13943,7 @@
       </p:sp>
       <p:sp>
         <p:nvSpPr>
-          <p:cNvPr id="42" name="Rectangle 41"/>
-          <p:cNvSpPr/>
-          <p:nvPr/>
-        </p:nvSpPr>
-        <p:spPr>
-          <a:xfrm>
-            <a:off x="502920" y="4389120"/>
-            <a:ext cx="2560320" cy="502920"/>
-          </a:xfrm>
-          <a:prstGeom prst="rect">
-            <a:avLst/>
-          </a:prstGeom>
-          <a:solidFill>
-            <a:srgbClr val="E8F1FA"/>
-          </a:solidFill>
-          <a:ln w="9525">
-            <a:solidFill>
-              <a:srgbClr val="D5DDE6"/>
-            </a:solidFill>
-          </a:ln>
-          <a:effectLst/>
-        </p:spPr>
-        <p:style>
-          <a:lnRef idx="1">
-            <a:schemeClr val="accent1"/>
-          </a:lnRef>
-          <a:fillRef idx="3">
-            <a:schemeClr val="accent1"/>
-          </a:fillRef>
-          <a:effectRef idx="2">
-            <a:schemeClr val="accent1"/>
-          </a:effectRef>
-          <a:fontRef idx="minor">
-            <a:schemeClr val="lt1"/>
-          </a:fontRef>
-        </p:style>
-        <p:txBody>
-          <a:bodyPr rtlCol="0" anchor="ctr"/>
-          <a:lstStyle/>
-          <a:p>
-            <a:pPr algn="ctr"/>
-          </a:p>
-        </p:txBody>
-      </p:sp>
-      <p:sp>
-        <p:nvSpPr>
-          <p:cNvPr id="43" name="TextBox 42"/>
-          <p:cNvSpPr txBox="1"/>
-          <p:nvPr/>
-        </p:nvSpPr>
-        <p:spPr>
-          <a:xfrm>
-            <a:off x="541020" y="4389120"/>
-            <a:ext cx="2484120" cy="502920"/>
-          </a:xfrm>
-          <a:prstGeom prst="rect">
-            <a:avLst/>
-          </a:prstGeom>
-          <a:noFill/>
-        </p:spPr>
-        <p:txBody>
-          <a:bodyPr wrap="square" anchor="ctr">
-            <a:spAutoFit/>
-          </a:bodyPr>
-          <a:lstStyle/>
-          <a:p>
-            <a:pPr algn="ctr">
-              <a:lnSpc>
-                <a:spcPct val="95000"/>
-              </a:lnSpc>
-              <a:spcAft>
-                <a:spcPts val="400"/>
-              </a:spcAft>
-            </a:pPr>
-            <a:r>
-              <a:rPr sz="1100" b="0">
-                <a:solidFill>
-                  <a:srgbClr val="444A55"/>
-                </a:solidFill>
-                <a:latin typeface="Apple SD Gothic Neo"/>
-              </a:rPr>
-              <a:t>최종 회로·양산 판단</a:t>
-            </a:r>
-          </a:p>
-        </p:txBody>
-      </p:sp>
-      <p:sp>
-        <p:nvSpPr>
-          <p:cNvPr id="44" name="Rectangle 43"/>
-          <p:cNvSpPr/>
-          <p:nvPr/>
-        </p:nvSpPr>
-        <p:spPr>
-          <a:xfrm>
-            <a:off x="3063240" y="4389120"/>
-            <a:ext cx="2286000" cy="502920"/>
-          </a:xfrm>
-          <a:prstGeom prst="rect">
-            <a:avLst/>
-          </a:prstGeom>
-          <a:solidFill>
-            <a:srgbClr val="E8F1FA"/>
-          </a:solidFill>
-          <a:ln w="9525">
-            <a:solidFill>
-              <a:srgbClr val="D5DDE6"/>
-            </a:solidFill>
-          </a:ln>
-          <a:effectLst/>
-        </p:spPr>
-        <p:style>
-          <a:lnRef idx="1">
-            <a:schemeClr val="accent1"/>
-          </a:lnRef>
-          <a:fillRef idx="3">
-            <a:schemeClr val="accent1"/>
-          </a:fillRef>
-          <a:effectRef idx="2">
-            <a:schemeClr val="accent1"/>
-          </a:effectRef>
-          <a:fontRef idx="minor">
-            <a:schemeClr val="lt1"/>
-          </a:fontRef>
-        </p:style>
-        <p:txBody>
-          <a:bodyPr rtlCol="0" anchor="ctr"/>
-          <a:lstStyle/>
-          <a:p>
-            <a:pPr algn="ctr"/>
-          </a:p>
-        </p:txBody>
-      </p:sp>
-      <p:sp>
-        <p:nvSpPr>
-          <p:cNvPr id="45" name="TextBox 44"/>
-          <p:cNvSpPr txBox="1"/>
-          <p:nvPr/>
-        </p:nvSpPr>
-        <p:spPr>
-          <a:xfrm>
-            <a:off x="3101340" y="4389120"/>
-            <a:ext cx="2209800" cy="502920"/>
-          </a:xfrm>
-          <a:prstGeom prst="rect">
-            <a:avLst/>
-          </a:prstGeom>
-          <a:noFill/>
-        </p:spPr>
-        <p:txBody>
-          <a:bodyPr wrap="square" anchor="ctr">
-            <a:spAutoFit/>
-          </a:bodyPr>
-          <a:lstStyle/>
-          <a:p>
-            <a:pPr algn="ctr">
-              <a:lnSpc>
-                <a:spcPct val="95000"/>
-              </a:lnSpc>
-              <a:spcAft>
-                <a:spcPts val="400"/>
-              </a:spcAft>
-            </a:pPr>
-            <a:r>
-              <a:rPr sz="1100" b="0">
-                <a:solidFill>
-                  <a:srgbClr val="444A55"/>
-                </a:solidFill>
-                <a:latin typeface="Apple SD Gothic Neo"/>
-              </a:rPr>
-              <a:t>엔지니어</a:t>
-            </a:r>
-          </a:p>
-        </p:txBody>
-      </p:sp>
-      <p:sp>
-        <p:nvSpPr>
-          <p:cNvPr id="46" name="Rectangle 45"/>
-          <p:cNvSpPr/>
-          <p:nvPr/>
-        </p:nvSpPr>
-        <p:spPr>
-          <a:xfrm>
-            <a:off x="5349240" y="4389120"/>
-            <a:ext cx="6355080" cy="502920"/>
-          </a:xfrm>
-          <a:prstGeom prst="rect">
-            <a:avLst/>
-          </a:prstGeom>
-          <a:solidFill>
-            <a:srgbClr val="E8F1FA"/>
-          </a:solidFill>
-          <a:ln w="9525">
-            <a:solidFill>
-              <a:srgbClr val="D5DDE6"/>
-            </a:solidFill>
-          </a:ln>
-          <a:effectLst/>
-        </p:spPr>
-        <p:style>
-          <a:lnRef idx="1">
-            <a:schemeClr val="accent1"/>
-          </a:lnRef>
-          <a:fillRef idx="3">
-            <a:schemeClr val="accent1"/>
-          </a:fillRef>
-          <a:effectRef idx="2">
-            <a:schemeClr val="accent1"/>
-          </a:effectRef>
-          <a:fontRef idx="minor">
-            <a:schemeClr val="lt1"/>
-          </a:fontRef>
-        </p:style>
-        <p:txBody>
-          <a:bodyPr rtlCol="0" anchor="ctr"/>
-          <a:lstStyle/>
-          <a:p>
-            <a:pPr algn="ctr"/>
-          </a:p>
-        </p:txBody>
-      </p:sp>
-      <p:sp>
-        <p:nvSpPr>
-          <p:cNvPr id="47" name="TextBox 46"/>
-          <p:cNvSpPr txBox="1"/>
-          <p:nvPr/>
-        </p:nvSpPr>
-        <p:spPr>
-          <a:xfrm>
-            <a:off x="5387340" y="4389120"/>
-            <a:ext cx="6278880" cy="502920"/>
-          </a:xfrm>
-          <a:prstGeom prst="rect">
-            <a:avLst/>
-          </a:prstGeom>
-          <a:noFill/>
-        </p:spPr>
-        <p:txBody>
-          <a:bodyPr wrap="square" anchor="ctr">
-            <a:spAutoFit/>
-          </a:bodyPr>
-          <a:lstStyle/>
-          <a:p>
-            <a:pPr algn="ctr">
-              <a:lnSpc>
-                <a:spcPct val="95000"/>
-              </a:lnSpc>
-              <a:spcAft>
-                <a:spcPts val="400"/>
-              </a:spcAft>
-            </a:pPr>
-            <a:r>
-              <a:rPr sz="1100" b="0">
-                <a:solidFill>
-                  <a:srgbClr val="444A55"/>
-                </a:solidFill>
-                <a:latin typeface="Apple SD Gothic Neo"/>
-              </a:rPr>
-              <a:t>AI는 보조 수단, 실측 검증 필수</a:t>
-            </a:r>
-          </a:p>
-        </p:txBody>
-      </p:sp>
-      <p:sp>
-        <p:nvSpPr>
-          <p:cNvPr id="48" name="Rounded Rectangle 47"/>
+          <p:cNvPr id="42" name="Rounded Rectangle 41"/>
           <p:cNvSpPr/>
           <p:nvPr/>
         </p:nvSpPr>
@@ -14253,7 +13989,7 @@
       </p:sp>
       <p:sp>
         <p:nvSpPr>
-          <p:cNvPr id="49" name="TextBox 48"/>
+          <p:cNvPr id="43" name="TextBox 42"/>
           <p:cNvSpPr txBox="1"/>
           <p:nvPr/>
         </p:nvSpPr>
@@ -14333,7 +14069,7 @@
       </p:sp>
       <p:sp>
         <p:nvSpPr>
-          <p:cNvPr id="50" name="TextBox 49"/>
+          <p:cNvPr id="44" name="TextBox 43"/>
           <p:cNvSpPr txBox="1"/>
           <p:nvPr/>
         </p:nvSpPr>
@@ -14566,7 +14302,7 @@
                 </a:solidFill>
                 <a:latin typeface="Apple SD Gothic Neo"/>
               </a:rPr>
-              <a:t>결론: LLM별 사내 활용 방안</a:t>
+              <a:t>결론: LLM별 사내 활용 방안과 도입 효과</a:t>
             </a:r>
           </a:p>
         </p:txBody>
@@ -14608,7 +14344,7 @@
                 </a:solidFill>
                 <a:latin typeface="Apple SD Gothic Neo"/>
               </a:rPr>
-              <a:t>공식 자료와 사용자 사용 사례를 종합한, HW 개발 업무에서의 효율적 활용 방안입니다.</a:t>
+              <a:t>목표는 정형·반복 업무를 최대한 AI가 직접 수행하도록 확대하여, 엔지니어가 핵심 설계·검증에 집중하는 것입니다.</a:t>
             </a:r>
           </a:p>
         </p:txBody>
@@ -15395,8 +15131,8 @@
         </p:nvSpPr>
         <p:spPr>
           <a:xfrm>
-            <a:off x="502920" y="4315968"/>
-            <a:ext cx="11247120" cy="1627632"/>
+            <a:off x="502920" y="4224528"/>
+            <a:ext cx="11247120" cy="1783080"/>
           </a:xfrm>
           <a:prstGeom prst="roundRect">
             <a:avLst/>
@@ -15439,8 +15175,8 @@
         </p:nvSpPr>
         <p:spPr>
           <a:xfrm>
-            <a:off x="777240" y="4315968"/>
-            <a:ext cx="10607040" cy="1627632"/>
+            <a:off x="777240" y="4224528"/>
+            <a:ext cx="10607040" cy="1783080"/>
           </a:xfrm>
           <a:prstGeom prst="rect">
             <a:avLst/>
@@ -15455,26 +15191,26 @@
           <a:p>
             <a:pPr algn="l">
               <a:lnSpc>
-                <a:spcPct val="125000"/>
-              </a:lnSpc>
-              <a:spcAft>
-                <a:spcPts val="400"/>
-              </a:spcAft>
-            </a:pPr>
-            <a:r>
-              <a:rPr sz="1500" b="1">
+                <a:spcPct val="128000"/>
+              </a:lnSpc>
+              <a:spcAft>
+                <a:spcPts val="400"/>
+              </a:spcAft>
+            </a:pPr>
+            <a:r>
+              <a:rPr sz="1400" b="1">
                 <a:solidFill>
                   <a:srgbClr val="9FC4E8"/>
                 </a:solidFill>
                 <a:latin typeface="Apple SD Gothic Neo"/>
               </a:rPr>
-              <a:t>종합 결론 및 도입 제언</a:t>
+              <a:t>사내 도입 시 기대 효과 (AI별)</a:t>
             </a:r>
           </a:p>
           <a:p>
             <a:pPr algn="l">
               <a:lnSpc>
-                <a:spcPct val="125000"/>
+                <a:spcPct val="128000"/>
               </a:lnSpc>
               <a:spcAft>
                 <a:spcPts val="400"/>
@@ -15487,13 +15223,13 @@
                 </a:solidFill>
                 <a:latin typeface="Apple SD Gothic Neo"/>
               </a:rPr>
-              <a:t>• 외부 LLM은 사내 Gauss를 대체하지 않고, 보안 검토 후 고급 보조 수단으로 역할 분담</a:t>
+              <a:t>• ChatGPT: 측정 자동화·문서 초안·도구 연동으로 반복 업무 처리 시간 대폭 단축</a:t>
             </a:r>
           </a:p>
           <a:p>
             <a:pPr algn="l">
               <a:lnSpc>
-                <a:spcPct val="125000"/>
+                <a:spcPct val="128000"/>
               </a:lnSpc>
               <a:spcAft>
                 <a:spcPts val="400"/>
@@ -15506,7 +15242,26 @@
                 </a:solidFill>
                 <a:latin typeface="Apple SD Gothic Neo"/>
               </a:rPr>
-              <a:t>• 업무별 PoC 1~2건 → 효과·보안·사용 한도 측정 → 팀 표준 활용 가이드 수립</a:t>
+              <a:t>• Gemini: 장문 사양서·데이터시트 분석을 자동화해 자료 조사 부담 경감</a:t>
+            </a:r>
+          </a:p>
+          <a:p>
+            <a:pPr algn="l">
+              <a:lnSpc>
+                <a:spcPct val="128000"/>
+              </a:lnSpc>
+              <a:spcAft>
+                <a:spcPts val="400"/>
+              </a:spcAft>
+            </a:pPr>
+            <a:r>
+              <a:rPr sz="1150" b="0">
+                <a:solidFill>
+                  <a:srgbClr val="FFFFFF"/>
+                </a:solidFill>
+                <a:latin typeface="Apple SD Gothic Neo"/>
+              </a:rPr>
+              <a:t>• Claude: 펌웨어·드라이버 코드 작성·리팩터링으로 개발 생산성 향상</a:t>
             </a:r>
           </a:p>
         </p:txBody>

</xml_diff>